<commit_message>
Add HW3 preview to floating point recitation
</commit_message>
<xml_diff>
--- a/public/presentations/CS211_Recitation_3.pptx
+++ b/public/presentations/CS211_Recitation_3.pptx
@@ -2,29 +2,32 @@
 <file path=ppt/presentation.xml><?xml version="1.0" encoding="utf-8"?>
 <p:presentation xmlns:p="http://schemas.openxmlformats.org/presentationml/2006/main">
   <p:sldMasterIdLst>
-    <p:sldMasterId xmlns:r="http://schemas.openxmlformats.org/officeDocument/2006/relationships" id="2147483648" r:id="R8ef0510d25a24440"/>
+    <p:sldMasterId xmlns:r="http://schemas.openxmlformats.org/officeDocument/2006/relationships" id="2147483648" r:id="Ra47e6fe55a134014"/>
   </p:sldMasterIdLst>
   <p:notesMasterIdLst>
-    <p:notesMasterId xmlns:r="http://schemas.openxmlformats.org/officeDocument/2006/relationships" r:id="R8aa4f0f4d1994147"/>
+    <p:notesMasterId xmlns:r="http://schemas.openxmlformats.org/officeDocument/2006/relationships" r:id="Rd3b23f1bb00e4b8d"/>
   </p:notesMasterIdLst>
   <p:sldIdLst>
-    <p:sldId xmlns:r="http://schemas.openxmlformats.org/officeDocument/2006/relationships" id="256" r:id="R2e5fd7b401034495"/>
-    <p:sldId xmlns:r="http://schemas.openxmlformats.org/officeDocument/2006/relationships" id="257" r:id="R1225c6ea891b4ed2"/>
-    <p:sldId xmlns:r="http://schemas.openxmlformats.org/officeDocument/2006/relationships" id="258" r:id="R461f0b8506044744"/>
-    <p:sldId xmlns:r="http://schemas.openxmlformats.org/officeDocument/2006/relationships" id="259" r:id="Rdb93ef0b09d84dfb"/>
-    <p:sldId xmlns:r="http://schemas.openxmlformats.org/officeDocument/2006/relationships" id="260" r:id="Rd313bce263f546a8"/>
-    <p:sldId xmlns:r="http://schemas.openxmlformats.org/officeDocument/2006/relationships" id="261" r:id="R358fc6bfdd2c40b7"/>
-    <p:sldId xmlns:r="http://schemas.openxmlformats.org/officeDocument/2006/relationships" id="262" r:id="R09bb18d6ecab4f9f"/>
-    <p:sldId xmlns:r="http://schemas.openxmlformats.org/officeDocument/2006/relationships" id="263" r:id="R1ab76bbb87ad4eeb"/>
-    <p:sldId xmlns:r="http://schemas.openxmlformats.org/officeDocument/2006/relationships" id="264" r:id="R20e0c0edd2f54e00"/>
-    <p:sldId xmlns:r="http://schemas.openxmlformats.org/officeDocument/2006/relationships" id="265" r:id="R453557a4695c48d0"/>
-    <p:sldId xmlns:r="http://schemas.openxmlformats.org/officeDocument/2006/relationships" id="266" r:id="R1f9e5f482c784e45"/>
-    <p:sldId xmlns:r="http://schemas.openxmlformats.org/officeDocument/2006/relationships" id="267" r:id="Re5ccc9e889de484c"/>
-    <p:sldId xmlns:r="http://schemas.openxmlformats.org/officeDocument/2006/relationships" id="268" r:id="Rb3843a33f808476c"/>
-    <p:sldId xmlns:r="http://schemas.openxmlformats.org/officeDocument/2006/relationships" id="269" r:id="R88c937303f4342cc"/>
-    <p:sldId xmlns:r="http://schemas.openxmlformats.org/officeDocument/2006/relationships" id="270" r:id="Re10018e583c2457c"/>
-    <p:sldId xmlns:r="http://schemas.openxmlformats.org/officeDocument/2006/relationships" id="271" r:id="R400764ad50c341f5"/>
-    <p:sldId xmlns:r="http://schemas.openxmlformats.org/officeDocument/2006/relationships" id="272" r:id="R267876eb78f74481"/>
+    <p:sldId xmlns:r="http://schemas.openxmlformats.org/officeDocument/2006/relationships" id="256" r:id="R4600a745c4114dc6"/>
+    <p:sldId xmlns:r="http://schemas.openxmlformats.org/officeDocument/2006/relationships" id="257" r:id="Rfbd2ab6f0c9b4982"/>
+    <p:sldId xmlns:r="http://schemas.openxmlformats.org/officeDocument/2006/relationships" id="258" r:id="R27b11eb247a749a8"/>
+    <p:sldId xmlns:r="http://schemas.openxmlformats.org/officeDocument/2006/relationships" id="259" r:id="Rf0d345b8f1a145d5"/>
+    <p:sldId xmlns:r="http://schemas.openxmlformats.org/officeDocument/2006/relationships" id="260" r:id="R8b0d79b20a25400a"/>
+    <p:sldId xmlns:r="http://schemas.openxmlformats.org/officeDocument/2006/relationships" id="261" r:id="R8e12034dd6864da2"/>
+    <p:sldId xmlns:r="http://schemas.openxmlformats.org/officeDocument/2006/relationships" id="262" r:id="R2dabec76ca8845d8"/>
+    <p:sldId xmlns:r="http://schemas.openxmlformats.org/officeDocument/2006/relationships" id="263" r:id="R1aaed51860dc4a9f"/>
+    <p:sldId xmlns:r="http://schemas.openxmlformats.org/officeDocument/2006/relationships" id="264" r:id="R6a5f4c0583294f71"/>
+    <p:sldId xmlns:r="http://schemas.openxmlformats.org/officeDocument/2006/relationships" id="265" r:id="Rc64204b446d54df8"/>
+    <p:sldId xmlns:r="http://schemas.openxmlformats.org/officeDocument/2006/relationships" id="266" r:id="R80e53087e4004862"/>
+    <p:sldId xmlns:r="http://schemas.openxmlformats.org/officeDocument/2006/relationships" id="267" r:id="R013ff6a4f2fe4cbe"/>
+    <p:sldId xmlns:r="http://schemas.openxmlformats.org/officeDocument/2006/relationships" id="268" r:id="R02cddb29a9df4149"/>
+    <p:sldId xmlns:r="http://schemas.openxmlformats.org/officeDocument/2006/relationships" id="269" r:id="R4b94b08c36fd40c3"/>
+    <p:sldId xmlns:r="http://schemas.openxmlformats.org/officeDocument/2006/relationships" id="270" r:id="Re6e10f2a9a304161"/>
+    <p:sldId xmlns:r="http://schemas.openxmlformats.org/officeDocument/2006/relationships" id="271" r:id="Rbde8424f5d854cb5"/>
+    <p:sldId xmlns:r="http://schemas.openxmlformats.org/officeDocument/2006/relationships" id="272" r:id="R43c57c166f024dbe"/>
+    <p:sldId xmlns:r="http://schemas.openxmlformats.org/officeDocument/2006/relationships" id="273" r:id="Ra6d0bdf5fc754bdc"/>
+    <p:sldId xmlns:r="http://schemas.openxmlformats.org/officeDocument/2006/relationships" id="274" r:id="Rd577631298fa4770"/>
+    <p:sldId xmlns:r="http://schemas.openxmlformats.org/officeDocument/2006/relationships" id="275" r:id="Ra16db4aea30a4f8b"/>
   </p:sldIdLst>
   <p:sldSz cx="12192000" cy="6858000"/>
   <p:notesSz cx="6858000" cy="9144000"/>
@@ -458,17 +461,7 @@
           <a:lstStyle xmlns:a="http://schemas.openxmlformats.org/drawingml/2006/main"/>
           <a:p xmlns:a="http://schemas.openxmlformats.org/drawingml/2006/main">
             <a:r>
-              <a:t>Suggested 50-minute pacing: binary place values and fields 8 min; normal values 12 min; subnormals and the boundary 12 min; decoding and encoding practice 12 min; rounding and recap 6 min. This teaches the concepts behind the professor’s planned assignment without displaying its unreleased prompt or solution. Source: lecture 6 and the professor’s description supplied by the TA.</a:t>
-            </a:r>
-          </a:p>
-          <a:p xmlns:a="http://schemas.openxmlformats.org/drawingml/2006/main">
-            <a:r>
-              <a:t/>
-            </a:r>
-          </a:p>
-          <a:p xmlns:a="http://schemas.openxmlformats.org/drawingml/2006/main">
-            <a:r>
-              <a:t>Source: https://firner.com/presentations/cs211/2026-Fall/cs211_06/#/</a:t>
+              <a:t>Suggested 50-minute pacing: binary place values and fields 7 min; normal values 10 min; subnormals and the boundary 10 min; decoding and encoding practice 10 min; rounding and spacing 5 min; HW3 preview and recap 8 min. The HW3 details are based on the professor’s description supplied by the TA; the assignment is not officially posted. Source: lecture 6.</a:t>
             </a:r>
           </a:p>
         </p:txBody>
@@ -541,16 +534,6 @@
               <a:t>Use the 3-exponent-bit, bias-3, 3-fraction-bit practice format. Largest subnormal is F=7, giving 7/32. Smallest normal is E=1,F=0, giving 2^(1−3)=1/4. This illustrates gradual underflow.</a:t>
             </a:r>
           </a:p>
-          <a:p xmlns:a="http://schemas.openxmlformats.org/drawingml/2006/main">
-            <a:r>
-              <a:t/>
-            </a:r>
-          </a:p>
-          <a:p xmlns:a="http://schemas.openxmlformats.org/drawingml/2006/main">
-            <a:r>
-              <a:t>Source: https://firner.com/presentations/cs211/2026-Fall/cs211_06/#/</a:t>
-            </a:r>
-          </a:p>
         </p:txBody>
       </p:sp>
       <p:sp>
@@ -621,16 +604,6 @@
               <a:t>Allow two to three minutes. A is normal: E=2,F=4, value (1+4/8)×2^-1=3/4. B is subnormal: E=0,F=3, value 3/32. Ask students to name the equation before calculating.</a:t>
             </a:r>
           </a:p>
-          <a:p xmlns:a="http://schemas.openxmlformats.org/drawingml/2006/main">
-            <a:r>
-              <a:t/>
-            </a:r>
-          </a:p>
-          <a:p xmlns:a="http://schemas.openxmlformats.org/drawingml/2006/main">
-            <a:r>
-              <a:t>Source: https://firner.com/presentations/cs211/2026-Fall/cs211_06/#/</a:t>
-            </a:r>
-          </a:p>
         </p:txBody>
       </p:sp>
       <p:sp>
@@ -701,16 +674,6 @@
               <a:t>Have students explain why B is not (1+3/8)×2^-3. The exponent for subnormals is fixed at 1−bias=-2, and the leading 1 is absent.</a:t>
             </a:r>
           </a:p>
-          <a:p xmlns:a="http://schemas.openxmlformats.org/drawingml/2006/main">
-            <a:r>
-              <a:t/>
-            </a:r>
-          </a:p>
-          <a:p xmlns:a="http://schemas.openxmlformats.org/drawingml/2006/main">
-            <a:r>
-              <a:t>Source: https://firner.com/presentations/cs211/2026-Fall/cs211_06/#/</a:t>
-            </a:r>
-          </a:p>
         </p:txBody>
       </p:sp>
       <p:sp>
@@ -781,16 +744,6 @@
               <a:t>Give two minutes. Both examples are exactly representable, so no rounding rule is needed. Ask students to check results by substituting E and F into the appropriate formula.</a:t>
             </a:r>
           </a:p>
-          <a:p xmlns:a="http://schemas.openxmlformats.org/drawingml/2006/main">
-            <a:r>
-              <a:t/>
-            </a:r>
-          </a:p>
-          <a:p xmlns:a="http://schemas.openxmlformats.org/drawingml/2006/main">
-            <a:r>
-              <a:t>Source: https://firner.com/presentations/cs211/2026-Fall/cs211_06/#/</a:t>
-            </a:r>
-          </a:p>
         </p:txBody>
       </p:sp>
       <p:sp>
@@ -861,16 +814,6 @@
               <a:t>Do not reveal until students have tried both. Emphasize that E=0 is a category marker here, not the unbiased exponent. E=3 represents true exponent zero because bias is three.</a:t>
             </a:r>
           </a:p>
-          <a:p xmlns:a="http://schemas.openxmlformats.org/drawingml/2006/main">
-            <a:r>
-              <a:t/>
-            </a:r>
-          </a:p>
-          <a:p xmlns:a="http://schemas.openxmlformats.org/drawingml/2006/main">
-            <a:r>
-              <a:t>Source: https://firner.com/presentations/cs211/2026-Fall/cs211_06/#/</a:t>
-            </a:r>
-          </a:p>
         </p:txBody>
       </p:sp>
       <p:sp>
@@ -941,16 +884,6 @@
               <a:t>The future homework description does not specify rounding, so do not teach truncation or nearest as a required rule. Here E=1 for both nearby normals. 5/16=0.3125, 11/32=0.34375, and 1/3≈0.3333. This replaces the earlier abstract associativity slide with a representation example directly tied to the professor's stated learning goal.</a:t>
             </a:r>
           </a:p>
-          <a:p xmlns:a="http://schemas.openxmlformats.org/drawingml/2006/main">
-            <a:r>
-              <a:t/>
-            </a:r>
-          </a:p>
-          <a:p xmlns:a="http://schemas.openxmlformats.org/drawingml/2006/main">
-            <a:r>
-              <a:t>Source: https://firner.com/presentations/cs211/2026-Fall/cs211_06/#/</a:t>
-            </a:r>
-          </a:p>
         </p:txBody>
       </p:sp>
       <p:sp>
@@ -1021,16 +954,6 @@
               <a:t>For normals with fixed E, incrementing F by one changes the value by 2^(E−bias)/8. Show how this connects to the rounding slide and lecture 6’s discussion of gaps between floats.</a:t>
             </a:r>
           </a:p>
-          <a:p xmlns:a="http://schemas.openxmlformats.org/drawingml/2006/main">
-            <a:r>
-              <a:t/>
-            </a:r>
-          </a:p>
-          <a:p xmlns:a="http://schemas.openxmlformats.org/drawingml/2006/main">
-            <a:r>
-              <a:t>Source: https://firner.com/presentations/cs211/2026-Fall/cs211_06/#/</a:t>
-            </a:r>
-          </a:p>
         </p:txBody>
       </p:sp>
       <p:sp>
@@ -1098,17 +1021,147 @@
           <a:lstStyle xmlns:a="http://schemas.openxmlformats.org/drawingml/2006/main"/>
           <a:p xmlns:a="http://schemas.openxmlformats.org/drawingml/2006/main">
             <a:r>
-              <a:t>Review the two mistakes most likely to occur: forgetting to add the bias for a normal exponent, and using the normal hidden 1 for a subnormal. Do not reveal the unreleased homework solution. Remind students to follow the eventual assignment’s rounding and valid-input rules.</a:t>
-            </a:r>
-          </a:p>
-          <a:p xmlns:a="http://schemas.openxmlformats.org/drawingml/2006/main">
-            <a:r>
-              <a:t/>
-            </a:r>
-          </a:p>
-          <a:p xmlns:a="http://schemas.openxmlformats.org/drawingml/2006/main">
-            <a:r>
-              <a:t>Source: https://firner.com/presentations/cs211/2026-Fall/cs211_06/#/</a:t>
+              <a:t>Based on the professor’s preview supplied by the TA. The intended command-line inputs are exponent bits, bias, significand bits, numerator, and denominator, in that order. The output contains the exponent and significand field values. Use 5/2 as a new teaching example. The final handout may add input and rounding details.</a:t>
+            </a:r>
+          </a:p>
+        </p:txBody>
+      </p:sp>
+      <p:sp>
+        <p:nvSpPr>
+          <p:cNvPr id="4" name="Slide Number Placeholder 3"/>
+          <p:cNvSpPr>
+            <a:spLocks xmlns:a="http://schemas.openxmlformats.org/drawingml/2006/main" noGrp="1"/>
+          </p:cNvSpPr>
+          <p:nvPr>
+            <p:ph type="sldNum" idx="5"/>
+          </p:nvPr>
+        </p:nvSpPr>
+        <p:spPr/>
+        <p:txBody>
+          <a:bodyPr xmlns:a="http://schemas.openxmlformats.org/drawingml/2006/main"/>
+          <a:lstStyle xmlns:a="http://schemas.openxmlformats.org/drawingml/2006/main"/>
+          <a:p xmlns:a="http://schemas.openxmlformats.org/drawingml/2006/main"/>
+        </p:txBody>
+      </p:sp>
+    </p:spTree>
+  </p:cSld>
+  <p:clrMapOvr>
+    <a:masterClrMapping xmlns:a="http://schemas.openxmlformats.org/drawingml/2006/main"/>
+  </p:clrMapOvr>
+</p:notes>
+</file>
+
+<file path=ppt/notesSlides/notesSlide18.xml><?xml version="1.0" encoding="utf-8"?>
+<p:notes xmlns:p="http://schemas.openxmlformats.org/presentationml/2006/main">
+  <p:cSld>
+    <p:spTree>
+      <p:nvGrpSpPr>
+        <p:cNvPr id="1" name=""/>
+        <p:cNvGrpSpPr/>
+        <p:nvPr/>
+      </p:nvGrpSpPr>
+      <p:grpSpPr>
+        <a:xfrm xmlns:a="http://schemas.openxmlformats.org/drawingml/2006/main"/>
+      </p:grpSpPr>
+      <p:sp>
+        <p:nvSpPr>
+          <p:cNvPr id="2" name="Slide Image Placeholder 1"/>
+          <p:cNvSpPr>
+            <a:spLocks xmlns:a="http://schemas.openxmlformats.org/drawingml/2006/main" noGrp="1"/>
+          </p:cNvSpPr>
+          <p:nvPr>
+            <p:ph type="sldImg" idx="0"/>
+          </p:nvPr>
+        </p:nvSpPr>
+        <p:spPr/>
+      </p:sp>
+      <p:sp>
+        <p:nvSpPr>
+          <p:cNvPr id="3" name="Notes Placeholder 2"/>
+          <p:cNvSpPr>
+            <a:spLocks xmlns:a="http://schemas.openxmlformats.org/drawingml/2006/main" noGrp="1"/>
+          </p:cNvSpPr>
+          <p:nvPr>
+            <p:ph type="body" idx="1"/>
+          </p:nvPr>
+        </p:nvSpPr>
+        <p:spPr/>
+        <p:txBody>
+          <a:bodyPr xmlns:a="http://schemas.openxmlformats.org/drawingml/2006/main"/>
+          <a:lstStyle xmlns:a="http://schemas.openxmlformats.org/drawingml/2006/main"/>
+          <a:p xmlns:a="http://schemas.openxmlformats.org/drawingml/2006/main">
+            <a:r>
+              <a:t>This example is mathematically exact and uses the planned input order. Important TA note: the supplied draft solution computes the normal significand as (numerator &lt;&lt; sig_bits)/denominator − 2^sig_bits without scaling by 2^power_of_two. For these inputs that draft gives F=12, outside the three-bit range, rather than F=2. Do not present that draft code as a correct answer key until the normal path is fixed. Source: professor’s preview and lecture 6 normal-value equation.</a:t>
+            </a:r>
+          </a:p>
+        </p:txBody>
+      </p:sp>
+      <p:sp>
+        <p:nvSpPr>
+          <p:cNvPr id="4" name="Slide Number Placeholder 3"/>
+          <p:cNvSpPr>
+            <a:spLocks xmlns:a="http://schemas.openxmlformats.org/drawingml/2006/main" noGrp="1"/>
+          </p:cNvSpPr>
+          <p:nvPr>
+            <p:ph type="sldNum" idx="5"/>
+          </p:nvPr>
+        </p:nvSpPr>
+        <p:spPr/>
+        <p:txBody>
+          <a:bodyPr xmlns:a="http://schemas.openxmlformats.org/drawingml/2006/main"/>
+          <a:lstStyle xmlns:a="http://schemas.openxmlformats.org/drawingml/2006/main"/>
+          <a:p xmlns:a="http://schemas.openxmlformats.org/drawingml/2006/main"/>
+        </p:txBody>
+      </p:sp>
+    </p:spTree>
+  </p:cSld>
+  <p:clrMapOvr>
+    <a:masterClrMapping xmlns:a="http://schemas.openxmlformats.org/drawingml/2006/main"/>
+  </p:clrMapOvr>
+</p:notes>
+</file>
+
+<file path=ppt/notesSlides/notesSlide19.xml><?xml version="1.0" encoding="utf-8"?>
+<p:notes xmlns:p="http://schemas.openxmlformats.org/presentationml/2006/main">
+  <p:cSld>
+    <p:spTree>
+      <p:nvGrpSpPr>
+        <p:cNvPr id="1" name=""/>
+        <p:cNvGrpSpPr/>
+        <p:nvPr/>
+      </p:nvGrpSpPr>
+      <p:grpSpPr>
+        <a:xfrm xmlns:a="http://schemas.openxmlformats.org/drawingml/2006/main"/>
+      </p:grpSpPr>
+      <p:sp>
+        <p:nvSpPr>
+          <p:cNvPr id="2" name="Slide Image Placeholder 1"/>
+          <p:cNvSpPr>
+            <a:spLocks xmlns:a="http://schemas.openxmlformats.org/drawingml/2006/main" noGrp="1"/>
+          </p:cNvSpPr>
+          <p:nvPr>
+            <p:ph type="sldImg" idx="0"/>
+          </p:nvPr>
+        </p:nvSpPr>
+        <p:spPr/>
+      </p:sp>
+      <p:sp>
+        <p:nvSpPr>
+          <p:cNvPr id="3" name="Notes Placeholder 2"/>
+          <p:cNvSpPr>
+            <a:spLocks xmlns:a="http://schemas.openxmlformats.org/drawingml/2006/main" noGrp="1"/>
+          </p:cNvSpPr>
+          <p:nvPr>
+            <p:ph type="body" idx="1"/>
+          </p:nvPr>
+        </p:nvSpPr>
+        <p:spPr/>
+        <p:txBody>
+          <a:bodyPr xmlns:a="http://schemas.openxmlformats.org/drawingml/2006/main"/>
+          <a:lstStyle xmlns:a="http://schemas.openxmlformats.org/drawingml/2006/main"/>
+          <a:p xmlns:a="http://schemas.openxmlformats.org/drawingml/2006/main">
+            <a:r>
+              <a:t>Here p is the number of significand bits. For exact examples, solve the equation algebraically. The eventual homework may specify how to round values that fall between encodings, so do not assume a rounding rule yet. This is a conceptual approach, not a copy of the unreleased source code. Source: professor’s preview and lecture 6 equations.</a:t>
             </a:r>
           </a:p>
         </p:txBody>
@@ -1181,14 +1234,74 @@
               <a:t>The planned assignment accepts exponent-bit count, bias, significand-bit count, numerator, and denominator. Do not present this as the released homework. Explain that these are stored fields, not decimal digits. Here F means the integer represented by the three fraction bits. Lecture 6 reviews normal and subnormal equations.</a:t>
             </a:r>
           </a:p>
-          <a:p xmlns:a="http://schemas.openxmlformats.org/drawingml/2006/main">
-            <a:r>
-              <a:t/>
-            </a:r>
-          </a:p>
-          <a:p xmlns:a="http://schemas.openxmlformats.org/drawingml/2006/main">
-            <a:r>
-              <a:t>Source: https://firner.com/presentations/cs211/2026-Fall/cs211_06/#/</a:t>
+        </p:txBody>
+      </p:sp>
+      <p:sp>
+        <p:nvSpPr>
+          <p:cNvPr id="4" name="Slide Number Placeholder 3"/>
+          <p:cNvSpPr>
+            <a:spLocks xmlns:a="http://schemas.openxmlformats.org/drawingml/2006/main" noGrp="1"/>
+          </p:cNvSpPr>
+          <p:nvPr>
+            <p:ph type="sldNum" idx="5"/>
+          </p:nvPr>
+        </p:nvSpPr>
+        <p:spPr/>
+        <p:txBody>
+          <a:bodyPr xmlns:a="http://schemas.openxmlformats.org/drawingml/2006/main"/>
+          <a:lstStyle xmlns:a="http://schemas.openxmlformats.org/drawingml/2006/main"/>
+          <a:p xmlns:a="http://schemas.openxmlformats.org/drawingml/2006/main"/>
+        </p:txBody>
+      </p:sp>
+    </p:spTree>
+  </p:cSld>
+  <p:clrMapOvr>
+    <a:masterClrMapping xmlns:a="http://schemas.openxmlformats.org/drawingml/2006/main"/>
+  </p:clrMapOvr>
+</p:notes>
+</file>
+
+<file path=ppt/notesSlides/notesSlide20.xml><?xml version="1.0" encoding="utf-8"?>
+<p:notes xmlns:p="http://schemas.openxmlformats.org/presentationml/2006/main">
+  <p:cSld>
+    <p:spTree>
+      <p:nvGrpSpPr>
+        <p:cNvPr id="1" name=""/>
+        <p:cNvGrpSpPr/>
+        <p:nvPr/>
+      </p:nvGrpSpPr>
+      <p:grpSpPr>
+        <a:xfrm xmlns:a="http://schemas.openxmlformats.org/drawingml/2006/main"/>
+      </p:grpSpPr>
+      <p:sp>
+        <p:nvSpPr>
+          <p:cNvPr id="2" name="Slide Image Placeholder 1"/>
+          <p:cNvSpPr>
+            <a:spLocks xmlns:a="http://schemas.openxmlformats.org/drawingml/2006/main" noGrp="1"/>
+          </p:cNvSpPr>
+          <p:nvPr>
+            <p:ph type="sldImg" idx="0"/>
+          </p:nvPr>
+        </p:nvSpPr>
+        <p:spPr/>
+      </p:sp>
+      <p:sp>
+        <p:nvSpPr>
+          <p:cNvPr id="3" name="Notes Placeholder 2"/>
+          <p:cNvSpPr>
+            <a:spLocks xmlns:a="http://schemas.openxmlformats.org/drawingml/2006/main" noGrp="1"/>
+          </p:cNvSpPr>
+          <p:nvPr>
+            <p:ph type="body" idx="1"/>
+          </p:nvPr>
+        </p:nvSpPr>
+        <p:spPr/>
+        <p:txBody>
+          <a:bodyPr xmlns:a="http://schemas.openxmlformats.org/drawingml/2006/main"/>
+          <a:lstStyle xmlns:a="http://schemas.openxmlformats.org/drawingml/2006/main"/>
+          <a:p xmlns:a="http://schemas.openxmlformats.org/drawingml/2006/main">
+            <a:r>
+              <a:t>Review the two mistakes most likely to occur: forgetting to add the bias for a normal exponent, and using the normal hidden 1 for a subnormal. Do not reveal the unreleased homework solution. Remind students to follow the eventual assignment’s rounding and valid-input rules.</a:t>
             </a:r>
           </a:p>
         </p:txBody>
@@ -1261,16 +1374,6 @@
               <a:t>Draw place-value columns before introducing exponent fields. This bridges base-2 arithmetic to the 5/4 and 3/16 examples. The 0.101₂ example equals 0.625.</a:t>
             </a:r>
           </a:p>
-          <a:p xmlns:a="http://schemas.openxmlformats.org/drawingml/2006/main">
-            <a:r>
-              <a:t/>
-            </a:r>
-          </a:p>
-          <a:p xmlns:a="http://schemas.openxmlformats.org/drawingml/2006/main">
-            <a:r>
-              <a:t>Source: https://firner.com/presentations/cs211/2026-Fall/cs211_06/#/</a:t>
-            </a:r>
-          </a:p>
         </p:txBody>
       </p:sp>
       <p:sp>
@@ -1341,16 +1444,6 @@
               <a:t>Draw place-value columns 1, 1/2, 1/4, 1/8. 1.010 binary is exactly 1.25. The trailing zero pads the practice format; it does not change the value. The examples are constructed for teaching, not copied from the unreleased solution.</a:t>
             </a:r>
           </a:p>
-          <a:p xmlns:a="http://schemas.openxmlformats.org/drawingml/2006/main">
-            <a:r>
-              <a:t/>
-            </a:r>
-          </a:p>
-          <a:p xmlns:a="http://schemas.openxmlformats.org/drawingml/2006/main">
-            <a:r>
-              <a:t>Source: https://firner.com/presentations/cs211/2026-Fall/cs211_06/#/</a:t>
-            </a:r>
-          </a:p>
         </p:txBody>
       </p:sp>
       <p:sp>
@@ -1421,16 +1514,6 @@
               <a:t>Normal fields have E from 1 through 6 in this toy format. The all-ones exponent is reserved for infinities/NaNs in IEEE-style formats. We are using the lecture's normal/subnormal equations and a toy format with bias 3. Avoid saying the bias always equals 2^(k−1)−1; the planned exercise supplies it explicitly.</a:t>
             </a:r>
           </a:p>
-          <a:p xmlns:a="http://schemas.openxmlformats.org/drawingml/2006/main">
-            <a:r>
-              <a:t/>
-            </a:r>
-          </a:p>
-          <a:p xmlns:a="http://schemas.openxmlformats.org/drawingml/2006/main">
-            <a:r>
-              <a:t>Source: https://firner.com/presentations/cs211/2026-Fall/cs211_06/#/</a:t>
-            </a:r>
-          </a:p>
         </p:txBody>
       </p:sp>
       <p:sp>
@@ -1501,16 +1584,6 @@
               <a:t>Work through this slowly on the board. Ask which part of 1.010 is stored: 010. The lecture equation is (−1)^S × 2^(E−bias) × (1+F/2^sig_bits). For E=3, bias=3, F=2, sig_bits=3 the result is exactly 1.25.</a:t>
             </a:r>
           </a:p>
-          <a:p xmlns:a="http://schemas.openxmlformats.org/drawingml/2006/main">
-            <a:r>
-              <a:t/>
-            </a:r>
-          </a:p>
-          <a:p xmlns:a="http://schemas.openxmlformats.org/drawingml/2006/main">
-            <a:r>
-              <a:t>Source: https://firner.com/presentations/cs211/2026-Fall/cs211_06/#/</a:t>
-            </a:r>
-          </a:p>
         </p:txBody>
       </p:sp>
       <p:sp>
@@ -1581,16 +1654,6 @@
               <a:t>Pause at each field and ask students what it means. The sign is zero. E=2 lies in the normal range, e=-1, and F=5. The value is 0.8125.</a:t>
             </a:r>
           </a:p>
-          <a:p xmlns:a="http://schemas.openxmlformats.org/drawingml/2006/main">
-            <a:r>
-              <a:t/>
-            </a:r>
-          </a:p>
-          <a:p xmlns:a="http://schemas.openxmlformats.org/drawingml/2006/main">
-            <a:r>
-              <a:t>Source: https://firner.com/presentations/cs211/2026-Fall/cs211_06/#/</a:t>
-            </a:r>
-          </a:p>
         </p:txBody>
       </p:sp>
       <p:sp>
@@ -1661,16 +1724,6 @@
               <a:t>This is the likely stumbling block: subnormals use exponent 1−bias, not 0−bias, and no hidden leading 1. For this format, F=0 gives zero, F=1 is 1/32, F=7 is 7/32, and the smallest normal is 1/4. Source: lecture 6 equations.</a:t>
             </a:r>
           </a:p>
-          <a:p xmlns:a="http://schemas.openxmlformats.org/drawingml/2006/main">
-            <a:r>
-              <a:t/>
-            </a:r>
-          </a:p>
-          <a:p xmlns:a="http://schemas.openxmlformats.org/drawingml/2006/main">
-            <a:r>
-              <a:t>Source: https://firner.com/presentations/cs211/2026-Fall/cs211_06/#/</a:t>
-            </a:r>
-          </a:p>
         </p:txBody>
       </p:sp>
       <p:sp>
@@ -1739,16 +1792,6 @@
           <a:p xmlns:a="http://schemas.openxmlformats.org/drawingml/2006/main">
             <a:r>
               <a:t>Contrast this with the normal 5/4 example. Students may try to store a negative exponent in E or include the hidden 1. Return to the formula to resolve both confusions.</a:t>
-            </a:r>
-          </a:p>
-          <a:p xmlns:a="http://schemas.openxmlformats.org/drawingml/2006/main">
-            <a:r>
-              <a:t/>
-            </a:r>
-          </a:p>
-          <a:p xmlns:a="http://schemas.openxmlformats.org/drawingml/2006/main">
-            <a:r>
-              <a:t>Source: https://firner.com/presentations/cs211/2026-Fall/cs211_06/#/</a:t>
             </a:r>
           </a:p>
         </p:txBody>
@@ -1816,7 +1859,7 @@
   </p:cSld>
   <p:clrMap bg1="lt1" tx1="dk1" bg2="lt2" tx2="dk2" accent1="accent1" accent2="accent2" accent3="accent3" accent4="accent4" accent5="accent5" accent6="accent6" hlink="hlink" folHlink="folHlink"/>
   <p:sldLayoutIdLst>
-    <p:sldLayoutId xmlns:r="http://schemas.openxmlformats.org/officeDocument/2006/relationships" id="2147483649" r:id="R1ec887bd53c348e7"/>
+    <p:sldLayoutId xmlns:r="http://schemas.openxmlformats.org/officeDocument/2006/relationships" id="2147483649" r:id="R9f6ca5ca0cc841de"/>
   </p:sldLayoutIdLst>
   <p:txStyles>
     <p:titleStyle>
@@ -2396,6 +2439,7 @@
           <a:lstStyle xmlns:a="http://schemas.openxmlformats.org/drawingml/2006/main"/>
           <a:p xmlns:a="http://schemas.openxmlformats.org/drawingml/2006/main">
             <a:pPr>
+              <a:buNone/>
               <a:defRPr sz="1275" b="0">
                 <a:solidFill>
                   <a:srgbClr val="6EE7B7"/>
@@ -2453,6 +2497,7 @@
           <a:lstStyle xmlns:a="http://schemas.openxmlformats.org/drawingml/2006/main"/>
           <a:p xmlns:a="http://schemas.openxmlformats.org/drawingml/2006/main">
             <a:pPr>
+              <a:buNone/>
               <a:defRPr sz="4500" b="0">
                 <a:solidFill>
                   <a:srgbClr val="FAFAFA"/>
@@ -2510,6 +2555,7 @@
           <a:lstStyle xmlns:a="http://schemas.openxmlformats.org/drawingml/2006/main"/>
           <a:p xmlns:a="http://schemas.openxmlformats.org/drawingml/2006/main">
             <a:pPr>
+              <a:buNone/>
               <a:defRPr sz="2100" b="0">
                 <a:solidFill>
                   <a:srgbClr val="D4D4D8"/>
@@ -2567,6 +2613,7 @@
           <a:lstStyle xmlns:a="http://schemas.openxmlformats.org/drawingml/2006/main"/>
           <a:p xmlns:a="http://schemas.openxmlformats.org/drawingml/2006/main">
             <a:pPr>
+              <a:buNone/>
               <a:defRPr sz="1650" b="0">
                 <a:solidFill>
                   <a:srgbClr val="A7F3D0"/>
@@ -2595,6 +2642,7 @@
           </a:p>
           <a:p xmlns:a="http://schemas.openxmlformats.org/drawingml/2006/main">
             <a:pPr>
+              <a:buNone/>
               <a:defRPr sz="1650" b="0">
                 <a:solidFill>
                   <a:srgbClr val="A7F3D0"/>
@@ -2618,6 +2666,7 @@
           </a:p>
           <a:p xmlns:a="http://schemas.openxmlformats.org/drawingml/2006/main">
             <a:pPr>
+              <a:buNone/>
               <a:defRPr sz="1650" b="0">
                 <a:solidFill>
                   <a:srgbClr val="A7F3D0"/>
@@ -2641,6 +2690,7 @@
           </a:p>
           <a:p xmlns:a="http://schemas.openxmlformats.org/drawingml/2006/main">
             <a:pPr>
+              <a:buNone/>
               <a:defRPr sz="1650" b="0">
                 <a:solidFill>
                   <a:srgbClr val="A7F3D0"/>
@@ -2664,6 +2714,7 @@
           </a:p>
           <a:p xmlns:a="http://schemas.openxmlformats.org/drawingml/2006/main">
             <a:pPr>
+              <a:buNone/>
               <a:defRPr sz="1650" b="0">
                 <a:solidFill>
                   <a:srgbClr val="A7F3D0"/>
@@ -2683,6 +2734,30 @@
                 <a:cs typeface="Courier New"/>
               </a:rPr>
               <a:t>Practice with ratios and bit patterns</a:t>
+            </a:r>
+          </a:p>
+          <a:p xmlns:a="http://schemas.openxmlformats.org/drawingml/2006/main">
+            <a:pPr>
+              <a:buNone/>
+              <a:defRPr sz="1650" b="0">
+                <a:solidFill>
+                  <a:srgbClr val="A7F3D0"/>
+                </a:solidFill>
+                <a:latin typeface="Courier New"/>
+                <a:ea typeface="Courier New"/>
+                <a:cs typeface="Courier New"/>
+              </a:defRPr>
+            </a:pPr>
+            <a:r>
+              <a:rPr sz="1650" b="0">
+                <a:solidFill>
+                  <a:srgbClr val="A7F3D0"/>
+                </a:solidFill>
+                <a:latin typeface="Courier New"/>
+                <a:ea typeface="Courier New"/>
+                <a:cs typeface="Courier New"/>
+              </a:rPr>
+              <a:t>HW3 preview</a:t>
             </a:r>
           </a:p>
         </p:txBody>
@@ -2721,6 +2796,7 @@
           <a:lstStyle xmlns:a="http://schemas.openxmlformats.org/drawingml/2006/main"/>
           <a:p xmlns:a="http://schemas.openxmlformats.org/drawingml/2006/main">
             <a:pPr>
+              <a:buNone/>
               <a:defRPr sz="1350" b="0">
                 <a:solidFill>
                   <a:srgbClr val="A1A1AA"/>
@@ -2778,6 +2854,7 @@
           <a:lstStyle xmlns:a="http://schemas.openxmlformats.org/drawingml/2006/main"/>
           <a:p xmlns:a="http://schemas.openxmlformats.org/drawingml/2006/main">
             <a:pPr>
+              <a:buNone/>
               <a:defRPr sz="1050" b="0">
                 <a:solidFill>
                   <a:srgbClr val="71717A"/>
@@ -2796,7 +2873,7 @@
                 <a:ea typeface="Courier New"/>
                 <a:cs typeface="Courier New"/>
               </a:rPr>
-              <a:t>01 / 17</a:t>
+              <a:t>01 / 20</a:t>
             </a:r>
           </a:p>
         </p:txBody>
@@ -2864,6 +2941,7 @@
           <a:lstStyle xmlns:a="http://schemas.openxmlformats.org/drawingml/2006/main"/>
           <a:p xmlns:a="http://schemas.openxmlformats.org/drawingml/2006/main">
             <a:pPr>
+              <a:buNone/>
               <a:defRPr sz="1275" b="0">
                 <a:solidFill>
                   <a:srgbClr val="6EE7B7"/>
@@ -2921,6 +2999,7 @@
           <a:lstStyle xmlns:a="http://schemas.openxmlformats.org/drawingml/2006/main"/>
           <a:p xmlns:a="http://schemas.openxmlformats.org/drawingml/2006/main">
             <a:pPr>
+              <a:buNone/>
               <a:defRPr sz="3600" b="0">
                 <a:solidFill>
                   <a:srgbClr val="FAFAFA"/>
@@ -2978,6 +3057,7 @@
           <a:lstStyle xmlns:a="http://schemas.openxmlformats.org/drawingml/2006/main"/>
           <a:p xmlns:a="http://schemas.openxmlformats.org/drawingml/2006/main">
             <a:pPr>
+              <a:buNone/>
               <a:defRPr sz="1950" b="0">
                 <a:solidFill>
                   <a:srgbClr val="D4D4D8"/>
@@ -3035,6 +3115,7 @@
           <a:lstStyle xmlns:a="http://schemas.openxmlformats.org/drawingml/2006/main"/>
           <a:p xmlns:a="http://schemas.openxmlformats.org/drawingml/2006/main">
             <a:pPr>
+              <a:buNone/>
               <a:defRPr sz="1650" b="0">
                 <a:solidFill>
                   <a:srgbClr val="A7F3D0"/>
@@ -3058,6 +3139,7 @@
           </a:p>
           <a:p xmlns:a="http://schemas.openxmlformats.org/drawingml/2006/main">
             <a:pPr>
+              <a:buNone/>
               <a:defRPr sz="1650" b="0">
                 <a:solidFill>
                   <a:srgbClr val="A7F3D0"/>
@@ -3086,6 +3168,7 @@
           </a:p>
           <a:p xmlns:a="http://schemas.openxmlformats.org/drawingml/2006/main">
             <a:pPr>
+              <a:buNone/>
               <a:defRPr sz="1650" b="0">
                 <a:solidFill>
                   <a:srgbClr val="A7F3D0"/>
@@ -3109,6 +3192,7 @@
           </a:p>
           <a:p xmlns:a="http://schemas.openxmlformats.org/drawingml/2006/main">
             <a:pPr>
+              <a:buNone/>
               <a:defRPr sz="1650" b="0">
                 <a:solidFill>
                   <a:srgbClr val="A7F3D0"/>
@@ -3137,6 +3221,7 @@
           </a:p>
           <a:p xmlns:a="http://schemas.openxmlformats.org/drawingml/2006/main">
             <a:pPr>
+              <a:buNone/>
               <a:defRPr sz="1650" b="0">
                 <a:solidFill>
                   <a:srgbClr val="A7F3D0"/>
@@ -3194,6 +3279,7 @@
           <a:lstStyle xmlns:a="http://schemas.openxmlformats.org/drawingml/2006/main"/>
           <a:p xmlns:a="http://schemas.openxmlformats.org/drawingml/2006/main">
             <a:pPr>
+              <a:buNone/>
               <a:defRPr sz="1350" b="0">
                 <a:solidFill>
                   <a:srgbClr val="A1A1AA"/>
@@ -3251,6 +3337,7 @@
           <a:lstStyle xmlns:a="http://schemas.openxmlformats.org/drawingml/2006/main"/>
           <a:p xmlns:a="http://schemas.openxmlformats.org/drawingml/2006/main">
             <a:pPr>
+              <a:buNone/>
               <a:defRPr sz="1050" b="0">
                 <a:solidFill>
                   <a:srgbClr val="71717A"/>
@@ -3269,7 +3356,7 @@
                 <a:ea typeface="Courier New"/>
                 <a:cs typeface="Courier New"/>
               </a:rPr>
-              <a:t>10 / 17</a:t>
+              <a:t>10 / 20</a:t>
             </a:r>
           </a:p>
         </p:txBody>
@@ -3337,6 +3424,7 @@
           <a:lstStyle xmlns:a="http://schemas.openxmlformats.org/drawingml/2006/main"/>
           <a:p xmlns:a="http://schemas.openxmlformats.org/drawingml/2006/main">
             <a:pPr>
+              <a:buNone/>
               <a:defRPr sz="1275" b="0">
                 <a:solidFill>
                   <a:srgbClr val="6EE7B7"/>
@@ -3394,6 +3482,7 @@
           <a:lstStyle xmlns:a="http://schemas.openxmlformats.org/drawingml/2006/main"/>
           <a:p xmlns:a="http://schemas.openxmlformats.org/drawingml/2006/main">
             <a:pPr>
+              <a:buNone/>
               <a:defRPr sz="3600" b="0">
                 <a:solidFill>
                   <a:srgbClr val="FAFAFA"/>
@@ -3451,6 +3540,7 @@
           <a:lstStyle xmlns:a="http://schemas.openxmlformats.org/drawingml/2006/main"/>
           <a:p xmlns:a="http://schemas.openxmlformats.org/drawingml/2006/main">
             <a:pPr>
+              <a:buNone/>
               <a:defRPr sz="1950" b="0">
                 <a:solidFill>
                   <a:srgbClr val="D4D4D8"/>
@@ -3479,6 +3569,7 @@
           </a:p>
           <a:p xmlns:a="http://schemas.openxmlformats.org/drawingml/2006/main">
             <a:pPr>
+              <a:buNone/>
               <a:defRPr sz="1950" b="0">
                 <a:solidFill>
                   <a:srgbClr val="D4D4D8"/>
@@ -3536,6 +3627,7 @@
           <a:lstStyle xmlns:a="http://schemas.openxmlformats.org/drawingml/2006/main"/>
           <a:p xmlns:a="http://schemas.openxmlformats.org/drawingml/2006/main">
             <a:pPr>
+              <a:buNone/>
               <a:defRPr sz="1650" b="0">
                 <a:solidFill>
                   <a:srgbClr val="A7F3D0"/>
@@ -3559,6 +3651,7 @@
           </a:p>
           <a:p xmlns:a="http://schemas.openxmlformats.org/drawingml/2006/main">
             <a:pPr>
+              <a:buNone/>
               <a:defRPr sz="1650" b="0">
                 <a:solidFill>
                   <a:srgbClr val="A7F3D0"/>
@@ -3582,6 +3675,7 @@
           </a:p>
           <a:p xmlns:a="http://schemas.openxmlformats.org/drawingml/2006/main">
             <a:pPr>
+              <a:buNone/>
               <a:defRPr sz="1650" b="0">
                 <a:solidFill>
                   <a:srgbClr val="A7F3D0"/>
@@ -3610,6 +3704,7 @@
           </a:p>
           <a:p xmlns:a="http://schemas.openxmlformats.org/drawingml/2006/main">
             <a:pPr>
+              <a:buNone/>
               <a:defRPr sz="1650" b="0">
                 <a:solidFill>
                   <a:srgbClr val="A7F3D0"/>
@@ -3633,6 +3728,7 @@
           </a:p>
           <a:p xmlns:a="http://schemas.openxmlformats.org/drawingml/2006/main">
             <a:pPr>
+              <a:buNone/>
               <a:defRPr sz="1650" b="0">
                 <a:solidFill>
                   <a:srgbClr val="A7F3D0"/>
@@ -3656,6 +3752,7 @@
           </a:p>
           <a:p xmlns:a="http://schemas.openxmlformats.org/drawingml/2006/main">
             <a:pPr>
+              <a:buNone/>
               <a:defRPr sz="1650" b="0">
                 <a:solidFill>
                   <a:srgbClr val="A7F3D0"/>
@@ -3713,6 +3810,7 @@
           <a:lstStyle xmlns:a="http://schemas.openxmlformats.org/drawingml/2006/main"/>
           <a:p xmlns:a="http://schemas.openxmlformats.org/drawingml/2006/main">
             <a:pPr>
+              <a:buNone/>
               <a:defRPr sz="1350" b="0">
                 <a:solidFill>
                   <a:srgbClr val="A1A1AA"/>
@@ -3770,6 +3868,7 @@
           <a:lstStyle xmlns:a="http://schemas.openxmlformats.org/drawingml/2006/main"/>
           <a:p xmlns:a="http://schemas.openxmlformats.org/drawingml/2006/main">
             <a:pPr>
+              <a:buNone/>
               <a:defRPr sz="1050" b="0">
                 <a:solidFill>
                   <a:srgbClr val="71717A"/>
@@ -3788,7 +3887,7 @@
                 <a:ea typeface="Courier New"/>
                 <a:cs typeface="Courier New"/>
               </a:rPr>
-              <a:t>11 / 17</a:t>
+              <a:t>11 / 20</a:t>
             </a:r>
           </a:p>
         </p:txBody>
@@ -3856,6 +3955,7 @@
           <a:lstStyle xmlns:a="http://schemas.openxmlformats.org/drawingml/2006/main"/>
           <a:p xmlns:a="http://schemas.openxmlformats.org/drawingml/2006/main">
             <a:pPr>
+              <a:buNone/>
               <a:defRPr sz="1275" b="0">
                 <a:solidFill>
                   <a:srgbClr val="6EE7B7"/>
@@ -3913,6 +4013,7 @@
           <a:lstStyle xmlns:a="http://schemas.openxmlformats.org/drawingml/2006/main"/>
           <a:p xmlns:a="http://schemas.openxmlformats.org/drawingml/2006/main">
             <a:pPr>
+              <a:buNone/>
               <a:defRPr sz="3600" b="0">
                 <a:solidFill>
                   <a:srgbClr val="FAFAFA"/>
@@ -3970,6 +4071,7 @@
           <a:lstStyle xmlns:a="http://schemas.openxmlformats.org/drawingml/2006/main"/>
           <a:p xmlns:a="http://schemas.openxmlformats.org/drawingml/2006/main">
             <a:pPr>
+              <a:buNone/>
               <a:defRPr sz="1950" b="0">
                 <a:solidFill>
                   <a:srgbClr val="D4D4D8"/>
@@ -3998,6 +4100,7 @@
           </a:p>
           <a:p xmlns:a="http://schemas.openxmlformats.org/drawingml/2006/main">
             <a:pPr>
+              <a:buNone/>
               <a:defRPr sz="1950" b="0">
                 <a:solidFill>
                   <a:srgbClr val="D4D4D8"/>
@@ -4055,6 +4158,7 @@
           <a:lstStyle xmlns:a="http://schemas.openxmlformats.org/drawingml/2006/main"/>
           <a:p xmlns:a="http://schemas.openxmlformats.org/drawingml/2006/main">
             <a:pPr>
+              <a:buNone/>
               <a:defRPr sz="1650" b="0">
                 <a:solidFill>
                   <a:srgbClr val="A7F3D0"/>
@@ -4078,6 +4182,7 @@
           </a:p>
           <a:p xmlns:a="http://schemas.openxmlformats.org/drawingml/2006/main">
             <a:pPr>
+              <a:buNone/>
               <a:defRPr sz="1650" b="0">
                 <a:solidFill>
                   <a:srgbClr val="A7F3D0"/>
@@ -4106,6 +4211,7 @@
           </a:p>
           <a:p xmlns:a="http://schemas.openxmlformats.org/drawingml/2006/main">
             <a:pPr>
+              <a:buNone/>
               <a:defRPr sz="1650" b="0">
                 <a:solidFill>
                   <a:srgbClr val="A7F3D0"/>
@@ -4129,6 +4235,7 @@
           </a:p>
           <a:p xmlns:a="http://schemas.openxmlformats.org/drawingml/2006/main">
             <a:pPr>
+              <a:buNone/>
               <a:defRPr sz="1650" b="0">
                 <a:solidFill>
                   <a:srgbClr val="A7F3D0"/>
@@ -4186,6 +4293,7 @@
           <a:lstStyle xmlns:a="http://schemas.openxmlformats.org/drawingml/2006/main"/>
           <a:p xmlns:a="http://schemas.openxmlformats.org/drawingml/2006/main">
             <a:pPr>
+              <a:buNone/>
               <a:defRPr sz="1350" b="0">
                 <a:solidFill>
                   <a:srgbClr val="A1A1AA"/>
@@ -4243,6 +4351,7 @@
           <a:lstStyle xmlns:a="http://schemas.openxmlformats.org/drawingml/2006/main"/>
           <a:p xmlns:a="http://schemas.openxmlformats.org/drawingml/2006/main">
             <a:pPr>
+              <a:buNone/>
               <a:defRPr sz="1050" b="0">
                 <a:solidFill>
                   <a:srgbClr val="71717A"/>
@@ -4261,7 +4370,7 @@
                 <a:ea typeface="Courier New"/>
                 <a:cs typeface="Courier New"/>
               </a:rPr>
-              <a:t>12 / 17</a:t>
+              <a:t>12 / 20</a:t>
             </a:r>
           </a:p>
         </p:txBody>
@@ -4329,6 +4438,7 @@
           <a:lstStyle xmlns:a="http://schemas.openxmlformats.org/drawingml/2006/main"/>
           <a:p xmlns:a="http://schemas.openxmlformats.org/drawingml/2006/main">
             <a:pPr>
+              <a:buNone/>
               <a:defRPr sz="1275" b="0">
                 <a:solidFill>
                   <a:srgbClr val="6EE7B7"/>
@@ -4386,6 +4496,7 @@
           <a:lstStyle xmlns:a="http://schemas.openxmlformats.org/drawingml/2006/main"/>
           <a:p xmlns:a="http://schemas.openxmlformats.org/drawingml/2006/main">
             <a:pPr>
+              <a:buNone/>
               <a:defRPr sz="3600" b="0">
                 <a:solidFill>
                   <a:srgbClr val="FAFAFA"/>
@@ -4443,6 +4554,7 @@
           <a:lstStyle xmlns:a="http://schemas.openxmlformats.org/drawingml/2006/main"/>
           <a:p xmlns:a="http://schemas.openxmlformats.org/drawingml/2006/main">
             <a:pPr>
+              <a:buNone/>
               <a:defRPr sz="1950" b="0">
                 <a:solidFill>
                   <a:srgbClr val="D4D4D8"/>
@@ -4471,6 +4583,7 @@
           </a:p>
           <a:p xmlns:a="http://schemas.openxmlformats.org/drawingml/2006/main">
             <a:pPr>
+              <a:buNone/>
               <a:defRPr sz="1950" b="0">
                 <a:solidFill>
                   <a:srgbClr val="D4D4D8"/>
@@ -4528,6 +4641,7 @@
           <a:lstStyle xmlns:a="http://schemas.openxmlformats.org/drawingml/2006/main"/>
           <a:p xmlns:a="http://schemas.openxmlformats.org/drawingml/2006/main">
             <a:pPr>
+              <a:buNone/>
               <a:defRPr sz="1650" b="0">
                 <a:solidFill>
                   <a:srgbClr val="A7F3D0"/>
@@ -4551,6 +4665,7 @@
           </a:p>
           <a:p xmlns:a="http://schemas.openxmlformats.org/drawingml/2006/main">
             <a:pPr>
+              <a:buNone/>
               <a:defRPr sz="1650" b="0">
                 <a:solidFill>
                   <a:srgbClr val="A7F3D0"/>
@@ -4574,6 +4689,7 @@
           </a:p>
           <a:p xmlns:a="http://schemas.openxmlformats.org/drawingml/2006/main">
             <a:pPr>
+              <a:buNone/>
               <a:defRPr sz="1650" b="0">
                 <a:solidFill>
                   <a:srgbClr val="A7F3D0"/>
@@ -4602,6 +4718,7 @@
           </a:p>
           <a:p xmlns:a="http://schemas.openxmlformats.org/drawingml/2006/main">
             <a:pPr>
+              <a:buNone/>
               <a:defRPr sz="1650" b="0">
                 <a:solidFill>
                   <a:srgbClr val="A7F3D0"/>
@@ -4625,6 +4742,7 @@
           </a:p>
           <a:p xmlns:a="http://schemas.openxmlformats.org/drawingml/2006/main">
             <a:pPr>
+              <a:buNone/>
               <a:defRPr sz="1650" b="0">
                 <a:solidFill>
                   <a:srgbClr val="A7F3D0"/>
@@ -4648,6 +4766,7 @@
           </a:p>
           <a:p xmlns:a="http://schemas.openxmlformats.org/drawingml/2006/main">
             <a:pPr>
+              <a:buNone/>
               <a:defRPr sz="1650" b="0">
                 <a:solidFill>
                   <a:srgbClr val="A7F3D0"/>
@@ -4705,6 +4824,7 @@
           <a:lstStyle xmlns:a="http://schemas.openxmlformats.org/drawingml/2006/main"/>
           <a:p xmlns:a="http://schemas.openxmlformats.org/drawingml/2006/main">
             <a:pPr>
+              <a:buNone/>
               <a:defRPr sz="1350" b="0">
                 <a:solidFill>
                   <a:srgbClr val="A1A1AA"/>
@@ -4762,6 +4882,7 @@
           <a:lstStyle xmlns:a="http://schemas.openxmlformats.org/drawingml/2006/main"/>
           <a:p xmlns:a="http://schemas.openxmlformats.org/drawingml/2006/main">
             <a:pPr>
+              <a:buNone/>
               <a:defRPr sz="1050" b="0">
                 <a:solidFill>
                   <a:srgbClr val="71717A"/>
@@ -4780,7 +4901,7 @@
                 <a:ea typeface="Courier New"/>
                 <a:cs typeface="Courier New"/>
               </a:rPr>
-              <a:t>13 / 17</a:t>
+              <a:t>13 / 20</a:t>
             </a:r>
           </a:p>
         </p:txBody>
@@ -4848,6 +4969,7 @@
           <a:lstStyle xmlns:a="http://schemas.openxmlformats.org/drawingml/2006/main"/>
           <a:p xmlns:a="http://schemas.openxmlformats.org/drawingml/2006/main">
             <a:pPr>
+              <a:buNone/>
               <a:defRPr sz="1275" b="0">
                 <a:solidFill>
                   <a:srgbClr val="6EE7B7"/>
@@ -4905,6 +5027,7 @@
           <a:lstStyle xmlns:a="http://schemas.openxmlformats.org/drawingml/2006/main"/>
           <a:p xmlns:a="http://schemas.openxmlformats.org/drawingml/2006/main">
             <a:pPr>
+              <a:buNone/>
               <a:defRPr sz="3600" b="0">
                 <a:solidFill>
                   <a:srgbClr val="FAFAFA"/>
@@ -4962,6 +5085,7 @@
           <a:lstStyle xmlns:a="http://schemas.openxmlformats.org/drawingml/2006/main"/>
           <a:p xmlns:a="http://schemas.openxmlformats.org/drawingml/2006/main">
             <a:pPr>
+              <a:buNone/>
               <a:defRPr sz="1950" b="0">
                 <a:solidFill>
                   <a:srgbClr val="D4D4D8"/>
@@ -4990,6 +5114,7 @@
           </a:p>
           <a:p xmlns:a="http://schemas.openxmlformats.org/drawingml/2006/main">
             <a:pPr>
+              <a:buNone/>
               <a:defRPr sz="1950" b="0">
                 <a:solidFill>
                   <a:srgbClr val="D4D4D8"/>
@@ -5047,6 +5172,7 @@
           <a:lstStyle xmlns:a="http://schemas.openxmlformats.org/drawingml/2006/main"/>
           <a:p xmlns:a="http://schemas.openxmlformats.org/drawingml/2006/main">
             <a:pPr>
+              <a:buNone/>
               <a:defRPr sz="1650" b="0">
                 <a:solidFill>
                   <a:srgbClr val="A7F3D0"/>
@@ -5070,6 +5196,7 @@
           </a:p>
           <a:p xmlns:a="http://schemas.openxmlformats.org/drawingml/2006/main">
             <a:pPr>
+              <a:buNone/>
               <a:defRPr sz="1650" b="0">
                 <a:solidFill>
                   <a:srgbClr val="A7F3D0"/>
@@ -5093,6 +5220,7 @@
           </a:p>
           <a:p xmlns:a="http://schemas.openxmlformats.org/drawingml/2006/main">
             <a:pPr>
+              <a:buNone/>
               <a:defRPr sz="1650" b="0">
                 <a:solidFill>
                   <a:srgbClr val="A7F3D0"/>
@@ -5116,6 +5244,7 @@
           </a:p>
           <a:p xmlns:a="http://schemas.openxmlformats.org/drawingml/2006/main">
             <a:pPr>
+              <a:buNone/>
               <a:defRPr sz="1650" b="0">
                 <a:solidFill>
                   <a:srgbClr val="A7F3D0"/>
@@ -5144,6 +5273,7 @@
           </a:p>
           <a:p xmlns:a="http://schemas.openxmlformats.org/drawingml/2006/main">
             <a:pPr>
+              <a:buNone/>
               <a:defRPr sz="1650" b="0">
                 <a:solidFill>
                   <a:srgbClr val="A7F3D0"/>
@@ -5167,6 +5297,7 @@
           </a:p>
           <a:p xmlns:a="http://schemas.openxmlformats.org/drawingml/2006/main">
             <a:pPr>
+              <a:buNone/>
               <a:defRPr sz="1650" b="0">
                 <a:solidFill>
                   <a:srgbClr val="A7F3D0"/>
@@ -5190,6 +5321,7 @@
           </a:p>
           <a:p xmlns:a="http://schemas.openxmlformats.org/drawingml/2006/main">
             <a:pPr>
+              <a:buNone/>
               <a:defRPr sz="1650" b="0">
                 <a:solidFill>
                   <a:srgbClr val="A7F3D0"/>
@@ -5213,6 +5345,7 @@
           </a:p>
           <a:p xmlns:a="http://schemas.openxmlformats.org/drawingml/2006/main">
             <a:pPr>
+              <a:buNone/>
               <a:defRPr sz="1650" b="0">
                 <a:solidFill>
                   <a:srgbClr val="A7F3D0"/>
@@ -5270,6 +5403,7 @@
           <a:lstStyle xmlns:a="http://schemas.openxmlformats.org/drawingml/2006/main"/>
           <a:p xmlns:a="http://schemas.openxmlformats.org/drawingml/2006/main">
             <a:pPr>
+              <a:buNone/>
               <a:defRPr sz="1350" b="0">
                 <a:solidFill>
                   <a:srgbClr val="A1A1AA"/>
@@ -5327,6 +5461,7 @@
           <a:lstStyle xmlns:a="http://schemas.openxmlformats.org/drawingml/2006/main"/>
           <a:p xmlns:a="http://schemas.openxmlformats.org/drawingml/2006/main">
             <a:pPr>
+              <a:buNone/>
               <a:defRPr sz="1050" b="0">
                 <a:solidFill>
                   <a:srgbClr val="71717A"/>
@@ -5345,7 +5480,7 @@
                 <a:ea typeface="Courier New"/>
                 <a:cs typeface="Courier New"/>
               </a:rPr>
-              <a:t>14 / 17</a:t>
+              <a:t>14 / 20</a:t>
             </a:r>
           </a:p>
         </p:txBody>
@@ -5413,6 +5548,7 @@
           <a:lstStyle xmlns:a="http://schemas.openxmlformats.org/drawingml/2006/main"/>
           <a:p xmlns:a="http://schemas.openxmlformats.org/drawingml/2006/main">
             <a:pPr>
+              <a:buNone/>
               <a:defRPr sz="1275" b="0">
                 <a:solidFill>
                   <a:srgbClr val="6EE7B7"/>
@@ -5470,6 +5606,7 @@
           <a:lstStyle xmlns:a="http://schemas.openxmlformats.org/drawingml/2006/main"/>
           <a:p xmlns:a="http://schemas.openxmlformats.org/drawingml/2006/main">
             <a:pPr>
+              <a:buNone/>
               <a:defRPr sz="3600" b="0">
                 <a:solidFill>
                   <a:srgbClr val="FAFAFA"/>
@@ -5527,6 +5664,7 @@
           <a:lstStyle xmlns:a="http://schemas.openxmlformats.org/drawingml/2006/main"/>
           <a:p xmlns:a="http://schemas.openxmlformats.org/drawingml/2006/main">
             <a:pPr>
+              <a:buNone/>
               <a:defRPr sz="1950" b="0">
                 <a:solidFill>
                   <a:srgbClr val="D4D4D8"/>
@@ -5555,6 +5693,7 @@
           </a:p>
           <a:p xmlns:a="http://schemas.openxmlformats.org/drawingml/2006/main">
             <a:pPr>
+              <a:buNone/>
               <a:defRPr sz="1950" b="0">
                 <a:solidFill>
                   <a:srgbClr val="D4D4D8"/>
@@ -5612,6 +5751,7 @@
           <a:lstStyle xmlns:a="http://schemas.openxmlformats.org/drawingml/2006/main"/>
           <a:p xmlns:a="http://schemas.openxmlformats.org/drawingml/2006/main">
             <a:pPr>
+              <a:buNone/>
               <a:defRPr sz="1650" b="0">
                 <a:solidFill>
                   <a:srgbClr val="A7F3D0"/>
@@ -5640,6 +5780,7 @@
           </a:p>
           <a:p xmlns:a="http://schemas.openxmlformats.org/drawingml/2006/main">
             <a:pPr>
+              <a:buNone/>
               <a:defRPr sz="1650" b="0">
                 <a:solidFill>
                   <a:srgbClr val="A7F3D0"/>
@@ -5663,6 +5804,7 @@
           </a:p>
           <a:p xmlns:a="http://schemas.openxmlformats.org/drawingml/2006/main">
             <a:pPr>
+              <a:buNone/>
               <a:defRPr sz="1650" b="0">
                 <a:solidFill>
                   <a:srgbClr val="A7F3D0"/>
@@ -5686,6 +5828,7 @@
           </a:p>
           <a:p xmlns:a="http://schemas.openxmlformats.org/drawingml/2006/main">
             <a:pPr>
+              <a:buNone/>
               <a:defRPr sz="1650" b="0">
                 <a:solidFill>
                   <a:srgbClr val="A7F3D0"/>
@@ -5714,6 +5857,7 @@
           </a:p>
           <a:p xmlns:a="http://schemas.openxmlformats.org/drawingml/2006/main">
             <a:pPr>
+              <a:buNone/>
               <a:defRPr sz="1650" b="0">
                 <a:solidFill>
                   <a:srgbClr val="A7F3D0"/>
@@ -5771,6 +5915,7 @@
           <a:lstStyle xmlns:a="http://schemas.openxmlformats.org/drawingml/2006/main"/>
           <a:p xmlns:a="http://schemas.openxmlformats.org/drawingml/2006/main">
             <a:pPr>
+              <a:buNone/>
               <a:defRPr sz="1350" b="0">
                 <a:solidFill>
                   <a:srgbClr val="A1A1AA"/>
@@ -5828,6 +5973,7 @@
           <a:lstStyle xmlns:a="http://schemas.openxmlformats.org/drawingml/2006/main"/>
           <a:p xmlns:a="http://schemas.openxmlformats.org/drawingml/2006/main">
             <a:pPr>
+              <a:buNone/>
               <a:defRPr sz="1050" b="0">
                 <a:solidFill>
                   <a:srgbClr val="71717A"/>
@@ -5846,7 +5992,7 @@
                 <a:ea typeface="Courier New"/>
                 <a:cs typeface="Courier New"/>
               </a:rPr>
-              <a:t>15 / 17</a:t>
+              <a:t>15 / 20</a:t>
             </a:r>
           </a:p>
         </p:txBody>
@@ -5914,6 +6060,7 @@
           <a:lstStyle xmlns:a="http://schemas.openxmlformats.org/drawingml/2006/main"/>
           <a:p xmlns:a="http://schemas.openxmlformats.org/drawingml/2006/main">
             <a:pPr>
+              <a:buNone/>
               <a:defRPr sz="1275" b="0">
                 <a:solidFill>
                   <a:srgbClr val="6EE7B7"/>
@@ -5971,6 +6118,7 @@
           <a:lstStyle xmlns:a="http://schemas.openxmlformats.org/drawingml/2006/main"/>
           <a:p xmlns:a="http://schemas.openxmlformats.org/drawingml/2006/main">
             <a:pPr>
+              <a:buNone/>
               <a:defRPr sz="3600" b="0">
                 <a:solidFill>
                   <a:srgbClr val="FAFAFA"/>
@@ -6028,6 +6176,7 @@
           <a:lstStyle xmlns:a="http://schemas.openxmlformats.org/drawingml/2006/main"/>
           <a:p xmlns:a="http://schemas.openxmlformats.org/drawingml/2006/main">
             <a:pPr>
+              <a:buNone/>
               <a:defRPr sz="1950" b="0">
                 <a:solidFill>
                   <a:srgbClr val="D4D4D8"/>
@@ -6056,6 +6205,7 @@
           </a:p>
           <a:p xmlns:a="http://schemas.openxmlformats.org/drawingml/2006/main">
             <a:pPr>
+              <a:buNone/>
               <a:defRPr sz="1950" b="0">
                 <a:solidFill>
                   <a:srgbClr val="D4D4D8"/>
@@ -6113,6 +6263,7 @@
           <a:lstStyle xmlns:a="http://schemas.openxmlformats.org/drawingml/2006/main"/>
           <a:p xmlns:a="http://schemas.openxmlformats.org/drawingml/2006/main">
             <a:pPr>
+              <a:buNone/>
               <a:defRPr sz="1650" b="0">
                 <a:solidFill>
                   <a:srgbClr val="A7F3D0"/>
@@ -6136,6 +6287,7 @@
           </a:p>
           <a:p xmlns:a="http://schemas.openxmlformats.org/drawingml/2006/main">
             <a:pPr>
+              <a:buNone/>
               <a:defRPr sz="1650" b="0">
                 <a:solidFill>
                   <a:srgbClr val="A7F3D0"/>
@@ -6159,6 +6311,7 @@
           </a:p>
           <a:p xmlns:a="http://schemas.openxmlformats.org/drawingml/2006/main">
             <a:pPr>
+              <a:buNone/>
               <a:defRPr sz="1650" b="0">
                 <a:solidFill>
                   <a:srgbClr val="A7F3D0"/>
@@ -6187,6 +6340,7 @@
           </a:p>
           <a:p xmlns:a="http://schemas.openxmlformats.org/drawingml/2006/main">
             <a:pPr>
+              <a:buNone/>
               <a:defRPr sz="1650" b="0">
                 <a:solidFill>
                   <a:srgbClr val="A7F3D0"/>
@@ -6210,6 +6364,7 @@
           </a:p>
           <a:p xmlns:a="http://schemas.openxmlformats.org/drawingml/2006/main">
             <a:pPr>
+              <a:buNone/>
               <a:defRPr sz="1650" b="0">
                 <a:solidFill>
                   <a:srgbClr val="A7F3D0"/>
@@ -6233,6 +6388,7 @@
           </a:p>
           <a:p xmlns:a="http://schemas.openxmlformats.org/drawingml/2006/main">
             <a:pPr>
+              <a:buNone/>
               <a:defRPr sz="1650" b="0">
                 <a:solidFill>
                   <a:srgbClr val="A7F3D0"/>
@@ -6290,6 +6446,7 @@
           <a:lstStyle xmlns:a="http://schemas.openxmlformats.org/drawingml/2006/main"/>
           <a:p xmlns:a="http://schemas.openxmlformats.org/drawingml/2006/main">
             <a:pPr>
+              <a:buNone/>
               <a:defRPr sz="1350" b="0">
                 <a:solidFill>
                   <a:srgbClr val="A1A1AA"/>
@@ -6347,6 +6504,7 @@
           <a:lstStyle xmlns:a="http://schemas.openxmlformats.org/drawingml/2006/main"/>
           <a:p xmlns:a="http://schemas.openxmlformats.org/drawingml/2006/main">
             <a:pPr>
+              <a:buNone/>
               <a:defRPr sz="1050" b="0">
                 <a:solidFill>
                   <a:srgbClr val="71717A"/>
@@ -6365,7 +6523,7 @@
                 <a:ea typeface="Courier New"/>
                 <a:cs typeface="Courier New"/>
               </a:rPr>
-              <a:t>16 / 17</a:t>
+              <a:t>16 / 20</a:t>
             </a:r>
           </a:p>
         </p:txBody>
@@ -6404,7 +6562,7 @@
           <p:cNvPr id="7" name="">
             <a:extLst xmlns:a="http://schemas.openxmlformats.org/drawingml/2006/main">
               <a:ext uri="{FF2B5EF4-FFF2-40B4-BE49-F238E27FC236}">
-                <a16:creationId xmlns:a16="http://schemas.microsoft.com/office/drawing/2014/main" id="{4989B079-C3E8-43BB-8638-96121018769A}"/>
+                <a16:creationId xmlns:a16="http://schemas.microsoft.com/office/drawing/2014/main" id="{0BCE7827-648B-4B62-AE80-F3CE9BFFD594}"/>
               </a:ext>
             </a:extLst>
           </p:cNvPr>
@@ -6433,6 +6591,7 @@
           <a:lstStyle xmlns:a="http://schemas.openxmlformats.org/drawingml/2006/main"/>
           <a:p xmlns:a="http://schemas.openxmlformats.org/drawingml/2006/main">
             <a:pPr>
+              <a:buNone/>
               <a:defRPr sz="1275" b="0">
                 <a:solidFill>
                   <a:srgbClr val="6EE7B7"/>
@@ -6451,7 +6610,7 @@
                 <a:ea typeface="Courier New"/>
                 <a:cs typeface="Courier New"/>
               </a:rPr>
-              <a:t>FLOATING POINT · RECAP</a:t>
+              <a:t>FLOATING POINT · ASSIGNMENT PREVIEW</a:t>
             </a:r>
           </a:p>
         </p:txBody>
@@ -6461,7 +6620,7 @@
           <p:cNvPr id="2" name="">
             <a:extLst xmlns:a="http://schemas.openxmlformats.org/drawingml/2006/main">
               <a:ext uri="{FF2B5EF4-FFF2-40B4-BE49-F238E27FC236}">
-                <a16:creationId xmlns:a16="http://schemas.microsoft.com/office/drawing/2014/main" id="{95D3113E-85F1-4E22-A62E-265E94FE3617}"/>
+                <a16:creationId xmlns:a16="http://schemas.microsoft.com/office/drawing/2014/main" id="{E6B69FE5-5D95-4306-AAF0-9A70AD531613}"/>
               </a:ext>
             </a:extLst>
           </p:cNvPr>
@@ -6490,6 +6649,7 @@
           <a:lstStyle xmlns:a="http://schemas.openxmlformats.org/drawingml/2006/main"/>
           <a:p xmlns:a="http://schemas.openxmlformats.org/drawingml/2006/main">
             <a:pPr>
+              <a:buNone/>
               <a:defRPr sz="3600" b="0">
                 <a:solidFill>
                   <a:srgbClr val="FAFAFA"/>
@@ -6508,7 +6668,7 @@
                 <a:ea typeface="Arial"/>
                 <a:cs typeface="Arial"/>
               </a:rPr>
-              <a:t>How to check an encoding</a:t>
+              <a:t>HW3 preview: five inputs</a:t>
             </a:r>
           </a:p>
         </p:txBody>
@@ -6518,7 +6678,7 @@
           <p:cNvPr id="3" name="">
             <a:extLst xmlns:a="http://schemas.openxmlformats.org/drawingml/2006/main">
               <a:ext uri="{FF2B5EF4-FFF2-40B4-BE49-F238E27FC236}">
-                <a16:creationId xmlns:a16="http://schemas.microsoft.com/office/drawing/2014/main" id="{8EC5E33C-BA7C-4ADE-9FC3-9ABD9F3C6FD4}"/>
+                <a16:creationId xmlns:a16="http://schemas.microsoft.com/office/drawing/2014/main" id="{887FE9A9-E5DE-4BC1-94AD-59371BF9B78C}"/>
               </a:ext>
             </a:extLst>
           </p:cNvPr>
@@ -6547,6 +6707,7 @@
           <a:lstStyle xmlns:a="http://schemas.openxmlformats.org/drawingml/2006/main"/>
           <a:p xmlns:a="http://schemas.openxmlformats.org/drawingml/2006/main">
             <a:pPr>
+              <a:buNone/>
               <a:defRPr sz="1950" b="0">
                 <a:solidFill>
                   <a:srgbClr val="D4D4D8"/>
@@ -6565,35 +6726,7 @@
                 <a:ea typeface="Arial"/>
                 <a:cs typeface="Arial"/>
               </a:rPr>
-              <a:t>Compare the value with the smallest normal. Choose the normal or subnormal equation, work out the fields, then decode them to check.</a:t>
-            </a:r>
-          </a:p>
-          <a:p xmlns:a="http://schemas.openxmlformats.org/drawingml/2006/main">
-            <a:r>
-              <a:t/>
-            </a:r>
-          </a:p>
-          <a:p xmlns:a="http://schemas.openxmlformats.org/drawingml/2006/main">
-            <a:pPr>
-              <a:defRPr sz="1950" b="0">
-                <a:solidFill>
-                  <a:srgbClr val="D4D4D8"/>
-                </a:solidFill>
-                <a:latin typeface="Arial"/>
-                <a:ea typeface="Arial"/>
-                <a:cs typeface="Arial"/>
-              </a:defRPr>
-            </a:pPr>
-            <a:r>
-              <a:rPr sz="1950" b="0">
-                <a:solidFill>
-                  <a:srgbClr val="D4D4D8"/>
-                </a:solidFill>
-                <a:latin typeface="Arial"/>
-                <a:ea typeface="Arial"/>
-                <a:cs typeface="Arial"/>
-              </a:rPr>
-              <a:t>If the value is not exact, use the rounding rule given with the problem.</a:t>
+              <a:t>The professor plans a program that reads a format and a nonnegative ratio. The assignment has not been posted, so treat these details as a preview.</a:t>
             </a:r>
           </a:p>
         </p:txBody>
@@ -6603,7 +6736,7 @@
           <p:cNvPr id="4" name="">
             <a:extLst xmlns:a="http://schemas.openxmlformats.org/drawingml/2006/main">
               <a:ext uri="{FF2B5EF4-FFF2-40B4-BE49-F238E27FC236}">
-                <a16:creationId xmlns:a16="http://schemas.microsoft.com/office/drawing/2014/main" id="{EA939046-DA6B-448C-A179-5B13743C72F3}"/>
+                <a16:creationId xmlns:a16="http://schemas.microsoft.com/office/drawing/2014/main" id="{CED75AEC-85E3-4520-B63E-09FCF9AACAE6}"/>
               </a:ext>
             </a:extLst>
           </p:cNvPr>
@@ -6632,6 +6765,7 @@
           <a:lstStyle xmlns:a="http://schemas.openxmlformats.org/drawingml/2006/main"/>
           <a:p xmlns:a="http://schemas.openxmlformats.org/drawingml/2006/main">
             <a:pPr>
+              <a:buNone/>
               <a:defRPr sz="1650" b="0">
                 <a:solidFill>
                   <a:srgbClr val="A7F3D0"/>
@@ -6650,7 +6784,55 @@
                 <a:ea typeface="Courier New"/>
                 <a:cs typeface="Courier New"/>
               </a:rPr>
-              <a:t>Our practice format</a:t>
+              <a:t>format:  exp_bits = 3</a:t>
+            </a:r>
+          </a:p>
+          <a:p xmlns:a="http://schemas.openxmlformats.org/drawingml/2006/main">
+            <a:pPr>
+              <a:buNone/>
+              <a:defRPr sz="1650" b="0">
+                <a:solidFill>
+                  <a:srgbClr val="A7F3D0"/>
+                </a:solidFill>
+                <a:latin typeface="Courier New"/>
+                <a:ea typeface="Courier New"/>
+                <a:cs typeface="Courier New"/>
+              </a:defRPr>
+            </a:pPr>
+            <a:r>
+              <a:rPr sz="1650" b="0">
+                <a:solidFill>
+                  <a:srgbClr val="A7F3D0"/>
+                </a:solidFill>
+                <a:latin typeface="Courier New"/>
+                <a:ea typeface="Courier New"/>
+                <a:cs typeface="Courier New"/>
+              </a:rPr>
+              <a:t>         bias = 3</a:t>
+            </a:r>
+          </a:p>
+          <a:p xmlns:a="http://schemas.openxmlformats.org/drawingml/2006/main">
+            <a:pPr>
+              <a:buNone/>
+              <a:defRPr sz="1650" b="0">
+                <a:solidFill>
+                  <a:srgbClr val="A7F3D0"/>
+                </a:solidFill>
+                <a:latin typeface="Courier New"/>
+                <a:ea typeface="Courier New"/>
+                <a:cs typeface="Courier New"/>
+              </a:defRPr>
+            </a:pPr>
+            <a:r>
+              <a:rPr sz="1650" b="0">
+                <a:solidFill>
+                  <a:srgbClr val="A7F3D0"/>
+                </a:solidFill>
+                <a:latin typeface="Courier New"/>
+                <a:ea typeface="Courier New"/>
+                <a:cs typeface="Courier New"/>
+              </a:rPr>
+              <a:t>         sig_bits = 3</a:t>
             </a:r>
           </a:p>
           <a:p xmlns:a="http://schemas.openxmlformats.org/drawingml/2006/main">
@@ -6660,6 +6842,7 @@
           </a:p>
           <a:p xmlns:a="http://schemas.openxmlformats.org/drawingml/2006/main">
             <a:pPr>
+              <a:buNone/>
               <a:defRPr sz="1650" b="0">
                 <a:solidFill>
                   <a:srgbClr val="A7F3D0"/>
@@ -6678,11 +6861,12 @@
                 <a:ea typeface="Courier New"/>
                 <a:cs typeface="Courier New"/>
               </a:rPr>
-              <a:t>Normal:    (1 + F/8) × 2^(E−3)</a:t>
-            </a:r>
-          </a:p>
-          <a:p xmlns:a="http://schemas.openxmlformats.org/drawingml/2006/main">
-            <a:pPr>
+              <a:t>value:   numerator = 5</a:t>
+            </a:r>
+          </a:p>
+          <a:p xmlns:a="http://schemas.openxmlformats.org/drawingml/2006/main">
+            <a:pPr>
+              <a:buNone/>
               <a:defRPr sz="1650" b="0">
                 <a:solidFill>
                   <a:srgbClr val="A7F3D0"/>
@@ -6701,16 +6885,36 @@
                 <a:ea typeface="Courier New"/>
                 <a:cs typeface="Courier New"/>
               </a:rPr>
-              <a:t>Subnormal: (    F/8) × 2⁻²</a:t>
-            </a:r>
-          </a:p>
-          <a:p xmlns:a="http://schemas.openxmlformats.org/drawingml/2006/main">
-            <a:r>
+              <a:t>         denominator = 2</a:t>
+            </a:r>
+          </a:p>
+          <a:p xmlns:a="http://schemas.openxmlformats.org/drawingml/2006/main">
+            <a:pPr>
+              <a:buNone/>
+              <a:defRPr sz="1650" b="0">
+                <a:solidFill>
+                  <a:srgbClr val="A7F3D0"/>
+                </a:solidFill>
+                <a:latin typeface="Courier New"/>
+                <a:ea typeface="Courier New"/>
+                <a:cs typeface="Courier New"/>
+              </a:defRPr>
+            </a:pPr>
+            <a:r>
+              <a:rPr sz="1650" b="0">
+                <a:solidFill>
+                  <a:srgbClr val="A7F3D0"/>
+                </a:solidFill>
+                <a:latin typeface="Courier New"/>
+                <a:ea typeface="Courier New"/>
+                <a:cs typeface="Courier New"/>
+              </a:rPr>
               <a:t/>
             </a:r>
           </a:p>
           <a:p xmlns:a="http://schemas.openxmlformats.org/drawingml/2006/main">
             <a:pPr>
+              <a:buNone/>
               <a:defRPr sz="1650" b="0">
                 <a:solidFill>
                   <a:srgbClr val="A7F3D0"/>
@@ -6729,35 +6933,7 @@
                 <a:ea typeface="Courier New"/>
                 <a:cs typeface="Courier New"/>
               </a:rPr>
-              <a:t>E = 0, F = 0  →  zero</a:t>
-            </a:r>
-          </a:p>
-          <a:p xmlns:a="http://schemas.openxmlformats.org/drawingml/2006/main">
-            <a:r>
-              <a:t/>
-            </a:r>
-          </a:p>
-          <a:p xmlns:a="http://schemas.openxmlformats.org/drawingml/2006/main">
-            <a:pPr>
-              <a:defRPr sz="1650" b="0">
-                <a:solidFill>
-                  <a:srgbClr val="A7F3D0"/>
-                </a:solidFill>
-                <a:latin typeface="Courier New"/>
-                <a:ea typeface="Courier New"/>
-                <a:cs typeface="Courier New"/>
-              </a:defRPr>
-            </a:pPr>
-            <a:r>
-              <a:rPr sz="1650" b="0">
-                <a:solidFill>
-                  <a:srgbClr val="A7F3D0"/>
-                </a:solidFill>
-                <a:latin typeface="Courier New"/>
-                <a:ea typeface="Courier New"/>
-                <a:cs typeface="Courier New"/>
-              </a:rPr>
-              <a:t>Decode your bits as a final check.</a:t>
+              <a:t>Find: E (exponent), F (fraction)</a:t>
             </a:r>
           </a:p>
         </p:txBody>
@@ -6767,7 +6943,7 @@
           <p:cNvPr id="5" name="">
             <a:extLst xmlns:a="http://schemas.openxmlformats.org/drawingml/2006/main">
               <a:ext uri="{FF2B5EF4-FFF2-40B4-BE49-F238E27FC236}">
-                <a16:creationId xmlns:a16="http://schemas.microsoft.com/office/drawing/2014/main" id="{585A0E73-828D-45A1-9AD7-8EED8C5E7EB1}"/>
+                <a16:creationId xmlns:a16="http://schemas.microsoft.com/office/drawing/2014/main" id="{7A18BC8F-2DC5-4B6B-A4F9-10CDE1183DE6}"/>
               </a:ext>
             </a:extLst>
           </p:cNvPr>
@@ -6796,6 +6972,7 @@
           <a:lstStyle xmlns:a="http://schemas.openxmlformats.org/drawingml/2006/main"/>
           <a:p xmlns:a="http://schemas.openxmlformats.org/drawingml/2006/main">
             <a:pPr>
+              <a:buNone/>
               <a:defRPr sz="1350" b="0">
                 <a:solidFill>
                   <a:srgbClr val="A1A1AA"/>
@@ -6814,7 +6991,7 @@
                 <a:ea typeface="Arial"/>
                 <a:cs typeface="Arial"/>
               </a:rPr>
-              <a:t>A correct encoding must reproduce the intended value or its required rounded value.</a:t>
+              <a:t>The first three inputs define the format; the last two define the value.</a:t>
             </a:r>
           </a:p>
         </p:txBody>
@@ -6824,7 +7001,7 @@
           <p:cNvPr id="6" name="">
             <a:extLst xmlns:a="http://schemas.openxmlformats.org/drawingml/2006/main">
               <a:ext uri="{FF2B5EF4-FFF2-40B4-BE49-F238E27FC236}">
-                <a16:creationId xmlns:a16="http://schemas.microsoft.com/office/drawing/2014/main" id="{E1FBC5BD-1F5D-42FA-AC83-E0BF862F4EDF}"/>
+                <a16:creationId xmlns:a16="http://schemas.microsoft.com/office/drawing/2014/main" id="{94269C50-3A0A-4FBB-A1D2-A33411F72ECA}"/>
               </a:ext>
             </a:extLst>
           </p:cNvPr>
@@ -6853,6 +7030,7 @@
           <a:lstStyle xmlns:a="http://schemas.openxmlformats.org/drawingml/2006/main"/>
           <a:p xmlns:a="http://schemas.openxmlformats.org/drawingml/2006/main">
             <a:pPr>
+              <a:buNone/>
               <a:defRPr sz="1050" b="0">
                 <a:solidFill>
                   <a:srgbClr val="71717A"/>
@@ -6871,7 +7049,7 @@
                 <a:ea typeface="Courier New"/>
                 <a:cs typeface="Courier New"/>
               </a:rPr>
-              <a:t>17 / 17</a:t>
+              <a:t>17 / 20</a:t>
             </a:r>
           </a:p>
         </p:txBody>
@@ -6879,7 +7057,1071 @@
     </p:spTree>
     <p:extLst>
       <p:ext uri="{BB962C8B-B14F-4D97-AF65-F5344CB8AC3E}">
-        <p14:creationId xmlns:p14="http://schemas.microsoft.com/office/powerpoint/2010/main" val="10196595"/>
+        <p14:creationId xmlns:p14="http://schemas.microsoft.com/office/powerpoint/2010/main" val="1018474765"/>
+      </p:ext>
+    </p:extLst>
+  </p:cSld>
+</p:sld>
+</file>
+
+<file path=ppt/slides/slide18.xml><?xml version="1.0" encoding="utf-8"?>
+<p:sld xmlns:p="http://schemas.openxmlformats.org/presentationml/2006/main">
+  <p:cSld>
+    <p:bg>
+      <p:bgPr>
+        <a:solidFill xmlns:a="http://schemas.openxmlformats.org/drawingml/2006/main">
+          <a:srgbClr val="09090B"/>
+        </a:solidFill>
+      </p:bgPr>
+    </p:bg>
+    <p:spTree>
+      <p:nvGrpSpPr>
+        <p:cNvPr id="1" name=""/>
+        <p:cNvGrpSpPr/>
+        <p:nvPr/>
+      </p:nvGrpSpPr>
+      <p:grpSpPr>
+        <a:xfrm xmlns:a="http://schemas.openxmlformats.org/drawingml/2006/main"/>
+      </p:grpSpPr>
+      <p:sp>
+        <p:nvSpPr>
+          <p:cNvPr id="7" name="">
+            <a:extLst xmlns:a="http://schemas.openxmlformats.org/drawingml/2006/main">
+              <a:ext uri="{FF2B5EF4-FFF2-40B4-BE49-F238E27FC236}">
+                <a16:creationId xmlns:a16="http://schemas.microsoft.com/office/drawing/2014/main" id="{0BCE7827-648B-4B62-AE80-F3CE9BFFD594}"/>
+              </a:ext>
+            </a:extLst>
+          </p:cNvPr>
+          <p:cNvSpPr>
+            <a:spLocks xmlns:a="http://schemas.openxmlformats.org/drawingml/2006/main" noGrp="1"/>
+          </p:cNvSpPr>
+          <p:nvPr/>
+        </p:nvSpPr>
+        <p:spPr>
+          <a:xfrm xmlns:a="http://schemas.openxmlformats.org/drawingml/2006/main">
+            <a:off x="685800" y="361950"/>
+            <a:ext cx="10477500" cy="285750"/>
+          </a:xfrm>
+          <a:prstGeom xmlns:a="http://schemas.openxmlformats.org/drawingml/2006/main" prst="rect">
+            <a:avLst/>
+          </a:prstGeom>
+          <a:noFill xmlns:a="http://schemas.openxmlformats.org/drawingml/2006/main"/>
+          <a:ln xmlns:a="http://schemas.openxmlformats.org/drawingml/2006/main" w="0">
+            <a:noFill/>
+          </a:ln>
+        </p:spPr>
+        <p:txBody>
+          <a:bodyPr xmlns:a="http://schemas.openxmlformats.org/drawingml/2006/main" anchor="t">
+            <a:normAutofit fontScale="100000"/>
+          </a:bodyPr>
+          <a:lstStyle xmlns:a="http://schemas.openxmlformats.org/drawingml/2006/main"/>
+          <a:p xmlns:a="http://schemas.openxmlformats.org/drawingml/2006/main">
+            <a:pPr>
+              <a:buNone/>
+              <a:defRPr sz="1275" b="0">
+                <a:solidFill>
+                  <a:srgbClr val="6EE7B7"/>
+                </a:solidFill>
+                <a:latin typeface="Courier New"/>
+                <a:ea typeface="Courier New"/>
+                <a:cs typeface="Courier New"/>
+              </a:defRPr>
+            </a:pPr>
+            <a:r>
+              <a:rPr sz="1275" b="0">
+                <a:solidFill>
+                  <a:srgbClr val="6EE7B7"/>
+                </a:solidFill>
+                <a:latin typeface="Courier New"/>
+                <a:ea typeface="Courier New"/>
+                <a:cs typeface="Courier New"/>
+              </a:rPr>
+              <a:t>FLOATING POINT · WORKED INPUT</a:t>
+            </a:r>
+          </a:p>
+        </p:txBody>
+      </p:sp>
+      <p:sp>
+        <p:nvSpPr>
+          <p:cNvPr id="2" name="">
+            <a:extLst xmlns:a="http://schemas.openxmlformats.org/drawingml/2006/main">
+              <a:ext uri="{FF2B5EF4-FFF2-40B4-BE49-F238E27FC236}">
+                <a16:creationId xmlns:a16="http://schemas.microsoft.com/office/drawing/2014/main" id="{E6B69FE5-5D95-4306-AAF0-9A70AD531613}"/>
+              </a:ext>
+            </a:extLst>
+          </p:cNvPr>
+          <p:cNvSpPr>
+            <a:spLocks xmlns:a="http://schemas.openxmlformats.org/drawingml/2006/main" noGrp="1"/>
+          </p:cNvSpPr>
+          <p:nvPr/>
+        </p:nvSpPr>
+        <p:spPr>
+          <a:xfrm xmlns:a="http://schemas.openxmlformats.org/drawingml/2006/main">
+            <a:off x="685800" y="885825"/>
+            <a:ext cx="10820400" cy="1066800"/>
+          </a:xfrm>
+          <a:prstGeom xmlns:a="http://schemas.openxmlformats.org/drawingml/2006/main" prst="rect">
+            <a:avLst/>
+          </a:prstGeom>
+          <a:noFill xmlns:a="http://schemas.openxmlformats.org/drawingml/2006/main"/>
+          <a:ln xmlns:a="http://schemas.openxmlformats.org/drawingml/2006/main" w="0">
+            <a:noFill/>
+          </a:ln>
+        </p:spPr>
+        <p:txBody>
+          <a:bodyPr xmlns:a="http://schemas.openxmlformats.org/drawingml/2006/main" anchor="t">
+            <a:normAutofit fontScale="100000"/>
+          </a:bodyPr>
+          <a:lstStyle xmlns:a="http://schemas.openxmlformats.org/drawingml/2006/main"/>
+          <a:p xmlns:a="http://schemas.openxmlformats.org/drawingml/2006/main">
+            <a:pPr>
+              <a:buNone/>
+              <a:defRPr sz="3600" b="0">
+                <a:solidFill>
+                  <a:srgbClr val="FAFAFA"/>
+                </a:solidFill>
+                <a:latin typeface="Arial"/>
+                <a:ea typeface="Arial"/>
+                <a:cs typeface="Arial"/>
+              </a:defRPr>
+            </a:pPr>
+            <a:r>
+              <a:rPr sz="3600" b="0">
+                <a:solidFill>
+                  <a:srgbClr val="FAFAFA"/>
+                </a:solidFill>
+                <a:latin typeface="Arial"/>
+                <a:ea typeface="Arial"/>
+                <a:cs typeface="Arial"/>
+              </a:rPr>
+              <a:t>HW3 preview: encode 5/2</a:t>
+            </a:r>
+          </a:p>
+        </p:txBody>
+      </p:sp>
+      <p:sp>
+        <p:nvSpPr>
+          <p:cNvPr id="3" name="">
+            <a:extLst xmlns:a="http://schemas.openxmlformats.org/drawingml/2006/main">
+              <a:ext uri="{FF2B5EF4-FFF2-40B4-BE49-F238E27FC236}">
+                <a16:creationId xmlns:a16="http://schemas.microsoft.com/office/drawing/2014/main" id="{887FE9A9-E5DE-4BC1-94AD-59371BF9B78C}"/>
+              </a:ext>
+            </a:extLst>
+          </p:cNvPr>
+          <p:cNvSpPr>
+            <a:spLocks xmlns:a="http://schemas.openxmlformats.org/drawingml/2006/main" noGrp="1"/>
+          </p:cNvSpPr>
+          <p:nvPr/>
+        </p:nvSpPr>
+        <p:spPr>
+          <a:xfrm xmlns:a="http://schemas.openxmlformats.org/drawingml/2006/main">
+            <a:off x="685800" y="2200275"/>
+            <a:ext cx="4857750" cy="3124200"/>
+          </a:xfrm>
+          <a:prstGeom xmlns:a="http://schemas.openxmlformats.org/drawingml/2006/main" prst="rect">
+            <a:avLst/>
+          </a:prstGeom>
+          <a:noFill xmlns:a="http://schemas.openxmlformats.org/drawingml/2006/main"/>
+          <a:ln xmlns:a="http://schemas.openxmlformats.org/drawingml/2006/main" w="0">
+            <a:noFill/>
+          </a:ln>
+        </p:spPr>
+        <p:txBody>
+          <a:bodyPr xmlns:a="http://schemas.openxmlformats.org/drawingml/2006/main" anchor="t">
+            <a:normAutofit fontScale="100000"/>
+          </a:bodyPr>
+          <a:lstStyle xmlns:a="http://schemas.openxmlformats.org/drawingml/2006/main"/>
+          <a:p xmlns:a="http://schemas.openxmlformats.org/drawingml/2006/main">
+            <a:pPr>
+              <a:buNone/>
+              <a:defRPr sz="1950" b="0">
+                <a:solidFill>
+                  <a:srgbClr val="D4D4D8"/>
+                </a:solidFill>
+                <a:latin typeface="Arial"/>
+                <a:ea typeface="Arial"/>
+                <a:cs typeface="Arial"/>
+              </a:defRPr>
+            </a:pPr>
+            <a:r>
+              <a:rPr sz="1950" b="0">
+                <a:solidFill>
+                  <a:srgbClr val="D4D4D8"/>
+                </a:solidFill>
+                <a:latin typeface="Arial"/>
+                <a:ea typeface="Arial"/>
+                <a:cs typeface="Arial"/>
+              </a:rPr>
+              <a:t>With 3 exponent bits, bias 3, and 3 fraction bits, write 5/2 as 1.010₂ × 2¹. The true exponent is 1, so E = 1 + 3 = 4. The stored fraction is 010₂, so F = 2.</a:t>
+            </a:r>
+          </a:p>
+        </p:txBody>
+      </p:sp>
+      <p:sp>
+        <p:nvSpPr>
+          <p:cNvPr id="4" name="">
+            <a:extLst xmlns:a="http://schemas.openxmlformats.org/drawingml/2006/main">
+              <a:ext uri="{FF2B5EF4-FFF2-40B4-BE49-F238E27FC236}">
+                <a16:creationId xmlns:a16="http://schemas.microsoft.com/office/drawing/2014/main" id="{CED75AEC-85E3-4520-B63E-09FCF9AACAE6}"/>
+              </a:ext>
+            </a:extLst>
+          </p:cNvPr>
+          <p:cNvSpPr>
+            <a:spLocks xmlns:a="http://schemas.openxmlformats.org/drawingml/2006/main" noGrp="1"/>
+          </p:cNvSpPr>
+          <p:nvPr/>
+        </p:nvSpPr>
+        <p:spPr>
+          <a:xfrm xmlns:a="http://schemas.openxmlformats.org/drawingml/2006/main">
+            <a:off x="6181725" y="2200275"/>
+            <a:ext cx="5238750" cy="3286125"/>
+          </a:xfrm>
+          <a:prstGeom xmlns:a="http://schemas.openxmlformats.org/drawingml/2006/main" prst="rect">
+            <a:avLst/>
+          </a:prstGeom>
+          <a:noFill xmlns:a="http://schemas.openxmlformats.org/drawingml/2006/main"/>
+          <a:ln xmlns:a="http://schemas.openxmlformats.org/drawingml/2006/main" w="0">
+            <a:noFill/>
+          </a:ln>
+        </p:spPr>
+        <p:txBody>
+          <a:bodyPr xmlns:a="http://schemas.openxmlformats.org/drawingml/2006/main" anchor="t">
+            <a:normAutofit fontScale="100000"/>
+          </a:bodyPr>
+          <a:lstStyle xmlns:a="http://schemas.openxmlformats.org/drawingml/2006/main"/>
+          <a:p xmlns:a="http://schemas.openxmlformats.org/drawingml/2006/main">
+            <a:pPr>
+              <a:buNone/>
+              <a:defRPr sz="1650" b="0">
+                <a:solidFill>
+                  <a:srgbClr val="A7F3D0"/>
+                </a:solidFill>
+                <a:latin typeface="Courier New"/>
+                <a:ea typeface="Courier New"/>
+                <a:cs typeface="Courier New"/>
+              </a:defRPr>
+            </a:pPr>
+            <a:r>
+              <a:rPr sz="1650" b="0">
+                <a:solidFill>
+                  <a:srgbClr val="A7F3D0"/>
+                </a:solidFill>
+                <a:latin typeface="Courier New"/>
+                <a:ea typeface="Courier New"/>
+                <a:cs typeface="Courier New"/>
+              </a:rPr>
+              <a:t>Inputs: 3 3 3 5 2</a:t>
+            </a:r>
+          </a:p>
+          <a:p xmlns:a="http://schemas.openxmlformats.org/drawingml/2006/main">
+            <a:pPr>
+              <a:buNone/>
+              <a:defRPr sz="1650" b="0">
+                <a:solidFill>
+                  <a:srgbClr val="A7F3D0"/>
+                </a:solidFill>
+                <a:latin typeface="Courier New"/>
+                <a:ea typeface="Courier New"/>
+                <a:cs typeface="Courier New"/>
+              </a:defRPr>
+            </a:pPr>
+            <a:r>
+              <a:rPr sz="1650" b="0">
+                <a:solidFill>
+                  <a:srgbClr val="A7F3D0"/>
+                </a:solidFill>
+                <a:latin typeface="Courier New"/>
+                <a:ea typeface="Courier New"/>
+                <a:cs typeface="Courier New"/>
+              </a:rPr>
+              <a:t/>
+            </a:r>
+          </a:p>
+          <a:p xmlns:a="http://schemas.openxmlformats.org/drawingml/2006/main">
+            <a:pPr>
+              <a:buNone/>
+              <a:defRPr sz="1650" b="0">
+                <a:solidFill>
+                  <a:srgbClr val="A7F3D0"/>
+                </a:solidFill>
+                <a:latin typeface="Courier New"/>
+                <a:ea typeface="Courier New"/>
+                <a:cs typeface="Courier New"/>
+              </a:defRPr>
+            </a:pPr>
+            <a:r>
+              <a:rPr sz="1650" b="0">
+                <a:solidFill>
+                  <a:srgbClr val="A7F3D0"/>
+                </a:solidFill>
+                <a:latin typeface="Courier New"/>
+                <a:ea typeface="Courier New"/>
+                <a:cs typeface="Courier New"/>
+              </a:rPr>
+              <a:t>E = 4 = 100₂</a:t>
+            </a:r>
+          </a:p>
+          <a:p xmlns:a="http://schemas.openxmlformats.org/drawingml/2006/main">
+            <a:pPr>
+              <a:defRPr sz="1650">
+                <a:solidFill>
+                  <a:srgbClr val="A7F3D0"/>
+                </a:solidFill>
+                <a:latin typeface="Courier New"/>
+                <a:ea typeface="Courier New"/>
+                <a:cs typeface="Courier New"/>
+              </a:defRPr>
+            </a:pPr>
+            <a:r>
+              <a:rPr sz="1650">
+                <a:solidFill>
+                  <a:srgbClr val="A7F3D0"/>
+                </a:solidFill>
+                <a:latin typeface="Courier New"/>
+                <a:ea typeface="Courier New"/>
+                <a:cs typeface="Courier New"/>
+              </a:rPr>
+              <a:t>F = 2 = 010₂</a:t>
+            </a:r>
+          </a:p>
+          <a:p xmlns:a="http://schemas.openxmlformats.org/drawingml/2006/main">
+            <a:pPr>
+              <a:buNone/>
+              <a:defRPr sz="1650" b="0">
+                <a:solidFill>
+                  <a:srgbClr val="A7F3D0"/>
+                </a:solidFill>
+                <a:latin typeface="Courier New"/>
+                <a:ea typeface="Courier New"/>
+                <a:cs typeface="Courier New"/>
+              </a:defRPr>
+            </a:pPr>
+            <a:r>
+              <a:rPr sz="1650" b="0">
+                <a:solidFill>
+                  <a:srgbClr val="A7F3D0"/>
+                </a:solidFill>
+                <a:latin typeface="Courier New"/>
+                <a:ea typeface="Courier New"/>
+                <a:cs typeface="Courier New"/>
+              </a:rPr>
+              <a:t/>
+            </a:r>
+          </a:p>
+          <a:p xmlns:a="http://schemas.openxmlformats.org/drawingml/2006/main">
+            <a:pPr>
+              <a:buNone/>
+              <a:defRPr sz="1650" b="0">
+                <a:solidFill>
+                  <a:srgbClr val="A7F3D0"/>
+                </a:solidFill>
+                <a:latin typeface="Courier New"/>
+                <a:ea typeface="Courier New"/>
+                <a:cs typeface="Courier New"/>
+              </a:defRPr>
+            </a:pPr>
+            <a:r>
+              <a:rPr sz="1650" b="0">
+                <a:solidFill>
+                  <a:srgbClr val="A7F3D0"/>
+                </a:solidFill>
+                <a:latin typeface="Courier New"/>
+                <a:ea typeface="Courier New"/>
+                <a:cs typeface="Courier New"/>
+              </a:rPr>
+              <a:t>Output: 4 2</a:t>
+            </a:r>
+          </a:p>
+          <a:p xmlns:a="http://schemas.openxmlformats.org/drawingml/2006/main">
+            <a:pPr>
+              <a:buNone/>
+              <a:defRPr sz="1650" b="0">
+                <a:solidFill>
+                  <a:srgbClr val="A7F3D0"/>
+                </a:solidFill>
+                <a:latin typeface="Courier New"/>
+                <a:ea typeface="Courier New"/>
+                <a:cs typeface="Courier New"/>
+              </a:defRPr>
+            </a:pPr>
+            <a:r>
+              <a:rPr sz="1650" b="0">
+                <a:solidFill>
+                  <a:srgbClr val="A7F3D0"/>
+                </a:solidFill>
+                <a:latin typeface="Courier New"/>
+                <a:ea typeface="Courier New"/>
+                <a:cs typeface="Courier New"/>
+              </a:rPr>
+              <a:t/>
+            </a:r>
+          </a:p>
+          <a:p xmlns:a="http://schemas.openxmlformats.org/drawingml/2006/main">
+            <a:pPr>
+              <a:buNone/>
+              <a:defRPr sz="1650" b="0">
+                <a:solidFill>
+                  <a:srgbClr val="A7F3D0"/>
+                </a:solidFill>
+                <a:latin typeface="Courier New"/>
+                <a:ea typeface="Courier New"/>
+                <a:cs typeface="Courier New"/>
+              </a:defRPr>
+            </a:pPr>
+            <a:r>
+              <a:rPr sz="1650" b="0">
+                <a:solidFill>
+                  <a:srgbClr val="A7F3D0"/>
+                </a:solidFill>
+                <a:latin typeface="Courier New"/>
+                <a:ea typeface="Courier New"/>
+                <a:cs typeface="Courier New"/>
+              </a:rPr>
+              <a:t>Check: (1 + 2/8) × 2¹ = 5/2</a:t>
+            </a:r>
+          </a:p>
+        </p:txBody>
+      </p:sp>
+      <p:sp>
+        <p:nvSpPr>
+          <p:cNvPr id="5" name="">
+            <a:extLst xmlns:a="http://schemas.openxmlformats.org/drawingml/2006/main">
+              <a:ext uri="{FF2B5EF4-FFF2-40B4-BE49-F238E27FC236}">
+                <a16:creationId xmlns:a16="http://schemas.microsoft.com/office/drawing/2014/main" id="{7A18BC8F-2DC5-4B6B-A4F9-10CDE1183DE6}"/>
+              </a:ext>
+            </a:extLst>
+          </p:cNvPr>
+          <p:cNvSpPr>
+            <a:spLocks xmlns:a="http://schemas.openxmlformats.org/drawingml/2006/main" noGrp="1"/>
+          </p:cNvSpPr>
+          <p:nvPr/>
+        </p:nvSpPr>
+        <p:spPr>
+          <a:xfrm xmlns:a="http://schemas.openxmlformats.org/drawingml/2006/main">
+            <a:off x="685800" y="5743575"/>
+            <a:ext cx="10191750" cy="428625"/>
+          </a:xfrm>
+          <a:prstGeom xmlns:a="http://schemas.openxmlformats.org/drawingml/2006/main" prst="rect">
+            <a:avLst/>
+          </a:prstGeom>
+          <a:noFill xmlns:a="http://schemas.openxmlformats.org/drawingml/2006/main"/>
+          <a:ln xmlns:a="http://schemas.openxmlformats.org/drawingml/2006/main" w="0">
+            <a:noFill/>
+          </a:ln>
+        </p:spPr>
+        <p:txBody>
+          <a:bodyPr xmlns:a="http://schemas.openxmlformats.org/drawingml/2006/main" anchor="t">
+            <a:normAutofit fontScale="100000"/>
+          </a:bodyPr>
+          <a:lstStyle xmlns:a="http://schemas.openxmlformats.org/drawingml/2006/main"/>
+          <a:p xmlns:a="http://schemas.openxmlformats.org/drawingml/2006/main">
+            <a:pPr>
+              <a:buNone/>
+              <a:defRPr sz="1350" b="0">
+                <a:solidFill>
+                  <a:srgbClr val="A1A1AA"/>
+                </a:solidFill>
+                <a:latin typeface="Arial"/>
+                <a:ea typeface="Arial"/>
+                <a:cs typeface="Arial"/>
+              </a:defRPr>
+            </a:pPr>
+            <a:r>
+              <a:rPr sz="1350" b="0">
+                <a:solidFill>
+                  <a:srgbClr val="A1A1AA"/>
+                </a:solidFill>
+                <a:latin typeface="Arial"/>
+                <a:ea typeface="Arial"/>
+                <a:cs typeface="Arial"/>
+              </a:rPr>
+              <a:t>Move the binary point before taking the stored fraction bits.</a:t>
+            </a:r>
+          </a:p>
+        </p:txBody>
+      </p:sp>
+      <p:sp>
+        <p:nvSpPr>
+          <p:cNvPr id="6" name="">
+            <a:extLst xmlns:a="http://schemas.openxmlformats.org/drawingml/2006/main">
+              <a:ext uri="{FF2B5EF4-FFF2-40B4-BE49-F238E27FC236}">
+                <a16:creationId xmlns:a16="http://schemas.microsoft.com/office/drawing/2014/main" id="{94269C50-3A0A-4FBB-A1D2-A33411F72ECA}"/>
+              </a:ext>
+            </a:extLst>
+          </p:cNvPr>
+          <p:cNvSpPr>
+            <a:spLocks xmlns:a="http://schemas.openxmlformats.org/drawingml/2006/main" noGrp="1"/>
+          </p:cNvSpPr>
+          <p:nvPr/>
+        </p:nvSpPr>
+        <p:spPr>
+          <a:xfrm xmlns:a="http://schemas.openxmlformats.org/drawingml/2006/main">
+            <a:off x="10477500" y="6210300"/>
+            <a:ext cx="1000125" cy="219075"/>
+          </a:xfrm>
+          <a:prstGeom xmlns:a="http://schemas.openxmlformats.org/drawingml/2006/main" prst="rect">
+            <a:avLst/>
+          </a:prstGeom>
+          <a:noFill xmlns:a="http://schemas.openxmlformats.org/drawingml/2006/main"/>
+          <a:ln xmlns:a="http://schemas.openxmlformats.org/drawingml/2006/main" w="0">
+            <a:noFill/>
+          </a:ln>
+        </p:spPr>
+        <p:txBody>
+          <a:bodyPr xmlns:a="http://schemas.openxmlformats.org/drawingml/2006/main" anchor="t">
+            <a:normAutofit fontScale="79762"/>
+          </a:bodyPr>
+          <a:lstStyle xmlns:a="http://schemas.openxmlformats.org/drawingml/2006/main"/>
+          <a:p xmlns:a="http://schemas.openxmlformats.org/drawingml/2006/main">
+            <a:pPr>
+              <a:buNone/>
+              <a:defRPr sz="1050" b="0">
+                <a:solidFill>
+                  <a:srgbClr val="71717A"/>
+                </a:solidFill>
+                <a:latin typeface="Courier New"/>
+                <a:ea typeface="Courier New"/>
+                <a:cs typeface="Courier New"/>
+              </a:defRPr>
+            </a:pPr>
+            <a:r>
+              <a:rPr sz="1050" b="0">
+                <a:solidFill>
+                  <a:srgbClr val="71717A"/>
+                </a:solidFill>
+                <a:latin typeface="Courier New"/>
+                <a:ea typeface="Courier New"/>
+                <a:cs typeface="Courier New"/>
+              </a:rPr>
+              <a:t>18 / 20</a:t>
+            </a:r>
+          </a:p>
+        </p:txBody>
+      </p:sp>
+    </p:spTree>
+    <p:extLst>
+      <p:ext uri="{BB962C8B-B14F-4D97-AF65-F5344CB8AC3E}">
+        <p14:creationId xmlns:p14="http://schemas.microsoft.com/office/powerpoint/2010/main" val="1018474765"/>
+      </p:ext>
+    </p:extLst>
+  </p:cSld>
+</p:sld>
+</file>
+
+<file path=ppt/slides/slide19.xml><?xml version="1.0" encoding="utf-8"?>
+<p:sld xmlns:p="http://schemas.openxmlformats.org/presentationml/2006/main">
+  <p:cSld>
+    <p:bg>
+      <p:bgPr>
+        <a:solidFill xmlns:a="http://schemas.openxmlformats.org/drawingml/2006/main">
+          <a:srgbClr val="09090B"/>
+        </a:solidFill>
+      </p:bgPr>
+    </p:bg>
+    <p:spTree>
+      <p:nvGrpSpPr>
+        <p:cNvPr id="1" name=""/>
+        <p:cNvGrpSpPr/>
+        <p:nvPr/>
+      </p:nvGrpSpPr>
+      <p:grpSpPr>
+        <a:xfrm xmlns:a="http://schemas.openxmlformats.org/drawingml/2006/main"/>
+      </p:grpSpPr>
+      <p:sp>
+        <p:nvSpPr>
+          <p:cNvPr id="7" name="">
+            <a:extLst xmlns:a="http://schemas.openxmlformats.org/drawingml/2006/main">
+              <a:ext uri="{FF2B5EF4-FFF2-40B4-BE49-F238E27FC236}">
+                <a16:creationId xmlns:a16="http://schemas.microsoft.com/office/drawing/2014/main" id="{0BCE7827-648B-4B62-AE80-F3CE9BFFD594}"/>
+              </a:ext>
+            </a:extLst>
+          </p:cNvPr>
+          <p:cNvSpPr>
+            <a:spLocks xmlns:a="http://schemas.openxmlformats.org/drawingml/2006/main" noGrp="1"/>
+          </p:cNvSpPr>
+          <p:nvPr/>
+        </p:nvSpPr>
+        <p:spPr>
+          <a:xfrm xmlns:a="http://schemas.openxmlformats.org/drawingml/2006/main">
+            <a:off x="685800" y="361950"/>
+            <a:ext cx="10477500" cy="285750"/>
+          </a:xfrm>
+          <a:prstGeom xmlns:a="http://schemas.openxmlformats.org/drawingml/2006/main" prst="rect">
+            <a:avLst/>
+          </a:prstGeom>
+          <a:noFill xmlns:a="http://schemas.openxmlformats.org/drawingml/2006/main"/>
+          <a:ln xmlns:a="http://schemas.openxmlformats.org/drawingml/2006/main" w="0">
+            <a:noFill/>
+          </a:ln>
+        </p:spPr>
+        <p:txBody>
+          <a:bodyPr xmlns:a="http://schemas.openxmlformats.org/drawingml/2006/main" anchor="t">
+            <a:normAutofit fontScale="100000"/>
+          </a:bodyPr>
+          <a:lstStyle xmlns:a="http://schemas.openxmlformats.org/drawingml/2006/main"/>
+          <a:p xmlns:a="http://schemas.openxmlformats.org/drawingml/2006/main">
+            <a:pPr>
+              <a:buNone/>
+              <a:defRPr sz="1275" b="0">
+                <a:solidFill>
+                  <a:srgbClr val="6EE7B7"/>
+                </a:solidFill>
+                <a:latin typeface="Courier New"/>
+                <a:ea typeface="Courier New"/>
+                <a:cs typeface="Courier New"/>
+              </a:defRPr>
+            </a:pPr>
+            <a:r>
+              <a:rPr sz="1275" b="0">
+                <a:solidFill>
+                  <a:srgbClr val="6EE7B7"/>
+                </a:solidFill>
+                <a:latin typeface="Courier New"/>
+                <a:ea typeface="Courier New"/>
+                <a:cs typeface="Courier New"/>
+              </a:rPr>
+              <a:t>FLOATING POINT · METHOD</a:t>
+            </a:r>
+          </a:p>
+        </p:txBody>
+      </p:sp>
+      <p:sp>
+        <p:nvSpPr>
+          <p:cNvPr id="2" name="">
+            <a:extLst xmlns:a="http://schemas.openxmlformats.org/drawingml/2006/main">
+              <a:ext uri="{FF2B5EF4-FFF2-40B4-BE49-F238E27FC236}">
+                <a16:creationId xmlns:a16="http://schemas.microsoft.com/office/drawing/2014/main" id="{E6B69FE5-5D95-4306-AAF0-9A70AD531613}"/>
+              </a:ext>
+            </a:extLst>
+          </p:cNvPr>
+          <p:cNvSpPr>
+            <a:spLocks xmlns:a="http://schemas.openxmlformats.org/drawingml/2006/main" noGrp="1"/>
+          </p:cNvSpPr>
+          <p:nvPr/>
+        </p:nvSpPr>
+        <p:spPr>
+          <a:xfrm xmlns:a="http://schemas.openxmlformats.org/drawingml/2006/main">
+            <a:off x="685800" y="885825"/>
+            <a:ext cx="10820400" cy="1066800"/>
+          </a:xfrm>
+          <a:prstGeom xmlns:a="http://schemas.openxmlformats.org/drawingml/2006/main" prst="rect">
+            <a:avLst/>
+          </a:prstGeom>
+          <a:noFill xmlns:a="http://schemas.openxmlformats.org/drawingml/2006/main"/>
+          <a:ln xmlns:a="http://schemas.openxmlformats.org/drawingml/2006/main" w="0">
+            <a:noFill/>
+          </a:ln>
+        </p:spPr>
+        <p:txBody>
+          <a:bodyPr xmlns:a="http://schemas.openxmlformats.org/drawingml/2006/main" anchor="t">
+            <a:normAutofit fontScale="100000"/>
+          </a:bodyPr>
+          <a:lstStyle xmlns:a="http://schemas.openxmlformats.org/drawingml/2006/main"/>
+          <a:p xmlns:a="http://schemas.openxmlformats.org/drawingml/2006/main">
+            <a:pPr>
+              <a:buNone/>
+              <a:defRPr sz="3600" b="0">
+                <a:solidFill>
+                  <a:srgbClr val="FAFAFA"/>
+                </a:solidFill>
+                <a:latin typeface="Arial"/>
+                <a:ea typeface="Arial"/>
+                <a:cs typeface="Arial"/>
+              </a:defRPr>
+            </a:pPr>
+            <a:r>
+              <a:rPr sz="3600" b="0">
+                <a:solidFill>
+                  <a:srgbClr val="FAFAFA"/>
+                </a:solidFill>
+                <a:latin typeface="Arial"/>
+                <a:ea typeface="Arial"/>
+                <a:cs typeface="Arial"/>
+              </a:rPr>
+              <a:t>HW3 preview: choose the equation</a:t>
+            </a:r>
+          </a:p>
+        </p:txBody>
+      </p:sp>
+      <p:sp>
+        <p:nvSpPr>
+          <p:cNvPr id="3" name="">
+            <a:extLst xmlns:a="http://schemas.openxmlformats.org/drawingml/2006/main">
+              <a:ext uri="{FF2B5EF4-FFF2-40B4-BE49-F238E27FC236}">
+                <a16:creationId xmlns:a16="http://schemas.microsoft.com/office/drawing/2014/main" id="{887FE9A9-E5DE-4BC1-94AD-59371BF9B78C}"/>
+              </a:ext>
+            </a:extLst>
+          </p:cNvPr>
+          <p:cNvSpPr>
+            <a:spLocks xmlns:a="http://schemas.openxmlformats.org/drawingml/2006/main" noGrp="1"/>
+          </p:cNvSpPr>
+          <p:nvPr/>
+        </p:nvSpPr>
+        <p:spPr>
+          <a:xfrm xmlns:a="http://schemas.openxmlformats.org/drawingml/2006/main">
+            <a:off x="685800" y="2200275"/>
+            <a:ext cx="4857750" cy="3124200"/>
+          </a:xfrm>
+          <a:prstGeom xmlns:a="http://schemas.openxmlformats.org/drawingml/2006/main" prst="rect">
+            <a:avLst/>
+          </a:prstGeom>
+          <a:noFill xmlns:a="http://schemas.openxmlformats.org/drawingml/2006/main"/>
+          <a:ln xmlns:a="http://schemas.openxmlformats.org/drawingml/2006/main" w="0">
+            <a:noFill/>
+          </a:ln>
+        </p:spPr>
+        <p:txBody>
+          <a:bodyPr xmlns:a="http://schemas.openxmlformats.org/drawingml/2006/main" anchor="t">
+            <a:normAutofit fontScale="100000"/>
+          </a:bodyPr>
+          <a:lstStyle xmlns:a="http://schemas.openxmlformats.org/drawingml/2006/main"/>
+          <a:p xmlns:a="http://schemas.openxmlformats.org/drawingml/2006/main">
+            <a:pPr>
+              <a:buNone/>
+              <a:defRPr sz="1950" b="0">
+                <a:solidFill>
+                  <a:srgbClr val="D4D4D8"/>
+                </a:solidFill>
+                <a:latin typeface="Arial"/>
+                <a:ea typeface="Arial"/>
+                <a:cs typeface="Arial"/>
+              </a:defRPr>
+            </a:pPr>
+            <a:r>
+              <a:rPr sz="1950" b="0">
+                <a:solidFill>
+                  <a:srgbClr val="D4D4D8"/>
+                </a:solidFill>
+                <a:latin typeface="Arial"/>
+                <a:ea typeface="Arial"/>
+                <a:cs typeface="Arial"/>
+              </a:rPr>
+              <a:t>For a nonzero ratio, compare its value with the smallest normal, 2^(1−bias). That tells you which equation to use. Solve for E and F, then decode them to check.</a:t>
+            </a:r>
+          </a:p>
+        </p:txBody>
+      </p:sp>
+      <p:sp>
+        <p:nvSpPr>
+          <p:cNvPr id="4" name="">
+            <a:extLst xmlns:a="http://schemas.openxmlformats.org/drawingml/2006/main">
+              <a:ext uri="{FF2B5EF4-FFF2-40B4-BE49-F238E27FC236}">
+                <a16:creationId xmlns:a16="http://schemas.microsoft.com/office/drawing/2014/main" id="{CED75AEC-85E3-4520-B63E-09FCF9AACAE6}"/>
+              </a:ext>
+            </a:extLst>
+          </p:cNvPr>
+          <p:cNvSpPr>
+            <a:spLocks xmlns:a="http://schemas.openxmlformats.org/drawingml/2006/main" noGrp="1"/>
+          </p:cNvSpPr>
+          <p:nvPr/>
+        </p:nvSpPr>
+        <p:spPr>
+          <a:xfrm xmlns:a="http://schemas.openxmlformats.org/drawingml/2006/main">
+            <a:off x="6181725" y="2200275"/>
+            <a:ext cx="5238750" cy="3286125"/>
+          </a:xfrm>
+          <a:prstGeom xmlns:a="http://schemas.openxmlformats.org/drawingml/2006/main" prst="rect">
+            <a:avLst/>
+          </a:prstGeom>
+          <a:noFill xmlns:a="http://schemas.openxmlformats.org/drawingml/2006/main"/>
+          <a:ln xmlns:a="http://schemas.openxmlformats.org/drawingml/2006/main" w="0">
+            <a:noFill/>
+          </a:ln>
+        </p:spPr>
+        <p:txBody>
+          <a:bodyPr xmlns:a="http://schemas.openxmlformats.org/drawingml/2006/main" anchor="t">
+            <a:normAutofit fontScale="100000"/>
+          </a:bodyPr>
+          <a:lstStyle xmlns:a="http://schemas.openxmlformats.org/drawingml/2006/main"/>
+          <a:p xmlns:a="http://schemas.openxmlformats.org/drawingml/2006/main">
+            <a:pPr>
+              <a:buNone/>
+              <a:defRPr sz="1650" b="0">
+                <a:solidFill>
+                  <a:srgbClr val="A7F3D0"/>
+                </a:solidFill>
+                <a:latin typeface="Courier New"/>
+                <a:ea typeface="Courier New"/>
+                <a:cs typeface="Courier New"/>
+              </a:defRPr>
+            </a:pPr>
+            <a:r>
+              <a:rPr sz="1650" b="0">
+                <a:solidFill>
+                  <a:srgbClr val="A7F3D0"/>
+                </a:solidFill>
+                <a:latin typeface="Courier New"/>
+                <a:ea typeface="Courier New"/>
+                <a:cs typeface="Courier New"/>
+              </a:rPr>
+              <a:t>Normal (E &gt; 0):</a:t>
+            </a:r>
+          </a:p>
+          <a:p xmlns:a="http://schemas.openxmlformats.org/drawingml/2006/main">
+            <a:pPr>
+              <a:buNone/>
+              <a:defRPr sz="1650" b="0">
+                <a:solidFill>
+                  <a:srgbClr val="A7F3D0"/>
+                </a:solidFill>
+                <a:latin typeface="Courier New"/>
+                <a:ea typeface="Courier New"/>
+                <a:cs typeface="Courier New"/>
+              </a:defRPr>
+            </a:pPr>
+            <a:r>
+              <a:rPr sz="1650" b="0">
+                <a:solidFill>
+                  <a:srgbClr val="A7F3D0"/>
+                </a:solidFill>
+                <a:latin typeface="Courier New"/>
+                <a:ea typeface="Courier New"/>
+                <a:cs typeface="Courier New"/>
+              </a:rPr>
+              <a:t>value = (1 + F/2^p) × 2^(E−bias)</a:t>
+            </a:r>
+          </a:p>
+          <a:p xmlns:a="http://schemas.openxmlformats.org/drawingml/2006/main">
+            <a:pPr>
+              <a:buNone/>
+              <a:defRPr sz="1650" b="0">
+                <a:solidFill>
+                  <a:srgbClr val="A7F3D0"/>
+                </a:solidFill>
+                <a:latin typeface="Courier New"/>
+                <a:ea typeface="Courier New"/>
+                <a:cs typeface="Courier New"/>
+              </a:defRPr>
+            </a:pPr>
+            <a:r>
+              <a:rPr sz="1650" b="0">
+                <a:solidFill>
+                  <a:srgbClr val="A7F3D0"/>
+                </a:solidFill>
+                <a:latin typeface="Courier New"/>
+                <a:ea typeface="Courier New"/>
+                <a:cs typeface="Courier New"/>
+              </a:rPr>
+              <a:t/>
+            </a:r>
+          </a:p>
+          <a:p xmlns:a="http://schemas.openxmlformats.org/drawingml/2006/main">
+            <a:pPr>
+              <a:defRPr sz="1650">
+                <a:solidFill>
+                  <a:srgbClr val="A7F3D0"/>
+                </a:solidFill>
+                <a:latin typeface="Courier New"/>
+                <a:ea typeface="Courier New"/>
+                <a:cs typeface="Courier New"/>
+              </a:defRPr>
+            </a:pPr>
+            <a:r>
+              <a:rPr sz="1650">
+                <a:solidFill>
+                  <a:srgbClr val="A7F3D0"/>
+                </a:solidFill>
+                <a:latin typeface="Courier New"/>
+                <a:ea typeface="Courier New"/>
+                <a:cs typeface="Courier New"/>
+              </a:rPr>
+              <a:t>Subnormal (E = 0):</a:t>
+            </a:r>
+          </a:p>
+          <a:p xmlns:a="http://schemas.openxmlformats.org/drawingml/2006/main">
+            <a:pPr>
+              <a:buNone/>
+              <a:defRPr sz="1650" b="0">
+                <a:solidFill>
+                  <a:srgbClr val="A7F3D0"/>
+                </a:solidFill>
+                <a:latin typeface="Courier New"/>
+                <a:ea typeface="Courier New"/>
+                <a:cs typeface="Courier New"/>
+              </a:defRPr>
+            </a:pPr>
+            <a:r>
+              <a:rPr sz="1650" b="0">
+                <a:solidFill>
+                  <a:srgbClr val="A7F3D0"/>
+                </a:solidFill>
+                <a:latin typeface="Courier New"/>
+                <a:ea typeface="Courier New"/>
+                <a:cs typeface="Courier New"/>
+              </a:rPr>
+              <a:t>value = (F/2^p) × 2^(1−bias)</a:t>
+            </a:r>
+          </a:p>
+          <a:p xmlns:a="http://schemas.openxmlformats.org/drawingml/2006/main">
+            <a:pPr>
+              <a:buNone/>
+              <a:defRPr sz="1650" b="0">
+                <a:solidFill>
+                  <a:srgbClr val="A7F3D0"/>
+                </a:solidFill>
+                <a:latin typeface="Courier New"/>
+                <a:ea typeface="Courier New"/>
+                <a:cs typeface="Courier New"/>
+              </a:defRPr>
+            </a:pPr>
+            <a:r>
+              <a:rPr sz="1650" b="0">
+                <a:solidFill>
+                  <a:srgbClr val="A7F3D0"/>
+                </a:solidFill>
+                <a:latin typeface="Courier New"/>
+                <a:ea typeface="Courier New"/>
+                <a:cs typeface="Courier New"/>
+              </a:rPr>
+              <a:t/>
+            </a:r>
+          </a:p>
+          <a:p xmlns:a="http://schemas.openxmlformats.org/drawingml/2006/main">
+            <a:pPr>
+              <a:buNone/>
+              <a:defRPr sz="1650" b="0">
+                <a:solidFill>
+                  <a:srgbClr val="A7F3D0"/>
+                </a:solidFill>
+                <a:latin typeface="Courier New"/>
+                <a:ea typeface="Courier New"/>
+                <a:cs typeface="Courier New"/>
+              </a:defRPr>
+            </a:pPr>
+            <a:r>
+              <a:rPr sz="1650" b="0">
+                <a:solidFill>
+                  <a:srgbClr val="A7F3D0"/>
+                </a:solidFill>
+                <a:latin typeface="Courier New"/>
+                <a:ea typeface="Courier New"/>
+                <a:cs typeface="Courier New"/>
+              </a:rPr>
+              <a:t>If numerator = 0: E = 0, F = 0</a:t>
+            </a:r>
+          </a:p>
+        </p:txBody>
+      </p:sp>
+      <p:sp>
+        <p:nvSpPr>
+          <p:cNvPr id="5" name="">
+            <a:extLst xmlns:a="http://schemas.openxmlformats.org/drawingml/2006/main">
+              <a:ext uri="{FF2B5EF4-FFF2-40B4-BE49-F238E27FC236}">
+                <a16:creationId xmlns:a16="http://schemas.microsoft.com/office/drawing/2014/main" id="{7A18BC8F-2DC5-4B6B-A4F9-10CDE1183DE6}"/>
+              </a:ext>
+            </a:extLst>
+          </p:cNvPr>
+          <p:cNvSpPr>
+            <a:spLocks xmlns:a="http://schemas.openxmlformats.org/drawingml/2006/main" noGrp="1"/>
+          </p:cNvSpPr>
+          <p:nvPr/>
+        </p:nvSpPr>
+        <p:spPr>
+          <a:xfrm xmlns:a="http://schemas.openxmlformats.org/drawingml/2006/main">
+            <a:off x="685800" y="5743575"/>
+            <a:ext cx="10191750" cy="428625"/>
+          </a:xfrm>
+          <a:prstGeom xmlns:a="http://schemas.openxmlformats.org/drawingml/2006/main" prst="rect">
+            <a:avLst/>
+          </a:prstGeom>
+          <a:noFill xmlns:a="http://schemas.openxmlformats.org/drawingml/2006/main"/>
+          <a:ln xmlns:a="http://schemas.openxmlformats.org/drawingml/2006/main" w="0">
+            <a:noFill/>
+          </a:ln>
+        </p:spPr>
+        <p:txBody>
+          <a:bodyPr xmlns:a="http://schemas.openxmlformats.org/drawingml/2006/main" anchor="t">
+            <a:normAutofit fontScale="100000"/>
+          </a:bodyPr>
+          <a:lstStyle xmlns:a="http://schemas.openxmlformats.org/drawingml/2006/main"/>
+          <a:p xmlns:a="http://schemas.openxmlformats.org/drawingml/2006/main">
+            <a:pPr>
+              <a:buNone/>
+              <a:defRPr sz="1350" b="0">
+                <a:solidFill>
+                  <a:srgbClr val="A1A1AA"/>
+                </a:solidFill>
+                <a:latin typeface="Arial"/>
+                <a:ea typeface="Arial"/>
+                <a:cs typeface="Arial"/>
+              </a:defRPr>
+            </a:pPr>
+            <a:r>
+              <a:rPr sz="1350" b="0">
+                <a:solidFill>
+                  <a:srgbClr val="A1A1AA"/>
+                </a:solidFill>
+                <a:latin typeface="Arial"/>
+                <a:ea typeface="Arial"/>
+                <a:cs typeface="Arial"/>
+              </a:rPr>
+              <a:t>Use the supplied p and bias, not the values from our practice format.</a:t>
+            </a:r>
+          </a:p>
+        </p:txBody>
+      </p:sp>
+      <p:sp>
+        <p:nvSpPr>
+          <p:cNvPr id="6" name="">
+            <a:extLst xmlns:a="http://schemas.openxmlformats.org/drawingml/2006/main">
+              <a:ext uri="{FF2B5EF4-FFF2-40B4-BE49-F238E27FC236}">
+                <a16:creationId xmlns:a16="http://schemas.microsoft.com/office/drawing/2014/main" id="{94269C50-3A0A-4FBB-A1D2-A33411F72ECA}"/>
+              </a:ext>
+            </a:extLst>
+          </p:cNvPr>
+          <p:cNvSpPr>
+            <a:spLocks xmlns:a="http://schemas.openxmlformats.org/drawingml/2006/main" noGrp="1"/>
+          </p:cNvSpPr>
+          <p:nvPr/>
+        </p:nvSpPr>
+        <p:spPr>
+          <a:xfrm xmlns:a="http://schemas.openxmlformats.org/drawingml/2006/main">
+            <a:off x="10477500" y="6210300"/>
+            <a:ext cx="1000125" cy="219075"/>
+          </a:xfrm>
+          <a:prstGeom xmlns:a="http://schemas.openxmlformats.org/drawingml/2006/main" prst="rect">
+            <a:avLst/>
+          </a:prstGeom>
+          <a:noFill xmlns:a="http://schemas.openxmlformats.org/drawingml/2006/main"/>
+          <a:ln xmlns:a="http://schemas.openxmlformats.org/drawingml/2006/main" w="0">
+            <a:noFill/>
+          </a:ln>
+        </p:spPr>
+        <p:txBody>
+          <a:bodyPr xmlns:a="http://schemas.openxmlformats.org/drawingml/2006/main" anchor="t">
+            <a:normAutofit fontScale="79762"/>
+          </a:bodyPr>
+          <a:lstStyle xmlns:a="http://schemas.openxmlformats.org/drawingml/2006/main"/>
+          <a:p xmlns:a="http://schemas.openxmlformats.org/drawingml/2006/main">
+            <a:pPr>
+              <a:buNone/>
+              <a:defRPr sz="1050" b="0">
+                <a:solidFill>
+                  <a:srgbClr val="71717A"/>
+                </a:solidFill>
+                <a:latin typeface="Courier New"/>
+                <a:ea typeface="Courier New"/>
+                <a:cs typeface="Courier New"/>
+              </a:defRPr>
+            </a:pPr>
+            <a:r>
+              <a:rPr sz="1050" b="0">
+                <a:solidFill>
+                  <a:srgbClr val="71717A"/>
+                </a:solidFill>
+                <a:latin typeface="Courier New"/>
+                <a:ea typeface="Courier New"/>
+                <a:cs typeface="Courier New"/>
+              </a:rPr>
+              <a:t>19 / 20</a:t>
+            </a:r>
+          </a:p>
+        </p:txBody>
+      </p:sp>
+    </p:spTree>
+    <p:extLst>
+      <p:ext uri="{BB962C8B-B14F-4D97-AF65-F5344CB8AC3E}">
+        <p14:creationId xmlns:p14="http://schemas.microsoft.com/office/powerpoint/2010/main" val="1018474765"/>
       </p:ext>
     </p:extLst>
   </p:cSld>
@@ -6939,6 +8181,7 @@
           <a:lstStyle xmlns:a="http://schemas.openxmlformats.org/drawingml/2006/main"/>
           <a:p xmlns:a="http://schemas.openxmlformats.org/drawingml/2006/main">
             <a:pPr>
+              <a:buNone/>
               <a:defRPr sz="1275" b="0">
                 <a:solidFill>
                   <a:srgbClr val="6EE7B7"/>
@@ -6996,6 +8239,7 @@
           <a:lstStyle xmlns:a="http://schemas.openxmlformats.org/drawingml/2006/main"/>
           <a:p xmlns:a="http://schemas.openxmlformats.org/drawingml/2006/main">
             <a:pPr>
+              <a:buNone/>
               <a:defRPr sz="3600" b="0">
                 <a:solidFill>
                   <a:srgbClr val="FAFAFA"/>
@@ -7053,6 +8297,7 @@
           <a:lstStyle xmlns:a="http://schemas.openxmlformats.org/drawingml/2006/main"/>
           <a:p xmlns:a="http://schemas.openxmlformats.org/drawingml/2006/main">
             <a:pPr>
+              <a:buNone/>
               <a:defRPr sz="1950" b="0">
                 <a:solidFill>
                   <a:srgbClr val="D4D4D8"/>
@@ -7081,6 +8326,7 @@
           </a:p>
           <a:p xmlns:a="http://schemas.openxmlformats.org/drawingml/2006/main">
             <a:pPr>
+              <a:buNone/>
               <a:defRPr sz="1950" b="0">
                 <a:solidFill>
                   <a:srgbClr val="D4D4D8"/>
@@ -7138,6 +8384,7 @@
           <a:lstStyle xmlns:a="http://schemas.openxmlformats.org/drawingml/2006/main"/>
           <a:p xmlns:a="http://schemas.openxmlformats.org/drawingml/2006/main">
             <a:pPr>
+              <a:buNone/>
               <a:defRPr sz="1650" b="0">
                 <a:solidFill>
                   <a:srgbClr val="A7F3D0"/>
@@ -7166,6 +8413,7 @@
           </a:p>
           <a:p xmlns:a="http://schemas.openxmlformats.org/drawingml/2006/main">
             <a:pPr>
+              <a:buNone/>
               <a:defRPr sz="1650" b="0">
                 <a:solidFill>
                   <a:srgbClr val="A7F3D0"/>
@@ -7189,6 +8437,7 @@
           </a:p>
           <a:p xmlns:a="http://schemas.openxmlformats.org/drawingml/2006/main">
             <a:pPr>
+              <a:buNone/>
               <a:defRPr sz="1650" b="0">
                 <a:solidFill>
                   <a:srgbClr val="A7F3D0"/>
@@ -7217,6 +8466,7 @@
           </a:p>
           <a:p xmlns:a="http://schemas.openxmlformats.org/drawingml/2006/main">
             <a:pPr>
+              <a:buNone/>
               <a:defRPr sz="1650" b="0">
                 <a:solidFill>
                   <a:srgbClr val="A7F3D0"/>
@@ -7240,6 +8490,7 @@
           </a:p>
           <a:p xmlns:a="http://schemas.openxmlformats.org/drawingml/2006/main">
             <a:pPr>
+              <a:buNone/>
               <a:defRPr sz="1650" b="0">
                 <a:solidFill>
                   <a:srgbClr val="A7F3D0"/>
@@ -7297,6 +8548,7 @@
           <a:lstStyle xmlns:a="http://schemas.openxmlformats.org/drawingml/2006/main"/>
           <a:p xmlns:a="http://schemas.openxmlformats.org/drawingml/2006/main">
             <a:pPr>
+              <a:buNone/>
               <a:defRPr sz="1350" b="0">
                 <a:solidFill>
                   <a:srgbClr val="A1A1AA"/>
@@ -7354,6 +8606,7 @@
           <a:lstStyle xmlns:a="http://schemas.openxmlformats.org/drawingml/2006/main"/>
           <a:p xmlns:a="http://schemas.openxmlformats.org/drawingml/2006/main">
             <a:pPr>
+              <a:buNone/>
               <a:defRPr sz="1050" b="0">
                 <a:solidFill>
                   <a:srgbClr val="71717A"/>
@@ -7372,7 +8625,7 @@
                 <a:ea typeface="Courier New"/>
                 <a:cs typeface="Courier New"/>
               </a:rPr>
-              <a:t>02 / 17</a:t>
+              <a:t>02 / 20</a:t>
             </a:r>
           </a:p>
         </p:txBody>
@@ -7381,6 +8634,523 @@
     <p:extLst>
       <p:ext uri="{BB962C8B-B14F-4D97-AF65-F5344CB8AC3E}">
         <p14:creationId xmlns:p14="http://schemas.microsoft.com/office/powerpoint/2010/main" val="543148191"/>
+      </p:ext>
+    </p:extLst>
+  </p:cSld>
+</p:sld>
+</file>
+
+<file path=ppt/slides/slide20.xml><?xml version="1.0" encoding="utf-8"?>
+<p:sld xmlns:p="http://schemas.openxmlformats.org/presentationml/2006/main">
+  <p:cSld>
+    <p:bg>
+      <p:bgPr>
+        <a:solidFill xmlns:a="http://schemas.openxmlformats.org/drawingml/2006/main">
+          <a:srgbClr val="09090B"/>
+        </a:solidFill>
+      </p:bgPr>
+    </p:bg>
+    <p:spTree>
+      <p:nvGrpSpPr>
+        <p:cNvPr id="1" name=""/>
+        <p:cNvGrpSpPr/>
+        <p:nvPr/>
+      </p:nvGrpSpPr>
+      <p:grpSpPr>
+        <a:xfrm xmlns:a="http://schemas.openxmlformats.org/drawingml/2006/main"/>
+      </p:grpSpPr>
+      <p:sp>
+        <p:nvSpPr>
+          <p:cNvPr id="7" name="">
+            <a:extLst xmlns:a="http://schemas.openxmlformats.org/drawingml/2006/main">
+              <a:ext uri="{FF2B5EF4-FFF2-40B4-BE49-F238E27FC236}">
+                <a16:creationId xmlns:a16="http://schemas.microsoft.com/office/drawing/2014/main" id="{4989B079-C3E8-43BB-8638-96121018769A}"/>
+              </a:ext>
+            </a:extLst>
+          </p:cNvPr>
+          <p:cNvSpPr>
+            <a:spLocks xmlns:a="http://schemas.openxmlformats.org/drawingml/2006/main" noGrp="1"/>
+          </p:cNvSpPr>
+          <p:nvPr/>
+        </p:nvSpPr>
+        <p:spPr>
+          <a:xfrm xmlns:a="http://schemas.openxmlformats.org/drawingml/2006/main">
+            <a:off x="685800" y="361950"/>
+            <a:ext cx="10477500" cy="285750"/>
+          </a:xfrm>
+          <a:prstGeom xmlns:a="http://schemas.openxmlformats.org/drawingml/2006/main" prst="rect">
+            <a:avLst/>
+          </a:prstGeom>
+          <a:noFill xmlns:a="http://schemas.openxmlformats.org/drawingml/2006/main"/>
+          <a:ln xmlns:a="http://schemas.openxmlformats.org/drawingml/2006/main" w="0">
+            <a:noFill/>
+          </a:ln>
+        </p:spPr>
+        <p:txBody>
+          <a:bodyPr xmlns:a="http://schemas.openxmlformats.org/drawingml/2006/main" anchor="t">
+            <a:normAutofit fontScale="100000"/>
+          </a:bodyPr>
+          <a:lstStyle xmlns:a="http://schemas.openxmlformats.org/drawingml/2006/main"/>
+          <a:p xmlns:a="http://schemas.openxmlformats.org/drawingml/2006/main">
+            <a:pPr>
+              <a:buNone/>
+              <a:defRPr sz="1275" b="0">
+                <a:solidFill>
+                  <a:srgbClr val="6EE7B7"/>
+                </a:solidFill>
+                <a:latin typeface="Courier New"/>
+                <a:ea typeface="Courier New"/>
+                <a:cs typeface="Courier New"/>
+              </a:defRPr>
+            </a:pPr>
+            <a:r>
+              <a:rPr sz="1275" b="0">
+                <a:solidFill>
+                  <a:srgbClr val="6EE7B7"/>
+                </a:solidFill>
+                <a:latin typeface="Courier New"/>
+                <a:ea typeface="Courier New"/>
+                <a:cs typeface="Courier New"/>
+              </a:rPr>
+              <a:t>FLOATING POINT · RECAP</a:t>
+            </a:r>
+          </a:p>
+        </p:txBody>
+      </p:sp>
+      <p:sp>
+        <p:nvSpPr>
+          <p:cNvPr id="2" name="">
+            <a:extLst xmlns:a="http://schemas.openxmlformats.org/drawingml/2006/main">
+              <a:ext uri="{FF2B5EF4-FFF2-40B4-BE49-F238E27FC236}">
+                <a16:creationId xmlns:a16="http://schemas.microsoft.com/office/drawing/2014/main" id="{95D3113E-85F1-4E22-A62E-265E94FE3617}"/>
+              </a:ext>
+            </a:extLst>
+          </p:cNvPr>
+          <p:cNvSpPr>
+            <a:spLocks xmlns:a="http://schemas.openxmlformats.org/drawingml/2006/main" noGrp="1"/>
+          </p:cNvSpPr>
+          <p:nvPr/>
+        </p:nvSpPr>
+        <p:spPr>
+          <a:xfrm xmlns:a="http://schemas.openxmlformats.org/drawingml/2006/main">
+            <a:off x="685800" y="885825"/>
+            <a:ext cx="10820400" cy="1066800"/>
+          </a:xfrm>
+          <a:prstGeom xmlns:a="http://schemas.openxmlformats.org/drawingml/2006/main" prst="rect">
+            <a:avLst/>
+          </a:prstGeom>
+          <a:noFill xmlns:a="http://schemas.openxmlformats.org/drawingml/2006/main"/>
+          <a:ln xmlns:a="http://schemas.openxmlformats.org/drawingml/2006/main" w="0">
+            <a:noFill/>
+          </a:ln>
+        </p:spPr>
+        <p:txBody>
+          <a:bodyPr xmlns:a="http://schemas.openxmlformats.org/drawingml/2006/main" anchor="t">
+            <a:normAutofit fontScale="100000"/>
+          </a:bodyPr>
+          <a:lstStyle xmlns:a="http://schemas.openxmlformats.org/drawingml/2006/main"/>
+          <a:p xmlns:a="http://schemas.openxmlformats.org/drawingml/2006/main">
+            <a:pPr>
+              <a:buNone/>
+              <a:defRPr sz="3600" b="0">
+                <a:solidFill>
+                  <a:srgbClr val="FAFAFA"/>
+                </a:solidFill>
+                <a:latin typeface="Arial"/>
+                <a:ea typeface="Arial"/>
+                <a:cs typeface="Arial"/>
+              </a:defRPr>
+            </a:pPr>
+            <a:r>
+              <a:rPr sz="3600" b="0">
+                <a:solidFill>
+                  <a:srgbClr val="FAFAFA"/>
+                </a:solidFill>
+                <a:latin typeface="Arial"/>
+                <a:ea typeface="Arial"/>
+                <a:cs typeface="Arial"/>
+              </a:rPr>
+              <a:t>How to check an encoding</a:t>
+            </a:r>
+          </a:p>
+        </p:txBody>
+      </p:sp>
+      <p:sp>
+        <p:nvSpPr>
+          <p:cNvPr id="3" name="">
+            <a:extLst xmlns:a="http://schemas.openxmlformats.org/drawingml/2006/main">
+              <a:ext uri="{FF2B5EF4-FFF2-40B4-BE49-F238E27FC236}">
+                <a16:creationId xmlns:a16="http://schemas.microsoft.com/office/drawing/2014/main" id="{8EC5E33C-BA7C-4ADE-9FC3-9ABD9F3C6FD4}"/>
+              </a:ext>
+            </a:extLst>
+          </p:cNvPr>
+          <p:cNvSpPr>
+            <a:spLocks xmlns:a="http://schemas.openxmlformats.org/drawingml/2006/main" noGrp="1"/>
+          </p:cNvSpPr>
+          <p:nvPr/>
+        </p:nvSpPr>
+        <p:spPr>
+          <a:xfrm xmlns:a="http://schemas.openxmlformats.org/drawingml/2006/main">
+            <a:off x="685800" y="2200275"/>
+            <a:ext cx="4857750" cy="3124200"/>
+          </a:xfrm>
+          <a:prstGeom xmlns:a="http://schemas.openxmlformats.org/drawingml/2006/main" prst="rect">
+            <a:avLst/>
+          </a:prstGeom>
+          <a:noFill xmlns:a="http://schemas.openxmlformats.org/drawingml/2006/main"/>
+          <a:ln xmlns:a="http://schemas.openxmlformats.org/drawingml/2006/main" w="0">
+            <a:noFill/>
+          </a:ln>
+        </p:spPr>
+        <p:txBody>
+          <a:bodyPr xmlns:a="http://schemas.openxmlformats.org/drawingml/2006/main" anchor="t">
+            <a:normAutofit fontScale="100000"/>
+          </a:bodyPr>
+          <a:lstStyle xmlns:a="http://schemas.openxmlformats.org/drawingml/2006/main"/>
+          <a:p xmlns:a="http://schemas.openxmlformats.org/drawingml/2006/main">
+            <a:pPr>
+              <a:buNone/>
+              <a:defRPr sz="1950" b="0">
+                <a:solidFill>
+                  <a:srgbClr val="D4D4D8"/>
+                </a:solidFill>
+                <a:latin typeface="Arial"/>
+                <a:ea typeface="Arial"/>
+                <a:cs typeface="Arial"/>
+              </a:defRPr>
+            </a:pPr>
+            <a:r>
+              <a:rPr sz="1950" b="0">
+                <a:solidFill>
+                  <a:srgbClr val="D4D4D8"/>
+                </a:solidFill>
+                <a:latin typeface="Arial"/>
+                <a:ea typeface="Arial"/>
+                <a:cs typeface="Arial"/>
+              </a:rPr>
+              <a:t>Compare the value with the smallest normal. Choose the normal or subnormal equation, work out the fields, then decode them to check.</a:t>
+            </a:r>
+          </a:p>
+          <a:p xmlns:a="http://schemas.openxmlformats.org/drawingml/2006/main">
+            <a:r>
+              <a:t/>
+            </a:r>
+          </a:p>
+          <a:p xmlns:a="http://schemas.openxmlformats.org/drawingml/2006/main">
+            <a:pPr>
+              <a:buNone/>
+              <a:defRPr sz="1950" b="0">
+                <a:solidFill>
+                  <a:srgbClr val="D4D4D8"/>
+                </a:solidFill>
+                <a:latin typeface="Arial"/>
+                <a:ea typeface="Arial"/>
+                <a:cs typeface="Arial"/>
+              </a:defRPr>
+            </a:pPr>
+            <a:r>
+              <a:rPr sz="1950" b="0">
+                <a:solidFill>
+                  <a:srgbClr val="D4D4D8"/>
+                </a:solidFill>
+                <a:latin typeface="Arial"/>
+                <a:ea typeface="Arial"/>
+                <a:cs typeface="Arial"/>
+              </a:rPr>
+              <a:t>If the value is not exact, use the rounding rule given with the problem.</a:t>
+            </a:r>
+          </a:p>
+        </p:txBody>
+      </p:sp>
+      <p:sp>
+        <p:nvSpPr>
+          <p:cNvPr id="4" name="">
+            <a:extLst xmlns:a="http://schemas.openxmlformats.org/drawingml/2006/main">
+              <a:ext uri="{FF2B5EF4-FFF2-40B4-BE49-F238E27FC236}">
+                <a16:creationId xmlns:a16="http://schemas.microsoft.com/office/drawing/2014/main" id="{EA939046-DA6B-448C-A179-5B13743C72F3}"/>
+              </a:ext>
+            </a:extLst>
+          </p:cNvPr>
+          <p:cNvSpPr>
+            <a:spLocks xmlns:a="http://schemas.openxmlformats.org/drawingml/2006/main" noGrp="1"/>
+          </p:cNvSpPr>
+          <p:nvPr/>
+        </p:nvSpPr>
+        <p:spPr>
+          <a:xfrm xmlns:a="http://schemas.openxmlformats.org/drawingml/2006/main">
+            <a:off x="6181725" y="2200275"/>
+            <a:ext cx="5238750" cy="3286125"/>
+          </a:xfrm>
+          <a:prstGeom xmlns:a="http://schemas.openxmlformats.org/drawingml/2006/main" prst="rect">
+            <a:avLst/>
+          </a:prstGeom>
+          <a:noFill xmlns:a="http://schemas.openxmlformats.org/drawingml/2006/main"/>
+          <a:ln xmlns:a="http://schemas.openxmlformats.org/drawingml/2006/main" w="0">
+            <a:noFill/>
+          </a:ln>
+        </p:spPr>
+        <p:txBody>
+          <a:bodyPr xmlns:a="http://schemas.openxmlformats.org/drawingml/2006/main" anchor="t">
+            <a:normAutofit fontScale="100000"/>
+          </a:bodyPr>
+          <a:lstStyle xmlns:a="http://schemas.openxmlformats.org/drawingml/2006/main"/>
+          <a:p xmlns:a="http://schemas.openxmlformats.org/drawingml/2006/main">
+            <a:pPr>
+              <a:buNone/>
+              <a:defRPr sz="1650" b="0">
+                <a:solidFill>
+                  <a:srgbClr val="A7F3D0"/>
+                </a:solidFill>
+                <a:latin typeface="Courier New"/>
+                <a:ea typeface="Courier New"/>
+                <a:cs typeface="Courier New"/>
+              </a:defRPr>
+            </a:pPr>
+            <a:r>
+              <a:rPr sz="1650" b="0">
+                <a:solidFill>
+                  <a:srgbClr val="A7F3D0"/>
+                </a:solidFill>
+                <a:latin typeface="Courier New"/>
+                <a:ea typeface="Courier New"/>
+                <a:cs typeface="Courier New"/>
+              </a:rPr>
+              <a:t>Our practice format</a:t>
+            </a:r>
+          </a:p>
+          <a:p xmlns:a="http://schemas.openxmlformats.org/drawingml/2006/main">
+            <a:r>
+              <a:t/>
+            </a:r>
+          </a:p>
+          <a:p xmlns:a="http://schemas.openxmlformats.org/drawingml/2006/main">
+            <a:pPr>
+              <a:buNone/>
+              <a:defRPr sz="1650" b="0">
+                <a:solidFill>
+                  <a:srgbClr val="A7F3D0"/>
+                </a:solidFill>
+                <a:latin typeface="Courier New"/>
+                <a:ea typeface="Courier New"/>
+                <a:cs typeface="Courier New"/>
+              </a:defRPr>
+            </a:pPr>
+            <a:r>
+              <a:rPr sz="1650" b="0">
+                <a:solidFill>
+                  <a:srgbClr val="A7F3D0"/>
+                </a:solidFill>
+                <a:latin typeface="Courier New"/>
+                <a:ea typeface="Courier New"/>
+                <a:cs typeface="Courier New"/>
+              </a:rPr>
+              <a:t>Normal:    (1 + F/8) × 2^(E−3)</a:t>
+            </a:r>
+          </a:p>
+          <a:p xmlns:a="http://schemas.openxmlformats.org/drawingml/2006/main">
+            <a:pPr>
+              <a:buNone/>
+              <a:defRPr sz="1650" b="0">
+                <a:solidFill>
+                  <a:srgbClr val="A7F3D0"/>
+                </a:solidFill>
+                <a:latin typeface="Courier New"/>
+                <a:ea typeface="Courier New"/>
+                <a:cs typeface="Courier New"/>
+              </a:defRPr>
+            </a:pPr>
+            <a:r>
+              <a:rPr sz="1650" b="0">
+                <a:solidFill>
+                  <a:srgbClr val="A7F3D0"/>
+                </a:solidFill>
+                <a:latin typeface="Courier New"/>
+                <a:ea typeface="Courier New"/>
+                <a:cs typeface="Courier New"/>
+              </a:rPr>
+              <a:t>Subnormal: (    F/8) × 2⁻²</a:t>
+            </a:r>
+          </a:p>
+          <a:p xmlns:a="http://schemas.openxmlformats.org/drawingml/2006/main">
+            <a:r>
+              <a:t/>
+            </a:r>
+          </a:p>
+          <a:p xmlns:a="http://schemas.openxmlformats.org/drawingml/2006/main">
+            <a:pPr>
+              <a:buNone/>
+              <a:defRPr sz="1650" b="0">
+                <a:solidFill>
+                  <a:srgbClr val="A7F3D0"/>
+                </a:solidFill>
+                <a:latin typeface="Courier New"/>
+                <a:ea typeface="Courier New"/>
+                <a:cs typeface="Courier New"/>
+              </a:defRPr>
+            </a:pPr>
+            <a:r>
+              <a:rPr sz="1650" b="0">
+                <a:solidFill>
+                  <a:srgbClr val="A7F3D0"/>
+                </a:solidFill>
+                <a:latin typeface="Courier New"/>
+                <a:ea typeface="Courier New"/>
+                <a:cs typeface="Courier New"/>
+              </a:rPr>
+              <a:t>E = 0, F = 0  →  zero</a:t>
+            </a:r>
+          </a:p>
+          <a:p xmlns:a="http://schemas.openxmlformats.org/drawingml/2006/main">
+            <a:r>
+              <a:t/>
+            </a:r>
+          </a:p>
+          <a:p xmlns:a="http://schemas.openxmlformats.org/drawingml/2006/main">
+            <a:pPr>
+              <a:buNone/>
+              <a:defRPr sz="1650" b="0">
+                <a:solidFill>
+                  <a:srgbClr val="A7F3D0"/>
+                </a:solidFill>
+                <a:latin typeface="Courier New"/>
+                <a:ea typeface="Courier New"/>
+                <a:cs typeface="Courier New"/>
+              </a:defRPr>
+            </a:pPr>
+            <a:r>
+              <a:rPr sz="1650" b="0">
+                <a:solidFill>
+                  <a:srgbClr val="A7F3D0"/>
+                </a:solidFill>
+                <a:latin typeface="Courier New"/>
+                <a:ea typeface="Courier New"/>
+                <a:cs typeface="Courier New"/>
+              </a:rPr>
+              <a:t>Decode your bits as a final check.</a:t>
+            </a:r>
+          </a:p>
+        </p:txBody>
+      </p:sp>
+      <p:sp>
+        <p:nvSpPr>
+          <p:cNvPr id="5" name="">
+            <a:extLst xmlns:a="http://schemas.openxmlformats.org/drawingml/2006/main">
+              <a:ext uri="{FF2B5EF4-FFF2-40B4-BE49-F238E27FC236}">
+                <a16:creationId xmlns:a16="http://schemas.microsoft.com/office/drawing/2014/main" id="{585A0E73-828D-45A1-9AD7-8EED8C5E7EB1}"/>
+              </a:ext>
+            </a:extLst>
+          </p:cNvPr>
+          <p:cNvSpPr>
+            <a:spLocks xmlns:a="http://schemas.openxmlformats.org/drawingml/2006/main" noGrp="1"/>
+          </p:cNvSpPr>
+          <p:nvPr/>
+        </p:nvSpPr>
+        <p:spPr>
+          <a:xfrm xmlns:a="http://schemas.openxmlformats.org/drawingml/2006/main">
+            <a:off x="685800" y="5743575"/>
+            <a:ext cx="10191750" cy="428625"/>
+          </a:xfrm>
+          <a:prstGeom xmlns:a="http://schemas.openxmlformats.org/drawingml/2006/main" prst="rect">
+            <a:avLst/>
+          </a:prstGeom>
+          <a:noFill xmlns:a="http://schemas.openxmlformats.org/drawingml/2006/main"/>
+          <a:ln xmlns:a="http://schemas.openxmlformats.org/drawingml/2006/main" w="0">
+            <a:noFill/>
+          </a:ln>
+        </p:spPr>
+        <p:txBody>
+          <a:bodyPr xmlns:a="http://schemas.openxmlformats.org/drawingml/2006/main" anchor="t">
+            <a:normAutofit fontScale="100000"/>
+          </a:bodyPr>
+          <a:lstStyle xmlns:a="http://schemas.openxmlformats.org/drawingml/2006/main"/>
+          <a:p xmlns:a="http://schemas.openxmlformats.org/drawingml/2006/main">
+            <a:pPr>
+              <a:buNone/>
+              <a:defRPr sz="1350" b="0">
+                <a:solidFill>
+                  <a:srgbClr val="A1A1AA"/>
+                </a:solidFill>
+                <a:latin typeface="Arial"/>
+                <a:ea typeface="Arial"/>
+                <a:cs typeface="Arial"/>
+              </a:defRPr>
+            </a:pPr>
+            <a:r>
+              <a:rPr sz="1350" b="0">
+                <a:solidFill>
+                  <a:srgbClr val="A1A1AA"/>
+                </a:solidFill>
+                <a:latin typeface="Arial"/>
+                <a:ea typeface="Arial"/>
+                <a:cs typeface="Arial"/>
+              </a:rPr>
+              <a:t>A correct encoding must reproduce the intended value or its required rounded value.</a:t>
+            </a:r>
+          </a:p>
+        </p:txBody>
+      </p:sp>
+      <p:sp>
+        <p:nvSpPr>
+          <p:cNvPr id="6" name="">
+            <a:extLst xmlns:a="http://schemas.openxmlformats.org/drawingml/2006/main">
+              <a:ext uri="{FF2B5EF4-FFF2-40B4-BE49-F238E27FC236}">
+                <a16:creationId xmlns:a16="http://schemas.microsoft.com/office/drawing/2014/main" id="{E1FBC5BD-1F5D-42FA-AC83-E0BF862F4EDF}"/>
+              </a:ext>
+            </a:extLst>
+          </p:cNvPr>
+          <p:cNvSpPr>
+            <a:spLocks xmlns:a="http://schemas.openxmlformats.org/drawingml/2006/main" noGrp="1"/>
+          </p:cNvSpPr>
+          <p:nvPr/>
+        </p:nvSpPr>
+        <p:spPr>
+          <a:xfrm xmlns:a="http://schemas.openxmlformats.org/drawingml/2006/main">
+            <a:off x="10477500" y="6210300"/>
+            <a:ext cx="1000125" cy="219075"/>
+          </a:xfrm>
+          <a:prstGeom xmlns:a="http://schemas.openxmlformats.org/drawingml/2006/main" prst="rect">
+            <a:avLst/>
+          </a:prstGeom>
+          <a:noFill xmlns:a="http://schemas.openxmlformats.org/drawingml/2006/main"/>
+          <a:ln xmlns:a="http://schemas.openxmlformats.org/drawingml/2006/main" w="0">
+            <a:noFill/>
+          </a:ln>
+        </p:spPr>
+        <p:txBody>
+          <a:bodyPr xmlns:a="http://schemas.openxmlformats.org/drawingml/2006/main" anchor="t">
+            <a:normAutofit fontScale="79762"/>
+          </a:bodyPr>
+          <a:lstStyle xmlns:a="http://schemas.openxmlformats.org/drawingml/2006/main"/>
+          <a:p xmlns:a="http://schemas.openxmlformats.org/drawingml/2006/main">
+            <a:pPr>
+              <a:buNone/>
+              <a:defRPr sz="1050" b="0">
+                <a:solidFill>
+                  <a:srgbClr val="71717A"/>
+                </a:solidFill>
+                <a:latin typeface="Courier New"/>
+                <a:ea typeface="Courier New"/>
+                <a:cs typeface="Courier New"/>
+              </a:defRPr>
+            </a:pPr>
+            <a:r>
+              <a:rPr sz="1050" b="0">
+                <a:solidFill>
+                  <a:srgbClr val="71717A"/>
+                </a:solidFill>
+                <a:latin typeface="Courier New"/>
+                <a:ea typeface="Courier New"/>
+                <a:cs typeface="Courier New"/>
+              </a:rPr>
+              <a:t>20 / 20</a:t>
+            </a:r>
+          </a:p>
+        </p:txBody>
+      </p:sp>
+    </p:spTree>
+    <p:extLst>
+      <p:ext uri="{BB962C8B-B14F-4D97-AF65-F5344CB8AC3E}">
+        <p14:creationId xmlns:p14="http://schemas.microsoft.com/office/powerpoint/2010/main" val="10196595"/>
       </p:ext>
     </p:extLst>
   </p:cSld>
@@ -7440,6 +9210,7 @@
           <a:lstStyle xmlns:a="http://schemas.openxmlformats.org/drawingml/2006/main"/>
           <a:p xmlns:a="http://schemas.openxmlformats.org/drawingml/2006/main">
             <a:pPr>
+              <a:buNone/>
               <a:defRPr sz="1275" b="0">
                 <a:solidFill>
                   <a:srgbClr val="6EE7B7"/>
@@ -7497,6 +9268,7 @@
           <a:lstStyle xmlns:a="http://schemas.openxmlformats.org/drawingml/2006/main"/>
           <a:p xmlns:a="http://schemas.openxmlformats.org/drawingml/2006/main">
             <a:pPr>
+              <a:buNone/>
               <a:defRPr sz="3600" b="0">
                 <a:solidFill>
                   <a:srgbClr val="FAFAFA"/>
@@ -7554,6 +9326,7 @@
           <a:lstStyle xmlns:a="http://schemas.openxmlformats.org/drawingml/2006/main"/>
           <a:p xmlns:a="http://schemas.openxmlformats.org/drawingml/2006/main">
             <a:pPr>
+              <a:buNone/>
               <a:defRPr sz="1950" b="0">
                 <a:solidFill>
                   <a:srgbClr val="D4D4D8"/>
@@ -7582,6 +9355,7 @@
           </a:p>
           <a:p xmlns:a="http://schemas.openxmlformats.org/drawingml/2006/main">
             <a:pPr>
+              <a:buNone/>
               <a:defRPr sz="1950" b="0">
                 <a:solidFill>
                   <a:srgbClr val="D4D4D8"/>
@@ -7639,6 +9413,7 @@
           <a:lstStyle xmlns:a="http://schemas.openxmlformats.org/drawingml/2006/main"/>
           <a:p xmlns:a="http://schemas.openxmlformats.org/drawingml/2006/main">
             <a:pPr>
+              <a:buNone/>
               <a:defRPr sz="1650" b="0">
                 <a:solidFill>
                   <a:srgbClr val="A7F3D0"/>
@@ -7667,6 +9442,7 @@
           </a:p>
           <a:p xmlns:a="http://schemas.openxmlformats.org/drawingml/2006/main">
             <a:pPr>
+              <a:buNone/>
               <a:defRPr sz="1650" b="0">
                 <a:solidFill>
                   <a:srgbClr val="A7F3D0"/>
@@ -7690,6 +9466,7 @@
           </a:p>
           <a:p xmlns:a="http://schemas.openxmlformats.org/drawingml/2006/main">
             <a:pPr>
+              <a:buNone/>
               <a:defRPr sz="1650" b="0">
                 <a:solidFill>
                   <a:srgbClr val="A7F3D0"/>
@@ -7713,6 +9490,7 @@
           </a:p>
           <a:p xmlns:a="http://schemas.openxmlformats.org/drawingml/2006/main">
             <a:pPr>
+              <a:buNone/>
               <a:defRPr sz="1650" b="0">
                 <a:solidFill>
                   <a:srgbClr val="A7F3D0"/>
@@ -7741,6 +9519,7 @@
           </a:p>
           <a:p xmlns:a="http://schemas.openxmlformats.org/drawingml/2006/main">
             <a:pPr>
+              <a:buNone/>
               <a:defRPr sz="1650" b="0">
                 <a:solidFill>
                   <a:srgbClr val="A7F3D0"/>
@@ -7798,6 +9577,7 @@
           <a:lstStyle xmlns:a="http://schemas.openxmlformats.org/drawingml/2006/main"/>
           <a:p xmlns:a="http://schemas.openxmlformats.org/drawingml/2006/main">
             <a:pPr>
+              <a:buNone/>
               <a:defRPr sz="1350" b="0">
                 <a:solidFill>
                   <a:srgbClr val="A1A1AA"/>
@@ -7855,6 +9635,7 @@
           <a:lstStyle xmlns:a="http://schemas.openxmlformats.org/drawingml/2006/main"/>
           <a:p xmlns:a="http://schemas.openxmlformats.org/drawingml/2006/main">
             <a:pPr>
+              <a:buNone/>
               <a:defRPr sz="1050" b="0">
                 <a:solidFill>
                   <a:srgbClr val="71717A"/>
@@ -7873,7 +9654,7 @@
                 <a:ea typeface="Courier New"/>
                 <a:cs typeface="Courier New"/>
               </a:rPr>
-              <a:t>03 / 17</a:t>
+              <a:t>03 / 20</a:t>
             </a:r>
           </a:p>
         </p:txBody>
@@ -7941,6 +9722,7 @@
           <a:lstStyle xmlns:a="http://schemas.openxmlformats.org/drawingml/2006/main"/>
           <a:p xmlns:a="http://schemas.openxmlformats.org/drawingml/2006/main">
             <a:pPr>
+              <a:buNone/>
               <a:defRPr sz="1275" b="0">
                 <a:solidFill>
                   <a:srgbClr val="6EE7B7"/>
@@ -7998,6 +9780,7 @@
           <a:lstStyle xmlns:a="http://schemas.openxmlformats.org/drawingml/2006/main"/>
           <a:p xmlns:a="http://schemas.openxmlformats.org/drawingml/2006/main">
             <a:pPr>
+              <a:buNone/>
               <a:defRPr sz="3600" b="0">
                 <a:solidFill>
                   <a:srgbClr val="FAFAFA"/>
@@ -8055,6 +9838,7 @@
           <a:lstStyle xmlns:a="http://schemas.openxmlformats.org/drawingml/2006/main"/>
           <a:p xmlns:a="http://schemas.openxmlformats.org/drawingml/2006/main">
             <a:pPr>
+              <a:buNone/>
               <a:defRPr sz="1950" b="0">
                 <a:solidFill>
                   <a:srgbClr val="D4D4D8"/>
@@ -8083,6 +9867,7 @@
           </a:p>
           <a:p xmlns:a="http://schemas.openxmlformats.org/drawingml/2006/main">
             <a:pPr>
+              <a:buNone/>
               <a:defRPr sz="1950" b="0">
                 <a:solidFill>
                   <a:srgbClr val="D4D4D8"/>
@@ -8140,6 +9925,7 @@
           <a:lstStyle xmlns:a="http://schemas.openxmlformats.org/drawingml/2006/main"/>
           <a:p xmlns:a="http://schemas.openxmlformats.org/drawingml/2006/main">
             <a:pPr>
+              <a:buNone/>
               <a:defRPr sz="1650" b="0">
                 <a:solidFill>
                   <a:srgbClr val="A7F3D0"/>
@@ -8163,6 +9949,7 @@
           </a:p>
           <a:p xmlns:a="http://schemas.openxmlformats.org/drawingml/2006/main">
             <a:pPr>
+              <a:buNone/>
               <a:defRPr sz="1650" b="0">
                 <a:solidFill>
                   <a:srgbClr val="A7F3D0"/>
@@ -8186,6 +9973,7 @@
           </a:p>
           <a:p xmlns:a="http://schemas.openxmlformats.org/drawingml/2006/main">
             <a:pPr>
+              <a:buNone/>
               <a:defRPr sz="1650" b="0">
                 <a:solidFill>
                   <a:srgbClr val="A7F3D0"/>
@@ -8214,6 +10002,7 @@
           </a:p>
           <a:p xmlns:a="http://schemas.openxmlformats.org/drawingml/2006/main">
             <a:pPr>
+              <a:buNone/>
               <a:defRPr sz="1650" b="0">
                 <a:solidFill>
                   <a:srgbClr val="A7F3D0"/>
@@ -8271,6 +10060,7 @@
           <a:lstStyle xmlns:a="http://schemas.openxmlformats.org/drawingml/2006/main"/>
           <a:p xmlns:a="http://schemas.openxmlformats.org/drawingml/2006/main">
             <a:pPr>
+              <a:buNone/>
               <a:defRPr sz="1350" b="0">
                 <a:solidFill>
                   <a:srgbClr val="A1A1AA"/>
@@ -8328,6 +10118,7 @@
           <a:lstStyle xmlns:a="http://schemas.openxmlformats.org/drawingml/2006/main"/>
           <a:p xmlns:a="http://schemas.openxmlformats.org/drawingml/2006/main">
             <a:pPr>
+              <a:buNone/>
               <a:defRPr sz="1050" b="0">
                 <a:solidFill>
                   <a:srgbClr val="71717A"/>
@@ -8346,7 +10137,7 @@
                 <a:ea typeface="Courier New"/>
                 <a:cs typeface="Courier New"/>
               </a:rPr>
-              <a:t>04 / 17</a:t>
+              <a:t>04 / 20</a:t>
             </a:r>
           </a:p>
         </p:txBody>
@@ -8414,6 +10205,7 @@
           <a:lstStyle xmlns:a="http://schemas.openxmlformats.org/drawingml/2006/main"/>
           <a:p xmlns:a="http://schemas.openxmlformats.org/drawingml/2006/main">
             <a:pPr>
+              <a:buNone/>
               <a:defRPr sz="1275" b="0">
                 <a:solidFill>
                   <a:srgbClr val="6EE7B7"/>
@@ -8471,6 +10263,7 @@
           <a:lstStyle xmlns:a="http://schemas.openxmlformats.org/drawingml/2006/main"/>
           <a:p xmlns:a="http://schemas.openxmlformats.org/drawingml/2006/main">
             <a:pPr>
+              <a:buNone/>
               <a:defRPr sz="3600" b="0">
                 <a:solidFill>
                   <a:srgbClr val="FAFAFA"/>
@@ -8528,6 +10321,7 @@
           <a:lstStyle xmlns:a="http://schemas.openxmlformats.org/drawingml/2006/main"/>
           <a:p xmlns:a="http://schemas.openxmlformats.org/drawingml/2006/main">
             <a:pPr>
+              <a:buNone/>
               <a:defRPr sz="1950" b="0">
                 <a:solidFill>
                   <a:srgbClr val="D4D4D8"/>
@@ -8556,6 +10350,7 @@
           </a:p>
           <a:p xmlns:a="http://schemas.openxmlformats.org/drawingml/2006/main">
             <a:pPr>
+              <a:buNone/>
               <a:defRPr sz="1950" b="0">
                 <a:solidFill>
                   <a:srgbClr val="D4D4D8"/>
@@ -8613,6 +10408,7 @@
           <a:lstStyle xmlns:a="http://schemas.openxmlformats.org/drawingml/2006/main"/>
           <a:p xmlns:a="http://schemas.openxmlformats.org/drawingml/2006/main">
             <a:pPr>
+              <a:buNone/>
               <a:defRPr sz="1650" b="0">
                 <a:solidFill>
                   <a:srgbClr val="A7F3D0"/>
@@ -8641,6 +10437,7 @@
           </a:p>
           <a:p xmlns:a="http://schemas.openxmlformats.org/drawingml/2006/main">
             <a:pPr>
+              <a:buNone/>
               <a:defRPr sz="1650" b="0">
                 <a:solidFill>
                   <a:srgbClr val="A7F3D0"/>
@@ -8664,6 +10461,7 @@
           </a:p>
           <a:p xmlns:a="http://schemas.openxmlformats.org/drawingml/2006/main">
             <a:pPr>
+              <a:buNone/>
               <a:defRPr sz="1650" b="0">
                 <a:solidFill>
                   <a:srgbClr val="A7F3D0"/>
@@ -8687,6 +10485,7 @@
           </a:p>
           <a:p xmlns:a="http://schemas.openxmlformats.org/drawingml/2006/main">
             <a:pPr>
+              <a:buNone/>
               <a:defRPr sz="1650" b="0">
                 <a:solidFill>
                   <a:srgbClr val="A7F3D0"/>
@@ -8744,6 +10543,7 @@
           <a:lstStyle xmlns:a="http://schemas.openxmlformats.org/drawingml/2006/main"/>
           <a:p xmlns:a="http://schemas.openxmlformats.org/drawingml/2006/main">
             <a:pPr>
+              <a:buNone/>
               <a:defRPr sz="1350" b="0">
                 <a:solidFill>
                   <a:srgbClr val="A1A1AA"/>
@@ -8801,6 +10601,7 @@
           <a:lstStyle xmlns:a="http://schemas.openxmlformats.org/drawingml/2006/main"/>
           <a:p xmlns:a="http://schemas.openxmlformats.org/drawingml/2006/main">
             <a:pPr>
+              <a:buNone/>
               <a:defRPr sz="1050" b="0">
                 <a:solidFill>
                   <a:srgbClr val="71717A"/>
@@ -8819,7 +10620,7 @@
                 <a:ea typeface="Courier New"/>
                 <a:cs typeface="Courier New"/>
               </a:rPr>
-              <a:t>05 / 17</a:t>
+              <a:t>05 / 20</a:t>
             </a:r>
           </a:p>
         </p:txBody>
@@ -8887,6 +10688,7 @@
           <a:lstStyle xmlns:a="http://schemas.openxmlformats.org/drawingml/2006/main"/>
           <a:p xmlns:a="http://schemas.openxmlformats.org/drawingml/2006/main">
             <a:pPr>
+              <a:buNone/>
               <a:defRPr sz="1275" b="0">
                 <a:solidFill>
                   <a:srgbClr val="6EE7B7"/>
@@ -8944,6 +10746,7 @@
           <a:lstStyle xmlns:a="http://schemas.openxmlformats.org/drawingml/2006/main"/>
           <a:p xmlns:a="http://schemas.openxmlformats.org/drawingml/2006/main">
             <a:pPr>
+              <a:buNone/>
               <a:defRPr sz="3600" b="0">
                 <a:solidFill>
                   <a:srgbClr val="FAFAFA"/>
@@ -9001,6 +10804,7 @@
           <a:lstStyle xmlns:a="http://schemas.openxmlformats.org/drawingml/2006/main"/>
           <a:p xmlns:a="http://schemas.openxmlformats.org/drawingml/2006/main">
             <a:pPr>
+              <a:buNone/>
               <a:defRPr sz="1950" b="0">
                 <a:solidFill>
                   <a:srgbClr val="D4D4D8"/>
@@ -9029,6 +10833,7 @@
           </a:p>
           <a:p xmlns:a="http://schemas.openxmlformats.org/drawingml/2006/main">
             <a:pPr>
+              <a:buNone/>
               <a:defRPr sz="1950" b="0">
                 <a:solidFill>
                   <a:srgbClr val="D4D4D8"/>
@@ -9086,6 +10891,7 @@
           <a:lstStyle xmlns:a="http://schemas.openxmlformats.org/drawingml/2006/main"/>
           <a:p xmlns:a="http://schemas.openxmlformats.org/drawingml/2006/main">
             <a:pPr>
+              <a:buNone/>
               <a:defRPr sz="1650" b="0">
                 <a:solidFill>
                   <a:srgbClr val="A7F3D0"/>
@@ -9109,6 +10915,7 @@
           </a:p>
           <a:p xmlns:a="http://schemas.openxmlformats.org/drawingml/2006/main">
             <a:pPr>
+              <a:buNone/>
               <a:defRPr sz="1650" b="0">
                 <a:solidFill>
                   <a:srgbClr val="A7F3D0"/>
@@ -9132,6 +10939,7 @@
           </a:p>
           <a:p xmlns:a="http://schemas.openxmlformats.org/drawingml/2006/main">
             <a:pPr>
+              <a:buNone/>
               <a:defRPr sz="1650" b="0">
                 <a:solidFill>
                   <a:srgbClr val="A7F3D0"/>
@@ -9160,6 +10968,7 @@
           </a:p>
           <a:p xmlns:a="http://schemas.openxmlformats.org/drawingml/2006/main">
             <a:pPr>
+              <a:buNone/>
               <a:defRPr sz="1650" b="0">
                 <a:solidFill>
                   <a:srgbClr val="A7F3D0"/>
@@ -9188,6 +10997,7 @@
           </a:p>
           <a:p xmlns:a="http://schemas.openxmlformats.org/drawingml/2006/main">
             <a:pPr>
+              <a:buNone/>
               <a:defRPr sz="1650" b="0">
                 <a:solidFill>
                   <a:srgbClr val="A7F3D0"/>
@@ -9245,6 +11055,7 @@
           <a:lstStyle xmlns:a="http://schemas.openxmlformats.org/drawingml/2006/main"/>
           <a:p xmlns:a="http://schemas.openxmlformats.org/drawingml/2006/main">
             <a:pPr>
+              <a:buNone/>
               <a:defRPr sz="1350" b="0">
                 <a:solidFill>
                   <a:srgbClr val="A1A1AA"/>
@@ -9302,6 +11113,7 @@
           <a:lstStyle xmlns:a="http://schemas.openxmlformats.org/drawingml/2006/main"/>
           <a:p xmlns:a="http://schemas.openxmlformats.org/drawingml/2006/main">
             <a:pPr>
+              <a:buNone/>
               <a:defRPr sz="1050" b="0">
                 <a:solidFill>
                   <a:srgbClr val="71717A"/>
@@ -9320,7 +11132,7 @@
                 <a:ea typeface="Courier New"/>
                 <a:cs typeface="Courier New"/>
               </a:rPr>
-              <a:t>06 / 17</a:t>
+              <a:t>06 / 20</a:t>
             </a:r>
           </a:p>
         </p:txBody>
@@ -9388,6 +11200,7 @@
           <a:lstStyle xmlns:a="http://schemas.openxmlformats.org/drawingml/2006/main"/>
           <a:p xmlns:a="http://schemas.openxmlformats.org/drawingml/2006/main">
             <a:pPr>
+              <a:buNone/>
               <a:defRPr sz="1275" b="0">
                 <a:solidFill>
                   <a:srgbClr val="6EE7B7"/>
@@ -9445,6 +11258,7 @@
           <a:lstStyle xmlns:a="http://schemas.openxmlformats.org/drawingml/2006/main"/>
           <a:p xmlns:a="http://schemas.openxmlformats.org/drawingml/2006/main">
             <a:pPr>
+              <a:buNone/>
               <a:defRPr sz="3600" b="0">
                 <a:solidFill>
                   <a:srgbClr val="FAFAFA"/>
@@ -9502,6 +11316,7 @@
           <a:lstStyle xmlns:a="http://schemas.openxmlformats.org/drawingml/2006/main"/>
           <a:p xmlns:a="http://schemas.openxmlformats.org/drawingml/2006/main">
             <a:pPr>
+              <a:buNone/>
               <a:defRPr sz="1950" b="0">
                 <a:solidFill>
                   <a:srgbClr val="D4D4D8"/>
@@ -9530,6 +11345,7 @@
           </a:p>
           <a:p xmlns:a="http://schemas.openxmlformats.org/drawingml/2006/main">
             <a:pPr>
+              <a:buNone/>
               <a:defRPr sz="1950" b="0">
                 <a:solidFill>
                   <a:srgbClr val="D4D4D8"/>
@@ -9587,6 +11403,7 @@
           <a:lstStyle xmlns:a="http://schemas.openxmlformats.org/drawingml/2006/main"/>
           <a:p xmlns:a="http://schemas.openxmlformats.org/drawingml/2006/main">
             <a:pPr>
+              <a:buNone/>
               <a:defRPr sz="1650" b="0">
                 <a:solidFill>
                   <a:srgbClr val="A7F3D0"/>
@@ -9615,6 +11432,7 @@
           </a:p>
           <a:p xmlns:a="http://schemas.openxmlformats.org/drawingml/2006/main">
             <a:pPr>
+              <a:buNone/>
               <a:defRPr sz="1650" b="0">
                 <a:solidFill>
                   <a:srgbClr val="A7F3D0"/>
@@ -9638,6 +11456,7 @@
           </a:p>
           <a:p xmlns:a="http://schemas.openxmlformats.org/drawingml/2006/main">
             <a:pPr>
+              <a:buNone/>
               <a:defRPr sz="1650" b="0">
                 <a:solidFill>
                   <a:srgbClr val="A7F3D0"/>
@@ -9666,6 +11485,7 @@
           </a:p>
           <a:p xmlns:a="http://schemas.openxmlformats.org/drawingml/2006/main">
             <a:pPr>
+              <a:buNone/>
               <a:defRPr sz="1650" b="0">
                 <a:solidFill>
                   <a:srgbClr val="A7F3D0"/>
@@ -9723,6 +11543,7 @@
           <a:lstStyle xmlns:a="http://schemas.openxmlformats.org/drawingml/2006/main"/>
           <a:p xmlns:a="http://schemas.openxmlformats.org/drawingml/2006/main">
             <a:pPr>
+              <a:buNone/>
               <a:defRPr sz="1350" b="0">
                 <a:solidFill>
                   <a:srgbClr val="A1A1AA"/>
@@ -9780,6 +11601,7 @@
           <a:lstStyle xmlns:a="http://schemas.openxmlformats.org/drawingml/2006/main"/>
           <a:p xmlns:a="http://schemas.openxmlformats.org/drawingml/2006/main">
             <a:pPr>
+              <a:buNone/>
               <a:defRPr sz="1050" b="0">
                 <a:solidFill>
                   <a:srgbClr val="71717A"/>
@@ -9798,7 +11620,7 @@
                 <a:ea typeface="Courier New"/>
                 <a:cs typeface="Courier New"/>
               </a:rPr>
-              <a:t>07 / 17</a:t>
+              <a:t>07 / 20</a:t>
             </a:r>
           </a:p>
         </p:txBody>
@@ -9866,6 +11688,7 @@
           <a:lstStyle xmlns:a="http://schemas.openxmlformats.org/drawingml/2006/main"/>
           <a:p xmlns:a="http://schemas.openxmlformats.org/drawingml/2006/main">
             <a:pPr>
+              <a:buNone/>
               <a:defRPr sz="1275" b="0">
                 <a:solidFill>
                   <a:srgbClr val="6EE7B7"/>
@@ -9923,6 +11746,7 @@
           <a:lstStyle xmlns:a="http://schemas.openxmlformats.org/drawingml/2006/main"/>
           <a:p xmlns:a="http://schemas.openxmlformats.org/drawingml/2006/main">
             <a:pPr>
+              <a:buNone/>
               <a:defRPr sz="3600" b="0">
                 <a:solidFill>
                   <a:srgbClr val="FAFAFA"/>
@@ -9980,6 +11804,7 @@
           <a:lstStyle xmlns:a="http://schemas.openxmlformats.org/drawingml/2006/main"/>
           <a:p xmlns:a="http://schemas.openxmlformats.org/drawingml/2006/main">
             <a:pPr>
+              <a:buNone/>
               <a:defRPr sz="1950" b="0">
                 <a:solidFill>
                   <a:srgbClr val="D4D4D8"/>
@@ -10008,6 +11833,7 @@
           </a:p>
           <a:p xmlns:a="http://schemas.openxmlformats.org/drawingml/2006/main">
             <a:pPr>
+              <a:buNone/>
               <a:defRPr sz="1950" b="0">
                 <a:solidFill>
                   <a:srgbClr val="D4D4D8"/>
@@ -10065,6 +11891,7 @@
           <a:lstStyle xmlns:a="http://schemas.openxmlformats.org/drawingml/2006/main"/>
           <a:p xmlns:a="http://schemas.openxmlformats.org/drawingml/2006/main">
             <a:pPr>
+              <a:buNone/>
               <a:defRPr sz="1650" b="0">
                 <a:solidFill>
                   <a:srgbClr val="A7F3D0"/>
@@ -10088,6 +11915,7 @@
           </a:p>
           <a:p xmlns:a="http://schemas.openxmlformats.org/drawingml/2006/main">
             <a:pPr>
+              <a:buNone/>
               <a:defRPr sz="1650" b="0">
                 <a:solidFill>
                   <a:srgbClr val="A7F3D0"/>
@@ -10116,6 +11944,7 @@
           </a:p>
           <a:p xmlns:a="http://schemas.openxmlformats.org/drawingml/2006/main">
             <a:pPr>
+              <a:buNone/>
               <a:defRPr sz="1650" b="0">
                 <a:solidFill>
                   <a:srgbClr val="A7F3D0"/>
@@ -10139,6 +11968,7 @@
           </a:p>
           <a:p xmlns:a="http://schemas.openxmlformats.org/drawingml/2006/main">
             <a:pPr>
+              <a:buNone/>
               <a:defRPr sz="1650" b="0">
                 <a:solidFill>
                   <a:srgbClr val="A7F3D0"/>
@@ -10196,6 +12026,7 @@
           <a:lstStyle xmlns:a="http://schemas.openxmlformats.org/drawingml/2006/main"/>
           <a:p xmlns:a="http://schemas.openxmlformats.org/drawingml/2006/main">
             <a:pPr>
+              <a:buNone/>
               <a:defRPr sz="1350" b="0">
                 <a:solidFill>
                   <a:srgbClr val="A1A1AA"/>
@@ -10253,6 +12084,7 @@
           <a:lstStyle xmlns:a="http://schemas.openxmlformats.org/drawingml/2006/main"/>
           <a:p xmlns:a="http://schemas.openxmlformats.org/drawingml/2006/main">
             <a:pPr>
+              <a:buNone/>
               <a:defRPr sz="1050" b="0">
                 <a:solidFill>
                   <a:srgbClr val="71717A"/>
@@ -10271,7 +12103,7 @@
                 <a:ea typeface="Courier New"/>
                 <a:cs typeface="Courier New"/>
               </a:rPr>
-              <a:t>08 / 17</a:t>
+              <a:t>08 / 20</a:t>
             </a:r>
           </a:p>
         </p:txBody>
@@ -10339,6 +12171,7 @@
           <a:lstStyle xmlns:a="http://schemas.openxmlformats.org/drawingml/2006/main"/>
           <a:p xmlns:a="http://schemas.openxmlformats.org/drawingml/2006/main">
             <a:pPr>
+              <a:buNone/>
               <a:defRPr sz="1275" b="0">
                 <a:solidFill>
                   <a:srgbClr val="6EE7B7"/>
@@ -10396,6 +12229,7 @@
           <a:lstStyle xmlns:a="http://schemas.openxmlformats.org/drawingml/2006/main"/>
           <a:p xmlns:a="http://schemas.openxmlformats.org/drawingml/2006/main">
             <a:pPr>
+              <a:buNone/>
               <a:defRPr sz="3600" b="0">
                 <a:solidFill>
                   <a:srgbClr val="FAFAFA"/>
@@ -10453,6 +12287,7 @@
           <a:lstStyle xmlns:a="http://schemas.openxmlformats.org/drawingml/2006/main"/>
           <a:p xmlns:a="http://schemas.openxmlformats.org/drawingml/2006/main">
             <a:pPr>
+              <a:buNone/>
               <a:defRPr sz="1950" b="0">
                 <a:solidFill>
                   <a:srgbClr val="D4D4D8"/>
@@ -10481,6 +12316,7 @@
           </a:p>
           <a:p xmlns:a="http://schemas.openxmlformats.org/drawingml/2006/main">
             <a:pPr>
+              <a:buNone/>
               <a:defRPr sz="1950" b="0">
                 <a:solidFill>
                   <a:srgbClr val="D4D4D8"/>
@@ -10538,6 +12374,7 @@
           <a:lstStyle xmlns:a="http://schemas.openxmlformats.org/drawingml/2006/main"/>
           <a:p xmlns:a="http://schemas.openxmlformats.org/drawingml/2006/main">
             <a:pPr>
+              <a:buNone/>
               <a:defRPr sz="1650" b="0">
                 <a:solidFill>
                   <a:srgbClr val="A7F3D0"/>
@@ -10561,6 +12398,7 @@
           </a:p>
           <a:p xmlns:a="http://schemas.openxmlformats.org/drawingml/2006/main">
             <a:pPr>
+              <a:buNone/>
               <a:defRPr sz="1650" b="0">
                 <a:solidFill>
                   <a:srgbClr val="A7F3D0"/>
@@ -10584,6 +12422,7 @@
           </a:p>
           <a:p xmlns:a="http://schemas.openxmlformats.org/drawingml/2006/main">
             <a:pPr>
+              <a:buNone/>
               <a:defRPr sz="1650" b="0">
                 <a:solidFill>
                   <a:srgbClr val="A7F3D0"/>
@@ -10612,6 +12451,7 @@
           </a:p>
           <a:p xmlns:a="http://schemas.openxmlformats.org/drawingml/2006/main">
             <a:pPr>
+              <a:buNone/>
               <a:defRPr sz="1650" b="0">
                 <a:solidFill>
                   <a:srgbClr val="A7F3D0"/>
@@ -10640,6 +12480,7 @@
           </a:p>
           <a:p xmlns:a="http://schemas.openxmlformats.org/drawingml/2006/main">
             <a:pPr>
+              <a:buNone/>
               <a:defRPr sz="1650" b="0">
                 <a:solidFill>
                   <a:srgbClr val="A7F3D0"/>
@@ -10697,6 +12538,7 @@
           <a:lstStyle xmlns:a="http://schemas.openxmlformats.org/drawingml/2006/main"/>
           <a:p xmlns:a="http://schemas.openxmlformats.org/drawingml/2006/main">
             <a:pPr>
+              <a:buNone/>
               <a:defRPr sz="1350" b="0">
                 <a:solidFill>
                   <a:srgbClr val="A1A1AA"/>
@@ -10754,6 +12596,7 @@
           <a:lstStyle xmlns:a="http://schemas.openxmlformats.org/drawingml/2006/main"/>
           <a:p xmlns:a="http://schemas.openxmlformats.org/drawingml/2006/main">
             <a:pPr>
+              <a:buNone/>
               <a:defRPr sz="1050" b="0">
                 <a:solidFill>
                   <a:srgbClr val="71717A"/>
@@ -10772,7 +12615,7 @@
                 <a:ea typeface="Courier New"/>
                 <a:cs typeface="Courier New"/>
               </a:rPr>
-              <a:t>09 / 17</a:t>
+              <a:t>09 / 20</a:t>
             </a:r>
           </a:p>
         </p:txBody>

</xml_diff>

<commit_message>
Clarify exponent bias and subnormal values
</commit_message>
<xml_diff>
--- a/public/presentations/CS211_Recitation_3.pptx
+++ b/public/presentations/CS211_Recitation_3.pptx
@@ -2,32 +2,34 @@
 <file path=ppt/presentation.xml><?xml version="1.0" encoding="utf-8"?>
 <p:presentation xmlns:p="http://schemas.openxmlformats.org/presentationml/2006/main">
   <p:sldMasterIdLst>
-    <p:sldMasterId xmlns:r="http://schemas.openxmlformats.org/officeDocument/2006/relationships" id="2147483648" r:id="Ra47e6fe55a134014"/>
+    <p:sldMasterId xmlns:r="http://schemas.openxmlformats.org/officeDocument/2006/relationships" id="2147483648" r:id="R8d68ad4fd84a47cc"/>
   </p:sldMasterIdLst>
   <p:notesMasterIdLst>
-    <p:notesMasterId xmlns:r="http://schemas.openxmlformats.org/officeDocument/2006/relationships" r:id="Rd3b23f1bb00e4b8d"/>
+    <p:notesMasterId xmlns:r="http://schemas.openxmlformats.org/officeDocument/2006/relationships" r:id="Rf14b7f2b99254511"/>
   </p:notesMasterIdLst>
   <p:sldIdLst>
-    <p:sldId xmlns:r="http://schemas.openxmlformats.org/officeDocument/2006/relationships" id="256" r:id="R4600a745c4114dc6"/>
-    <p:sldId xmlns:r="http://schemas.openxmlformats.org/officeDocument/2006/relationships" id="257" r:id="Rfbd2ab6f0c9b4982"/>
-    <p:sldId xmlns:r="http://schemas.openxmlformats.org/officeDocument/2006/relationships" id="258" r:id="R27b11eb247a749a8"/>
-    <p:sldId xmlns:r="http://schemas.openxmlformats.org/officeDocument/2006/relationships" id="259" r:id="Rf0d345b8f1a145d5"/>
-    <p:sldId xmlns:r="http://schemas.openxmlformats.org/officeDocument/2006/relationships" id="260" r:id="R8b0d79b20a25400a"/>
-    <p:sldId xmlns:r="http://schemas.openxmlformats.org/officeDocument/2006/relationships" id="261" r:id="R8e12034dd6864da2"/>
-    <p:sldId xmlns:r="http://schemas.openxmlformats.org/officeDocument/2006/relationships" id="262" r:id="R2dabec76ca8845d8"/>
-    <p:sldId xmlns:r="http://schemas.openxmlformats.org/officeDocument/2006/relationships" id="263" r:id="R1aaed51860dc4a9f"/>
-    <p:sldId xmlns:r="http://schemas.openxmlformats.org/officeDocument/2006/relationships" id="264" r:id="R6a5f4c0583294f71"/>
-    <p:sldId xmlns:r="http://schemas.openxmlformats.org/officeDocument/2006/relationships" id="265" r:id="Rc64204b446d54df8"/>
-    <p:sldId xmlns:r="http://schemas.openxmlformats.org/officeDocument/2006/relationships" id="266" r:id="R80e53087e4004862"/>
-    <p:sldId xmlns:r="http://schemas.openxmlformats.org/officeDocument/2006/relationships" id="267" r:id="R013ff6a4f2fe4cbe"/>
-    <p:sldId xmlns:r="http://schemas.openxmlformats.org/officeDocument/2006/relationships" id="268" r:id="R02cddb29a9df4149"/>
-    <p:sldId xmlns:r="http://schemas.openxmlformats.org/officeDocument/2006/relationships" id="269" r:id="R4b94b08c36fd40c3"/>
-    <p:sldId xmlns:r="http://schemas.openxmlformats.org/officeDocument/2006/relationships" id="270" r:id="Re6e10f2a9a304161"/>
-    <p:sldId xmlns:r="http://schemas.openxmlformats.org/officeDocument/2006/relationships" id="271" r:id="Rbde8424f5d854cb5"/>
-    <p:sldId xmlns:r="http://schemas.openxmlformats.org/officeDocument/2006/relationships" id="272" r:id="R43c57c166f024dbe"/>
-    <p:sldId xmlns:r="http://schemas.openxmlformats.org/officeDocument/2006/relationships" id="273" r:id="Ra6d0bdf5fc754bdc"/>
-    <p:sldId xmlns:r="http://schemas.openxmlformats.org/officeDocument/2006/relationships" id="274" r:id="Rd577631298fa4770"/>
-    <p:sldId xmlns:r="http://schemas.openxmlformats.org/officeDocument/2006/relationships" id="275" r:id="Ra16db4aea30a4f8b"/>
+    <p:sldId xmlns:r="http://schemas.openxmlformats.org/officeDocument/2006/relationships" id="256" r:id="R5267d73aa5874270"/>
+    <p:sldId xmlns:r="http://schemas.openxmlformats.org/officeDocument/2006/relationships" id="257" r:id="R4aae4a14d1454a16"/>
+    <p:sldId xmlns:r="http://schemas.openxmlformats.org/officeDocument/2006/relationships" id="258" r:id="Rc0f65d20b6634bdb"/>
+    <p:sldId xmlns:r="http://schemas.openxmlformats.org/officeDocument/2006/relationships" id="259" r:id="Rd38053d8d9e74084"/>
+    <p:sldId xmlns:r="http://schemas.openxmlformats.org/officeDocument/2006/relationships" id="260" r:id="R3b9dd25fa84345d1"/>
+    <p:sldId xmlns:r="http://schemas.openxmlformats.org/officeDocument/2006/relationships" id="261" r:id="R6b5d7bf35bdf495a"/>
+    <p:sldId xmlns:r="http://schemas.openxmlformats.org/officeDocument/2006/relationships" id="262" r:id="R2ec18e9e512745e0"/>
+    <p:sldId xmlns:r="http://schemas.openxmlformats.org/officeDocument/2006/relationships" id="263" r:id="R1f840f1fbef04f32"/>
+    <p:sldId xmlns:r="http://schemas.openxmlformats.org/officeDocument/2006/relationships" id="264" r:id="Rfecf66dcab394e97"/>
+    <p:sldId xmlns:r="http://schemas.openxmlformats.org/officeDocument/2006/relationships" id="265" r:id="R60723292eea841aa"/>
+    <p:sldId xmlns:r="http://schemas.openxmlformats.org/officeDocument/2006/relationships" id="266" r:id="Re1f14d0166f34c45"/>
+    <p:sldId xmlns:r="http://schemas.openxmlformats.org/officeDocument/2006/relationships" id="267" r:id="R7fb7ed0b61e149be"/>
+    <p:sldId xmlns:r="http://schemas.openxmlformats.org/officeDocument/2006/relationships" id="268" r:id="Rc9360792d54144b3"/>
+    <p:sldId xmlns:r="http://schemas.openxmlformats.org/officeDocument/2006/relationships" id="269" r:id="R194cd94b0dce415d"/>
+    <p:sldId xmlns:r="http://schemas.openxmlformats.org/officeDocument/2006/relationships" id="270" r:id="R27ffca7f438c4ed5"/>
+    <p:sldId xmlns:r="http://schemas.openxmlformats.org/officeDocument/2006/relationships" id="271" r:id="Rc8e7e17d97f643df"/>
+    <p:sldId xmlns:r="http://schemas.openxmlformats.org/officeDocument/2006/relationships" id="272" r:id="Rf2a99ac22aca4a16"/>
+    <p:sldId xmlns:r="http://schemas.openxmlformats.org/officeDocument/2006/relationships" id="273" r:id="Rd4ee585781d84149"/>
+    <p:sldId xmlns:r="http://schemas.openxmlformats.org/officeDocument/2006/relationships" id="274" r:id="Re9e87104bc05434b"/>
+    <p:sldId xmlns:r="http://schemas.openxmlformats.org/officeDocument/2006/relationships" id="275" r:id="Rb2e27981acfa43a2"/>
+    <p:sldId xmlns:r="http://schemas.openxmlformats.org/officeDocument/2006/relationships" id="276" r:id="R188c15c14f384b7c"/>
+    <p:sldId xmlns:r="http://schemas.openxmlformats.org/officeDocument/2006/relationships" id="277" r:id="Rf43030d33e9541e3"/>
   </p:sldIdLst>
   <p:sldSz cx="12192000" cy="6858000"/>
   <p:notesSz cx="6858000" cy="9144000"/>
@@ -461,7 +463,7 @@
           <a:lstStyle xmlns:a="http://schemas.openxmlformats.org/drawingml/2006/main"/>
           <a:p xmlns:a="http://schemas.openxmlformats.org/drawingml/2006/main">
             <a:r>
-              <a:t>Suggested 50-minute pacing: binary place values and fields 7 min; normal values 10 min; subnormals and the boundary 10 min; decoding and encoding practice 10 min; rounding and spacing 5 min; HW3 preview and recap 8 min. The HW3 details are based on the professor’s description supplied by the TA; the assignment is not officially posted. Source: lecture 6.</a:t>
+              <a:t>Suggested 50-minute pacing: binary place values and fields 7 min; normal values 10 min; subnormals and the boundary 14 min; decoding and encoding practice 8 min; rounding and spacing 4 min; HW3 preview and recap 7 min. Pause after the subnormal step table and ask students to name the next value after 7/32. The HW3 details are based on the professor’s description supplied by the TA; the assignment is not officially posted. Source: lecture 6.</a:t>
             </a:r>
           </a:p>
         </p:txBody>
@@ -531,7 +533,7 @@
           <a:lstStyle xmlns:a="http://schemas.openxmlformats.org/drawingml/2006/main"/>
           <a:p xmlns:a="http://schemas.openxmlformats.org/drawingml/2006/main">
             <a:r>
-              <a:t>Use the 3-exponent-bit, bias-3, 3-fraction-bit practice format. Largest subnormal is F=7, giving 7/32. Smallest normal is E=1,F=0, giving 2^(1−3)=1/4. This illustrates gradual underflow.</a:t>
+              <a:t>Derive the step: one fraction unit is 1/8; multiplying by 2^-2=1/4 gives 1/32. For this practice format, E=0,F=0 is zero and E=0,F=1..7 are positive subnormals. Let students answer 8/32=1/4 before the boundary slide. Source: lecture 6 subnormal equation.</a:t>
             </a:r>
           </a:p>
         </p:txBody>
@@ -601,7 +603,7 @@
           <a:lstStyle xmlns:a="http://schemas.openxmlformats.org/drawingml/2006/main"/>
           <a:p xmlns:a="http://schemas.openxmlformats.org/drawingml/2006/main">
             <a:r>
-              <a:t>Allow two to three minutes. A is normal: E=2,F=4, value (1+4/8)×2^-1=3/4. B is subnormal: E=0,F=3, value 3/32. Ask students to name the equation before calculating.</a:t>
+              <a:t>Keep the calculation concrete: 1/8=4/32, so F=4. Decode using 0.100 binary times 2^-2: 1/2 times 1/4 is 1/8. Ask why E is zero and why F is four. Source: lecture 6 subnormal equation.</a:t>
             </a:r>
           </a:p>
         </p:txBody>
@@ -671,7 +673,7 @@
           <a:lstStyle xmlns:a="http://schemas.openxmlformats.org/drawingml/2006/main"/>
           <a:p xmlns:a="http://schemas.openxmlformats.org/drawingml/2006/main">
             <a:r>
-              <a:t>Have students explain why B is not (1+3/8)×2^-3. The exponent for subnormals is fixed at 1−bias=-2, and the leading 1 is absent.</a:t>
+              <a:t>Link back to the question on the previous step table. The step from 7/32 to 8/32 is 1/32, matching the subnormal spacing. E=0 does not mean exponent −3; both values use 2^-2. Source: lecture 6 normal and subnormal equations.</a:t>
             </a:r>
           </a:p>
         </p:txBody>
@@ -741,7 +743,7 @@
           <a:lstStyle xmlns:a="http://schemas.openxmlformats.org/drawingml/2006/main"/>
           <a:p xmlns:a="http://schemas.openxmlformats.org/drawingml/2006/main">
             <a:r>
-              <a:t>Give two minutes. Both examples are exactly representable, so no rounding rule is needed. Ask students to check results by substituting E and F into the appropriate formula.</a:t>
+              <a:t>Allow two to three minutes. A is normal: E=2,F=4, value (1+4/8)×2^-1=3/4. B is subnormal: E=0,F=3, value 3/32. Ask students to name the equation before calculating.</a:t>
             </a:r>
           </a:p>
         </p:txBody>
@@ -811,7 +813,7 @@
           <a:lstStyle xmlns:a="http://schemas.openxmlformats.org/drawingml/2006/main"/>
           <a:p xmlns:a="http://schemas.openxmlformats.org/drawingml/2006/main">
             <a:r>
-              <a:t>Do not reveal until students have tried both. Emphasize that E=0 is a category marker here, not the unbiased exponent. E=3 represents true exponent zero because bias is three.</a:t>
+              <a:t>Have students explain why B is not (1+3/8)×2^-3. The exponent for subnormals is fixed at 1−bias=-2, and the leading 1 is absent.</a:t>
             </a:r>
           </a:p>
         </p:txBody>
@@ -881,7 +883,7 @@
           <a:lstStyle xmlns:a="http://schemas.openxmlformats.org/drawingml/2006/main"/>
           <a:p xmlns:a="http://schemas.openxmlformats.org/drawingml/2006/main">
             <a:r>
-              <a:t>The future homework description does not specify rounding, so do not teach truncation or nearest as a required rule. Here E=1 for both nearby normals. 5/16=0.3125, 11/32=0.34375, and 1/3≈0.3333. This replaces the earlier abstract associativity slide with a representation example directly tied to the professor's stated learning goal.</a:t>
+              <a:t>Give two minutes. Both examples are exactly representable, so no rounding rule is needed. Ask students to check results by substituting E and F into the appropriate formula.</a:t>
             </a:r>
           </a:p>
         </p:txBody>
@@ -951,7 +953,7 @@
           <a:lstStyle xmlns:a="http://schemas.openxmlformats.org/drawingml/2006/main"/>
           <a:p xmlns:a="http://schemas.openxmlformats.org/drawingml/2006/main">
             <a:r>
-              <a:t>For normals with fixed E, incrementing F by one changes the value by 2^(E−bias)/8. Show how this connects to the rounding slide and lecture 6’s discussion of gaps between floats.</a:t>
+              <a:t>Do not reveal until students have tried both. Emphasize that E=0 is a category marker here, not the unbiased exponent. E=3 represents true exponent zero because bias is three.</a:t>
             </a:r>
           </a:p>
         </p:txBody>
@@ -1021,7 +1023,7 @@
           <a:lstStyle xmlns:a="http://schemas.openxmlformats.org/drawingml/2006/main"/>
           <a:p xmlns:a="http://schemas.openxmlformats.org/drawingml/2006/main">
             <a:r>
-              <a:t>Based on the professor’s preview supplied by the TA. The intended command-line inputs are exponent bits, bias, significand bits, numerator, and denominator, in that order. The output contains the exponent and significand field values. Use 5/2 as a new teaching example. The final handout may add input and rounding details.</a:t>
+              <a:t>The future homework description does not specify rounding, so do not teach truncation or nearest as a required rule. Here E=1 for both nearby normals. 5/16=0.3125, 11/32=0.34375, and 1/3≈0.3333. This replaces the earlier abstract associativity slide with a representation example directly tied to the professor's stated learning goal.</a:t>
             </a:r>
           </a:p>
         </p:txBody>
@@ -1091,7 +1093,7 @@
           <a:lstStyle xmlns:a="http://schemas.openxmlformats.org/drawingml/2006/main"/>
           <a:p xmlns:a="http://schemas.openxmlformats.org/drawingml/2006/main">
             <a:r>
-              <a:t>This example is mathematically exact and uses the planned input order. Important TA note: the supplied draft solution computes the normal significand as (numerator &lt;&lt; sig_bits)/denominator − 2^sig_bits without scaling by 2^power_of_two. For these inputs that draft gives F=12, outside the three-bit range, rather than F=2. Do not present that draft code as a correct answer key until the normal path is fixed. Source: professor’s preview and lecture 6 normal-value equation.</a:t>
+              <a:t>For normals with fixed E, incrementing F by one changes the value by 2^(E−bias)/8. Show how this connects to the rounding slide and lecture 6’s discussion of gaps between floats.</a:t>
             </a:r>
           </a:p>
         </p:txBody>
@@ -1161,7 +1163,7 @@
           <a:lstStyle xmlns:a="http://schemas.openxmlformats.org/drawingml/2006/main"/>
           <a:p xmlns:a="http://schemas.openxmlformats.org/drawingml/2006/main">
             <a:r>
-              <a:t>Here p is the number of significand bits. For exact examples, solve the equation algebraically. The eventual homework may specify how to round values that fall between encodings, so do not assume a rounding rule yet. This is a conceptual approach, not a copy of the unreleased source code. Source: professor’s preview and lecture 6 equations.</a:t>
+              <a:t>Based on the professor’s preview supplied by the TA. The intended command-line inputs are exponent bits, bias, significand bits, numerator, and denominator, in that order. The output contains the exponent and significand field values. Use 5/2 as a new teaching example. The final handout may add input and rounding details.</a:t>
             </a:r>
           </a:p>
         </p:txBody>
@@ -1301,6 +1303,146 @@
           <a:lstStyle xmlns:a="http://schemas.openxmlformats.org/drawingml/2006/main"/>
           <a:p xmlns:a="http://schemas.openxmlformats.org/drawingml/2006/main">
             <a:r>
+              <a:t>This example is mathematically exact and uses the planned input order. Important TA note: the supplied draft solution computes the normal significand as (numerator &lt;&lt; sig_bits)/denominator − 2^sig_bits without scaling by 2^power_of_two. For these inputs that draft gives F=12, outside the three-bit range, rather than F=2. Do not present that draft code as a correct answer key until the normal path is fixed. Source: professor’s preview and lecture 6 normal-value equation.</a:t>
+            </a:r>
+          </a:p>
+        </p:txBody>
+      </p:sp>
+      <p:sp>
+        <p:nvSpPr>
+          <p:cNvPr id="4" name="Slide Number Placeholder 3"/>
+          <p:cNvSpPr>
+            <a:spLocks xmlns:a="http://schemas.openxmlformats.org/drawingml/2006/main" noGrp="1"/>
+          </p:cNvSpPr>
+          <p:nvPr>
+            <p:ph type="sldNum" idx="5"/>
+          </p:nvPr>
+        </p:nvSpPr>
+        <p:spPr/>
+        <p:txBody>
+          <a:bodyPr xmlns:a="http://schemas.openxmlformats.org/drawingml/2006/main"/>
+          <a:lstStyle xmlns:a="http://schemas.openxmlformats.org/drawingml/2006/main"/>
+          <a:p xmlns:a="http://schemas.openxmlformats.org/drawingml/2006/main"/>
+        </p:txBody>
+      </p:sp>
+    </p:spTree>
+  </p:cSld>
+  <p:clrMapOvr>
+    <a:masterClrMapping xmlns:a="http://schemas.openxmlformats.org/drawingml/2006/main"/>
+  </p:clrMapOvr>
+</p:notes>
+</file>
+
+<file path=ppt/notesSlides/notesSlide21.xml><?xml version="1.0" encoding="utf-8"?>
+<p:notes xmlns:p="http://schemas.openxmlformats.org/presentationml/2006/main">
+  <p:cSld>
+    <p:spTree>
+      <p:nvGrpSpPr>
+        <p:cNvPr id="1" name=""/>
+        <p:cNvGrpSpPr/>
+        <p:nvPr/>
+      </p:nvGrpSpPr>
+      <p:grpSpPr>
+        <a:xfrm xmlns:a="http://schemas.openxmlformats.org/drawingml/2006/main"/>
+      </p:grpSpPr>
+      <p:sp>
+        <p:nvSpPr>
+          <p:cNvPr id="2" name="Slide Image Placeholder 1"/>
+          <p:cNvSpPr>
+            <a:spLocks xmlns:a="http://schemas.openxmlformats.org/drawingml/2006/main" noGrp="1"/>
+          </p:cNvSpPr>
+          <p:nvPr>
+            <p:ph type="sldImg" idx="0"/>
+          </p:nvPr>
+        </p:nvSpPr>
+        <p:spPr/>
+      </p:sp>
+      <p:sp>
+        <p:nvSpPr>
+          <p:cNvPr id="3" name="Notes Placeholder 2"/>
+          <p:cNvSpPr>
+            <a:spLocks xmlns:a="http://schemas.openxmlformats.org/drawingml/2006/main" noGrp="1"/>
+          </p:cNvSpPr>
+          <p:nvPr>
+            <p:ph type="body" idx="1"/>
+          </p:nvPr>
+        </p:nvSpPr>
+        <p:spPr/>
+        <p:txBody>
+          <a:bodyPr xmlns:a="http://schemas.openxmlformats.org/drawingml/2006/main"/>
+          <a:lstStyle xmlns:a="http://schemas.openxmlformats.org/drawingml/2006/main"/>
+          <a:p xmlns:a="http://schemas.openxmlformats.org/drawingml/2006/main">
+            <a:r>
+              <a:t>Here p is the number of significand bits. For exact examples, solve the equation algebraically. The eventual homework may specify how to round values that fall between encodings, so do not assume a rounding rule yet. This is a conceptual approach, not a copy of the unreleased source code. Source: professor’s preview and lecture 6 equations.</a:t>
+            </a:r>
+          </a:p>
+        </p:txBody>
+      </p:sp>
+      <p:sp>
+        <p:nvSpPr>
+          <p:cNvPr id="4" name="Slide Number Placeholder 3"/>
+          <p:cNvSpPr>
+            <a:spLocks xmlns:a="http://schemas.openxmlformats.org/drawingml/2006/main" noGrp="1"/>
+          </p:cNvSpPr>
+          <p:nvPr>
+            <p:ph type="sldNum" idx="5"/>
+          </p:nvPr>
+        </p:nvSpPr>
+        <p:spPr/>
+        <p:txBody>
+          <a:bodyPr xmlns:a="http://schemas.openxmlformats.org/drawingml/2006/main"/>
+          <a:lstStyle xmlns:a="http://schemas.openxmlformats.org/drawingml/2006/main"/>
+          <a:p xmlns:a="http://schemas.openxmlformats.org/drawingml/2006/main"/>
+        </p:txBody>
+      </p:sp>
+    </p:spTree>
+  </p:cSld>
+  <p:clrMapOvr>
+    <a:masterClrMapping xmlns:a="http://schemas.openxmlformats.org/drawingml/2006/main"/>
+  </p:clrMapOvr>
+</p:notes>
+</file>
+
+<file path=ppt/notesSlides/notesSlide22.xml><?xml version="1.0" encoding="utf-8"?>
+<p:notes xmlns:p="http://schemas.openxmlformats.org/presentationml/2006/main">
+  <p:cSld>
+    <p:spTree>
+      <p:nvGrpSpPr>
+        <p:cNvPr id="1" name=""/>
+        <p:cNvGrpSpPr/>
+        <p:nvPr/>
+      </p:nvGrpSpPr>
+      <p:grpSpPr>
+        <a:xfrm xmlns:a="http://schemas.openxmlformats.org/drawingml/2006/main"/>
+      </p:grpSpPr>
+      <p:sp>
+        <p:nvSpPr>
+          <p:cNvPr id="2" name="Slide Image Placeholder 1"/>
+          <p:cNvSpPr>
+            <a:spLocks xmlns:a="http://schemas.openxmlformats.org/drawingml/2006/main" noGrp="1"/>
+          </p:cNvSpPr>
+          <p:nvPr>
+            <p:ph type="sldImg" idx="0"/>
+          </p:nvPr>
+        </p:nvSpPr>
+        <p:spPr/>
+      </p:sp>
+      <p:sp>
+        <p:nvSpPr>
+          <p:cNvPr id="3" name="Notes Placeholder 2"/>
+          <p:cNvSpPr>
+            <a:spLocks xmlns:a="http://schemas.openxmlformats.org/drawingml/2006/main" noGrp="1"/>
+          </p:cNvSpPr>
+          <p:nvPr>
+            <p:ph type="body" idx="1"/>
+          </p:nvPr>
+        </p:nvSpPr>
+        <p:spPr/>
+        <p:txBody>
+          <a:bodyPr xmlns:a="http://schemas.openxmlformats.org/drawingml/2006/main"/>
+          <a:lstStyle xmlns:a="http://schemas.openxmlformats.org/drawingml/2006/main"/>
+          <a:p xmlns:a="http://schemas.openxmlformats.org/drawingml/2006/main">
+            <a:r>
               <a:t>Review the two mistakes most likely to occur: forgetting to add the bias for a normal exponent, and using the normal hidden 1 for a subnormal. Do not reveal the unreleased homework solution. Remind students to follow the eventual assignment’s rounding and valid-input rules.</a:t>
             </a:r>
           </a:p>
@@ -1511,7 +1653,7 @@
           <a:lstStyle xmlns:a="http://schemas.openxmlformats.org/drawingml/2006/main"/>
           <a:p xmlns:a="http://schemas.openxmlformats.org/drawingml/2006/main">
             <a:r>
-              <a:t>Normal fields have E from 1 through 6 in this toy format. The all-ones exponent is reserved for infinities/NaNs in IEEE-style formats. We are using the lecture's normal/subnormal equations and a toy format with bias 3. Avoid saying the bias always equals 2^(k−1)−1; the planned exercise supplies it explicitly.</a:t>
+              <a:t>State the notation before either formula: this deck uses E for the stored unsigned field and e for the unbiased true exponent. Thus decode e=E−bias; encode E=e+bias. A student may have seen E=e−bias where their E means true exponent. Both describe the same operation with different names. Normal fields have stored E from 1 through 6 in this toy format. E=0 is for zero/subnormals and E=7 is reserved. The planned homework supplies the bias explicitly.</a:t>
             </a:r>
           </a:p>
         </p:txBody>
@@ -1721,7 +1863,7 @@
           <a:lstStyle xmlns:a="http://schemas.openxmlformats.org/drawingml/2006/main"/>
           <a:p xmlns:a="http://schemas.openxmlformats.org/drawingml/2006/main">
             <a:r>
-              <a:t>This is the likely stumbling block: subnormals use exponent 1−bias, not 0−bias, and no hidden leading 1. For this format, F=0 gives zero, F=1 is 1/32, F=7 is 7/32, and the smallest normal is 1/4. Source: lecture 6 equations.</a:t>
+              <a:t>Pause before giving the subnormal rule. Ask: if E=1 is the smallest normal field, where could 1/8 go? A normal encoding would need true exponent −3 and stored E=0, but zero is reserved for a different rule. The next slide explains that rule using binary digits rather than a formula first. Source: lecture 6 normal and subnormal equations.</a:t>
             </a:r>
           </a:p>
         </p:txBody>
@@ -1791,7 +1933,7 @@
           <a:lstStyle xmlns:a="http://schemas.openxmlformats.org/drawingml/2006/main"/>
           <a:p xmlns:a="http://schemas.openxmlformats.org/drawingml/2006/main">
             <a:r>
-              <a:t>Contrast this with the normal 5/4 example. Students may try to store a negative exponent in E or include the hidden 1. Return to the formula to resolve both confusions.</a:t>
+              <a:t>Use the same scale before and after the boundary: 2^(1−bias)=2^-2. This is the key change: replace the normal hidden 1 with 0. Do not compute 0−bias for E=0. Ask students why 0.100 binary is 1/2, then multiply by 1/4 to get 1/8. Source: lecture 6 subnormal equation.</a:t>
             </a:r>
           </a:p>
         </p:txBody>
@@ -1859,7 +2001,7 @@
   </p:cSld>
   <p:clrMap bg1="lt1" tx1="dk1" bg2="lt2" tx2="dk2" accent1="accent1" accent2="accent2" accent3="accent3" accent4="accent4" accent5="accent5" accent6="accent6" hlink="hlink" folHlink="folHlink"/>
   <p:sldLayoutIdLst>
-    <p:sldLayoutId xmlns:r="http://schemas.openxmlformats.org/officeDocument/2006/relationships" id="2147483649" r:id="R9f6ca5ca0cc841de"/>
+    <p:sldLayoutId xmlns:r="http://schemas.openxmlformats.org/officeDocument/2006/relationships" id="2147483649" r:id="R2eed2ef29c5a483c"/>
   </p:sldLayoutIdLst>
   <p:txStyles>
     <p:titleStyle>
@@ -2873,7 +3015,7 @@
                 <a:ea typeface="Courier New"/>
                 <a:cs typeface="Courier New"/>
               </a:rPr>
-              <a:t>01 / 20</a:t>
+              <a:t>01 / 22</a:t>
             </a:r>
           </a:p>
         </p:txBody>
@@ -2960,7 +3102,7 @@
                 <a:ea typeface="Courier New"/>
                 <a:cs typeface="Courier New"/>
               </a:rPr>
-              <a:t>FLOATING POINT · SMALLEST VALUES</a:t>
+              <a:t>FLOATING POINT · PLACE VALUES</a:t>
             </a:r>
           </a:p>
         </p:txBody>
@@ -3018,7 +3160,7 @@
                 <a:ea typeface="Arial"/>
                 <a:cs typeface="Arial"/>
               </a:rPr>
-              <a:t>The normal–subnormal boundary</a:t>
+              <a:t>Subnormals count in steps of 1/32</a:t>
             </a:r>
           </a:p>
         </p:txBody>
@@ -3076,7 +3218,7 @@
                 <a:ea typeface="Arial"/>
                 <a:cs typeface="Arial"/>
               </a:rPr>
-              <a:t>The largest subnormal sits directly below the smallest normal. The exponent stays at −2 across this boundary, but the implied leading 1 appears only for the normal value.</a:t>
+              <a:t>The three stored fraction bits make 0.FFF₂ increase by 1/8 each time. Multiplying by the fixed 2⁻² scale makes each step 1/32. So the field value F counts steps of 1/32.</a:t>
             </a:r>
           </a:p>
         </p:txBody>
@@ -3134,7 +3276,7 @@
                 <a:ea typeface="Courier New"/>
                 <a:cs typeface="Courier New"/>
               </a:rPr>
-              <a:t>Largest subnormal: E=0, F=7</a:t>
+              <a:t>F     bits     value</a:t>
             </a:r>
           </a:p>
           <a:p xmlns:a="http://schemas.openxmlformats.org/drawingml/2006/main">
@@ -3158,7 +3300,78 @@
                 <a:ea typeface="Courier New"/>
                 <a:cs typeface="Courier New"/>
               </a:rPr>
-              <a:t>value = 7/32</a:t>
+              <a:t>0     000      0/32</a:t>
+            </a:r>
+          </a:p>
+          <a:p xmlns:a="http://schemas.openxmlformats.org/drawingml/2006/main">
+            <a:pPr>
+              <a:defRPr sz="1650">
+                <a:solidFill>
+                  <a:srgbClr val="A7F3D0"/>
+                </a:solidFill>
+                <a:latin typeface="Courier New"/>
+                <a:ea typeface="Courier New"/>
+                <a:cs typeface="Courier New"/>
+              </a:defRPr>
+            </a:pPr>
+            <a:r>
+              <a:rPr sz="1650">
+                <a:solidFill>
+                  <a:srgbClr val="A7F3D0"/>
+                </a:solidFill>
+                <a:latin typeface="Courier New"/>
+                <a:ea typeface="Courier New"/>
+                <a:cs typeface="Courier New"/>
+              </a:rPr>
+              <a:t>1     001      1/32</a:t>
+            </a:r>
+          </a:p>
+          <a:p xmlns:a="http://schemas.openxmlformats.org/drawingml/2006/main">
+            <a:pPr>
+              <a:buNone/>
+              <a:defRPr sz="1650" b="0">
+                <a:solidFill>
+                  <a:srgbClr val="A7F3D0"/>
+                </a:solidFill>
+                <a:latin typeface="Courier New"/>
+                <a:ea typeface="Courier New"/>
+                <a:cs typeface="Courier New"/>
+              </a:defRPr>
+            </a:pPr>
+            <a:r>
+              <a:rPr sz="1650" b="0">
+                <a:solidFill>
+                  <a:srgbClr val="A7F3D0"/>
+                </a:solidFill>
+                <a:latin typeface="Courier New"/>
+                <a:ea typeface="Courier New"/>
+                <a:cs typeface="Courier New"/>
+              </a:rPr>
+              <a:t>4     100      4/32 = 1/8</a:t>
+            </a:r>
+          </a:p>
+          <a:p xmlns:a="http://schemas.openxmlformats.org/drawingml/2006/main">
+            <a:pPr>
+              <a:buNone/>
+              <a:defRPr sz="1650" b="0">
+                <a:solidFill>
+                  <a:srgbClr val="A7F3D0"/>
+                </a:solidFill>
+                <a:latin typeface="Courier New"/>
+                <a:ea typeface="Courier New"/>
+                <a:cs typeface="Courier New"/>
+              </a:defRPr>
+            </a:pPr>
+            <a:r>
+              <a:rPr sz="1650" b="0">
+                <a:solidFill>
+                  <a:srgbClr val="A7F3D0"/>
+                </a:solidFill>
+                <a:latin typeface="Courier New"/>
+                <a:ea typeface="Courier New"/>
+                <a:cs typeface="Courier New"/>
+              </a:rPr>
+              <a:t>7     111      7/32</a:t>
             </a:r>
           </a:p>
           <a:p xmlns:a="http://schemas.openxmlformats.org/drawingml/2006/main">
@@ -3187,60 +3400,7 @@
                 <a:ea typeface="Courier New"/>
                 <a:cs typeface="Courier New"/>
               </a:rPr>
-              <a:t>Smallest normal: E=1, F=0</a:t>
-            </a:r>
-          </a:p>
-          <a:p xmlns:a="http://schemas.openxmlformats.org/drawingml/2006/main">
-            <a:pPr>
-              <a:buNone/>
-              <a:defRPr sz="1650" b="0">
-                <a:solidFill>
-                  <a:srgbClr val="A7F3D0"/>
-                </a:solidFill>
-                <a:latin typeface="Courier New"/>
-                <a:ea typeface="Courier New"/>
-                <a:cs typeface="Courier New"/>
-              </a:defRPr>
-            </a:pPr>
-            <a:r>
-              <a:rPr sz="1650" b="0">
-                <a:solidFill>
-                  <a:srgbClr val="A7F3D0"/>
-                </a:solidFill>
-                <a:latin typeface="Courier New"/>
-                <a:ea typeface="Courier New"/>
-                <a:cs typeface="Courier New"/>
-              </a:rPr>
-              <a:t>value = 1/4 = 8/32</a:t>
-            </a:r>
-          </a:p>
-          <a:p xmlns:a="http://schemas.openxmlformats.org/drawingml/2006/main">
-            <a:r>
-              <a:t/>
-            </a:r>
-          </a:p>
-          <a:p xmlns:a="http://schemas.openxmlformats.org/drawingml/2006/main">
-            <a:pPr>
-              <a:buNone/>
-              <a:defRPr sz="1650" b="0">
-                <a:solidFill>
-                  <a:srgbClr val="A7F3D0"/>
-                </a:solidFill>
-                <a:latin typeface="Courier New"/>
-                <a:ea typeface="Courier New"/>
-                <a:cs typeface="Courier New"/>
-              </a:defRPr>
-            </a:pPr>
-            <a:r>
-              <a:rPr sz="1650" b="0">
-                <a:solidFill>
-                  <a:srgbClr val="A7F3D0"/>
-                </a:solidFill>
-                <a:latin typeface="Courier New"/>
-                <a:ea typeface="Courier New"/>
-                <a:cs typeface="Courier New"/>
-              </a:rPr>
-              <a:t>Gap = 1/32</a:t>
+              <a:t>Subnormal value = F/32</a:t>
             </a:r>
           </a:p>
         </p:txBody>
@@ -3298,7 +3458,7 @@
                 <a:ea typeface="Arial"/>
                 <a:cs typeface="Arial"/>
               </a:rPr>
-              <a:t>Subnormals fill the gap between zero and the smallest normal.</a:t>
+              <a:t>Ask: what is the next value after 7/32?</a:t>
             </a:r>
           </a:p>
         </p:txBody>
@@ -3356,7 +3516,7 @@
                 <a:ea typeface="Courier New"/>
                 <a:cs typeface="Courier New"/>
               </a:rPr>
-              <a:t>10 / 20</a:t>
+              <a:t>10 / 22</a:t>
             </a:r>
           </a:p>
         </p:txBody>
@@ -3395,7 +3555,7 @@
           <p:cNvPr id="7" name="">
             <a:extLst xmlns:a="http://schemas.openxmlformats.org/drawingml/2006/main">
               <a:ext uri="{FF2B5EF4-FFF2-40B4-BE49-F238E27FC236}">
-                <a16:creationId xmlns:a16="http://schemas.microsoft.com/office/drawing/2014/main" id="{ED6F0A3D-C361-4FA6-9CFE-2E669E0D919F}"/>
+                <a16:creationId xmlns:a16="http://schemas.microsoft.com/office/drawing/2014/main" id="{0E1C1D56-F3B0-4FC7-8312-5DCE66DE8296}"/>
               </a:ext>
             </a:extLst>
           </p:cNvPr>
@@ -3443,7 +3603,7 @@
                 <a:ea typeface="Courier New"/>
                 <a:cs typeface="Courier New"/>
               </a:rPr>
-              <a:t>FLOATING POINT · PRACTICE</a:t>
+              <a:t>FLOATING POINT · WORKED EXAMPLE</a:t>
             </a:r>
           </a:p>
         </p:txBody>
@@ -3453,7 +3613,7 @@
           <p:cNvPr id="2" name="">
             <a:extLst xmlns:a="http://schemas.openxmlformats.org/drawingml/2006/main">
               <a:ext uri="{FF2B5EF4-FFF2-40B4-BE49-F238E27FC236}">
-                <a16:creationId xmlns:a16="http://schemas.microsoft.com/office/drawing/2014/main" id="{8531682B-A598-4D48-84FE-CD10468FEB1D}"/>
+                <a16:creationId xmlns:a16="http://schemas.microsoft.com/office/drawing/2014/main" id="{47EC4111-990D-4F27-A48D-9B66E8564E29}"/>
               </a:ext>
             </a:extLst>
           </p:cNvPr>
@@ -3501,7 +3661,7 @@
                 <a:ea typeface="Arial"/>
                 <a:cs typeface="Arial"/>
               </a:rPr>
-              <a:t>Your turn: decode two patterns</a:t>
+              <a:t>Encode a subnormal: 1/8</a:t>
             </a:r>
           </a:p>
         </p:txBody>
@@ -3511,7 +3671,7 @@
           <p:cNvPr id="3" name="">
             <a:extLst xmlns:a="http://schemas.openxmlformats.org/drawingml/2006/main">
               <a:ext uri="{FF2B5EF4-FFF2-40B4-BE49-F238E27FC236}">
-                <a16:creationId xmlns:a16="http://schemas.microsoft.com/office/drawing/2014/main" id="{7C4976BE-C2D5-4F13-B1DA-E2F9D2612B6A}"/>
+                <a16:creationId xmlns:a16="http://schemas.microsoft.com/office/drawing/2014/main" id="{EA7FC2C0-68E4-440B-B218-A53A78DE1183}"/>
               </a:ext>
             </a:extLst>
           </p:cNvPr>
@@ -3559,36 +3719,7 @@
                 <a:ea typeface="Arial"/>
                 <a:cs typeface="Arial"/>
               </a:rPr>
-              <a:t>Use the same format: 3 exponent bits, bias 3, and 3 fraction bits.</a:t>
-            </a:r>
-          </a:p>
-          <a:p xmlns:a="http://schemas.openxmlformats.org/drawingml/2006/main">
-            <a:r>
-              <a:t/>
-            </a:r>
-          </a:p>
-          <a:p xmlns:a="http://schemas.openxmlformats.org/drawingml/2006/main">
-            <a:pPr>
-              <a:buNone/>
-              <a:defRPr sz="1950" b="0">
-                <a:solidFill>
-                  <a:srgbClr val="D4D4D8"/>
-                </a:solidFill>
-                <a:latin typeface="Arial"/>
-                <a:ea typeface="Arial"/>
-                <a:cs typeface="Arial"/>
-              </a:defRPr>
-            </a:pPr>
-            <a:r>
-              <a:rPr sz="1950" b="0">
-                <a:solidFill>
-                  <a:srgbClr val="D4D4D8"/>
-                </a:solidFill>
-                <a:latin typeface="Arial"/>
-                <a:ea typeface="Arial"/>
-                <a:cs typeface="Arial"/>
-              </a:rPr>
-              <a:t>For each pattern, classify it, find E and F, then calculate the value.</a:t>
+              <a:t>1/8 is below the smallest normal, 1/4, so E = 0. A subnormal here is worth F/32. Solve F/32 = 1/8: F = 4, which is 100₂ in three bits.</a:t>
             </a:r>
           </a:p>
         </p:txBody>
@@ -3598,7 +3729,7 @@
           <p:cNvPr id="4" name="">
             <a:extLst xmlns:a="http://schemas.openxmlformats.org/drawingml/2006/main">
               <a:ext uri="{FF2B5EF4-FFF2-40B4-BE49-F238E27FC236}">
-                <a16:creationId xmlns:a16="http://schemas.microsoft.com/office/drawing/2014/main" id="{97877AB9-DA81-4CB4-8D40-AAADEA86261B}"/>
+                <a16:creationId xmlns:a16="http://schemas.microsoft.com/office/drawing/2014/main" id="{C7B97746-2F05-4C79-997B-46EF673FF248}"/>
               </a:ext>
             </a:extLst>
           </p:cNvPr>
@@ -3646,7 +3777,7 @@
                 <a:ea typeface="Courier New"/>
                 <a:cs typeface="Courier New"/>
               </a:rPr>
-              <a:t>A. 0 | 010 | 100</a:t>
+              <a:t>S = 0</a:t>
             </a:r>
           </a:p>
           <a:p xmlns:a="http://schemas.openxmlformats.org/drawingml/2006/main">
@@ -3670,7 +3801,7 @@
                 <a:ea typeface="Courier New"/>
                 <a:cs typeface="Courier New"/>
               </a:rPr>
-              <a:t>   normal or subnormal?</a:t>
+              <a:t>E = 0 = 000₂</a:t>
             </a:r>
           </a:p>
           <a:p xmlns:a="http://schemas.openxmlformats.org/drawingml/2006/main">
@@ -3694,7 +3825,7 @@
                 <a:ea typeface="Courier New"/>
                 <a:cs typeface="Courier New"/>
               </a:rPr>
-              <a:t>   value = ?</a:t>
+              <a:t>F = 4 = 100₂</a:t>
             </a:r>
           </a:p>
           <a:p xmlns:a="http://schemas.openxmlformats.org/drawingml/2006/main">
@@ -3723,7 +3854,12 @@
                 <a:ea typeface="Courier New"/>
                 <a:cs typeface="Courier New"/>
               </a:rPr>
-              <a:t>B. 0 | 000 | 011</a:t>
+              <a:t>Fields: 0 | 000 | 100</a:t>
+            </a:r>
+          </a:p>
+          <a:p xmlns:a="http://schemas.openxmlformats.org/drawingml/2006/main">
+            <a:r>
+              <a:t/>
             </a:r>
           </a:p>
           <a:p xmlns:a="http://schemas.openxmlformats.org/drawingml/2006/main">
@@ -3747,31 +3883,7 @@
                 <a:ea typeface="Courier New"/>
                 <a:cs typeface="Courier New"/>
               </a:rPr>
-              <a:t>   normal or subnormal?</a:t>
-            </a:r>
-          </a:p>
-          <a:p xmlns:a="http://schemas.openxmlformats.org/drawingml/2006/main">
-            <a:pPr>
-              <a:buNone/>
-              <a:defRPr sz="1650" b="0">
-                <a:solidFill>
-                  <a:srgbClr val="A7F3D0"/>
-                </a:solidFill>
-                <a:latin typeface="Courier New"/>
-                <a:ea typeface="Courier New"/>
-                <a:cs typeface="Courier New"/>
-              </a:defRPr>
-            </a:pPr>
-            <a:r>
-              <a:rPr sz="1650" b="0">
-                <a:solidFill>
-                  <a:srgbClr val="A7F3D0"/>
-                </a:solidFill>
-                <a:latin typeface="Courier New"/>
-                <a:ea typeface="Courier New"/>
-                <a:cs typeface="Courier New"/>
-              </a:rPr>
-              <a:t>   value = ?</a:t>
+              <a:t>Check: 4/32 = 1/8</a:t>
             </a:r>
           </a:p>
         </p:txBody>
@@ -3781,7 +3893,7 @@
           <p:cNvPr id="5" name="">
             <a:extLst xmlns:a="http://schemas.openxmlformats.org/drawingml/2006/main">
               <a:ext uri="{FF2B5EF4-FFF2-40B4-BE49-F238E27FC236}">
-                <a16:creationId xmlns:a16="http://schemas.microsoft.com/office/drawing/2014/main" id="{0C768E93-B810-439B-9ECE-DACDD6255183}"/>
+                <a16:creationId xmlns:a16="http://schemas.microsoft.com/office/drawing/2014/main" id="{C953FAB2-7571-49A3-B6C8-87F90FA9D556}"/>
               </a:ext>
             </a:extLst>
           </p:cNvPr>
@@ -3829,7 +3941,7 @@
                 <a:ea typeface="Arial"/>
                 <a:cs typeface="Arial"/>
               </a:rPr>
-              <a:t>Check E first: it selects the equation.</a:t>
+              <a:t>No hidden 1: read the significand as 0.100₂.</a:t>
             </a:r>
           </a:p>
         </p:txBody>
@@ -3839,7 +3951,7 @@
           <p:cNvPr id="6" name="">
             <a:extLst xmlns:a="http://schemas.openxmlformats.org/drawingml/2006/main">
               <a:ext uri="{FF2B5EF4-FFF2-40B4-BE49-F238E27FC236}">
-                <a16:creationId xmlns:a16="http://schemas.microsoft.com/office/drawing/2014/main" id="{4E485357-E888-4A45-92E1-47CDEA8A71B2}"/>
+                <a16:creationId xmlns:a16="http://schemas.microsoft.com/office/drawing/2014/main" id="{ECE7F5E9-2417-44C6-925E-4767F90FA696}"/>
               </a:ext>
             </a:extLst>
           </p:cNvPr>
@@ -3887,7 +3999,7 @@
                 <a:ea typeface="Courier New"/>
                 <a:cs typeface="Courier New"/>
               </a:rPr>
-              <a:t>11 / 20</a:t>
+              <a:t>11 / 22</a:t>
             </a:r>
           </a:p>
         </p:txBody>
@@ -3895,7 +4007,7 @@
     </p:spTree>
     <p:extLst>
       <p:ext uri="{BB962C8B-B14F-4D97-AF65-F5344CB8AC3E}">
-        <p14:creationId xmlns:p14="http://schemas.microsoft.com/office/powerpoint/2010/main" val="1507595076"/>
+        <p14:creationId xmlns:p14="http://schemas.microsoft.com/office/powerpoint/2010/main" val="1082036242"/>
       </p:ext>
     </p:extLst>
   </p:cSld>
@@ -3926,7 +4038,7 @@
           <p:cNvPr id="7" name="">
             <a:extLst xmlns:a="http://schemas.openxmlformats.org/drawingml/2006/main">
               <a:ext uri="{FF2B5EF4-FFF2-40B4-BE49-F238E27FC236}">
-                <a16:creationId xmlns:a16="http://schemas.microsoft.com/office/drawing/2014/main" id="{7AC5D697-73A9-4130-AF88-3B9A153D538D}"/>
+                <a16:creationId xmlns:a16="http://schemas.microsoft.com/office/drawing/2014/main" id="{DF65E5C3-C59B-4F4C-8123-D26BB20B62FC}"/>
               </a:ext>
             </a:extLst>
           </p:cNvPr>
@@ -3974,7 +4086,7 @@
                 <a:ea typeface="Courier New"/>
                 <a:cs typeface="Courier New"/>
               </a:rPr>
-              <a:t>FLOATING POINT · CHECK</a:t>
+              <a:t>FLOATING POINT · BOUNDARY</a:t>
             </a:r>
           </a:p>
         </p:txBody>
@@ -3984,7 +4096,7 @@
           <p:cNvPr id="2" name="">
             <a:extLst xmlns:a="http://schemas.openxmlformats.org/drawingml/2006/main">
               <a:ext uri="{FF2B5EF4-FFF2-40B4-BE49-F238E27FC236}">
-                <a16:creationId xmlns:a16="http://schemas.microsoft.com/office/drawing/2014/main" id="{1059792B-54CD-4C1F-8A87-49C3F494D2AD}"/>
+                <a16:creationId xmlns:a16="http://schemas.microsoft.com/office/drawing/2014/main" id="{AAF148DA-667A-4F17-8947-3A10B5D66209}"/>
               </a:ext>
             </a:extLst>
           </p:cNvPr>
@@ -4032,7 +4144,7 @@
                 <a:ea typeface="Arial"/>
                 <a:cs typeface="Arial"/>
               </a:rPr>
-              <a:t>Decode answers</a:t>
+              <a:t>The next normal is one step away</a:t>
             </a:r>
           </a:p>
         </p:txBody>
@@ -4042,7 +4154,7 @@
           <p:cNvPr id="3" name="">
             <a:extLst xmlns:a="http://schemas.openxmlformats.org/drawingml/2006/main">
               <a:ext uri="{FF2B5EF4-FFF2-40B4-BE49-F238E27FC236}">
-                <a16:creationId xmlns:a16="http://schemas.microsoft.com/office/drawing/2014/main" id="{26F3E9C7-6AC5-4E40-B664-B323C1BA5CEA}"/>
+                <a16:creationId xmlns:a16="http://schemas.microsoft.com/office/drawing/2014/main" id="{9CBE9A2B-E617-4407-BF21-6D1C10DB5F7C}"/>
               </a:ext>
             </a:extLst>
           </p:cNvPr>
@@ -4090,36 +4202,7 @@
                 <a:ea typeface="Arial"/>
                 <a:cs typeface="Arial"/>
               </a:rPr>
-              <a:t>A uses the normal equation because E = 2.</a:t>
-            </a:r>
-          </a:p>
-          <a:p xmlns:a="http://schemas.openxmlformats.org/drawingml/2006/main">
-            <a:r>
-              <a:t/>
-            </a:r>
-          </a:p>
-          <a:p xmlns:a="http://schemas.openxmlformats.org/drawingml/2006/main">
-            <a:pPr>
-              <a:buNone/>
-              <a:defRPr sz="1950" b="0">
-                <a:solidFill>
-                  <a:srgbClr val="D4D4D8"/>
-                </a:solidFill>
-                <a:latin typeface="Arial"/>
-                <a:ea typeface="Arial"/>
-                <a:cs typeface="Arial"/>
-              </a:defRPr>
-            </a:pPr>
-            <a:r>
-              <a:rPr sz="1950" b="0">
-                <a:solidFill>
-                  <a:srgbClr val="D4D4D8"/>
-                </a:solidFill>
-                <a:latin typeface="Arial"/>
-                <a:ea typeface="Arial"/>
-                <a:cs typeface="Arial"/>
-              </a:rPr>
-              <a:t>B uses the subnormal equation because E = 0; there is no implied leading 1.</a:t>
+              <a:t>The largest subnormal is 7/32. The smallest normal is 8/32. Both use the 2⁻² scale; the implied leading digit changes from 0 to 1 when E changes from 0 to 1.</a:t>
             </a:r>
           </a:p>
         </p:txBody>
@@ -4129,7 +4212,7 @@
           <p:cNvPr id="4" name="">
             <a:extLst xmlns:a="http://schemas.openxmlformats.org/drawingml/2006/main">
               <a:ext uri="{FF2B5EF4-FFF2-40B4-BE49-F238E27FC236}">
-                <a16:creationId xmlns:a16="http://schemas.microsoft.com/office/drawing/2014/main" id="{737C1F1B-87F6-43C2-BCA8-B1C729031D72}"/>
+                <a16:creationId xmlns:a16="http://schemas.microsoft.com/office/drawing/2014/main" id="{F24EA955-1341-477F-B9E0-1F67FB906026}"/>
               </a:ext>
             </a:extLst>
           </p:cNvPr>
@@ -4177,7 +4260,7 @@
                 <a:ea typeface="Courier New"/>
                 <a:cs typeface="Courier New"/>
               </a:rPr>
-              <a:t>A. 0 | 010 | 100</a:t>
+              <a:t>E = 0, F = 111₂</a:t>
             </a:r>
           </a:p>
           <a:p xmlns:a="http://schemas.openxmlformats.org/drawingml/2006/main">
@@ -4201,7 +4284,7 @@
                 <a:ea typeface="Courier New"/>
                 <a:cs typeface="Courier New"/>
               </a:rPr>
-              <a:t>   (1 + 4/8) × 2⁻¹ = 3/4</a:t>
+              <a:t>0.111₂ × 2⁻² = 7/32</a:t>
             </a:r>
           </a:p>
           <a:p xmlns:a="http://schemas.openxmlformats.org/drawingml/2006/main">
@@ -4230,7 +4313,7 @@
                 <a:ea typeface="Courier New"/>
                 <a:cs typeface="Courier New"/>
               </a:rPr>
-              <a:t>B. 0 | 000 | 011</a:t>
+              <a:t>E = 1, F = 000₂</a:t>
             </a:r>
           </a:p>
           <a:p xmlns:a="http://schemas.openxmlformats.org/drawingml/2006/main">
@@ -4254,7 +4337,36 @@
                 <a:ea typeface="Courier New"/>
                 <a:cs typeface="Courier New"/>
               </a:rPr>
-              <a:t>   (3/8) × 2⁻² = 3/32</a:t>
+              <a:t>1.000₂ × 2⁻² = 8/32</a:t>
+            </a:r>
+          </a:p>
+          <a:p xmlns:a="http://schemas.openxmlformats.org/drawingml/2006/main">
+            <a:r>
+              <a:t/>
+            </a:r>
+          </a:p>
+          <a:p xmlns:a="http://schemas.openxmlformats.org/drawingml/2006/main">
+            <a:pPr>
+              <a:buNone/>
+              <a:defRPr sz="1650" b="0">
+                <a:solidFill>
+                  <a:srgbClr val="A7F3D0"/>
+                </a:solidFill>
+                <a:latin typeface="Courier New"/>
+                <a:ea typeface="Courier New"/>
+                <a:cs typeface="Courier New"/>
+              </a:defRPr>
+            </a:pPr>
+            <a:r>
+              <a:rPr sz="1650" b="0">
+                <a:solidFill>
+                  <a:srgbClr val="A7F3D0"/>
+                </a:solidFill>
+                <a:latin typeface="Courier New"/>
+                <a:ea typeface="Courier New"/>
+                <a:cs typeface="Courier New"/>
+              </a:rPr>
+              <a:t>Gap = 1/32</a:t>
             </a:r>
           </a:p>
         </p:txBody>
@@ -4264,7 +4376,7 @@
           <p:cNvPr id="5" name="">
             <a:extLst xmlns:a="http://schemas.openxmlformats.org/drawingml/2006/main">
               <a:ext uri="{FF2B5EF4-FFF2-40B4-BE49-F238E27FC236}">
-                <a16:creationId xmlns:a16="http://schemas.microsoft.com/office/drawing/2014/main" id="{9DAD2664-9B32-4402-A088-C1DEBD68E3CD}"/>
+                <a16:creationId xmlns:a16="http://schemas.microsoft.com/office/drawing/2014/main" id="{E8B59BBF-C1FE-4848-A1BE-0E49C6150211}"/>
               </a:ext>
             </a:extLst>
           </p:cNvPr>
@@ -4312,7 +4424,7 @@
                 <a:ea typeface="Arial"/>
                 <a:cs typeface="Arial"/>
               </a:rPr>
-              <a:t>If the answer seems surprising, decode the same fields back into the formula.</a:t>
+              <a:t>Subnormal values fill the space between zero and 1/4.</a:t>
             </a:r>
           </a:p>
         </p:txBody>
@@ -4322,7 +4434,7 @@
           <p:cNvPr id="6" name="">
             <a:extLst xmlns:a="http://schemas.openxmlformats.org/drawingml/2006/main">
               <a:ext uri="{FF2B5EF4-FFF2-40B4-BE49-F238E27FC236}">
-                <a16:creationId xmlns:a16="http://schemas.microsoft.com/office/drawing/2014/main" id="{DBE61FAB-FD81-4893-85F8-90700B31187C}"/>
+                <a16:creationId xmlns:a16="http://schemas.microsoft.com/office/drawing/2014/main" id="{C1D8CDEF-F520-47D3-A60F-E6AFCB834AE6}"/>
               </a:ext>
             </a:extLst>
           </p:cNvPr>
@@ -4370,7 +4482,7 @@
                 <a:ea typeface="Courier New"/>
                 <a:cs typeface="Courier New"/>
               </a:rPr>
-              <a:t>12 / 20</a:t>
+              <a:t>12 / 22</a:t>
             </a:r>
           </a:p>
         </p:txBody>
@@ -4378,7 +4490,7 @@
     </p:spTree>
     <p:extLst>
       <p:ext uri="{BB962C8B-B14F-4D97-AF65-F5344CB8AC3E}">
-        <p14:creationId xmlns:p14="http://schemas.microsoft.com/office/powerpoint/2010/main" val="1502731382"/>
+        <p14:creationId xmlns:p14="http://schemas.microsoft.com/office/powerpoint/2010/main" val="1006218793"/>
       </p:ext>
     </p:extLst>
   </p:cSld>
@@ -4409,7 +4521,7 @@
           <p:cNvPr id="7" name="">
             <a:extLst xmlns:a="http://schemas.openxmlformats.org/drawingml/2006/main">
               <a:ext uri="{FF2B5EF4-FFF2-40B4-BE49-F238E27FC236}">
-                <a16:creationId xmlns:a16="http://schemas.microsoft.com/office/drawing/2014/main" id="{35A724E8-02D1-4C78-A9D3-AE6AD6E2D594}"/>
+                <a16:creationId xmlns:a16="http://schemas.microsoft.com/office/drawing/2014/main" id="{ED6F0A3D-C361-4FA6-9CFE-2E669E0D919F}"/>
               </a:ext>
             </a:extLst>
           </p:cNvPr>
@@ -4467,7 +4579,7 @@
           <p:cNvPr id="2" name="">
             <a:extLst xmlns:a="http://schemas.openxmlformats.org/drawingml/2006/main">
               <a:ext uri="{FF2B5EF4-FFF2-40B4-BE49-F238E27FC236}">
-                <a16:creationId xmlns:a16="http://schemas.microsoft.com/office/drawing/2014/main" id="{D68140D5-AD40-4B2D-9276-45B94835A98B}"/>
+                <a16:creationId xmlns:a16="http://schemas.microsoft.com/office/drawing/2014/main" id="{8531682B-A598-4D48-84FE-CD10468FEB1D}"/>
               </a:ext>
             </a:extLst>
           </p:cNvPr>
@@ -4515,7 +4627,7 @@
                 <a:ea typeface="Arial"/>
                 <a:cs typeface="Arial"/>
               </a:rPr>
-              <a:t>Your turn: classify two ratios</a:t>
+              <a:t>Your turn: decode two patterns</a:t>
             </a:r>
           </a:p>
         </p:txBody>
@@ -4525,7 +4637,7 @@
           <p:cNvPr id="3" name="">
             <a:extLst xmlns:a="http://schemas.openxmlformats.org/drawingml/2006/main">
               <a:ext uri="{FF2B5EF4-FFF2-40B4-BE49-F238E27FC236}">
-                <a16:creationId xmlns:a16="http://schemas.microsoft.com/office/drawing/2014/main" id="{AA9609DC-0513-451F-B1A4-CD75618D8A9F}"/>
+                <a16:creationId xmlns:a16="http://schemas.microsoft.com/office/drawing/2014/main" id="{7C4976BE-C2D5-4F13-B1DA-E2F9D2612B6A}"/>
               </a:ext>
             </a:extLst>
           </p:cNvPr>
@@ -4573,7 +4685,7 @@
                 <a:ea typeface="Arial"/>
                 <a:cs typeface="Arial"/>
               </a:rPr>
-              <a:t>Use the same practice format: 3 exponent bits, bias 3, and 3 fraction bits.</a:t>
+              <a:t>Use the same format: 3 exponent bits, bias 3, and 3 fraction bits.</a:t>
             </a:r>
           </a:p>
           <a:p xmlns:a="http://schemas.openxmlformats.org/drawingml/2006/main">
@@ -4602,7 +4714,7 @@
                 <a:ea typeface="Arial"/>
                 <a:cs typeface="Arial"/>
               </a:rPr>
-              <a:t>For each ratio, decide normal or subnormal, then find E and F.</a:t>
+              <a:t>For each pattern, classify it, find E and F, then calculate the value.</a:t>
             </a:r>
           </a:p>
         </p:txBody>
@@ -4612,7 +4724,7 @@
           <p:cNvPr id="4" name="">
             <a:extLst xmlns:a="http://schemas.openxmlformats.org/drawingml/2006/main">
               <a:ext uri="{FF2B5EF4-FFF2-40B4-BE49-F238E27FC236}">
-                <a16:creationId xmlns:a16="http://schemas.microsoft.com/office/drawing/2014/main" id="{37A2E272-B675-4F8B-8D9A-1DD0C7D3E885}"/>
+                <a16:creationId xmlns:a16="http://schemas.microsoft.com/office/drawing/2014/main" id="{97877AB9-DA81-4CB4-8D40-AAADEA86261B}"/>
               </a:ext>
             </a:extLst>
           </p:cNvPr>
@@ -4660,7 +4772,7 @@
                 <a:ea typeface="Courier New"/>
                 <a:cs typeface="Courier New"/>
               </a:rPr>
-              <a:t>A. 3/2</a:t>
+              <a:t>A. 0 | 010 | 100</a:t>
             </a:r>
           </a:p>
           <a:p xmlns:a="http://schemas.openxmlformats.org/drawingml/2006/main">
@@ -4708,7 +4820,7 @@
                 <a:ea typeface="Courier New"/>
                 <a:cs typeface="Courier New"/>
               </a:rPr>
-              <a:t>   E = ?   F = ?</a:t>
+              <a:t>   value = ?</a:t>
             </a:r>
           </a:p>
           <a:p xmlns:a="http://schemas.openxmlformats.org/drawingml/2006/main">
@@ -4737,7 +4849,7 @@
                 <a:ea typeface="Courier New"/>
                 <a:cs typeface="Courier New"/>
               </a:rPr>
-              <a:t>B. 3/16</a:t>
+              <a:t>B. 0 | 000 | 011</a:t>
             </a:r>
           </a:p>
           <a:p xmlns:a="http://schemas.openxmlformats.org/drawingml/2006/main">
@@ -4785,7 +4897,7 @@
                 <a:ea typeface="Courier New"/>
                 <a:cs typeface="Courier New"/>
               </a:rPr>
-              <a:t>   E = ?   F = ?</a:t>
+              <a:t>   value = ?</a:t>
             </a:r>
           </a:p>
         </p:txBody>
@@ -4795,7 +4907,7 @@
           <p:cNvPr id="5" name="">
             <a:extLst xmlns:a="http://schemas.openxmlformats.org/drawingml/2006/main">
               <a:ext uri="{FF2B5EF4-FFF2-40B4-BE49-F238E27FC236}">
-                <a16:creationId xmlns:a16="http://schemas.microsoft.com/office/drawing/2014/main" id="{8F900304-F8E7-4C1C-B3A0-F1A0DD604211}"/>
+                <a16:creationId xmlns:a16="http://schemas.microsoft.com/office/drawing/2014/main" id="{0C768E93-B810-439B-9ECE-DACDD6255183}"/>
               </a:ext>
             </a:extLst>
           </p:cNvPr>
@@ -4843,7 +4955,7 @@
                 <a:ea typeface="Arial"/>
                 <a:cs typeface="Arial"/>
               </a:rPr>
-              <a:t>Compare each value with the smallest normal, 1/4, before finding bits.</a:t>
+              <a:t>If E = 0, count F steps of 1/32. Otherwise use the normal rule.</a:t>
             </a:r>
           </a:p>
         </p:txBody>
@@ -4853,7 +4965,7 @@
           <p:cNvPr id="6" name="">
             <a:extLst xmlns:a="http://schemas.openxmlformats.org/drawingml/2006/main">
               <a:ext uri="{FF2B5EF4-FFF2-40B4-BE49-F238E27FC236}">
-                <a16:creationId xmlns:a16="http://schemas.microsoft.com/office/drawing/2014/main" id="{16200DCD-0F16-4BE6-9538-9FDAF86C958E}"/>
+                <a16:creationId xmlns:a16="http://schemas.microsoft.com/office/drawing/2014/main" id="{4E485357-E888-4A45-92E1-47CDEA8A71B2}"/>
               </a:ext>
             </a:extLst>
           </p:cNvPr>
@@ -4901,7 +5013,7 @@
                 <a:ea typeface="Courier New"/>
                 <a:cs typeface="Courier New"/>
               </a:rPr>
-              <a:t>13 / 20</a:t>
+              <a:t>13 / 22</a:t>
             </a:r>
           </a:p>
         </p:txBody>
@@ -4909,7 +5021,7 @@
     </p:spTree>
     <p:extLst>
       <p:ext uri="{BB962C8B-B14F-4D97-AF65-F5344CB8AC3E}">
-        <p14:creationId xmlns:p14="http://schemas.microsoft.com/office/powerpoint/2010/main" val="2079659254"/>
+        <p14:creationId xmlns:p14="http://schemas.microsoft.com/office/powerpoint/2010/main" val="1507595076"/>
       </p:ext>
     </p:extLst>
   </p:cSld>
@@ -4940,7 +5052,7 @@
           <p:cNvPr id="7" name="">
             <a:extLst xmlns:a="http://schemas.openxmlformats.org/drawingml/2006/main">
               <a:ext uri="{FF2B5EF4-FFF2-40B4-BE49-F238E27FC236}">
-                <a16:creationId xmlns:a16="http://schemas.microsoft.com/office/drawing/2014/main" id="{D25A2A70-779E-4A39-9AD5-537DDE3C5B7A}"/>
+                <a16:creationId xmlns:a16="http://schemas.microsoft.com/office/drawing/2014/main" id="{7AC5D697-73A9-4130-AF88-3B9A153D538D}"/>
               </a:ext>
             </a:extLst>
           </p:cNvPr>
@@ -4998,7 +5110,7 @@
           <p:cNvPr id="2" name="">
             <a:extLst xmlns:a="http://schemas.openxmlformats.org/drawingml/2006/main">
               <a:ext uri="{FF2B5EF4-FFF2-40B4-BE49-F238E27FC236}">
-                <a16:creationId xmlns:a16="http://schemas.microsoft.com/office/drawing/2014/main" id="{2F2733A3-E106-4C90-B097-BE7CB4577892}"/>
+                <a16:creationId xmlns:a16="http://schemas.microsoft.com/office/drawing/2014/main" id="{1059792B-54CD-4C1F-8A87-49C3F494D2AD}"/>
               </a:ext>
             </a:extLst>
           </p:cNvPr>
@@ -5046,7 +5158,7 @@
                 <a:ea typeface="Arial"/>
                 <a:cs typeface="Arial"/>
               </a:rPr>
-              <a:t>Practice answers</a:t>
+              <a:t>Decode answers</a:t>
             </a:r>
           </a:p>
         </p:txBody>
@@ -5056,7 +5168,7 @@
           <p:cNvPr id="3" name="">
             <a:extLst xmlns:a="http://schemas.openxmlformats.org/drawingml/2006/main">
               <a:ext uri="{FF2B5EF4-FFF2-40B4-BE49-F238E27FC236}">
-                <a16:creationId xmlns:a16="http://schemas.microsoft.com/office/drawing/2014/main" id="{53BB6D32-B5C1-4BFB-8D41-7B7055B1A606}"/>
+                <a16:creationId xmlns:a16="http://schemas.microsoft.com/office/drawing/2014/main" id="{26F3E9C7-6AC5-4E40-B664-B323C1BA5CEA}"/>
               </a:ext>
             </a:extLst>
           </p:cNvPr>
@@ -5104,36 +5216,7 @@
                 <a:ea typeface="Arial"/>
                 <a:cs typeface="Arial"/>
               </a:rPr>
-              <a:t>3/2 = 1.100₂ × 2⁰, so it is normal.</a:t>
-            </a:r>
-          </a:p>
-          <a:p xmlns:a="http://schemas.openxmlformats.org/drawingml/2006/main">
-            <a:r>
-              <a:t/>
-            </a:r>
-          </a:p>
-          <a:p xmlns:a="http://schemas.openxmlformats.org/drawingml/2006/main">
-            <a:pPr>
-              <a:buNone/>
-              <a:defRPr sz="1950" b="0">
-                <a:solidFill>
-                  <a:srgbClr val="D4D4D8"/>
-                </a:solidFill>
-                <a:latin typeface="Arial"/>
-                <a:ea typeface="Arial"/>
-                <a:cs typeface="Arial"/>
-              </a:defRPr>
-            </a:pPr>
-            <a:r>
-              <a:rPr sz="1950" b="0">
-                <a:solidFill>
-                  <a:srgbClr val="D4D4D8"/>
-                </a:solidFill>
-                <a:latin typeface="Arial"/>
-                <a:ea typeface="Arial"/>
-                <a:cs typeface="Arial"/>
-              </a:rPr>
-              <a:t>3/16 is below 1/4, so it is subnormal. Since value = F/32, F = 6.</a:t>
+              <a:t>A has E = 2, so decode a normal value. B has E = 0, so its F = 3 means three steps of 1/32.</a:t>
             </a:r>
           </a:p>
         </p:txBody>
@@ -5143,7 +5226,7 @@
           <p:cNvPr id="4" name="">
             <a:extLst xmlns:a="http://schemas.openxmlformats.org/drawingml/2006/main">
               <a:ext uri="{FF2B5EF4-FFF2-40B4-BE49-F238E27FC236}">
-                <a16:creationId xmlns:a16="http://schemas.microsoft.com/office/drawing/2014/main" id="{CD85FA7D-EF72-4F2A-85B4-517634BC5BE7}"/>
+                <a16:creationId xmlns:a16="http://schemas.microsoft.com/office/drawing/2014/main" id="{737C1F1B-87F6-43C2-BCA8-B1C729031D72}"/>
               </a:ext>
             </a:extLst>
           </p:cNvPr>
@@ -5191,7 +5274,7 @@
                 <a:ea typeface="Courier New"/>
                 <a:cs typeface="Courier New"/>
               </a:rPr>
-              <a:t>A. 3/2</a:t>
+              <a:t>A. 0 | 010 | 100</a:t>
             </a:r>
           </a:p>
           <a:p xmlns:a="http://schemas.openxmlformats.org/drawingml/2006/main">
@@ -5215,7 +5298,12 @@
                 <a:ea typeface="Courier New"/>
                 <a:cs typeface="Courier New"/>
               </a:rPr>
-              <a:t>   E = 3 = 011₂</a:t>
+              <a:t>   (1 + 4/8) × 2⁻¹ = 3/4</a:t>
+            </a:r>
+          </a:p>
+          <a:p xmlns:a="http://schemas.openxmlformats.org/drawingml/2006/main">
+            <a:r>
+              <a:t/>
             </a:r>
           </a:p>
           <a:p xmlns:a="http://schemas.openxmlformats.org/drawingml/2006/main">
@@ -5239,7 +5327,7 @@
                 <a:ea typeface="Courier New"/>
                 <a:cs typeface="Courier New"/>
               </a:rPr>
-              <a:t>   F = 4 = 100₂</a:t>
+              <a:t>B. 0 | 000 | 011</a:t>
             </a:r>
           </a:p>
           <a:p xmlns:a="http://schemas.openxmlformats.org/drawingml/2006/main">
@@ -5263,108 +5351,7 @@
                 <a:ea typeface="Courier New"/>
                 <a:cs typeface="Courier New"/>
               </a:rPr>
-              <a:t>   Check: (1 + 4/8) × 1 = 3/2</a:t>
-            </a:r>
-          </a:p>
-          <a:p xmlns:a="http://schemas.openxmlformats.org/drawingml/2006/main">
-            <a:r>
-              <a:t/>
-            </a:r>
-          </a:p>
-          <a:p xmlns:a="http://schemas.openxmlformats.org/drawingml/2006/main">
-            <a:pPr>
-              <a:buNone/>
-              <a:defRPr sz="1650" b="0">
-                <a:solidFill>
-                  <a:srgbClr val="A7F3D0"/>
-                </a:solidFill>
-                <a:latin typeface="Courier New"/>
-                <a:ea typeface="Courier New"/>
-                <a:cs typeface="Courier New"/>
-              </a:defRPr>
-            </a:pPr>
-            <a:r>
-              <a:rPr sz="1650" b="0">
-                <a:solidFill>
-                  <a:srgbClr val="A7F3D0"/>
-                </a:solidFill>
-                <a:latin typeface="Courier New"/>
-                <a:ea typeface="Courier New"/>
-                <a:cs typeface="Courier New"/>
-              </a:rPr>
-              <a:t>B. 3/16</a:t>
-            </a:r>
-          </a:p>
-          <a:p xmlns:a="http://schemas.openxmlformats.org/drawingml/2006/main">
-            <a:pPr>
-              <a:buNone/>
-              <a:defRPr sz="1650" b="0">
-                <a:solidFill>
-                  <a:srgbClr val="A7F3D0"/>
-                </a:solidFill>
-                <a:latin typeface="Courier New"/>
-                <a:ea typeface="Courier New"/>
-                <a:cs typeface="Courier New"/>
-              </a:defRPr>
-            </a:pPr>
-            <a:r>
-              <a:rPr sz="1650" b="0">
-                <a:solidFill>
-                  <a:srgbClr val="A7F3D0"/>
-                </a:solidFill>
-                <a:latin typeface="Courier New"/>
-                <a:ea typeface="Courier New"/>
-                <a:cs typeface="Courier New"/>
-              </a:rPr>
-              <a:t>   E = 0 = 000₂</a:t>
-            </a:r>
-          </a:p>
-          <a:p xmlns:a="http://schemas.openxmlformats.org/drawingml/2006/main">
-            <a:pPr>
-              <a:buNone/>
-              <a:defRPr sz="1650" b="0">
-                <a:solidFill>
-                  <a:srgbClr val="A7F3D0"/>
-                </a:solidFill>
-                <a:latin typeface="Courier New"/>
-                <a:ea typeface="Courier New"/>
-                <a:cs typeface="Courier New"/>
-              </a:defRPr>
-            </a:pPr>
-            <a:r>
-              <a:rPr sz="1650" b="0">
-                <a:solidFill>
-                  <a:srgbClr val="A7F3D0"/>
-                </a:solidFill>
-                <a:latin typeface="Courier New"/>
-                <a:ea typeface="Courier New"/>
-                <a:cs typeface="Courier New"/>
-              </a:rPr>
-              <a:t>   F = 6 = 110₂</a:t>
-            </a:r>
-          </a:p>
-          <a:p xmlns:a="http://schemas.openxmlformats.org/drawingml/2006/main">
-            <a:pPr>
-              <a:buNone/>
-              <a:defRPr sz="1650" b="0">
-                <a:solidFill>
-                  <a:srgbClr val="A7F3D0"/>
-                </a:solidFill>
-                <a:latin typeface="Courier New"/>
-                <a:ea typeface="Courier New"/>
-                <a:cs typeface="Courier New"/>
-              </a:defRPr>
-            </a:pPr>
-            <a:r>
-              <a:rPr sz="1650" b="0">
-                <a:solidFill>
-                  <a:srgbClr val="A7F3D0"/>
-                </a:solidFill>
-                <a:latin typeface="Courier New"/>
-                <a:ea typeface="Courier New"/>
-                <a:cs typeface="Courier New"/>
-              </a:rPr>
-              <a:t>   Check: 6/32 = 3/16</a:t>
+              <a:t>   F = 3  →  3/32</a:t>
             </a:r>
           </a:p>
         </p:txBody>
@@ -5374,7 +5361,7 @@
           <p:cNvPr id="5" name="">
             <a:extLst xmlns:a="http://schemas.openxmlformats.org/drawingml/2006/main">
               <a:ext uri="{FF2B5EF4-FFF2-40B4-BE49-F238E27FC236}">
-                <a16:creationId xmlns:a16="http://schemas.microsoft.com/office/drawing/2014/main" id="{09DD94A5-8CF6-4CC6-9FAF-1AAE9F86C651}"/>
+                <a16:creationId xmlns:a16="http://schemas.microsoft.com/office/drawing/2014/main" id="{9DAD2664-9B32-4402-A088-C1DEBD68E3CD}"/>
               </a:ext>
             </a:extLst>
           </p:cNvPr>
@@ -5422,7 +5409,7 @@
                 <a:ea typeface="Arial"/>
                 <a:cs typeface="Arial"/>
               </a:rPr>
-              <a:t>A fraction can be exactly representable in one format and not another.</a:t>
+              <a:t>If the answer seems surprising, decode the same fields back into the formula.</a:t>
             </a:r>
           </a:p>
         </p:txBody>
@@ -5432,7 +5419,7 @@
           <p:cNvPr id="6" name="">
             <a:extLst xmlns:a="http://schemas.openxmlformats.org/drawingml/2006/main">
               <a:ext uri="{FF2B5EF4-FFF2-40B4-BE49-F238E27FC236}">
-                <a16:creationId xmlns:a16="http://schemas.microsoft.com/office/drawing/2014/main" id="{BEB8226B-AC16-4616-9E79-3B5C231B3962}"/>
+                <a16:creationId xmlns:a16="http://schemas.microsoft.com/office/drawing/2014/main" id="{DBE61FAB-FD81-4893-85F8-90700B31187C}"/>
               </a:ext>
             </a:extLst>
           </p:cNvPr>
@@ -5480,7 +5467,7 @@
                 <a:ea typeface="Courier New"/>
                 <a:cs typeface="Courier New"/>
               </a:rPr>
-              <a:t>14 / 20</a:t>
+              <a:t>14 / 22</a:t>
             </a:r>
           </a:p>
         </p:txBody>
@@ -5488,7 +5475,7 @@
     </p:spTree>
     <p:extLst>
       <p:ext uri="{BB962C8B-B14F-4D97-AF65-F5344CB8AC3E}">
-        <p14:creationId xmlns:p14="http://schemas.microsoft.com/office/powerpoint/2010/main" val="1590754296"/>
+        <p14:creationId xmlns:p14="http://schemas.microsoft.com/office/powerpoint/2010/main" val="1502731382"/>
       </p:ext>
     </p:extLst>
   </p:cSld>
@@ -5519,7 +5506,7 @@
           <p:cNvPr id="7" name="">
             <a:extLst xmlns:a="http://schemas.openxmlformats.org/drawingml/2006/main">
               <a:ext uri="{FF2B5EF4-FFF2-40B4-BE49-F238E27FC236}">
-                <a16:creationId xmlns:a16="http://schemas.microsoft.com/office/drawing/2014/main" id="{93E43C1D-677A-4484-B42E-435337BCED51}"/>
+                <a16:creationId xmlns:a16="http://schemas.microsoft.com/office/drawing/2014/main" id="{35A724E8-02D1-4C78-A9D3-AE6AD6E2D594}"/>
               </a:ext>
             </a:extLst>
           </p:cNvPr>
@@ -5567,7 +5554,7 @@
                 <a:ea typeface="Courier New"/>
                 <a:cs typeface="Courier New"/>
               </a:rPr>
-              <a:t>FLOATING POINT · PRECISION</a:t>
+              <a:t>FLOATING POINT · PRACTICE</a:t>
             </a:r>
           </a:p>
         </p:txBody>
@@ -5577,7 +5564,7 @@
           <p:cNvPr id="2" name="">
             <a:extLst xmlns:a="http://schemas.openxmlformats.org/drawingml/2006/main">
               <a:ext uri="{FF2B5EF4-FFF2-40B4-BE49-F238E27FC236}">
-                <a16:creationId xmlns:a16="http://schemas.microsoft.com/office/drawing/2014/main" id="{074B736B-6CBC-48AB-BB9C-B94B56E89F35}"/>
+                <a16:creationId xmlns:a16="http://schemas.microsoft.com/office/drawing/2014/main" id="{D68140D5-AD40-4B2D-9276-45B94835A98B}"/>
               </a:ext>
             </a:extLst>
           </p:cNvPr>
@@ -5625,7 +5612,7 @@
                 <a:ea typeface="Arial"/>
                 <a:cs typeface="Arial"/>
               </a:rPr>
-              <a:t>Some ratios need rounding</a:t>
+              <a:t>Your turn: classify two ratios</a:t>
             </a:r>
           </a:p>
         </p:txBody>
@@ -5635,7 +5622,7 @@
           <p:cNvPr id="3" name="">
             <a:extLst xmlns:a="http://schemas.openxmlformats.org/drawingml/2006/main">
               <a:ext uri="{FF2B5EF4-FFF2-40B4-BE49-F238E27FC236}">
-                <a16:creationId xmlns:a16="http://schemas.microsoft.com/office/drawing/2014/main" id="{31BF5015-85C0-4422-9A8D-3AB1598AB1B5}"/>
+                <a16:creationId xmlns:a16="http://schemas.microsoft.com/office/drawing/2014/main" id="{AA9609DC-0513-451F-B1A4-CD75618D8A9F}"/>
               </a:ext>
             </a:extLst>
           </p:cNvPr>
@@ -5683,7 +5670,7 @@
                 <a:ea typeface="Arial"/>
                 <a:cs typeface="Arial"/>
               </a:rPr>
-              <a:t>Only eight fraction patterns fit in three bits. A ratio such as 1/3 has a repeating binary expansion and cannot be stored exactly.</a:t>
+              <a:t>Use the same practice format: 3 exponent bits, bias 3, and 3 fraction bits.</a:t>
             </a:r>
           </a:p>
           <a:p xmlns:a="http://schemas.openxmlformats.org/drawingml/2006/main">
@@ -5712,7 +5699,7 @@
                 <a:ea typeface="Arial"/>
                 <a:cs typeface="Arial"/>
               </a:rPr>
-              <a:t>The required rounding rule decides which nearby value to store.</a:t>
+              <a:t>For each ratio, decide normal or subnormal, then find E and F.</a:t>
             </a:r>
           </a:p>
         </p:txBody>
@@ -5722,7 +5709,7 @@
           <p:cNvPr id="4" name="">
             <a:extLst xmlns:a="http://schemas.openxmlformats.org/drawingml/2006/main">
               <a:ext uri="{FF2B5EF4-FFF2-40B4-BE49-F238E27FC236}">
-                <a16:creationId xmlns:a16="http://schemas.microsoft.com/office/drawing/2014/main" id="{442E6650-2F07-46E8-968E-92CAC81BA173}"/>
+                <a16:creationId xmlns:a16="http://schemas.microsoft.com/office/drawing/2014/main" id="{37A2E272-B675-4F8B-8D9A-1DD0C7D3E885}"/>
               </a:ext>
             </a:extLst>
           </p:cNvPr>
@@ -5770,7 +5757,55 @@
                 <a:ea typeface="Courier New"/>
                 <a:cs typeface="Courier New"/>
               </a:rPr>
-              <a:t>1/3 = 1.010101…₂ × 2⁻²</a:t>
+              <a:t>A. 3/2</a:t>
+            </a:r>
+          </a:p>
+          <a:p xmlns:a="http://schemas.openxmlformats.org/drawingml/2006/main">
+            <a:pPr>
+              <a:buNone/>
+              <a:defRPr sz="1650" b="0">
+                <a:solidFill>
+                  <a:srgbClr val="A7F3D0"/>
+                </a:solidFill>
+                <a:latin typeface="Courier New"/>
+                <a:ea typeface="Courier New"/>
+                <a:cs typeface="Courier New"/>
+              </a:defRPr>
+            </a:pPr>
+            <a:r>
+              <a:rPr sz="1650" b="0">
+                <a:solidFill>
+                  <a:srgbClr val="A7F3D0"/>
+                </a:solidFill>
+                <a:latin typeface="Courier New"/>
+                <a:ea typeface="Courier New"/>
+                <a:cs typeface="Courier New"/>
+              </a:rPr>
+              <a:t>   normal or subnormal?</a:t>
+            </a:r>
+          </a:p>
+          <a:p xmlns:a="http://schemas.openxmlformats.org/drawingml/2006/main">
+            <a:pPr>
+              <a:buNone/>
+              <a:defRPr sz="1650" b="0">
+                <a:solidFill>
+                  <a:srgbClr val="A7F3D0"/>
+                </a:solidFill>
+                <a:latin typeface="Courier New"/>
+                <a:ea typeface="Courier New"/>
+                <a:cs typeface="Courier New"/>
+              </a:defRPr>
+            </a:pPr>
+            <a:r>
+              <a:rPr sz="1650" b="0">
+                <a:solidFill>
+                  <a:srgbClr val="A7F3D0"/>
+                </a:solidFill>
+                <a:latin typeface="Courier New"/>
+                <a:ea typeface="Courier New"/>
+                <a:cs typeface="Courier New"/>
+              </a:rPr>
+              <a:t>   E = ?   F = ?</a:t>
             </a:r>
           </a:p>
           <a:p xmlns:a="http://schemas.openxmlformats.org/drawingml/2006/main">
@@ -5799,7 +5834,7 @@
                 <a:ea typeface="Courier New"/>
                 <a:cs typeface="Courier New"/>
               </a:rPr>
-              <a:t>Nearby values in this format:</a:t>
+              <a:t>B. 3/16</a:t>
             </a:r>
           </a:p>
           <a:p xmlns:a="http://schemas.openxmlformats.org/drawingml/2006/main">
@@ -5823,7 +5858,7 @@
                 <a:ea typeface="Courier New"/>
                 <a:cs typeface="Courier New"/>
               </a:rPr>
-              <a:t>F = 010₂  →  5/16</a:t>
+              <a:t>   normal or subnormal?</a:t>
             </a:r>
           </a:p>
           <a:p xmlns:a="http://schemas.openxmlformats.org/drawingml/2006/main">
@@ -5847,36 +5882,7 @@
                 <a:ea typeface="Courier New"/>
                 <a:cs typeface="Courier New"/>
               </a:rPr>
-              <a:t>F = 011₂  →  11/32</a:t>
-            </a:r>
-          </a:p>
-          <a:p xmlns:a="http://schemas.openxmlformats.org/drawingml/2006/main">
-            <a:r>
-              <a:t/>
-            </a:r>
-          </a:p>
-          <a:p xmlns:a="http://schemas.openxmlformats.org/drawingml/2006/main">
-            <a:pPr>
-              <a:buNone/>
-              <a:defRPr sz="1650" b="0">
-                <a:solidFill>
-                  <a:srgbClr val="A7F3D0"/>
-                </a:solidFill>
-                <a:latin typeface="Courier New"/>
-                <a:ea typeface="Courier New"/>
-                <a:cs typeface="Courier New"/>
-              </a:defRPr>
-            </a:pPr>
-            <a:r>
-              <a:rPr sz="1650" b="0">
-                <a:solidFill>
-                  <a:srgbClr val="A7F3D0"/>
-                </a:solidFill>
-                <a:latin typeface="Courier New"/>
-                <a:ea typeface="Courier New"/>
-                <a:cs typeface="Courier New"/>
-              </a:rPr>
-              <a:t>Neither is exactly 1/3.</a:t>
+              <a:t>   E = ?   F = ?</a:t>
             </a:r>
           </a:p>
         </p:txBody>
@@ -5886,7 +5892,7 @@
           <p:cNvPr id="5" name="">
             <a:extLst xmlns:a="http://schemas.openxmlformats.org/drawingml/2006/main">
               <a:ext uri="{FF2B5EF4-FFF2-40B4-BE49-F238E27FC236}">
-                <a16:creationId xmlns:a16="http://schemas.microsoft.com/office/drawing/2014/main" id="{7550F9BB-98E4-470C-A339-F30A270C656C}"/>
+                <a16:creationId xmlns:a16="http://schemas.microsoft.com/office/drawing/2014/main" id="{8F900304-F8E7-4C1C-B3A0-F1A0DD604211}"/>
               </a:ext>
             </a:extLst>
           </p:cNvPr>
@@ -5934,7 +5940,7 @@
                 <a:ea typeface="Arial"/>
                 <a:cs typeface="Arial"/>
               </a:rPr>
-              <a:t>Wait for the assignment’s rounding instructions before choosing a stored result.</a:t>
+              <a:t>Compare each value with the smallest normal, 1/4, before finding bits.</a:t>
             </a:r>
           </a:p>
         </p:txBody>
@@ -5944,7 +5950,7 @@
           <p:cNvPr id="6" name="">
             <a:extLst xmlns:a="http://schemas.openxmlformats.org/drawingml/2006/main">
               <a:ext uri="{FF2B5EF4-FFF2-40B4-BE49-F238E27FC236}">
-                <a16:creationId xmlns:a16="http://schemas.microsoft.com/office/drawing/2014/main" id="{73B702C8-3DF9-406E-8087-CF675ECCC2D1}"/>
+                <a16:creationId xmlns:a16="http://schemas.microsoft.com/office/drawing/2014/main" id="{16200DCD-0F16-4BE6-9538-9FDAF86C958E}"/>
               </a:ext>
             </a:extLst>
           </p:cNvPr>
@@ -5992,7 +5998,7 @@
                 <a:ea typeface="Courier New"/>
                 <a:cs typeface="Courier New"/>
               </a:rPr>
-              <a:t>15 / 20</a:t>
+              <a:t>15 / 22</a:t>
             </a:r>
           </a:p>
         </p:txBody>
@@ -6000,7 +6006,7 @@
     </p:spTree>
     <p:extLst>
       <p:ext uri="{BB962C8B-B14F-4D97-AF65-F5344CB8AC3E}">
-        <p14:creationId xmlns:p14="http://schemas.microsoft.com/office/powerpoint/2010/main" val="1704851840"/>
+        <p14:creationId xmlns:p14="http://schemas.microsoft.com/office/powerpoint/2010/main" val="2079659254"/>
       </p:ext>
     </p:extLst>
   </p:cSld>
@@ -6031,7 +6037,7 @@
           <p:cNvPr id="7" name="">
             <a:extLst xmlns:a="http://schemas.openxmlformats.org/drawingml/2006/main">
               <a:ext uri="{FF2B5EF4-FFF2-40B4-BE49-F238E27FC236}">
-                <a16:creationId xmlns:a16="http://schemas.microsoft.com/office/drawing/2014/main" id="{0BCE7827-648B-4B62-AE80-F3CE9BFFD594}"/>
+                <a16:creationId xmlns:a16="http://schemas.microsoft.com/office/drawing/2014/main" id="{D25A2A70-779E-4A39-9AD5-537DDE3C5B7A}"/>
               </a:ext>
             </a:extLst>
           </p:cNvPr>
@@ -6079,7 +6085,7 @@
                 <a:ea typeface="Courier New"/>
                 <a:cs typeface="Courier New"/>
               </a:rPr>
-              <a:t>FLOATING POINT · SPACING</a:t>
+              <a:t>FLOATING POINT · CHECK</a:t>
             </a:r>
           </a:p>
         </p:txBody>
@@ -6089,7 +6095,7 @@
           <p:cNvPr id="2" name="">
             <a:extLst xmlns:a="http://schemas.openxmlformats.org/drawingml/2006/main">
               <a:ext uri="{FF2B5EF4-FFF2-40B4-BE49-F238E27FC236}">
-                <a16:creationId xmlns:a16="http://schemas.microsoft.com/office/drawing/2014/main" id="{E6B69FE5-5D95-4306-AAF0-9A70AD531613}"/>
+                <a16:creationId xmlns:a16="http://schemas.microsoft.com/office/drawing/2014/main" id="{2F2733A3-E106-4C90-B097-BE7CB4577892}"/>
               </a:ext>
             </a:extLst>
           </p:cNvPr>
@@ -6137,7 +6143,7 @@
                 <a:ea typeface="Arial"/>
                 <a:cs typeface="Arial"/>
               </a:rPr>
-              <a:t>Precision changes with scale</a:t>
+              <a:t>Practice answers</a:t>
             </a:r>
           </a:p>
         </p:txBody>
@@ -6147,7 +6153,7 @@
           <p:cNvPr id="3" name="">
             <a:extLst xmlns:a="http://schemas.openxmlformats.org/drawingml/2006/main">
               <a:ext uri="{FF2B5EF4-FFF2-40B4-BE49-F238E27FC236}">
-                <a16:creationId xmlns:a16="http://schemas.microsoft.com/office/drawing/2014/main" id="{887FE9A9-E5DE-4BC1-94AD-59371BF9B78C}"/>
+                <a16:creationId xmlns:a16="http://schemas.microsoft.com/office/drawing/2014/main" id="{53BB6D32-B5C1-4BFB-8D41-7B7055B1A606}"/>
               </a:ext>
             </a:extLst>
           </p:cNvPr>
@@ -6195,7 +6201,7 @@
                 <a:ea typeface="Arial"/>
                 <a:cs typeface="Arial"/>
               </a:rPr>
-              <a:t>The same three fraction bits give eight values within each normal exponent range.</a:t>
+              <a:t>3/2 = 1.100₂ × 2⁰, so it is normal.</a:t>
             </a:r>
           </a:p>
           <a:p xmlns:a="http://schemas.openxmlformats.org/drawingml/2006/main">
@@ -6224,7 +6230,7 @@
                 <a:ea typeface="Arial"/>
                 <a:cs typeface="Arial"/>
               </a:rPr>
-              <a:t>When the exponent increases by one, the distance between neighboring values doubles.</a:t>
+              <a:t>3/16 is below 1/4, so it is subnormal. Since value = F/32, F = 6.</a:t>
             </a:r>
           </a:p>
         </p:txBody>
@@ -6234,7 +6240,7 @@
           <p:cNvPr id="4" name="">
             <a:extLst xmlns:a="http://schemas.openxmlformats.org/drawingml/2006/main">
               <a:ext uri="{FF2B5EF4-FFF2-40B4-BE49-F238E27FC236}">
-                <a16:creationId xmlns:a16="http://schemas.microsoft.com/office/drawing/2014/main" id="{CED75AEC-85E3-4520-B63E-09FCF9AACAE6}"/>
+                <a16:creationId xmlns:a16="http://schemas.microsoft.com/office/drawing/2014/main" id="{CD85FA7D-EF72-4F2A-85B4-517634BC5BE7}"/>
               </a:ext>
             </a:extLst>
           </p:cNvPr>
@@ -6282,7 +6288,7 @@
                 <a:ea typeface="Courier New"/>
                 <a:cs typeface="Courier New"/>
               </a:rPr>
-              <a:t>E = 3 (e = 0)</a:t>
+              <a:t>A. 3/2</a:t>
             </a:r>
           </a:p>
           <a:p xmlns:a="http://schemas.openxmlformats.org/drawingml/2006/main">
@@ -6306,7 +6312,7 @@
                 <a:ea typeface="Courier New"/>
                 <a:cs typeface="Courier New"/>
               </a:rPr>
-              <a:t>F = 0 → 1       F = 1 → 9/8</a:t>
+              <a:t>   E = 3 = 011₂</a:t>
             </a:r>
           </a:p>
           <a:p xmlns:a="http://schemas.openxmlformats.org/drawingml/2006/main">
@@ -6330,7 +6336,31 @@
                 <a:ea typeface="Courier New"/>
                 <a:cs typeface="Courier New"/>
               </a:rPr>
-              <a:t>step = 1/8</a:t>
+              <a:t>   F = 4 = 100₂</a:t>
+            </a:r>
+          </a:p>
+          <a:p xmlns:a="http://schemas.openxmlformats.org/drawingml/2006/main">
+            <a:pPr>
+              <a:buNone/>
+              <a:defRPr sz="1650" b="0">
+                <a:solidFill>
+                  <a:srgbClr val="A7F3D0"/>
+                </a:solidFill>
+                <a:latin typeface="Courier New"/>
+                <a:ea typeface="Courier New"/>
+                <a:cs typeface="Courier New"/>
+              </a:defRPr>
+            </a:pPr>
+            <a:r>
+              <a:rPr sz="1650" b="0">
+                <a:solidFill>
+                  <a:srgbClr val="A7F3D0"/>
+                </a:solidFill>
+                <a:latin typeface="Courier New"/>
+                <a:ea typeface="Courier New"/>
+                <a:cs typeface="Courier New"/>
+              </a:rPr>
+              <a:t>   Check: (1 + 4/8) × 1 = 3/2</a:t>
             </a:r>
           </a:p>
           <a:p xmlns:a="http://schemas.openxmlformats.org/drawingml/2006/main">
@@ -6359,7 +6389,7 @@
                 <a:ea typeface="Courier New"/>
                 <a:cs typeface="Courier New"/>
               </a:rPr>
-              <a:t>E = 4 (e = 1)</a:t>
+              <a:t>B. 3/16</a:t>
             </a:r>
           </a:p>
           <a:p xmlns:a="http://schemas.openxmlformats.org/drawingml/2006/main">
@@ -6383,7 +6413,7 @@
                 <a:ea typeface="Courier New"/>
                 <a:cs typeface="Courier New"/>
               </a:rPr>
-              <a:t>F = 0 → 2       F = 1 → 9/4</a:t>
+              <a:t>   E = 0 = 000₂</a:t>
             </a:r>
           </a:p>
           <a:p xmlns:a="http://schemas.openxmlformats.org/drawingml/2006/main">
@@ -6407,7 +6437,31 @@
                 <a:ea typeface="Courier New"/>
                 <a:cs typeface="Courier New"/>
               </a:rPr>
-              <a:t>step = 1/4</a:t>
+              <a:t>   F = 6 = 110₂</a:t>
+            </a:r>
+          </a:p>
+          <a:p xmlns:a="http://schemas.openxmlformats.org/drawingml/2006/main">
+            <a:pPr>
+              <a:buNone/>
+              <a:defRPr sz="1650" b="0">
+                <a:solidFill>
+                  <a:srgbClr val="A7F3D0"/>
+                </a:solidFill>
+                <a:latin typeface="Courier New"/>
+                <a:ea typeface="Courier New"/>
+                <a:cs typeface="Courier New"/>
+              </a:defRPr>
+            </a:pPr>
+            <a:r>
+              <a:rPr sz="1650" b="0">
+                <a:solidFill>
+                  <a:srgbClr val="A7F3D0"/>
+                </a:solidFill>
+                <a:latin typeface="Courier New"/>
+                <a:ea typeface="Courier New"/>
+                <a:cs typeface="Courier New"/>
+              </a:rPr>
+              <a:t>   Check: 6/32 = 3/16</a:t>
             </a:r>
           </a:p>
         </p:txBody>
@@ -6417,7 +6471,7 @@
           <p:cNvPr id="5" name="">
             <a:extLst xmlns:a="http://schemas.openxmlformats.org/drawingml/2006/main">
               <a:ext uri="{FF2B5EF4-FFF2-40B4-BE49-F238E27FC236}">
-                <a16:creationId xmlns:a16="http://schemas.microsoft.com/office/drawing/2014/main" id="{7A18BC8F-2DC5-4B6B-A4F9-10CDE1183DE6}"/>
+                <a16:creationId xmlns:a16="http://schemas.microsoft.com/office/drawing/2014/main" id="{09DD94A5-8CF6-4CC6-9FAF-1AAE9F86C651}"/>
               </a:ext>
             </a:extLst>
           </p:cNvPr>
@@ -6465,7 +6519,7 @@
                 <a:ea typeface="Arial"/>
                 <a:cs typeface="Arial"/>
               </a:rPr>
-              <a:t>This is why large floating point values have larger gaps.</a:t>
+              <a:t>A fraction can be exactly representable in one format and not another.</a:t>
             </a:r>
           </a:p>
         </p:txBody>
@@ -6475,7 +6529,7 @@
           <p:cNvPr id="6" name="">
             <a:extLst xmlns:a="http://schemas.openxmlformats.org/drawingml/2006/main">
               <a:ext uri="{FF2B5EF4-FFF2-40B4-BE49-F238E27FC236}">
-                <a16:creationId xmlns:a16="http://schemas.microsoft.com/office/drawing/2014/main" id="{94269C50-3A0A-4FBB-A1D2-A33411F72ECA}"/>
+                <a16:creationId xmlns:a16="http://schemas.microsoft.com/office/drawing/2014/main" id="{BEB8226B-AC16-4616-9E79-3B5C231B3962}"/>
               </a:ext>
             </a:extLst>
           </p:cNvPr>
@@ -6523,7 +6577,7 @@
                 <a:ea typeface="Courier New"/>
                 <a:cs typeface="Courier New"/>
               </a:rPr>
-              <a:t>16 / 20</a:t>
+              <a:t>16 / 22</a:t>
             </a:r>
           </a:p>
         </p:txBody>
@@ -6531,7 +6585,7 @@
     </p:spTree>
     <p:extLst>
       <p:ext uri="{BB962C8B-B14F-4D97-AF65-F5344CB8AC3E}">
-        <p14:creationId xmlns:p14="http://schemas.microsoft.com/office/powerpoint/2010/main" val="1018474765"/>
+        <p14:creationId xmlns:p14="http://schemas.microsoft.com/office/powerpoint/2010/main" val="1590754296"/>
       </p:ext>
     </p:extLst>
   </p:cSld>
@@ -6562,7 +6616,7 @@
           <p:cNvPr id="7" name="">
             <a:extLst xmlns:a="http://schemas.openxmlformats.org/drawingml/2006/main">
               <a:ext uri="{FF2B5EF4-FFF2-40B4-BE49-F238E27FC236}">
-                <a16:creationId xmlns:a16="http://schemas.microsoft.com/office/drawing/2014/main" id="{0BCE7827-648B-4B62-AE80-F3CE9BFFD594}"/>
+                <a16:creationId xmlns:a16="http://schemas.microsoft.com/office/drawing/2014/main" id="{93E43C1D-677A-4484-B42E-435337BCED51}"/>
               </a:ext>
             </a:extLst>
           </p:cNvPr>
@@ -6610,7 +6664,7 @@
                 <a:ea typeface="Courier New"/>
                 <a:cs typeface="Courier New"/>
               </a:rPr>
-              <a:t>FLOATING POINT · ASSIGNMENT PREVIEW</a:t>
+              <a:t>FLOATING POINT · PRECISION</a:t>
             </a:r>
           </a:p>
         </p:txBody>
@@ -6620,7 +6674,7 @@
           <p:cNvPr id="2" name="">
             <a:extLst xmlns:a="http://schemas.openxmlformats.org/drawingml/2006/main">
               <a:ext uri="{FF2B5EF4-FFF2-40B4-BE49-F238E27FC236}">
-                <a16:creationId xmlns:a16="http://schemas.microsoft.com/office/drawing/2014/main" id="{E6B69FE5-5D95-4306-AAF0-9A70AD531613}"/>
+                <a16:creationId xmlns:a16="http://schemas.microsoft.com/office/drawing/2014/main" id="{074B736B-6CBC-48AB-BB9C-B94B56E89F35}"/>
               </a:ext>
             </a:extLst>
           </p:cNvPr>
@@ -6668,7 +6722,7 @@
                 <a:ea typeface="Arial"/>
                 <a:cs typeface="Arial"/>
               </a:rPr>
-              <a:t>HW3 preview: five inputs</a:t>
+              <a:t>Some ratios need rounding</a:t>
             </a:r>
           </a:p>
         </p:txBody>
@@ -6678,7 +6732,7 @@
           <p:cNvPr id="3" name="">
             <a:extLst xmlns:a="http://schemas.openxmlformats.org/drawingml/2006/main">
               <a:ext uri="{FF2B5EF4-FFF2-40B4-BE49-F238E27FC236}">
-                <a16:creationId xmlns:a16="http://schemas.microsoft.com/office/drawing/2014/main" id="{887FE9A9-E5DE-4BC1-94AD-59371BF9B78C}"/>
+                <a16:creationId xmlns:a16="http://schemas.microsoft.com/office/drawing/2014/main" id="{31BF5015-85C0-4422-9A8D-3AB1598AB1B5}"/>
               </a:ext>
             </a:extLst>
           </p:cNvPr>
@@ -6726,7 +6780,36 @@
                 <a:ea typeface="Arial"/>
                 <a:cs typeface="Arial"/>
               </a:rPr>
-              <a:t>The professor plans a program that reads a format and a nonnegative ratio. The assignment has not been posted, so treat these details as a preview.</a:t>
+              <a:t>Only eight fraction patterns fit in three bits. A ratio such as 1/3 has a repeating binary expansion and cannot be stored exactly.</a:t>
+            </a:r>
+          </a:p>
+          <a:p xmlns:a="http://schemas.openxmlformats.org/drawingml/2006/main">
+            <a:r>
+              <a:t/>
+            </a:r>
+          </a:p>
+          <a:p xmlns:a="http://schemas.openxmlformats.org/drawingml/2006/main">
+            <a:pPr>
+              <a:buNone/>
+              <a:defRPr sz="1950" b="0">
+                <a:solidFill>
+                  <a:srgbClr val="D4D4D8"/>
+                </a:solidFill>
+                <a:latin typeface="Arial"/>
+                <a:ea typeface="Arial"/>
+                <a:cs typeface="Arial"/>
+              </a:defRPr>
+            </a:pPr>
+            <a:r>
+              <a:rPr sz="1950" b="0">
+                <a:solidFill>
+                  <a:srgbClr val="D4D4D8"/>
+                </a:solidFill>
+                <a:latin typeface="Arial"/>
+                <a:ea typeface="Arial"/>
+                <a:cs typeface="Arial"/>
+              </a:rPr>
+              <a:t>The required rounding rule decides which nearby value to store.</a:t>
             </a:r>
           </a:p>
         </p:txBody>
@@ -6736,7 +6819,7 @@
           <p:cNvPr id="4" name="">
             <a:extLst xmlns:a="http://schemas.openxmlformats.org/drawingml/2006/main">
               <a:ext uri="{FF2B5EF4-FFF2-40B4-BE49-F238E27FC236}">
-                <a16:creationId xmlns:a16="http://schemas.microsoft.com/office/drawing/2014/main" id="{CED75AEC-85E3-4520-B63E-09FCF9AACAE6}"/>
+                <a16:creationId xmlns:a16="http://schemas.microsoft.com/office/drawing/2014/main" id="{442E6650-2F07-46E8-968E-92CAC81BA173}"/>
               </a:ext>
             </a:extLst>
           </p:cNvPr>
@@ -6784,7 +6867,12 @@
                 <a:ea typeface="Courier New"/>
                 <a:cs typeface="Courier New"/>
               </a:rPr>
-              <a:t>format:  exp_bits = 3</a:t>
+              <a:t>1/3 = 1.010101…₂ × 2⁻²</a:t>
+            </a:r>
+          </a:p>
+          <a:p xmlns:a="http://schemas.openxmlformats.org/drawingml/2006/main">
+            <a:r>
+              <a:t/>
             </a:r>
           </a:p>
           <a:p xmlns:a="http://schemas.openxmlformats.org/drawingml/2006/main">
@@ -6808,7 +6896,7 @@
                 <a:ea typeface="Courier New"/>
                 <a:cs typeface="Courier New"/>
               </a:rPr>
-              <a:t>         bias = 3</a:t>
+              <a:t>Nearby values in this format:</a:t>
             </a:r>
           </a:p>
           <a:p xmlns:a="http://schemas.openxmlformats.org/drawingml/2006/main">
@@ -6832,7 +6920,31 @@
                 <a:ea typeface="Courier New"/>
                 <a:cs typeface="Courier New"/>
               </a:rPr>
-              <a:t>         sig_bits = 3</a:t>
+              <a:t>F = 010₂  →  5/16</a:t>
+            </a:r>
+          </a:p>
+          <a:p xmlns:a="http://schemas.openxmlformats.org/drawingml/2006/main">
+            <a:pPr>
+              <a:buNone/>
+              <a:defRPr sz="1650" b="0">
+                <a:solidFill>
+                  <a:srgbClr val="A7F3D0"/>
+                </a:solidFill>
+                <a:latin typeface="Courier New"/>
+                <a:ea typeface="Courier New"/>
+                <a:cs typeface="Courier New"/>
+              </a:defRPr>
+            </a:pPr>
+            <a:r>
+              <a:rPr sz="1650" b="0">
+                <a:solidFill>
+                  <a:srgbClr val="A7F3D0"/>
+                </a:solidFill>
+                <a:latin typeface="Courier New"/>
+                <a:ea typeface="Courier New"/>
+                <a:cs typeface="Courier New"/>
+              </a:rPr>
+              <a:t>F = 011₂  →  11/32</a:t>
             </a:r>
           </a:p>
           <a:p xmlns:a="http://schemas.openxmlformats.org/drawingml/2006/main">
@@ -6861,79 +6973,7 @@
                 <a:ea typeface="Courier New"/>
                 <a:cs typeface="Courier New"/>
               </a:rPr>
-              <a:t>value:   numerator = 5</a:t>
-            </a:r>
-          </a:p>
-          <a:p xmlns:a="http://schemas.openxmlformats.org/drawingml/2006/main">
-            <a:pPr>
-              <a:buNone/>
-              <a:defRPr sz="1650" b="0">
-                <a:solidFill>
-                  <a:srgbClr val="A7F3D0"/>
-                </a:solidFill>
-                <a:latin typeface="Courier New"/>
-                <a:ea typeface="Courier New"/>
-                <a:cs typeface="Courier New"/>
-              </a:defRPr>
-            </a:pPr>
-            <a:r>
-              <a:rPr sz="1650" b="0">
-                <a:solidFill>
-                  <a:srgbClr val="A7F3D0"/>
-                </a:solidFill>
-                <a:latin typeface="Courier New"/>
-                <a:ea typeface="Courier New"/>
-                <a:cs typeface="Courier New"/>
-              </a:rPr>
-              <a:t>         denominator = 2</a:t>
-            </a:r>
-          </a:p>
-          <a:p xmlns:a="http://schemas.openxmlformats.org/drawingml/2006/main">
-            <a:pPr>
-              <a:buNone/>
-              <a:defRPr sz="1650" b="0">
-                <a:solidFill>
-                  <a:srgbClr val="A7F3D0"/>
-                </a:solidFill>
-                <a:latin typeface="Courier New"/>
-                <a:ea typeface="Courier New"/>
-                <a:cs typeface="Courier New"/>
-              </a:defRPr>
-            </a:pPr>
-            <a:r>
-              <a:rPr sz="1650" b="0">
-                <a:solidFill>
-                  <a:srgbClr val="A7F3D0"/>
-                </a:solidFill>
-                <a:latin typeface="Courier New"/>
-                <a:ea typeface="Courier New"/>
-                <a:cs typeface="Courier New"/>
-              </a:rPr>
-              <a:t/>
-            </a:r>
-          </a:p>
-          <a:p xmlns:a="http://schemas.openxmlformats.org/drawingml/2006/main">
-            <a:pPr>
-              <a:buNone/>
-              <a:defRPr sz="1650" b="0">
-                <a:solidFill>
-                  <a:srgbClr val="A7F3D0"/>
-                </a:solidFill>
-                <a:latin typeface="Courier New"/>
-                <a:ea typeface="Courier New"/>
-                <a:cs typeface="Courier New"/>
-              </a:defRPr>
-            </a:pPr>
-            <a:r>
-              <a:rPr sz="1650" b="0">
-                <a:solidFill>
-                  <a:srgbClr val="A7F3D0"/>
-                </a:solidFill>
-                <a:latin typeface="Courier New"/>
-                <a:ea typeface="Courier New"/>
-                <a:cs typeface="Courier New"/>
-              </a:rPr>
-              <a:t>Find: E (exponent), F (fraction)</a:t>
+              <a:t>Neither is exactly 1/3.</a:t>
             </a:r>
           </a:p>
         </p:txBody>
@@ -6943,7 +6983,7 @@
           <p:cNvPr id="5" name="">
             <a:extLst xmlns:a="http://schemas.openxmlformats.org/drawingml/2006/main">
               <a:ext uri="{FF2B5EF4-FFF2-40B4-BE49-F238E27FC236}">
-                <a16:creationId xmlns:a16="http://schemas.microsoft.com/office/drawing/2014/main" id="{7A18BC8F-2DC5-4B6B-A4F9-10CDE1183DE6}"/>
+                <a16:creationId xmlns:a16="http://schemas.microsoft.com/office/drawing/2014/main" id="{7550F9BB-98E4-470C-A339-F30A270C656C}"/>
               </a:ext>
             </a:extLst>
           </p:cNvPr>
@@ -6991,7 +7031,7 @@
                 <a:ea typeface="Arial"/>
                 <a:cs typeface="Arial"/>
               </a:rPr>
-              <a:t>The first three inputs define the format; the last two define the value.</a:t>
+              <a:t>Wait for the assignment’s rounding instructions before choosing a stored result.</a:t>
             </a:r>
           </a:p>
         </p:txBody>
@@ -7001,7 +7041,7 @@
           <p:cNvPr id="6" name="">
             <a:extLst xmlns:a="http://schemas.openxmlformats.org/drawingml/2006/main">
               <a:ext uri="{FF2B5EF4-FFF2-40B4-BE49-F238E27FC236}">
-                <a16:creationId xmlns:a16="http://schemas.microsoft.com/office/drawing/2014/main" id="{94269C50-3A0A-4FBB-A1D2-A33411F72ECA}"/>
+                <a16:creationId xmlns:a16="http://schemas.microsoft.com/office/drawing/2014/main" id="{73B702C8-3DF9-406E-8087-CF675ECCC2D1}"/>
               </a:ext>
             </a:extLst>
           </p:cNvPr>
@@ -7049,7 +7089,7 @@
                 <a:ea typeface="Courier New"/>
                 <a:cs typeface="Courier New"/>
               </a:rPr>
-              <a:t>17 / 20</a:t>
+              <a:t>17 / 22</a:t>
             </a:r>
           </a:p>
         </p:txBody>
@@ -7057,7 +7097,7 @@
     </p:spTree>
     <p:extLst>
       <p:ext uri="{BB962C8B-B14F-4D97-AF65-F5344CB8AC3E}">
-        <p14:creationId xmlns:p14="http://schemas.microsoft.com/office/powerpoint/2010/main" val="1018474765"/>
+        <p14:creationId xmlns:p14="http://schemas.microsoft.com/office/powerpoint/2010/main" val="1704851840"/>
       </p:ext>
     </p:extLst>
   </p:cSld>
@@ -7136,7 +7176,7 @@
                 <a:ea typeface="Courier New"/>
                 <a:cs typeface="Courier New"/>
               </a:rPr>
-              <a:t>FLOATING POINT · WORKED INPUT</a:t>
+              <a:t>FLOATING POINT · SPACING</a:t>
             </a:r>
           </a:p>
         </p:txBody>
@@ -7194,7 +7234,7 @@
                 <a:ea typeface="Arial"/>
                 <a:cs typeface="Arial"/>
               </a:rPr>
-              <a:t>HW3 preview: encode 5/2</a:t>
+              <a:t>Precision changes with scale</a:t>
             </a:r>
           </a:p>
         </p:txBody>
@@ -7252,7 +7292,36 @@
                 <a:ea typeface="Arial"/>
                 <a:cs typeface="Arial"/>
               </a:rPr>
-              <a:t>With 3 exponent bits, bias 3, and 3 fraction bits, write 5/2 as 1.010₂ × 2¹. The true exponent is 1, so E = 1 + 3 = 4. The stored fraction is 010₂, so F = 2.</a:t>
+              <a:t>The same three fraction bits give eight values within each normal exponent range.</a:t>
+            </a:r>
+          </a:p>
+          <a:p xmlns:a="http://schemas.openxmlformats.org/drawingml/2006/main">
+            <a:r>
+              <a:t/>
+            </a:r>
+          </a:p>
+          <a:p xmlns:a="http://schemas.openxmlformats.org/drawingml/2006/main">
+            <a:pPr>
+              <a:buNone/>
+              <a:defRPr sz="1950" b="0">
+                <a:solidFill>
+                  <a:srgbClr val="D4D4D8"/>
+                </a:solidFill>
+                <a:latin typeface="Arial"/>
+                <a:ea typeface="Arial"/>
+                <a:cs typeface="Arial"/>
+              </a:defRPr>
+            </a:pPr>
+            <a:r>
+              <a:rPr sz="1950" b="0">
+                <a:solidFill>
+                  <a:srgbClr val="D4D4D8"/>
+                </a:solidFill>
+                <a:latin typeface="Arial"/>
+                <a:ea typeface="Arial"/>
+                <a:cs typeface="Arial"/>
+              </a:rPr>
+              <a:t>When the exponent increases by one, the distance between neighboring values doubles.</a:t>
             </a:r>
           </a:p>
         </p:txBody>
@@ -7310,7 +7379,7 @@
                 <a:ea typeface="Courier New"/>
                 <a:cs typeface="Courier New"/>
               </a:rPr>
-              <a:t>Inputs: 3 3 3 5 2</a:t>
+              <a:t>E = 3 (e = 0)</a:t>
             </a:r>
           </a:p>
           <a:p xmlns:a="http://schemas.openxmlformats.org/drawingml/2006/main">
@@ -7334,6 +7403,35 @@
                 <a:ea typeface="Courier New"/>
                 <a:cs typeface="Courier New"/>
               </a:rPr>
+              <a:t>F = 0 → 1       F = 1 → 9/8</a:t>
+            </a:r>
+          </a:p>
+          <a:p xmlns:a="http://schemas.openxmlformats.org/drawingml/2006/main">
+            <a:pPr>
+              <a:buNone/>
+              <a:defRPr sz="1650" b="0">
+                <a:solidFill>
+                  <a:srgbClr val="A7F3D0"/>
+                </a:solidFill>
+                <a:latin typeface="Courier New"/>
+                <a:ea typeface="Courier New"/>
+                <a:cs typeface="Courier New"/>
+              </a:defRPr>
+            </a:pPr>
+            <a:r>
+              <a:rPr sz="1650" b="0">
+                <a:solidFill>
+                  <a:srgbClr val="A7F3D0"/>
+                </a:solidFill>
+                <a:latin typeface="Courier New"/>
+                <a:ea typeface="Courier New"/>
+                <a:cs typeface="Courier New"/>
+              </a:rPr>
+              <a:t>step = 1/8</a:t>
+            </a:r>
+          </a:p>
+          <a:p xmlns:a="http://schemas.openxmlformats.org/drawingml/2006/main">
+            <a:r>
               <a:t/>
             </a:r>
           </a:p>
@@ -7358,30 +7456,7 @@
                 <a:ea typeface="Courier New"/>
                 <a:cs typeface="Courier New"/>
               </a:rPr>
-              <a:t>E = 4 = 100₂</a:t>
-            </a:r>
-          </a:p>
-          <a:p xmlns:a="http://schemas.openxmlformats.org/drawingml/2006/main">
-            <a:pPr>
-              <a:defRPr sz="1650">
-                <a:solidFill>
-                  <a:srgbClr val="A7F3D0"/>
-                </a:solidFill>
-                <a:latin typeface="Courier New"/>
-                <a:ea typeface="Courier New"/>
-                <a:cs typeface="Courier New"/>
-              </a:defRPr>
-            </a:pPr>
-            <a:r>
-              <a:rPr sz="1650">
-                <a:solidFill>
-                  <a:srgbClr val="A7F3D0"/>
-                </a:solidFill>
-                <a:latin typeface="Courier New"/>
-                <a:ea typeface="Courier New"/>
-                <a:cs typeface="Courier New"/>
-              </a:rPr>
-              <a:t>F = 2 = 010₂</a:t>
+              <a:t>E = 4 (e = 1)</a:t>
             </a:r>
           </a:p>
           <a:p xmlns:a="http://schemas.openxmlformats.org/drawingml/2006/main">
@@ -7405,7 +7480,7 @@
                 <a:ea typeface="Courier New"/>
                 <a:cs typeface="Courier New"/>
               </a:rPr>
-              <a:t/>
+              <a:t>F = 0 → 2       F = 1 → 9/4</a:t>
             </a:r>
           </a:p>
           <a:p xmlns:a="http://schemas.openxmlformats.org/drawingml/2006/main">
@@ -7429,55 +7504,7 @@
                 <a:ea typeface="Courier New"/>
                 <a:cs typeface="Courier New"/>
               </a:rPr>
-              <a:t>Output: 4 2</a:t>
-            </a:r>
-          </a:p>
-          <a:p xmlns:a="http://schemas.openxmlformats.org/drawingml/2006/main">
-            <a:pPr>
-              <a:buNone/>
-              <a:defRPr sz="1650" b="0">
-                <a:solidFill>
-                  <a:srgbClr val="A7F3D0"/>
-                </a:solidFill>
-                <a:latin typeface="Courier New"/>
-                <a:ea typeface="Courier New"/>
-                <a:cs typeface="Courier New"/>
-              </a:defRPr>
-            </a:pPr>
-            <a:r>
-              <a:rPr sz="1650" b="0">
-                <a:solidFill>
-                  <a:srgbClr val="A7F3D0"/>
-                </a:solidFill>
-                <a:latin typeface="Courier New"/>
-                <a:ea typeface="Courier New"/>
-                <a:cs typeface="Courier New"/>
-              </a:rPr>
-              <a:t/>
-            </a:r>
-          </a:p>
-          <a:p xmlns:a="http://schemas.openxmlformats.org/drawingml/2006/main">
-            <a:pPr>
-              <a:buNone/>
-              <a:defRPr sz="1650" b="0">
-                <a:solidFill>
-                  <a:srgbClr val="A7F3D0"/>
-                </a:solidFill>
-                <a:latin typeface="Courier New"/>
-                <a:ea typeface="Courier New"/>
-                <a:cs typeface="Courier New"/>
-              </a:defRPr>
-            </a:pPr>
-            <a:r>
-              <a:rPr sz="1650" b="0">
-                <a:solidFill>
-                  <a:srgbClr val="A7F3D0"/>
-                </a:solidFill>
-                <a:latin typeface="Courier New"/>
-                <a:ea typeface="Courier New"/>
-                <a:cs typeface="Courier New"/>
-              </a:rPr>
-              <a:t>Check: (1 + 2/8) × 2¹ = 5/2</a:t>
+              <a:t>step = 1/4</a:t>
             </a:r>
           </a:p>
         </p:txBody>
@@ -7535,7 +7562,7 @@
                 <a:ea typeface="Arial"/>
                 <a:cs typeface="Arial"/>
               </a:rPr>
-              <a:t>Move the binary point before taking the stored fraction bits.</a:t>
+              <a:t>This is why large floating point values have larger gaps.</a:t>
             </a:r>
           </a:p>
         </p:txBody>
@@ -7593,7 +7620,7 @@
                 <a:ea typeface="Courier New"/>
                 <a:cs typeface="Courier New"/>
               </a:rPr>
-              <a:t>18 / 20</a:t>
+              <a:t>18 / 22</a:t>
             </a:r>
           </a:p>
         </p:txBody>
@@ -7680,7 +7707,7 @@
                 <a:ea typeface="Courier New"/>
                 <a:cs typeface="Courier New"/>
               </a:rPr>
-              <a:t>FLOATING POINT · METHOD</a:t>
+              <a:t>FLOATING POINT · ASSIGNMENT PREVIEW</a:t>
             </a:r>
           </a:p>
         </p:txBody>
@@ -7738,7 +7765,7 @@
                 <a:ea typeface="Arial"/>
                 <a:cs typeface="Arial"/>
               </a:rPr>
-              <a:t>HW3 preview: choose the equation</a:t>
+              <a:t>HW3 preview: five inputs</a:t>
             </a:r>
           </a:p>
         </p:txBody>
@@ -7796,7 +7823,7 @@
                 <a:ea typeface="Arial"/>
                 <a:cs typeface="Arial"/>
               </a:rPr>
-              <a:t>For a nonzero ratio, compare its value with the smallest normal, 2^(1−bias). That tells you which equation to use. Solve for E and F, then decode them to check.</a:t>
+              <a:t>The professor plans a program that reads a format and a nonnegative ratio. The assignment has not been posted, so treat these details as a preview.</a:t>
             </a:r>
           </a:p>
         </p:txBody>
@@ -7854,7 +7881,7 @@
                 <a:ea typeface="Courier New"/>
                 <a:cs typeface="Courier New"/>
               </a:rPr>
-              <a:t>Normal (E &gt; 0):</a:t>
+              <a:t>format:  exp_bits = 3</a:t>
             </a:r>
           </a:p>
           <a:p xmlns:a="http://schemas.openxmlformats.org/drawingml/2006/main">
@@ -7878,7 +7905,7 @@
                 <a:ea typeface="Courier New"/>
                 <a:cs typeface="Courier New"/>
               </a:rPr>
-              <a:t>value = (1 + F/2^p) × 2^(E−bias)</a:t>
+              <a:t>         bias = 3</a:t>
             </a:r>
           </a:p>
           <a:p xmlns:a="http://schemas.openxmlformats.org/drawingml/2006/main">
@@ -7902,34 +7929,16 @@
                 <a:ea typeface="Courier New"/>
                 <a:cs typeface="Courier New"/>
               </a:rPr>
+              <a:t>         sig_bits = 3</a:t>
+            </a:r>
+          </a:p>
+          <a:p xmlns:a="http://schemas.openxmlformats.org/drawingml/2006/main">
+            <a:r>
               <a:t/>
             </a:r>
           </a:p>
           <a:p xmlns:a="http://schemas.openxmlformats.org/drawingml/2006/main">
             <a:pPr>
-              <a:defRPr sz="1650">
-                <a:solidFill>
-                  <a:srgbClr val="A7F3D0"/>
-                </a:solidFill>
-                <a:latin typeface="Courier New"/>
-                <a:ea typeface="Courier New"/>
-                <a:cs typeface="Courier New"/>
-              </a:defRPr>
-            </a:pPr>
-            <a:r>
-              <a:rPr sz="1650">
-                <a:solidFill>
-                  <a:srgbClr val="A7F3D0"/>
-                </a:solidFill>
-                <a:latin typeface="Courier New"/>
-                <a:ea typeface="Courier New"/>
-                <a:cs typeface="Courier New"/>
-              </a:rPr>
-              <a:t>Subnormal (E = 0):</a:t>
-            </a:r>
-          </a:p>
-          <a:p xmlns:a="http://schemas.openxmlformats.org/drawingml/2006/main">
-            <a:pPr>
               <a:buNone/>
               <a:defRPr sz="1650" b="0">
                 <a:solidFill>
@@ -7949,7 +7958,7 @@
                 <a:ea typeface="Courier New"/>
                 <a:cs typeface="Courier New"/>
               </a:rPr>
-              <a:t>value = (F/2^p) × 2^(1−bias)</a:t>
+              <a:t>value:   numerator = 5</a:t>
             </a:r>
           </a:p>
           <a:p xmlns:a="http://schemas.openxmlformats.org/drawingml/2006/main">
@@ -7973,6 +7982,30 @@
                 <a:ea typeface="Courier New"/>
                 <a:cs typeface="Courier New"/>
               </a:rPr>
+              <a:t>         denominator = 2</a:t>
+            </a:r>
+          </a:p>
+          <a:p xmlns:a="http://schemas.openxmlformats.org/drawingml/2006/main">
+            <a:pPr>
+              <a:buNone/>
+              <a:defRPr sz="1650" b="0">
+                <a:solidFill>
+                  <a:srgbClr val="A7F3D0"/>
+                </a:solidFill>
+                <a:latin typeface="Courier New"/>
+                <a:ea typeface="Courier New"/>
+                <a:cs typeface="Courier New"/>
+              </a:defRPr>
+            </a:pPr>
+            <a:r>
+              <a:rPr sz="1650" b="0">
+                <a:solidFill>
+                  <a:srgbClr val="A7F3D0"/>
+                </a:solidFill>
+                <a:latin typeface="Courier New"/>
+                <a:ea typeface="Courier New"/>
+                <a:cs typeface="Courier New"/>
+              </a:rPr>
               <a:t/>
             </a:r>
           </a:p>
@@ -7997,7 +8030,7 @@
                 <a:ea typeface="Courier New"/>
                 <a:cs typeface="Courier New"/>
               </a:rPr>
-              <a:t>If numerator = 0: E = 0, F = 0</a:t>
+              <a:t>Find: E (exponent), F (fraction)</a:t>
             </a:r>
           </a:p>
         </p:txBody>
@@ -8055,7 +8088,7 @@
                 <a:ea typeface="Arial"/>
                 <a:cs typeface="Arial"/>
               </a:rPr>
-              <a:t>Use the supplied p and bias, not the values from our practice format.</a:t>
+              <a:t>The first three inputs define the format; the last two define the value.</a:t>
             </a:r>
           </a:p>
         </p:txBody>
@@ -8113,7 +8146,7 @@
                 <a:ea typeface="Courier New"/>
                 <a:cs typeface="Courier New"/>
               </a:rPr>
-              <a:t>19 / 20</a:t>
+              <a:t>19 / 22</a:t>
             </a:r>
           </a:p>
         </p:txBody>
@@ -8509,7 +8542,7 @@
                 <a:ea typeface="Courier New"/>
                 <a:cs typeface="Courier New"/>
               </a:rPr>
-              <a:t>3 stored fraction bits</a:t>
+              <a:t>3 stored significand (fraction) bits</a:t>
             </a:r>
           </a:p>
         </p:txBody>
@@ -8625,7 +8658,7 @@
                 <a:ea typeface="Courier New"/>
                 <a:cs typeface="Courier New"/>
               </a:rPr>
-              <a:t>02 / 20</a:t>
+              <a:t>02 / 22</a:t>
             </a:r>
           </a:p>
         </p:txBody>
@@ -8664,7 +8697,7 @@
           <p:cNvPr id="7" name="">
             <a:extLst xmlns:a="http://schemas.openxmlformats.org/drawingml/2006/main">
               <a:ext uri="{FF2B5EF4-FFF2-40B4-BE49-F238E27FC236}">
-                <a16:creationId xmlns:a16="http://schemas.microsoft.com/office/drawing/2014/main" id="{4989B079-C3E8-43BB-8638-96121018769A}"/>
+                <a16:creationId xmlns:a16="http://schemas.microsoft.com/office/drawing/2014/main" id="{0BCE7827-648B-4B62-AE80-F3CE9BFFD594}"/>
               </a:ext>
             </a:extLst>
           </p:cNvPr>
@@ -8712,7 +8745,7 @@
                 <a:ea typeface="Courier New"/>
                 <a:cs typeface="Courier New"/>
               </a:rPr>
-              <a:t>FLOATING POINT · RECAP</a:t>
+              <a:t>FLOATING POINT · WORKED INPUT</a:t>
             </a:r>
           </a:p>
         </p:txBody>
@@ -8722,7 +8755,7 @@
           <p:cNvPr id="2" name="">
             <a:extLst xmlns:a="http://schemas.openxmlformats.org/drawingml/2006/main">
               <a:ext uri="{FF2B5EF4-FFF2-40B4-BE49-F238E27FC236}">
-                <a16:creationId xmlns:a16="http://schemas.microsoft.com/office/drawing/2014/main" id="{95D3113E-85F1-4E22-A62E-265E94FE3617}"/>
+                <a16:creationId xmlns:a16="http://schemas.microsoft.com/office/drawing/2014/main" id="{E6B69FE5-5D95-4306-AAF0-9A70AD531613}"/>
               </a:ext>
             </a:extLst>
           </p:cNvPr>
@@ -8770,7 +8803,7 @@
                 <a:ea typeface="Arial"/>
                 <a:cs typeface="Arial"/>
               </a:rPr>
-              <a:t>How to check an encoding</a:t>
+              <a:t>HW3 preview: encode 5/2</a:t>
             </a:r>
           </a:p>
         </p:txBody>
@@ -8780,7 +8813,7 @@
           <p:cNvPr id="3" name="">
             <a:extLst xmlns:a="http://schemas.openxmlformats.org/drawingml/2006/main">
               <a:ext uri="{FF2B5EF4-FFF2-40B4-BE49-F238E27FC236}">
-                <a16:creationId xmlns:a16="http://schemas.microsoft.com/office/drawing/2014/main" id="{8EC5E33C-BA7C-4ADE-9FC3-9ABD9F3C6FD4}"/>
+                <a16:creationId xmlns:a16="http://schemas.microsoft.com/office/drawing/2014/main" id="{887FE9A9-E5DE-4BC1-94AD-59371BF9B78C}"/>
               </a:ext>
             </a:extLst>
           </p:cNvPr>
@@ -8828,36 +8861,7 @@
                 <a:ea typeface="Arial"/>
                 <a:cs typeface="Arial"/>
               </a:rPr>
-              <a:t>Compare the value with the smallest normal. Choose the normal or subnormal equation, work out the fields, then decode them to check.</a:t>
-            </a:r>
-          </a:p>
-          <a:p xmlns:a="http://schemas.openxmlformats.org/drawingml/2006/main">
-            <a:r>
-              <a:t/>
-            </a:r>
-          </a:p>
-          <a:p xmlns:a="http://schemas.openxmlformats.org/drawingml/2006/main">
-            <a:pPr>
-              <a:buNone/>
-              <a:defRPr sz="1950" b="0">
-                <a:solidFill>
-                  <a:srgbClr val="D4D4D8"/>
-                </a:solidFill>
-                <a:latin typeface="Arial"/>
-                <a:ea typeface="Arial"/>
-                <a:cs typeface="Arial"/>
-              </a:defRPr>
-            </a:pPr>
-            <a:r>
-              <a:rPr sz="1950" b="0">
-                <a:solidFill>
-                  <a:srgbClr val="D4D4D8"/>
-                </a:solidFill>
-                <a:latin typeface="Arial"/>
-                <a:ea typeface="Arial"/>
-                <a:cs typeface="Arial"/>
-              </a:rPr>
-              <a:t>If the value is not exact, use the rounding rule given with the problem.</a:t>
+              <a:t>With 3 exponent bits, bias 3, and 3 fraction bits, write 5/2 as 1.010₂ × 2¹. The true exponent is 1, so E = 1 + 3 = 4. The stored fraction is 010₂, so F = 2.</a:t>
             </a:r>
           </a:p>
         </p:txBody>
@@ -8867,7 +8871,7 @@
           <p:cNvPr id="4" name="">
             <a:extLst xmlns:a="http://schemas.openxmlformats.org/drawingml/2006/main">
               <a:ext uri="{FF2B5EF4-FFF2-40B4-BE49-F238E27FC236}">
-                <a16:creationId xmlns:a16="http://schemas.microsoft.com/office/drawing/2014/main" id="{EA939046-DA6B-448C-A179-5B13743C72F3}"/>
+                <a16:creationId xmlns:a16="http://schemas.microsoft.com/office/drawing/2014/main" id="{CED75AEC-85E3-4520-B63E-09FCF9AACAE6}"/>
               </a:ext>
             </a:extLst>
           </p:cNvPr>
@@ -8915,11 +8919,30 @@
                 <a:ea typeface="Courier New"/>
                 <a:cs typeface="Courier New"/>
               </a:rPr>
-              <a:t>Our practice format</a:t>
-            </a:r>
-          </a:p>
-          <a:p xmlns:a="http://schemas.openxmlformats.org/drawingml/2006/main">
-            <a:r>
+              <a:t>Inputs: 3 3 3 5 2</a:t>
+            </a:r>
+          </a:p>
+          <a:p xmlns:a="http://schemas.openxmlformats.org/drawingml/2006/main">
+            <a:pPr>
+              <a:buNone/>
+              <a:defRPr sz="1650" b="0">
+                <a:solidFill>
+                  <a:srgbClr val="A7F3D0"/>
+                </a:solidFill>
+                <a:latin typeface="Courier New"/>
+                <a:ea typeface="Courier New"/>
+                <a:cs typeface="Courier New"/>
+              </a:defRPr>
+            </a:pPr>
+            <a:r>
+              <a:rPr sz="1650" b="0">
+                <a:solidFill>
+                  <a:srgbClr val="A7F3D0"/>
+                </a:solidFill>
+                <a:latin typeface="Courier New"/>
+                <a:ea typeface="Courier New"/>
+                <a:cs typeface="Courier New"/>
+              </a:rPr>
               <a:t/>
             </a:r>
           </a:p>
@@ -8944,7 +8967,31 @@
                 <a:ea typeface="Courier New"/>
                 <a:cs typeface="Courier New"/>
               </a:rPr>
-              <a:t>Normal:    (1 + F/8) × 2^(E−3)</a:t>
+              <a:t>E = 4 = 100₂</a:t>
+            </a:r>
+          </a:p>
+          <a:p xmlns:a="http://schemas.openxmlformats.org/drawingml/2006/main">
+            <a:pPr>
+              <a:buNone/>
+              <a:defRPr sz="1650">
+                <a:solidFill>
+                  <a:srgbClr val="A7F3D0"/>
+                </a:solidFill>
+                <a:latin typeface="Courier New"/>
+                <a:ea typeface="Courier New"/>
+                <a:cs typeface="Courier New"/>
+              </a:defRPr>
+            </a:pPr>
+            <a:r>
+              <a:rPr sz="1650">
+                <a:solidFill>
+                  <a:srgbClr val="A7F3D0"/>
+                </a:solidFill>
+                <a:latin typeface="Courier New"/>
+                <a:ea typeface="Courier New"/>
+                <a:cs typeface="Courier New"/>
+              </a:rPr>
+              <a:t>F = 2 = 010₂</a:t>
             </a:r>
           </a:p>
           <a:p xmlns:a="http://schemas.openxmlformats.org/drawingml/2006/main">
@@ -8968,11 +9015,6 @@
                 <a:ea typeface="Courier New"/>
                 <a:cs typeface="Courier New"/>
               </a:rPr>
-              <a:t>Subnormal: (    F/8) × 2⁻²</a:t>
-            </a:r>
-          </a:p>
-          <a:p xmlns:a="http://schemas.openxmlformats.org/drawingml/2006/main">
-            <a:r>
               <a:t/>
             </a:r>
           </a:p>
@@ -8997,11 +9039,30 @@
                 <a:ea typeface="Courier New"/>
                 <a:cs typeface="Courier New"/>
               </a:rPr>
-              <a:t>E = 0, F = 0  →  zero</a:t>
-            </a:r>
-          </a:p>
-          <a:p xmlns:a="http://schemas.openxmlformats.org/drawingml/2006/main">
-            <a:r>
+              <a:t>Output: 4 2</a:t>
+            </a:r>
+          </a:p>
+          <a:p xmlns:a="http://schemas.openxmlformats.org/drawingml/2006/main">
+            <a:pPr>
+              <a:buNone/>
+              <a:defRPr sz="1650" b="0">
+                <a:solidFill>
+                  <a:srgbClr val="A7F3D0"/>
+                </a:solidFill>
+                <a:latin typeface="Courier New"/>
+                <a:ea typeface="Courier New"/>
+                <a:cs typeface="Courier New"/>
+              </a:defRPr>
+            </a:pPr>
+            <a:r>
+              <a:rPr sz="1650" b="0">
+                <a:solidFill>
+                  <a:srgbClr val="A7F3D0"/>
+                </a:solidFill>
+                <a:latin typeface="Courier New"/>
+                <a:ea typeface="Courier New"/>
+                <a:cs typeface="Courier New"/>
+              </a:rPr>
               <a:t/>
             </a:r>
           </a:p>
@@ -9026,7 +9087,7 @@
                 <a:ea typeface="Courier New"/>
                 <a:cs typeface="Courier New"/>
               </a:rPr>
-              <a:t>Decode your bits as a final check.</a:t>
+              <a:t>Check: (1 + 2/8) × 2¹ = 5/2</a:t>
             </a:r>
           </a:p>
         </p:txBody>
@@ -9036,7 +9097,7 @@
           <p:cNvPr id="5" name="">
             <a:extLst xmlns:a="http://schemas.openxmlformats.org/drawingml/2006/main">
               <a:ext uri="{FF2B5EF4-FFF2-40B4-BE49-F238E27FC236}">
-                <a16:creationId xmlns:a16="http://schemas.microsoft.com/office/drawing/2014/main" id="{585A0E73-828D-45A1-9AD7-8EED8C5E7EB1}"/>
+                <a16:creationId xmlns:a16="http://schemas.microsoft.com/office/drawing/2014/main" id="{7A18BC8F-2DC5-4B6B-A4F9-10CDE1183DE6}"/>
               </a:ext>
             </a:extLst>
           </p:cNvPr>
@@ -9084,7 +9145,7 @@
                 <a:ea typeface="Arial"/>
                 <a:cs typeface="Arial"/>
               </a:rPr>
-              <a:t>A correct encoding must reproduce the intended value or its required rounded value.</a:t>
+              <a:t>Move the binary point before taking the stored fraction bits.</a:t>
             </a:r>
           </a:p>
         </p:txBody>
@@ -9094,7 +9155,7 @@
           <p:cNvPr id="6" name="">
             <a:extLst xmlns:a="http://schemas.openxmlformats.org/drawingml/2006/main">
               <a:ext uri="{FF2B5EF4-FFF2-40B4-BE49-F238E27FC236}">
-                <a16:creationId xmlns:a16="http://schemas.microsoft.com/office/drawing/2014/main" id="{E1FBC5BD-1F5D-42FA-AC83-E0BF862F4EDF}"/>
+                <a16:creationId xmlns:a16="http://schemas.microsoft.com/office/drawing/2014/main" id="{94269C50-3A0A-4FBB-A1D2-A33411F72ECA}"/>
               </a:ext>
             </a:extLst>
           </p:cNvPr>
@@ -9142,7 +9203,1093 @@
                 <a:ea typeface="Courier New"/>
                 <a:cs typeface="Courier New"/>
               </a:rPr>
-              <a:t>20 / 20</a:t>
+              <a:t>20 / 22</a:t>
+            </a:r>
+          </a:p>
+        </p:txBody>
+      </p:sp>
+    </p:spTree>
+    <p:extLst>
+      <p:ext uri="{BB962C8B-B14F-4D97-AF65-F5344CB8AC3E}">
+        <p14:creationId xmlns:p14="http://schemas.microsoft.com/office/powerpoint/2010/main" val="1018474765"/>
+      </p:ext>
+    </p:extLst>
+  </p:cSld>
+</p:sld>
+</file>
+
+<file path=ppt/slides/slide21.xml><?xml version="1.0" encoding="utf-8"?>
+<p:sld xmlns:p="http://schemas.openxmlformats.org/presentationml/2006/main">
+  <p:cSld>
+    <p:bg>
+      <p:bgPr>
+        <a:solidFill xmlns:a="http://schemas.openxmlformats.org/drawingml/2006/main">
+          <a:srgbClr val="09090B"/>
+        </a:solidFill>
+      </p:bgPr>
+    </p:bg>
+    <p:spTree>
+      <p:nvGrpSpPr>
+        <p:cNvPr id="1" name=""/>
+        <p:cNvGrpSpPr/>
+        <p:nvPr/>
+      </p:nvGrpSpPr>
+      <p:grpSpPr>
+        <a:xfrm xmlns:a="http://schemas.openxmlformats.org/drawingml/2006/main"/>
+      </p:grpSpPr>
+      <p:sp>
+        <p:nvSpPr>
+          <p:cNvPr id="7" name="">
+            <a:extLst xmlns:a="http://schemas.openxmlformats.org/drawingml/2006/main">
+              <a:ext uri="{FF2B5EF4-FFF2-40B4-BE49-F238E27FC236}">
+                <a16:creationId xmlns:a16="http://schemas.microsoft.com/office/drawing/2014/main" id="{0BCE7827-648B-4B62-AE80-F3CE9BFFD594}"/>
+              </a:ext>
+            </a:extLst>
+          </p:cNvPr>
+          <p:cNvSpPr>
+            <a:spLocks xmlns:a="http://schemas.openxmlformats.org/drawingml/2006/main" noGrp="1"/>
+          </p:cNvSpPr>
+          <p:nvPr/>
+        </p:nvSpPr>
+        <p:spPr>
+          <a:xfrm xmlns:a="http://schemas.openxmlformats.org/drawingml/2006/main">
+            <a:off x="685800" y="361950"/>
+            <a:ext cx="10477500" cy="285750"/>
+          </a:xfrm>
+          <a:prstGeom xmlns:a="http://schemas.openxmlformats.org/drawingml/2006/main" prst="rect">
+            <a:avLst/>
+          </a:prstGeom>
+          <a:noFill xmlns:a="http://schemas.openxmlformats.org/drawingml/2006/main"/>
+          <a:ln xmlns:a="http://schemas.openxmlformats.org/drawingml/2006/main" w="0">
+            <a:noFill/>
+          </a:ln>
+        </p:spPr>
+        <p:txBody>
+          <a:bodyPr xmlns:a="http://schemas.openxmlformats.org/drawingml/2006/main" anchor="t">
+            <a:normAutofit fontScale="100000"/>
+          </a:bodyPr>
+          <a:lstStyle xmlns:a="http://schemas.openxmlformats.org/drawingml/2006/main"/>
+          <a:p xmlns:a="http://schemas.openxmlformats.org/drawingml/2006/main">
+            <a:pPr>
+              <a:buNone/>
+              <a:defRPr sz="1275" b="0">
+                <a:solidFill>
+                  <a:srgbClr val="6EE7B7"/>
+                </a:solidFill>
+                <a:latin typeface="Courier New"/>
+                <a:ea typeface="Courier New"/>
+                <a:cs typeface="Courier New"/>
+              </a:defRPr>
+            </a:pPr>
+            <a:r>
+              <a:rPr sz="1275" b="0">
+                <a:solidFill>
+                  <a:srgbClr val="6EE7B7"/>
+                </a:solidFill>
+                <a:latin typeface="Courier New"/>
+                <a:ea typeface="Courier New"/>
+                <a:cs typeface="Courier New"/>
+              </a:rPr>
+              <a:t>FLOATING POINT · METHOD</a:t>
+            </a:r>
+          </a:p>
+        </p:txBody>
+      </p:sp>
+      <p:sp>
+        <p:nvSpPr>
+          <p:cNvPr id="2" name="">
+            <a:extLst xmlns:a="http://schemas.openxmlformats.org/drawingml/2006/main">
+              <a:ext uri="{FF2B5EF4-FFF2-40B4-BE49-F238E27FC236}">
+                <a16:creationId xmlns:a16="http://schemas.microsoft.com/office/drawing/2014/main" id="{E6B69FE5-5D95-4306-AAF0-9A70AD531613}"/>
+              </a:ext>
+            </a:extLst>
+          </p:cNvPr>
+          <p:cNvSpPr>
+            <a:spLocks xmlns:a="http://schemas.openxmlformats.org/drawingml/2006/main" noGrp="1"/>
+          </p:cNvSpPr>
+          <p:nvPr/>
+        </p:nvSpPr>
+        <p:spPr>
+          <a:xfrm xmlns:a="http://schemas.openxmlformats.org/drawingml/2006/main">
+            <a:off x="685800" y="885825"/>
+            <a:ext cx="10820400" cy="1066800"/>
+          </a:xfrm>
+          <a:prstGeom xmlns:a="http://schemas.openxmlformats.org/drawingml/2006/main" prst="rect">
+            <a:avLst/>
+          </a:prstGeom>
+          <a:noFill xmlns:a="http://schemas.openxmlformats.org/drawingml/2006/main"/>
+          <a:ln xmlns:a="http://schemas.openxmlformats.org/drawingml/2006/main" w="0">
+            <a:noFill/>
+          </a:ln>
+        </p:spPr>
+        <p:txBody>
+          <a:bodyPr xmlns:a="http://schemas.openxmlformats.org/drawingml/2006/main" anchor="t">
+            <a:normAutofit fontScale="100000"/>
+          </a:bodyPr>
+          <a:lstStyle xmlns:a="http://schemas.openxmlformats.org/drawingml/2006/main"/>
+          <a:p xmlns:a="http://schemas.openxmlformats.org/drawingml/2006/main">
+            <a:pPr>
+              <a:buNone/>
+              <a:defRPr sz="3600" b="0">
+                <a:solidFill>
+                  <a:srgbClr val="FAFAFA"/>
+                </a:solidFill>
+                <a:latin typeface="Arial"/>
+                <a:ea typeface="Arial"/>
+                <a:cs typeface="Arial"/>
+              </a:defRPr>
+            </a:pPr>
+            <a:r>
+              <a:rPr sz="3600" b="0">
+                <a:solidFill>
+                  <a:srgbClr val="FAFAFA"/>
+                </a:solidFill>
+                <a:latin typeface="Arial"/>
+                <a:ea typeface="Arial"/>
+                <a:cs typeface="Arial"/>
+              </a:rPr>
+              <a:t>HW3 preview: choose the equation</a:t>
+            </a:r>
+          </a:p>
+        </p:txBody>
+      </p:sp>
+      <p:sp>
+        <p:nvSpPr>
+          <p:cNvPr id="3" name="">
+            <a:extLst xmlns:a="http://schemas.openxmlformats.org/drawingml/2006/main">
+              <a:ext uri="{FF2B5EF4-FFF2-40B4-BE49-F238E27FC236}">
+                <a16:creationId xmlns:a16="http://schemas.microsoft.com/office/drawing/2014/main" id="{887FE9A9-E5DE-4BC1-94AD-59371BF9B78C}"/>
+              </a:ext>
+            </a:extLst>
+          </p:cNvPr>
+          <p:cNvSpPr>
+            <a:spLocks xmlns:a="http://schemas.openxmlformats.org/drawingml/2006/main" noGrp="1"/>
+          </p:cNvSpPr>
+          <p:nvPr/>
+        </p:nvSpPr>
+        <p:spPr>
+          <a:xfrm xmlns:a="http://schemas.openxmlformats.org/drawingml/2006/main">
+            <a:off x="685800" y="2200275"/>
+            <a:ext cx="4857750" cy="3124200"/>
+          </a:xfrm>
+          <a:prstGeom xmlns:a="http://schemas.openxmlformats.org/drawingml/2006/main" prst="rect">
+            <a:avLst/>
+          </a:prstGeom>
+          <a:noFill xmlns:a="http://schemas.openxmlformats.org/drawingml/2006/main"/>
+          <a:ln xmlns:a="http://schemas.openxmlformats.org/drawingml/2006/main" w="0">
+            <a:noFill/>
+          </a:ln>
+        </p:spPr>
+        <p:txBody>
+          <a:bodyPr xmlns:a="http://schemas.openxmlformats.org/drawingml/2006/main" anchor="t">
+            <a:normAutofit fontScale="100000"/>
+          </a:bodyPr>
+          <a:lstStyle xmlns:a="http://schemas.openxmlformats.org/drawingml/2006/main"/>
+          <a:p xmlns:a="http://schemas.openxmlformats.org/drawingml/2006/main">
+            <a:pPr>
+              <a:buNone/>
+              <a:defRPr sz="1950" b="0">
+                <a:solidFill>
+                  <a:srgbClr val="D4D4D8"/>
+                </a:solidFill>
+                <a:latin typeface="Arial"/>
+                <a:ea typeface="Arial"/>
+                <a:cs typeface="Arial"/>
+              </a:defRPr>
+            </a:pPr>
+            <a:r>
+              <a:rPr sz="1950" b="0">
+                <a:solidFill>
+                  <a:srgbClr val="D4D4D8"/>
+                </a:solidFill>
+                <a:latin typeface="Arial"/>
+                <a:ea typeface="Arial"/>
+                <a:cs typeface="Arial"/>
+              </a:rPr>
+              <a:t>Compare a nonzero ratio with the smallest normal, 2^(1−bias). Below that threshold, set E = 0 and use no hidden 1.</a:t>
+            </a:r>
+          </a:p>
+          <a:p xmlns:a="http://schemas.openxmlformats.org/drawingml/2006/main">
+            <a:pPr>
+              <a:buNone/>
+              <a:defRPr sz="1950" b="0">
+                <a:solidFill>
+                  <a:srgbClr val="D4D4D8"/>
+                </a:solidFill>
+                <a:latin typeface="Arial"/>
+                <a:ea typeface="Arial"/>
+                <a:cs typeface="Arial"/>
+              </a:defRPr>
+            </a:pPr>
+            <a:r>
+              <a:rPr sz="1950" b="0">
+                <a:solidFill>
+                  <a:srgbClr val="D4D4D8"/>
+                </a:solidFill>
+                <a:latin typeface="Arial"/>
+                <a:ea typeface="Arial"/>
+                <a:cs typeface="Arial"/>
+              </a:rPr>
+              <a:t/>
+            </a:r>
+          </a:p>
+          <a:p xmlns:a="http://schemas.openxmlformats.org/drawingml/2006/main">
+            <a:pPr>
+              <a:buNone/>
+              <a:defRPr sz="1950" b="0">
+                <a:solidFill>
+                  <a:srgbClr val="D4D4D8"/>
+                </a:solidFill>
+                <a:latin typeface="Arial"/>
+                <a:ea typeface="Arial"/>
+                <a:cs typeface="Arial"/>
+              </a:defRPr>
+            </a:pPr>
+            <a:r>
+              <a:rPr sz="1950" b="0">
+                <a:solidFill>
+                  <a:srgbClr val="D4D4D8"/>
+                </a:solidFill>
+                <a:latin typeface="Arial"/>
+                <a:ea typeface="Arial"/>
+                <a:cs typeface="Arial"/>
+              </a:rPr>
+              <a:t>Otherwise find the true exponent e and store E = e + bias. Solve for F, then decode to check.</a:t>
+            </a:r>
+          </a:p>
+        </p:txBody>
+      </p:sp>
+      <p:sp>
+        <p:nvSpPr>
+          <p:cNvPr id="4" name="">
+            <a:extLst xmlns:a="http://schemas.openxmlformats.org/drawingml/2006/main">
+              <a:ext uri="{FF2B5EF4-FFF2-40B4-BE49-F238E27FC236}">
+                <a16:creationId xmlns:a16="http://schemas.microsoft.com/office/drawing/2014/main" id="{CED75AEC-85E3-4520-B63E-09FCF9AACAE6}"/>
+              </a:ext>
+            </a:extLst>
+          </p:cNvPr>
+          <p:cNvSpPr>
+            <a:spLocks xmlns:a="http://schemas.openxmlformats.org/drawingml/2006/main" noGrp="1"/>
+          </p:cNvSpPr>
+          <p:nvPr/>
+        </p:nvSpPr>
+        <p:spPr>
+          <a:xfrm xmlns:a="http://schemas.openxmlformats.org/drawingml/2006/main">
+            <a:off x="6181725" y="2200275"/>
+            <a:ext cx="5238750" cy="3286125"/>
+          </a:xfrm>
+          <a:prstGeom xmlns:a="http://schemas.openxmlformats.org/drawingml/2006/main" prst="rect">
+            <a:avLst/>
+          </a:prstGeom>
+          <a:noFill xmlns:a="http://schemas.openxmlformats.org/drawingml/2006/main"/>
+          <a:ln xmlns:a="http://schemas.openxmlformats.org/drawingml/2006/main" w="0">
+            <a:noFill/>
+          </a:ln>
+        </p:spPr>
+        <p:txBody>
+          <a:bodyPr xmlns:a="http://schemas.openxmlformats.org/drawingml/2006/main" anchor="t">
+            <a:normAutofit fontScale="100000"/>
+          </a:bodyPr>
+          <a:lstStyle xmlns:a="http://schemas.openxmlformats.org/drawingml/2006/main"/>
+          <a:p xmlns:a="http://schemas.openxmlformats.org/drawingml/2006/main">
+            <a:pPr>
+              <a:buNone/>
+              <a:defRPr sz="1650" b="0">
+                <a:solidFill>
+                  <a:srgbClr val="A7F3D0"/>
+                </a:solidFill>
+                <a:latin typeface="Courier New"/>
+                <a:ea typeface="Courier New"/>
+                <a:cs typeface="Courier New"/>
+              </a:defRPr>
+            </a:pPr>
+            <a:r>
+              <a:rPr sz="1650" b="0">
+                <a:solidFill>
+                  <a:srgbClr val="A7F3D0"/>
+                </a:solidFill>
+                <a:latin typeface="Courier New"/>
+                <a:ea typeface="Courier New"/>
+                <a:cs typeface="Courier New"/>
+              </a:rPr>
+              <a:t>Normal (E &gt; 0):</a:t>
+            </a:r>
+          </a:p>
+          <a:p xmlns:a="http://schemas.openxmlformats.org/drawingml/2006/main">
+            <a:pPr>
+              <a:buNone/>
+              <a:defRPr sz="1650" b="0">
+                <a:solidFill>
+                  <a:srgbClr val="A7F3D0"/>
+                </a:solidFill>
+                <a:latin typeface="Courier New"/>
+                <a:ea typeface="Courier New"/>
+                <a:cs typeface="Courier New"/>
+              </a:defRPr>
+            </a:pPr>
+            <a:r>
+              <a:rPr sz="1650" b="0">
+                <a:solidFill>
+                  <a:srgbClr val="A7F3D0"/>
+                </a:solidFill>
+                <a:latin typeface="Courier New"/>
+                <a:ea typeface="Courier New"/>
+                <a:cs typeface="Courier New"/>
+              </a:rPr>
+              <a:t>value = (1 + F/2^p) × 2^(E−bias)</a:t>
+            </a:r>
+          </a:p>
+          <a:p xmlns:a="http://schemas.openxmlformats.org/drawingml/2006/main">
+            <a:pPr>
+              <a:buNone/>
+              <a:defRPr sz="1650" b="0">
+                <a:solidFill>
+                  <a:srgbClr val="A7F3D0"/>
+                </a:solidFill>
+                <a:latin typeface="Courier New"/>
+                <a:ea typeface="Courier New"/>
+                <a:cs typeface="Courier New"/>
+              </a:defRPr>
+            </a:pPr>
+            <a:r>
+              <a:rPr sz="1650" b="0">
+                <a:solidFill>
+                  <a:srgbClr val="A7F3D0"/>
+                </a:solidFill>
+                <a:latin typeface="Courier New"/>
+                <a:ea typeface="Courier New"/>
+                <a:cs typeface="Courier New"/>
+              </a:rPr>
+              <a:t/>
+            </a:r>
+          </a:p>
+          <a:p xmlns:a="http://schemas.openxmlformats.org/drawingml/2006/main">
+            <a:pPr>
+              <a:buNone/>
+              <a:defRPr sz="1650">
+                <a:solidFill>
+                  <a:srgbClr val="A7F3D0"/>
+                </a:solidFill>
+                <a:latin typeface="Courier New"/>
+                <a:ea typeface="Courier New"/>
+                <a:cs typeface="Courier New"/>
+              </a:defRPr>
+            </a:pPr>
+            <a:r>
+              <a:rPr sz="1650">
+                <a:solidFill>
+                  <a:srgbClr val="A7F3D0"/>
+                </a:solidFill>
+                <a:latin typeface="Courier New"/>
+                <a:ea typeface="Courier New"/>
+                <a:cs typeface="Courier New"/>
+              </a:rPr>
+              <a:t>Subnormal (E = 0):</a:t>
+            </a:r>
+          </a:p>
+          <a:p xmlns:a="http://schemas.openxmlformats.org/drawingml/2006/main">
+            <a:pPr>
+              <a:buNone/>
+              <a:defRPr sz="1650" b="0">
+                <a:solidFill>
+                  <a:srgbClr val="A7F3D0"/>
+                </a:solidFill>
+                <a:latin typeface="Courier New"/>
+                <a:ea typeface="Courier New"/>
+                <a:cs typeface="Courier New"/>
+              </a:defRPr>
+            </a:pPr>
+            <a:r>
+              <a:rPr sz="1650" b="0">
+                <a:solidFill>
+                  <a:srgbClr val="A7F3D0"/>
+                </a:solidFill>
+                <a:latin typeface="Courier New"/>
+                <a:ea typeface="Courier New"/>
+                <a:cs typeface="Courier New"/>
+              </a:rPr>
+              <a:t>value = (F/2^p) × 2^(1−bias)</a:t>
+            </a:r>
+          </a:p>
+          <a:p xmlns:a="http://schemas.openxmlformats.org/drawingml/2006/main">
+            <a:pPr>
+              <a:buNone/>
+              <a:defRPr sz="1650" b="0">
+                <a:solidFill>
+                  <a:srgbClr val="A7F3D0"/>
+                </a:solidFill>
+                <a:latin typeface="Courier New"/>
+                <a:ea typeface="Courier New"/>
+                <a:cs typeface="Courier New"/>
+              </a:defRPr>
+            </a:pPr>
+            <a:r>
+              <a:rPr sz="1650" b="0">
+                <a:solidFill>
+                  <a:srgbClr val="A7F3D0"/>
+                </a:solidFill>
+                <a:latin typeface="Courier New"/>
+                <a:ea typeface="Courier New"/>
+                <a:cs typeface="Courier New"/>
+              </a:rPr>
+              <a:t/>
+            </a:r>
+          </a:p>
+          <a:p xmlns:a="http://schemas.openxmlformats.org/drawingml/2006/main">
+            <a:pPr>
+              <a:buNone/>
+              <a:defRPr sz="1650" b="0">
+                <a:solidFill>
+                  <a:srgbClr val="A7F3D0"/>
+                </a:solidFill>
+                <a:latin typeface="Courier New"/>
+                <a:ea typeface="Courier New"/>
+                <a:cs typeface="Courier New"/>
+              </a:defRPr>
+            </a:pPr>
+            <a:r>
+              <a:rPr sz="1650" b="0">
+                <a:solidFill>
+                  <a:srgbClr val="A7F3D0"/>
+                </a:solidFill>
+                <a:latin typeface="Courier New"/>
+                <a:ea typeface="Courier New"/>
+                <a:cs typeface="Courier New"/>
+              </a:rPr>
+              <a:t>If numerator = 0: E = 0, F = 0</a:t>
+            </a:r>
+          </a:p>
+        </p:txBody>
+      </p:sp>
+      <p:sp>
+        <p:nvSpPr>
+          <p:cNvPr id="5" name="">
+            <a:extLst xmlns:a="http://schemas.openxmlformats.org/drawingml/2006/main">
+              <a:ext uri="{FF2B5EF4-FFF2-40B4-BE49-F238E27FC236}">
+                <a16:creationId xmlns:a16="http://schemas.microsoft.com/office/drawing/2014/main" id="{7A18BC8F-2DC5-4B6B-A4F9-10CDE1183DE6}"/>
+              </a:ext>
+            </a:extLst>
+          </p:cNvPr>
+          <p:cNvSpPr>
+            <a:spLocks xmlns:a="http://schemas.openxmlformats.org/drawingml/2006/main" noGrp="1"/>
+          </p:cNvSpPr>
+          <p:nvPr/>
+        </p:nvSpPr>
+        <p:spPr>
+          <a:xfrm xmlns:a="http://schemas.openxmlformats.org/drawingml/2006/main">
+            <a:off x="685800" y="5743575"/>
+            <a:ext cx="10191750" cy="428625"/>
+          </a:xfrm>
+          <a:prstGeom xmlns:a="http://schemas.openxmlformats.org/drawingml/2006/main" prst="rect">
+            <a:avLst/>
+          </a:prstGeom>
+          <a:noFill xmlns:a="http://schemas.openxmlformats.org/drawingml/2006/main"/>
+          <a:ln xmlns:a="http://schemas.openxmlformats.org/drawingml/2006/main" w="0">
+            <a:noFill/>
+          </a:ln>
+        </p:spPr>
+        <p:txBody>
+          <a:bodyPr xmlns:a="http://schemas.openxmlformats.org/drawingml/2006/main" anchor="t">
+            <a:normAutofit fontScale="100000"/>
+          </a:bodyPr>
+          <a:lstStyle xmlns:a="http://schemas.openxmlformats.org/drawingml/2006/main"/>
+          <a:p xmlns:a="http://schemas.openxmlformats.org/drawingml/2006/main">
+            <a:pPr>
+              <a:buNone/>
+              <a:defRPr sz="1350" b="0">
+                <a:solidFill>
+                  <a:srgbClr val="A1A1AA"/>
+                </a:solidFill>
+                <a:latin typeface="Arial"/>
+                <a:ea typeface="Arial"/>
+                <a:cs typeface="Arial"/>
+              </a:defRPr>
+            </a:pPr>
+            <a:r>
+              <a:rPr sz="1350" b="0">
+                <a:solidFill>
+                  <a:srgbClr val="A1A1AA"/>
+                </a:solidFill>
+                <a:latin typeface="Arial"/>
+                <a:ea typeface="Arial"/>
+                <a:cs typeface="Arial"/>
+              </a:rPr>
+              <a:t>Use the supplied p and bias, not the values from our practice format.</a:t>
+            </a:r>
+          </a:p>
+        </p:txBody>
+      </p:sp>
+      <p:sp>
+        <p:nvSpPr>
+          <p:cNvPr id="6" name="">
+            <a:extLst xmlns:a="http://schemas.openxmlformats.org/drawingml/2006/main">
+              <a:ext uri="{FF2B5EF4-FFF2-40B4-BE49-F238E27FC236}">
+                <a16:creationId xmlns:a16="http://schemas.microsoft.com/office/drawing/2014/main" id="{94269C50-3A0A-4FBB-A1D2-A33411F72ECA}"/>
+              </a:ext>
+            </a:extLst>
+          </p:cNvPr>
+          <p:cNvSpPr>
+            <a:spLocks xmlns:a="http://schemas.openxmlformats.org/drawingml/2006/main" noGrp="1"/>
+          </p:cNvSpPr>
+          <p:nvPr/>
+        </p:nvSpPr>
+        <p:spPr>
+          <a:xfrm xmlns:a="http://schemas.openxmlformats.org/drawingml/2006/main">
+            <a:off x="10477500" y="6210300"/>
+            <a:ext cx="1000125" cy="219075"/>
+          </a:xfrm>
+          <a:prstGeom xmlns:a="http://schemas.openxmlformats.org/drawingml/2006/main" prst="rect">
+            <a:avLst/>
+          </a:prstGeom>
+          <a:noFill xmlns:a="http://schemas.openxmlformats.org/drawingml/2006/main"/>
+          <a:ln xmlns:a="http://schemas.openxmlformats.org/drawingml/2006/main" w="0">
+            <a:noFill/>
+          </a:ln>
+        </p:spPr>
+        <p:txBody>
+          <a:bodyPr xmlns:a="http://schemas.openxmlformats.org/drawingml/2006/main" anchor="t">
+            <a:normAutofit fontScale="79762"/>
+          </a:bodyPr>
+          <a:lstStyle xmlns:a="http://schemas.openxmlformats.org/drawingml/2006/main"/>
+          <a:p xmlns:a="http://schemas.openxmlformats.org/drawingml/2006/main">
+            <a:pPr>
+              <a:buNone/>
+              <a:defRPr sz="1050" b="0">
+                <a:solidFill>
+                  <a:srgbClr val="71717A"/>
+                </a:solidFill>
+                <a:latin typeface="Courier New"/>
+                <a:ea typeface="Courier New"/>
+                <a:cs typeface="Courier New"/>
+              </a:defRPr>
+            </a:pPr>
+            <a:r>
+              <a:rPr sz="1050" b="0">
+                <a:solidFill>
+                  <a:srgbClr val="71717A"/>
+                </a:solidFill>
+                <a:latin typeface="Courier New"/>
+                <a:ea typeface="Courier New"/>
+                <a:cs typeface="Courier New"/>
+              </a:rPr>
+              <a:t>21 / 22</a:t>
+            </a:r>
+          </a:p>
+        </p:txBody>
+      </p:sp>
+    </p:spTree>
+    <p:extLst>
+      <p:ext uri="{BB962C8B-B14F-4D97-AF65-F5344CB8AC3E}">
+        <p14:creationId xmlns:p14="http://schemas.microsoft.com/office/powerpoint/2010/main" val="1018474765"/>
+      </p:ext>
+    </p:extLst>
+  </p:cSld>
+</p:sld>
+</file>
+
+<file path=ppt/slides/slide22.xml><?xml version="1.0" encoding="utf-8"?>
+<p:sld xmlns:p="http://schemas.openxmlformats.org/presentationml/2006/main">
+  <p:cSld>
+    <p:bg>
+      <p:bgPr>
+        <a:solidFill xmlns:a="http://schemas.openxmlformats.org/drawingml/2006/main">
+          <a:srgbClr val="09090B"/>
+        </a:solidFill>
+      </p:bgPr>
+    </p:bg>
+    <p:spTree>
+      <p:nvGrpSpPr>
+        <p:cNvPr id="1" name=""/>
+        <p:cNvGrpSpPr/>
+        <p:nvPr/>
+      </p:nvGrpSpPr>
+      <p:grpSpPr>
+        <a:xfrm xmlns:a="http://schemas.openxmlformats.org/drawingml/2006/main"/>
+      </p:grpSpPr>
+      <p:sp>
+        <p:nvSpPr>
+          <p:cNvPr id="7" name="">
+            <a:extLst xmlns:a="http://schemas.openxmlformats.org/drawingml/2006/main">
+              <a:ext uri="{FF2B5EF4-FFF2-40B4-BE49-F238E27FC236}">
+                <a16:creationId xmlns:a16="http://schemas.microsoft.com/office/drawing/2014/main" id="{4989B079-C3E8-43BB-8638-96121018769A}"/>
+              </a:ext>
+            </a:extLst>
+          </p:cNvPr>
+          <p:cNvSpPr>
+            <a:spLocks xmlns:a="http://schemas.openxmlformats.org/drawingml/2006/main" noGrp="1"/>
+          </p:cNvSpPr>
+          <p:nvPr/>
+        </p:nvSpPr>
+        <p:spPr>
+          <a:xfrm xmlns:a="http://schemas.openxmlformats.org/drawingml/2006/main">
+            <a:off x="685800" y="361950"/>
+            <a:ext cx="10477500" cy="285750"/>
+          </a:xfrm>
+          <a:prstGeom xmlns:a="http://schemas.openxmlformats.org/drawingml/2006/main" prst="rect">
+            <a:avLst/>
+          </a:prstGeom>
+          <a:noFill xmlns:a="http://schemas.openxmlformats.org/drawingml/2006/main"/>
+          <a:ln xmlns:a="http://schemas.openxmlformats.org/drawingml/2006/main" w="0">
+            <a:noFill/>
+          </a:ln>
+        </p:spPr>
+        <p:txBody>
+          <a:bodyPr xmlns:a="http://schemas.openxmlformats.org/drawingml/2006/main" anchor="t">
+            <a:normAutofit fontScale="100000"/>
+          </a:bodyPr>
+          <a:lstStyle xmlns:a="http://schemas.openxmlformats.org/drawingml/2006/main"/>
+          <a:p xmlns:a="http://schemas.openxmlformats.org/drawingml/2006/main">
+            <a:pPr>
+              <a:buNone/>
+              <a:defRPr sz="1275" b="0">
+                <a:solidFill>
+                  <a:srgbClr val="6EE7B7"/>
+                </a:solidFill>
+                <a:latin typeface="Courier New"/>
+                <a:ea typeface="Courier New"/>
+                <a:cs typeface="Courier New"/>
+              </a:defRPr>
+            </a:pPr>
+            <a:r>
+              <a:rPr sz="1275" b="0">
+                <a:solidFill>
+                  <a:srgbClr val="6EE7B7"/>
+                </a:solidFill>
+                <a:latin typeface="Courier New"/>
+                <a:ea typeface="Courier New"/>
+                <a:cs typeface="Courier New"/>
+              </a:rPr>
+              <a:t>FLOATING POINT · RECAP</a:t>
+            </a:r>
+          </a:p>
+        </p:txBody>
+      </p:sp>
+      <p:sp>
+        <p:nvSpPr>
+          <p:cNvPr id="2" name="">
+            <a:extLst xmlns:a="http://schemas.openxmlformats.org/drawingml/2006/main">
+              <a:ext uri="{FF2B5EF4-FFF2-40B4-BE49-F238E27FC236}">
+                <a16:creationId xmlns:a16="http://schemas.microsoft.com/office/drawing/2014/main" id="{95D3113E-85F1-4E22-A62E-265E94FE3617}"/>
+              </a:ext>
+            </a:extLst>
+          </p:cNvPr>
+          <p:cNvSpPr>
+            <a:spLocks xmlns:a="http://schemas.openxmlformats.org/drawingml/2006/main" noGrp="1"/>
+          </p:cNvSpPr>
+          <p:nvPr/>
+        </p:nvSpPr>
+        <p:spPr>
+          <a:xfrm xmlns:a="http://schemas.openxmlformats.org/drawingml/2006/main">
+            <a:off x="685800" y="885825"/>
+            <a:ext cx="10820400" cy="1066800"/>
+          </a:xfrm>
+          <a:prstGeom xmlns:a="http://schemas.openxmlformats.org/drawingml/2006/main" prst="rect">
+            <a:avLst/>
+          </a:prstGeom>
+          <a:noFill xmlns:a="http://schemas.openxmlformats.org/drawingml/2006/main"/>
+          <a:ln xmlns:a="http://schemas.openxmlformats.org/drawingml/2006/main" w="0">
+            <a:noFill/>
+          </a:ln>
+        </p:spPr>
+        <p:txBody>
+          <a:bodyPr xmlns:a="http://schemas.openxmlformats.org/drawingml/2006/main" anchor="t">
+            <a:normAutofit fontScale="100000"/>
+          </a:bodyPr>
+          <a:lstStyle xmlns:a="http://schemas.openxmlformats.org/drawingml/2006/main"/>
+          <a:p xmlns:a="http://schemas.openxmlformats.org/drawingml/2006/main">
+            <a:pPr>
+              <a:buNone/>
+              <a:defRPr sz="3600" b="0">
+                <a:solidFill>
+                  <a:srgbClr val="FAFAFA"/>
+                </a:solidFill>
+                <a:latin typeface="Arial"/>
+                <a:ea typeface="Arial"/>
+                <a:cs typeface="Arial"/>
+              </a:defRPr>
+            </a:pPr>
+            <a:r>
+              <a:rPr sz="3600" b="0">
+                <a:solidFill>
+                  <a:srgbClr val="FAFAFA"/>
+                </a:solidFill>
+                <a:latin typeface="Arial"/>
+                <a:ea typeface="Arial"/>
+                <a:cs typeface="Arial"/>
+              </a:rPr>
+              <a:t>How to check an encoding</a:t>
+            </a:r>
+          </a:p>
+        </p:txBody>
+      </p:sp>
+      <p:sp>
+        <p:nvSpPr>
+          <p:cNvPr id="3" name="">
+            <a:extLst xmlns:a="http://schemas.openxmlformats.org/drawingml/2006/main">
+              <a:ext uri="{FF2B5EF4-FFF2-40B4-BE49-F238E27FC236}">
+                <a16:creationId xmlns:a16="http://schemas.microsoft.com/office/drawing/2014/main" id="{8EC5E33C-BA7C-4ADE-9FC3-9ABD9F3C6FD4}"/>
+              </a:ext>
+            </a:extLst>
+          </p:cNvPr>
+          <p:cNvSpPr>
+            <a:spLocks xmlns:a="http://schemas.openxmlformats.org/drawingml/2006/main" noGrp="1"/>
+          </p:cNvSpPr>
+          <p:nvPr/>
+        </p:nvSpPr>
+        <p:spPr>
+          <a:xfrm xmlns:a="http://schemas.openxmlformats.org/drawingml/2006/main">
+            <a:off x="685800" y="2200275"/>
+            <a:ext cx="4857750" cy="3124200"/>
+          </a:xfrm>
+          <a:prstGeom xmlns:a="http://schemas.openxmlformats.org/drawingml/2006/main" prst="rect">
+            <a:avLst/>
+          </a:prstGeom>
+          <a:noFill xmlns:a="http://schemas.openxmlformats.org/drawingml/2006/main"/>
+          <a:ln xmlns:a="http://schemas.openxmlformats.org/drawingml/2006/main" w="0">
+            <a:noFill/>
+          </a:ln>
+        </p:spPr>
+        <p:txBody>
+          <a:bodyPr xmlns:a="http://schemas.openxmlformats.org/drawingml/2006/main" anchor="t">
+            <a:normAutofit fontScale="100000"/>
+          </a:bodyPr>
+          <a:lstStyle xmlns:a="http://schemas.openxmlformats.org/drawingml/2006/main"/>
+          <a:p xmlns:a="http://schemas.openxmlformats.org/drawingml/2006/main">
+            <a:pPr>
+              <a:buNone/>
+              <a:defRPr sz="1950" b="0">
+                <a:solidFill>
+                  <a:srgbClr val="D4D4D8"/>
+                </a:solidFill>
+                <a:latin typeface="Arial"/>
+                <a:ea typeface="Arial"/>
+                <a:cs typeface="Arial"/>
+              </a:defRPr>
+            </a:pPr>
+            <a:r>
+              <a:rPr sz="1950" b="0">
+                <a:solidFill>
+                  <a:srgbClr val="D4D4D8"/>
+                </a:solidFill>
+                <a:latin typeface="Arial"/>
+                <a:ea typeface="Arial"/>
+                <a:cs typeface="Arial"/>
+              </a:rPr>
+              <a:t>In our practice format, E = 0 means count F steps of 1/32. Otherwise decode e = E − 3 and use the implied leading 1.</a:t>
+            </a:r>
+          </a:p>
+          <a:p xmlns:a="http://schemas.openxmlformats.org/drawingml/2006/main">
+            <a:r>
+              <a:t/>
+            </a:r>
+          </a:p>
+          <a:p xmlns:a="http://schemas.openxmlformats.org/drawingml/2006/main">
+            <a:pPr>
+              <a:buNone/>
+              <a:defRPr sz="1950" b="0">
+                <a:solidFill>
+                  <a:srgbClr val="D4D4D8"/>
+                </a:solidFill>
+                <a:latin typeface="Arial"/>
+                <a:ea typeface="Arial"/>
+                <a:cs typeface="Arial"/>
+              </a:defRPr>
+            </a:pPr>
+            <a:r>
+              <a:rPr sz="1950" b="0">
+                <a:solidFill>
+                  <a:srgbClr val="D4D4D8"/>
+                </a:solidFill>
+                <a:latin typeface="Arial"/>
+                <a:ea typeface="Arial"/>
+                <a:cs typeface="Arial"/>
+              </a:rPr>
+              <a:t>For an inexact value, follow the problem’s rounding rule.</a:t>
+            </a:r>
+          </a:p>
+        </p:txBody>
+      </p:sp>
+      <p:sp>
+        <p:nvSpPr>
+          <p:cNvPr id="4" name="">
+            <a:extLst xmlns:a="http://schemas.openxmlformats.org/drawingml/2006/main">
+              <a:ext uri="{FF2B5EF4-FFF2-40B4-BE49-F238E27FC236}">
+                <a16:creationId xmlns:a16="http://schemas.microsoft.com/office/drawing/2014/main" id="{EA939046-DA6B-448C-A179-5B13743C72F3}"/>
+              </a:ext>
+            </a:extLst>
+          </p:cNvPr>
+          <p:cNvSpPr>
+            <a:spLocks xmlns:a="http://schemas.openxmlformats.org/drawingml/2006/main" noGrp="1"/>
+          </p:cNvSpPr>
+          <p:nvPr/>
+        </p:nvSpPr>
+        <p:spPr>
+          <a:xfrm xmlns:a="http://schemas.openxmlformats.org/drawingml/2006/main">
+            <a:off x="6181725" y="2200275"/>
+            <a:ext cx="5238750" cy="3286125"/>
+          </a:xfrm>
+          <a:prstGeom xmlns:a="http://schemas.openxmlformats.org/drawingml/2006/main" prst="rect">
+            <a:avLst/>
+          </a:prstGeom>
+          <a:noFill xmlns:a="http://schemas.openxmlformats.org/drawingml/2006/main"/>
+          <a:ln xmlns:a="http://schemas.openxmlformats.org/drawingml/2006/main" w="0">
+            <a:noFill/>
+          </a:ln>
+        </p:spPr>
+        <p:txBody>
+          <a:bodyPr xmlns:a="http://schemas.openxmlformats.org/drawingml/2006/main" anchor="t">
+            <a:normAutofit fontScale="100000"/>
+          </a:bodyPr>
+          <a:lstStyle xmlns:a="http://schemas.openxmlformats.org/drawingml/2006/main"/>
+          <a:p xmlns:a="http://schemas.openxmlformats.org/drawingml/2006/main">
+            <a:pPr>
+              <a:buNone/>
+              <a:defRPr sz="1650" b="0">
+                <a:solidFill>
+                  <a:srgbClr val="A7F3D0"/>
+                </a:solidFill>
+                <a:latin typeface="Courier New"/>
+                <a:ea typeface="Courier New"/>
+                <a:cs typeface="Courier New"/>
+              </a:defRPr>
+            </a:pPr>
+            <a:r>
+              <a:rPr sz="1650" b="0">
+                <a:solidFill>
+                  <a:srgbClr val="A7F3D0"/>
+                </a:solidFill>
+                <a:latin typeface="Courier New"/>
+                <a:ea typeface="Courier New"/>
+                <a:cs typeface="Courier New"/>
+              </a:rPr>
+              <a:t>Our practice format</a:t>
+            </a:r>
+          </a:p>
+          <a:p xmlns:a="http://schemas.openxmlformats.org/drawingml/2006/main">
+            <a:r>
+              <a:t/>
+            </a:r>
+          </a:p>
+          <a:p xmlns:a="http://schemas.openxmlformats.org/drawingml/2006/main">
+            <a:pPr>
+              <a:buNone/>
+              <a:defRPr sz="1650" b="0">
+                <a:solidFill>
+                  <a:srgbClr val="A7F3D0"/>
+                </a:solidFill>
+                <a:latin typeface="Courier New"/>
+                <a:ea typeface="Courier New"/>
+                <a:cs typeface="Courier New"/>
+              </a:defRPr>
+            </a:pPr>
+            <a:r>
+              <a:rPr sz="1650" b="0">
+                <a:solidFill>
+                  <a:srgbClr val="A7F3D0"/>
+                </a:solidFill>
+                <a:latin typeface="Courier New"/>
+                <a:ea typeface="Courier New"/>
+                <a:cs typeface="Courier New"/>
+              </a:rPr>
+              <a:t>Normal:    (1 + F/8) × 2^(E−3)</a:t>
+            </a:r>
+          </a:p>
+          <a:p xmlns:a="http://schemas.openxmlformats.org/drawingml/2006/main">
+            <a:pPr>
+              <a:buNone/>
+              <a:defRPr sz="1650" b="0">
+                <a:solidFill>
+                  <a:srgbClr val="A7F3D0"/>
+                </a:solidFill>
+                <a:latin typeface="Courier New"/>
+                <a:ea typeface="Courier New"/>
+                <a:cs typeface="Courier New"/>
+              </a:defRPr>
+            </a:pPr>
+            <a:r>
+              <a:rPr sz="1650" b="0">
+                <a:solidFill>
+                  <a:srgbClr val="A7F3D0"/>
+                </a:solidFill>
+                <a:latin typeface="Courier New"/>
+                <a:ea typeface="Courier New"/>
+                <a:cs typeface="Courier New"/>
+              </a:rPr>
+              <a:t>Subnormal: F/32  (E = 0)</a:t>
+            </a:r>
+          </a:p>
+          <a:p xmlns:a="http://schemas.openxmlformats.org/drawingml/2006/main">
+            <a:r>
+              <a:t/>
+            </a:r>
+          </a:p>
+          <a:p xmlns:a="http://schemas.openxmlformats.org/drawingml/2006/main">
+            <a:pPr>
+              <a:buNone/>
+              <a:defRPr sz="1650" b="0">
+                <a:solidFill>
+                  <a:srgbClr val="A7F3D0"/>
+                </a:solidFill>
+                <a:latin typeface="Courier New"/>
+                <a:ea typeface="Courier New"/>
+                <a:cs typeface="Courier New"/>
+              </a:defRPr>
+            </a:pPr>
+            <a:r>
+              <a:rPr sz="1650" b="0">
+                <a:solidFill>
+                  <a:srgbClr val="A7F3D0"/>
+                </a:solidFill>
+                <a:latin typeface="Courier New"/>
+                <a:ea typeface="Courier New"/>
+                <a:cs typeface="Courier New"/>
+              </a:rPr>
+              <a:t>E = 0, F = 0  →  zero</a:t>
+            </a:r>
+          </a:p>
+          <a:p xmlns:a="http://schemas.openxmlformats.org/drawingml/2006/main">
+            <a:r>
+              <a:t/>
+            </a:r>
+          </a:p>
+          <a:p xmlns:a="http://schemas.openxmlformats.org/drawingml/2006/main">
+            <a:pPr>
+              <a:buNone/>
+              <a:defRPr sz="1650" b="0">
+                <a:solidFill>
+                  <a:srgbClr val="A7F3D0"/>
+                </a:solidFill>
+                <a:latin typeface="Courier New"/>
+                <a:ea typeface="Courier New"/>
+                <a:cs typeface="Courier New"/>
+              </a:defRPr>
+            </a:pPr>
+            <a:r>
+              <a:rPr sz="1650" b="0">
+                <a:solidFill>
+                  <a:srgbClr val="A7F3D0"/>
+                </a:solidFill>
+                <a:latin typeface="Courier New"/>
+                <a:ea typeface="Courier New"/>
+                <a:cs typeface="Courier New"/>
+              </a:rPr>
+              <a:t>Decode your bits as a final check.</a:t>
+            </a:r>
+          </a:p>
+        </p:txBody>
+      </p:sp>
+      <p:sp>
+        <p:nvSpPr>
+          <p:cNvPr id="5" name="">
+            <a:extLst xmlns:a="http://schemas.openxmlformats.org/drawingml/2006/main">
+              <a:ext uri="{FF2B5EF4-FFF2-40B4-BE49-F238E27FC236}">
+                <a16:creationId xmlns:a16="http://schemas.microsoft.com/office/drawing/2014/main" id="{585A0E73-828D-45A1-9AD7-8EED8C5E7EB1}"/>
+              </a:ext>
+            </a:extLst>
+          </p:cNvPr>
+          <p:cNvSpPr>
+            <a:spLocks xmlns:a="http://schemas.openxmlformats.org/drawingml/2006/main" noGrp="1"/>
+          </p:cNvSpPr>
+          <p:nvPr/>
+        </p:nvSpPr>
+        <p:spPr>
+          <a:xfrm xmlns:a="http://schemas.openxmlformats.org/drawingml/2006/main">
+            <a:off x="685800" y="5743575"/>
+            <a:ext cx="10191750" cy="428625"/>
+          </a:xfrm>
+          <a:prstGeom xmlns:a="http://schemas.openxmlformats.org/drawingml/2006/main" prst="rect">
+            <a:avLst/>
+          </a:prstGeom>
+          <a:noFill xmlns:a="http://schemas.openxmlformats.org/drawingml/2006/main"/>
+          <a:ln xmlns:a="http://schemas.openxmlformats.org/drawingml/2006/main" w="0">
+            <a:noFill/>
+          </a:ln>
+        </p:spPr>
+        <p:txBody>
+          <a:bodyPr xmlns:a="http://schemas.openxmlformats.org/drawingml/2006/main" anchor="t">
+            <a:normAutofit fontScale="100000"/>
+          </a:bodyPr>
+          <a:lstStyle xmlns:a="http://schemas.openxmlformats.org/drawingml/2006/main"/>
+          <a:p xmlns:a="http://schemas.openxmlformats.org/drawingml/2006/main">
+            <a:pPr>
+              <a:buNone/>
+              <a:defRPr sz="1350" b="0">
+                <a:solidFill>
+                  <a:srgbClr val="A1A1AA"/>
+                </a:solidFill>
+                <a:latin typeface="Arial"/>
+                <a:ea typeface="Arial"/>
+                <a:cs typeface="Arial"/>
+              </a:defRPr>
+            </a:pPr>
+            <a:r>
+              <a:rPr sz="1350" b="0">
+                <a:solidFill>
+                  <a:srgbClr val="A1A1AA"/>
+                </a:solidFill>
+                <a:latin typeface="Arial"/>
+                <a:ea typeface="Arial"/>
+                <a:cs typeface="Arial"/>
+              </a:rPr>
+              <a:t>A correct encoding must reproduce the intended value or its required rounded value.</a:t>
+            </a:r>
+          </a:p>
+        </p:txBody>
+      </p:sp>
+      <p:sp>
+        <p:nvSpPr>
+          <p:cNvPr id="6" name="">
+            <a:extLst xmlns:a="http://schemas.openxmlformats.org/drawingml/2006/main">
+              <a:ext uri="{FF2B5EF4-FFF2-40B4-BE49-F238E27FC236}">
+                <a16:creationId xmlns:a16="http://schemas.microsoft.com/office/drawing/2014/main" id="{E1FBC5BD-1F5D-42FA-AC83-E0BF862F4EDF}"/>
+              </a:ext>
+            </a:extLst>
+          </p:cNvPr>
+          <p:cNvSpPr>
+            <a:spLocks xmlns:a="http://schemas.openxmlformats.org/drawingml/2006/main" noGrp="1"/>
+          </p:cNvSpPr>
+          <p:nvPr/>
+        </p:nvSpPr>
+        <p:spPr>
+          <a:xfrm xmlns:a="http://schemas.openxmlformats.org/drawingml/2006/main">
+            <a:off x="10477500" y="6210300"/>
+            <a:ext cx="1000125" cy="219075"/>
+          </a:xfrm>
+          <a:prstGeom xmlns:a="http://schemas.openxmlformats.org/drawingml/2006/main" prst="rect">
+            <a:avLst/>
+          </a:prstGeom>
+          <a:noFill xmlns:a="http://schemas.openxmlformats.org/drawingml/2006/main"/>
+          <a:ln xmlns:a="http://schemas.openxmlformats.org/drawingml/2006/main" w="0">
+            <a:noFill/>
+          </a:ln>
+        </p:spPr>
+        <p:txBody>
+          <a:bodyPr xmlns:a="http://schemas.openxmlformats.org/drawingml/2006/main" anchor="t">
+            <a:normAutofit fontScale="79762"/>
+          </a:bodyPr>
+          <a:lstStyle xmlns:a="http://schemas.openxmlformats.org/drawingml/2006/main"/>
+          <a:p xmlns:a="http://schemas.openxmlformats.org/drawingml/2006/main">
+            <a:pPr>
+              <a:buNone/>
+              <a:defRPr sz="1050" b="0">
+                <a:solidFill>
+                  <a:srgbClr val="71717A"/>
+                </a:solidFill>
+                <a:latin typeface="Courier New"/>
+                <a:ea typeface="Courier New"/>
+                <a:cs typeface="Courier New"/>
+              </a:defRPr>
+            </a:pPr>
+            <a:r>
+              <a:rPr sz="1050" b="0">
+                <a:solidFill>
+                  <a:srgbClr val="71717A"/>
+                </a:solidFill>
+                <a:latin typeface="Courier New"/>
+                <a:ea typeface="Courier New"/>
+                <a:cs typeface="Courier New"/>
+              </a:rPr>
+              <a:t>22 / 22</a:t>
             </a:r>
           </a:p>
         </p:txBody>
@@ -9654,7 +10801,7 @@
                 <a:ea typeface="Courier New"/>
                 <a:cs typeface="Courier New"/>
               </a:rPr>
-              <a:t>03 / 20</a:t>
+              <a:t>03 / 22</a:t>
             </a:r>
           </a:p>
         </p:txBody>
@@ -10137,7 +11284,7 @@
                 <a:ea typeface="Courier New"/>
                 <a:cs typeface="Courier New"/>
               </a:rPr>
-              <a:t>04 / 20</a:t>
+              <a:t>04 / 22</a:t>
             </a:r>
           </a:p>
         </p:txBody>
@@ -10282,7 +11429,7 @@
                 <a:ea typeface="Arial"/>
                 <a:cs typeface="Arial"/>
               </a:rPr>
-              <a:t>The exponent has a bias</a:t>
+              <a:t>Stored and true exponents</a:t>
             </a:r>
           </a:p>
         </p:txBody>
@@ -10340,36 +11487,7 @@
                 <a:ea typeface="Arial"/>
                 <a:cs typeface="Arial"/>
               </a:rPr>
-              <a:t>A normal value is written as 1.fraction × 2ᵉ. The leading 1 is implied and is not stored.</a:t>
-            </a:r>
-          </a:p>
-          <a:p xmlns:a="http://schemas.openxmlformats.org/drawingml/2006/main">
-            <a:r>
-              <a:t/>
-            </a:r>
-          </a:p>
-          <a:p xmlns:a="http://schemas.openxmlformats.org/drawingml/2006/main">
-            <a:pPr>
-              <a:buNone/>
-              <a:defRPr sz="1950" b="0">
-                <a:solidFill>
-                  <a:srgbClr val="D4D4D8"/>
-                </a:solidFill>
-                <a:latin typeface="Arial"/>
-                <a:ea typeface="Arial"/>
-                <a:cs typeface="Arial"/>
-              </a:defRPr>
-            </a:pPr>
-            <a:r>
-              <a:rPr sz="1950" b="0">
-                <a:solidFill>
-                  <a:srgbClr val="D4D4D8"/>
-                </a:solidFill>
-                <a:latin typeface="Arial"/>
-                <a:ea typeface="Arial"/>
-                <a:cs typeface="Arial"/>
-              </a:rPr>
-              <a:t>The stored exponent E equals e + bias.</a:t>
+              <a:t>Here E is the unsigned number stored in the exponent bits. Lowercase e is the true exponent in 2ᵉ. For normal values, subtract the bias when decoding and add it when encoding.</a:t>
             </a:r>
           </a:p>
         </p:txBody>
@@ -10456,7 +11574,7 @@
                 <a:ea typeface="Courier New"/>
                 <a:cs typeface="Courier New"/>
               </a:rPr>
-              <a:t>e = −2  →  E = 1  →  bits 001</a:t>
+              <a:t>Decode bits 001₂:</a:t>
             </a:r>
           </a:p>
           <a:p xmlns:a="http://schemas.openxmlformats.org/drawingml/2006/main">
@@ -10480,7 +11598,7 @@
                 <a:ea typeface="Courier New"/>
                 <a:cs typeface="Courier New"/>
               </a:rPr>
-              <a:t>e =  0  →  E = 3  →  bits 011</a:t>
+              <a:t>E = 1  →  e = 1 − 3 = −2</a:t>
             </a:r>
           </a:p>
           <a:p xmlns:a="http://schemas.openxmlformats.org/drawingml/2006/main">
@@ -10504,7 +11622,55 @@
                 <a:ea typeface="Courier New"/>
                 <a:cs typeface="Courier New"/>
               </a:rPr>
-              <a:t>e =  2  →  E = 5  →  bits 101</a:t>
+              <a:t/>
+            </a:r>
+          </a:p>
+          <a:p xmlns:a="http://schemas.openxmlformats.org/drawingml/2006/main">
+            <a:pPr>
+              <a:buNone/>
+              <a:defRPr sz="1650" b="0">
+                <a:solidFill>
+                  <a:srgbClr val="A7F3D0"/>
+                </a:solidFill>
+                <a:latin typeface="Courier New"/>
+                <a:ea typeface="Courier New"/>
+                <a:cs typeface="Courier New"/>
+              </a:defRPr>
+            </a:pPr>
+            <a:r>
+              <a:rPr sz="1650" b="0">
+                <a:solidFill>
+                  <a:srgbClr val="A7F3D0"/>
+                </a:solidFill>
+                <a:latin typeface="Courier New"/>
+                <a:ea typeface="Courier New"/>
+                <a:cs typeface="Courier New"/>
+              </a:rPr>
+              <a:t>Encode true exponent e = −2:</a:t>
+            </a:r>
+          </a:p>
+          <a:p xmlns:a="http://schemas.openxmlformats.org/drawingml/2006/main">
+            <a:pPr>
+              <a:buNone/>
+              <a:defRPr sz="1650" b="0">
+                <a:solidFill>
+                  <a:srgbClr val="A7F3D0"/>
+                </a:solidFill>
+                <a:latin typeface="Courier New"/>
+                <a:ea typeface="Courier New"/>
+                <a:cs typeface="Courier New"/>
+              </a:defRPr>
+            </a:pPr>
+            <a:r>
+              <a:rPr sz="1650" b="0">
+                <a:solidFill>
+                  <a:srgbClr val="A7F3D0"/>
+                </a:solidFill>
+                <a:latin typeface="Courier New"/>
+                <a:ea typeface="Courier New"/>
+                <a:cs typeface="Courier New"/>
+              </a:rPr>
+              <a:t>E = −2 + 3 = 1  →  bits 001</a:t>
             </a:r>
           </a:p>
         </p:txBody>
@@ -10562,7 +11728,7 @@
                 <a:ea typeface="Arial"/>
                 <a:cs typeface="Arial"/>
               </a:rPr>
-              <a:t>In this 3-bit format, E = 0 is for zero or subnormals; E = 7 is reserved.</a:t>
+              <a:t>Symbols vary by source: first decide which exponent is stored.</a:t>
             </a:r>
           </a:p>
         </p:txBody>
@@ -10620,7 +11786,7 @@
                 <a:ea typeface="Courier New"/>
                 <a:cs typeface="Courier New"/>
               </a:rPr>
-              <a:t>05 / 20</a:t>
+              <a:t>05 / 22</a:t>
             </a:r>
           </a:p>
         </p:txBody>
@@ -11132,7 +12298,7 @@
                 <a:ea typeface="Courier New"/>
                 <a:cs typeface="Courier New"/>
               </a:rPr>
-              <a:t>06 / 20</a:t>
+              <a:t>06 / 22</a:t>
             </a:r>
           </a:p>
         </p:txBody>
@@ -11620,7 +12786,7 @@
                 <a:ea typeface="Courier New"/>
                 <a:cs typeface="Courier New"/>
               </a:rPr>
-              <a:t>07 / 20</a:t>
+              <a:t>07 / 22</a:t>
             </a:r>
           </a:p>
         </p:txBody>
@@ -11707,7 +12873,7 @@
                 <a:ea typeface="Courier New"/>
                 <a:cs typeface="Courier New"/>
               </a:rPr>
-              <a:t>FLOATING POINT · SUBNORMALS</a:t>
+              <a:t>FLOATING POINT · WHY SUBNORMALS</a:t>
             </a:r>
           </a:p>
         </p:txBody>
@@ -11765,7 +12931,7 @@
                 <a:ea typeface="Arial"/>
                 <a:cs typeface="Arial"/>
               </a:rPr>
-              <a:t>What happens below the normal range?</a:t>
+              <a:t>The smallest normal is 1/4</a:t>
             </a:r>
           </a:p>
         </p:txBody>
@@ -11823,36 +12989,7 @@
                 <a:ea typeface="Arial"/>
                 <a:cs typeface="Arial"/>
               </a:rPr>
-              <a:t>The smallest positive normal value here is 1.000₂ × 2⁻² = 1/4.</a:t>
-            </a:r>
-          </a:p>
-          <a:p xmlns:a="http://schemas.openxmlformats.org/drawingml/2006/main">
-            <a:r>
-              <a:t/>
-            </a:r>
-          </a:p>
-          <a:p xmlns:a="http://schemas.openxmlformats.org/drawingml/2006/main">
-            <a:pPr>
-              <a:buNone/>
-              <a:defRPr sz="1950" b="0">
-                <a:solidFill>
-                  <a:srgbClr val="D4D4D8"/>
-                </a:solidFill>
-                <a:latin typeface="Arial"/>
-                <a:ea typeface="Arial"/>
-                <a:cs typeface="Arial"/>
-              </a:defRPr>
-            </a:pPr>
-            <a:r>
-              <a:rPr sz="1950" b="0">
-                <a:solidFill>
-                  <a:srgbClr val="D4D4D8"/>
-                </a:solidFill>
-                <a:latin typeface="Arial"/>
-                <a:ea typeface="Arial"/>
-                <a:cs typeface="Arial"/>
-              </a:rPr>
-              <a:t>Smaller positive values use E = 0. They have no implied leading 1. Their exponent is fixed at 1 − bias.</a:t>
+              <a:t>The smallest normal exponent field is E = 1. With bias 3, that means e = −2. If the stored fraction is 000, the value is 1/4. We need another way to represent smaller positive values such as 1/8.</a:t>
             </a:r>
           </a:p>
         </p:txBody>
@@ -11910,7 +13047,7 @@
                 <a:ea typeface="Courier New"/>
                 <a:cs typeface="Courier New"/>
               </a:rPr>
-              <a:t>Normal:    (1 + F/8) × 2^(E−3)</a:t>
+              <a:t>Smallest normal</a:t>
             </a:r>
           </a:p>
           <a:p xmlns:a="http://schemas.openxmlformats.org/drawingml/2006/main">
@@ -11934,16 +13071,34 @@
                 <a:ea typeface="Courier New"/>
                 <a:cs typeface="Courier New"/>
               </a:rPr>
-              <a:t>Subnormal: (    F/8) × 2^(1−3)</a:t>
-            </a:r>
-          </a:p>
-          <a:p xmlns:a="http://schemas.openxmlformats.org/drawingml/2006/main">
-            <a:r>
               <a:t/>
             </a:r>
           </a:p>
           <a:p xmlns:a="http://schemas.openxmlformats.org/drawingml/2006/main">
             <a:pPr>
+              <a:defRPr sz="1650">
+                <a:solidFill>
+                  <a:srgbClr val="A7F3D0"/>
+                </a:solidFill>
+                <a:latin typeface="Courier New"/>
+                <a:ea typeface="Courier New"/>
+                <a:cs typeface="Courier New"/>
+              </a:defRPr>
+            </a:pPr>
+            <a:r>
+              <a:rPr sz="1650">
+                <a:solidFill>
+                  <a:srgbClr val="A7F3D0"/>
+                </a:solidFill>
+                <a:latin typeface="Courier New"/>
+                <a:ea typeface="Courier New"/>
+                <a:cs typeface="Courier New"/>
+              </a:rPr>
+              <a:t>E = 001₂  →  e = 1 − 3 = −2</a:t>
+            </a:r>
+          </a:p>
+          <a:p xmlns:a="http://schemas.openxmlformats.org/drawingml/2006/main">
+            <a:pPr>
               <a:buNone/>
               <a:defRPr sz="1650" b="0">
                 <a:solidFill>
@@ -11963,7 +13118,7 @@
                 <a:ea typeface="Courier New"/>
                 <a:cs typeface="Courier New"/>
               </a:rPr>
-              <a:t>With E = 0:</a:t>
+              <a:t>F = 000₂  →  significand 1.000₂</a:t>
             </a:r>
           </a:p>
           <a:p xmlns:a="http://schemas.openxmlformats.org/drawingml/2006/main">
@@ -11987,7 +13142,79 @@
                 <a:ea typeface="Courier New"/>
                 <a:cs typeface="Courier New"/>
               </a:rPr>
-              <a:t>value = (F/8) × 1/4 = F/32</a:t>
+              <a:t/>
+            </a:r>
+          </a:p>
+          <a:p xmlns:a="http://schemas.openxmlformats.org/drawingml/2006/main">
+            <a:pPr>
+              <a:buNone/>
+              <a:defRPr sz="1650" b="0">
+                <a:solidFill>
+                  <a:srgbClr val="A7F3D0"/>
+                </a:solidFill>
+                <a:latin typeface="Courier New"/>
+                <a:ea typeface="Courier New"/>
+                <a:cs typeface="Courier New"/>
+              </a:defRPr>
+            </a:pPr>
+            <a:r>
+              <a:rPr sz="1650" b="0">
+                <a:solidFill>
+                  <a:srgbClr val="A7F3D0"/>
+                </a:solidFill>
+                <a:latin typeface="Courier New"/>
+                <a:ea typeface="Courier New"/>
+                <a:cs typeface="Courier New"/>
+              </a:rPr>
+              <a:t>value = 1.000₂ × 2⁻² = 1/4</a:t>
+            </a:r>
+          </a:p>
+          <a:p xmlns:a="http://schemas.openxmlformats.org/drawingml/2006/main">
+            <a:pPr>
+              <a:buNone/>
+              <a:defRPr sz="1650" b="0">
+                <a:solidFill>
+                  <a:srgbClr val="A7F3D0"/>
+                </a:solidFill>
+                <a:latin typeface="Courier New"/>
+                <a:ea typeface="Courier New"/>
+                <a:cs typeface="Courier New"/>
+              </a:defRPr>
+            </a:pPr>
+            <a:r>
+              <a:rPr sz="1650" b="0">
+                <a:solidFill>
+                  <a:srgbClr val="A7F3D0"/>
+                </a:solidFill>
+                <a:latin typeface="Courier New"/>
+                <a:ea typeface="Courier New"/>
+                <a:cs typeface="Courier New"/>
+              </a:rPr>
+              <a:t/>
+            </a:r>
+          </a:p>
+          <a:p xmlns:a="http://schemas.openxmlformats.org/drawingml/2006/main">
+            <a:pPr>
+              <a:buNone/>
+              <a:defRPr sz="1650" b="0">
+                <a:solidFill>
+                  <a:srgbClr val="A7F3D0"/>
+                </a:solidFill>
+                <a:latin typeface="Courier New"/>
+                <a:ea typeface="Courier New"/>
+                <a:cs typeface="Courier New"/>
+              </a:defRPr>
+            </a:pPr>
+            <a:r>
+              <a:rPr sz="1650" b="0">
+                <a:solidFill>
+                  <a:srgbClr val="A7F3D0"/>
+                </a:solidFill>
+                <a:latin typeface="Courier New"/>
+                <a:ea typeface="Courier New"/>
+                <a:cs typeface="Courier New"/>
+              </a:rPr>
+              <a:t>1/8 is smaller. E = 0 marks a new case.</a:t>
             </a:r>
           </a:p>
         </p:txBody>
@@ -12045,7 +13272,7 @@
                 <a:ea typeface="Arial"/>
                 <a:cs typeface="Arial"/>
               </a:rPr>
-              <a:t>E = 0 changes the formula; it does not mean the true exponent is −3.</a:t>
+              <a:t>For E = 0, use the subnormal rule instead of subtracting the bias.</a:t>
             </a:r>
           </a:p>
         </p:txBody>
@@ -12103,7 +13330,7 @@
                 <a:ea typeface="Courier New"/>
                 <a:cs typeface="Courier New"/>
               </a:rPr>
-              <a:t>08 / 20</a:t>
+              <a:t>08 / 22</a:t>
             </a:r>
           </a:p>
         </p:txBody>
@@ -12190,7 +13417,7 @@
                 <a:ea typeface="Courier New"/>
                 <a:cs typeface="Courier New"/>
               </a:rPr>
-              <a:t>FLOATING POINT · WORKED EXAMPLE</a:t>
+              <a:t>FLOATING POINT · SUBNORMAL RULE</a:t>
             </a:r>
           </a:p>
         </p:txBody>
@@ -12248,7 +13475,7 @@
                 <a:ea typeface="Arial"/>
                 <a:cs typeface="Arial"/>
               </a:rPr>
-              <a:t>Encode a subnormal value: 1/8</a:t>
+              <a:t>E = 0 drops the hidden 1</a:t>
             </a:r>
           </a:p>
         </p:txBody>
@@ -12306,36 +13533,7 @@
                 <a:ea typeface="Arial"/>
                 <a:cs typeface="Arial"/>
               </a:rPr>
-              <a:t>1/8 is below the smallest normal value, 1/4. Set E = 0.</a:t>
-            </a:r>
-          </a:p>
-          <a:p xmlns:a="http://schemas.openxmlformats.org/drawingml/2006/main">
-            <a:r>
-              <a:t/>
-            </a:r>
-          </a:p>
-          <a:p xmlns:a="http://schemas.openxmlformats.org/drawingml/2006/main">
-            <a:pPr>
-              <a:buNone/>
-              <a:defRPr sz="1950" b="0">
-                <a:solidFill>
-                  <a:srgbClr val="D4D4D8"/>
-                </a:solidFill>
-                <a:latin typeface="Arial"/>
-                <a:ea typeface="Arial"/>
-                <a:cs typeface="Arial"/>
-              </a:defRPr>
-            </a:pPr>
-            <a:r>
-              <a:rPr sz="1950" b="0">
-                <a:solidFill>
-                  <a:srgbClr val="D4D4D8"/>
-                </a:solidFill>
-                <a:latin typeface="Arial"/>
-                <a:ea typeface="Arial"/>
-                <a:cs typeface="Arial"/>
-              </a:rPr>
-              <a:t>For this format, a subnormal has value F/32. Solve F/32 = 1/8, giving F = 4.</a:t>
+              <a:t>Normal values start with an implied 1 before the fraction bits. When E = 0, use an implied 0 instead. Keep the same 2⁻² scale as the smallest normal so the values grow smoothly from zero.</a:t>
             </a:r>
           </a:p>
         </p:txBody>
@@ -12393,7 +13591,7 @@
                 <a:ea typeface="Courier New"/>
                 <a:cs typeface="Courier New"/>
               </a:rPr>
-              <a:t>S = 0</a:t>
+              <a:t>Fixed e = 1 − bias = −2</a:t>
             </a:r>
           </a:p>
           <a:p xmlns:a="http://schemas.openxmlformats.org/drawingml/2006/main">
@@ -12417,7 +13615,7 @@
                 <a:ea typeface="Courier New"/>
                 <a:cs typeface="Courier New"/>
               </a:rPr>
-              <a:t>E = 0 = 000₂</a:t>
+              <a:t/>
             </a:r>
           </a:p>
           <a:p xmlns:a="http://schemas.openxmlformats.org/drawingml/2006/main">
@@ -12441,16 +13639,81 @@
                 <a:ea typeface="Courier New"/>
                 <a:cs typeface="Courier New"/>
               </a:rPr>
-              <a:t>F = 4 = 100₂</a:t>
-            </a:r>
-          </a:p>
-          <a:p xmlns:a="http://schemas.openxmlformats.org/drawingml/2006/main">
-            <a:r>
+              <a:t>Normal, E = 1:</a:t>
+            </a:r>
+          </a:p>
+          <a:p xmlns:a="http://schemas.openxmlformats.org/drawingml/2006/main">
+            <a:pPr>
+              <a:defRPr sz="1650">
+                <a:solidFill>
+                  <a:srgbClr val="A7F3D0"/>
+                </a:solidFill>
+                <a:latin typeface="Courier New"/>
+                <a:ea typeface="Courier New"/>
+                <a:cs typeface="Courier New"/>
+              </a:defRPr>
+            </a:pPr>
+            <a:r>
+              <a:rPr sz="1650">
+                <a:solidFill>
+                  <a:srgbClr val="A7F3D0"/>
+                </a:solidFill>
+                <a:latin typeface="Courier New"/>
+                <a:ea typeface="Courier New"/>
+                <a:cs typeface="Courier New"/>
+              </a:rPr>
+              <a:t>1.FFF₂ × 2⁻²</a:t>
+            </a:r>
+          </a:p>
+          <a:p xmlns:a="http://schemas.openxmlformats.org/drawingml/2006/main">
+            <a:pPr>
+              <a:buNone/>
+              <a:defRPr sz="1650" b="0">
+                <a:solidFill>
+                  <a:srgbClr val="A7F3D0"/>
+                </a:solidFill>
+                <a:latin typeface="Courier New"/>
+                <a:ea typeface="Courier New"/>
+                <a:cs typeface="Courier New"/>
+              </a:defRPr>
+            </a:pPr>
+            <a:r>
+              <a:rPr sz="1650" b="0">
+                <a:solidFill>
+                  <a:srgbClr val="A7F3D0"/>
+                </a:solidFill>
+                <a:latin typeface="Courier New"/>
+                <a:ea typeface="Courier New"/>
+                <a:cs typeface="Courier New"/>
+              </a:rPr>
               <a:t/>
             </a:r>
           </a:p>
           <a:p xmlns:a="http://schemas.openxmlformats.org/drawingml/2006/main">
             <a:pPr>
+              <a:defRPr sz="1650">
+                <a:solidFill>
+                  <a:srgbClr val="A7F3D0"/>
+                </a:solidFill>
+                <a:latin typeface="Courier New"/>
+                <a:ea typeface="Courier New"/>
+                <a:cs typeface="Courier New"/>
+              </a:defRPr>
+            </a:pPr>
+            <a:r>
+              <a:rPr sz="1650">
+                <a:solidFill>
+                  <a:srgbClr val="A7F3D0"/>
+                </a:solidFill>
+                <a:latin typeface="Courier New"/>
+                <a:ea typeface="Courier New"/>
+                <a:cs typeface="Courier New"/>
+              </a:rPr>
+              <a:t>Subnormal, E = 0:</a:t>
+            </a:r>
+          </a:p>
+          <a:p xmlns:a="http://schemas.openxmlformats.org/drawingml/2006/main">
+            <a:pPr>
               <a:buNone/>
               <a:defRPr sz="1650" b="0">
                 <a:solidFill>
@@ -12470,11 +13733,30 @@
                 <a:ea typeface="Courier New"/>
                 <a:cs typeface="Courier New"/>
               </a:rPr>
-              <a:t>Fields: 0 | 000 | 100</a:t>
-            </a:r>
-          </a:p>
-          <a:p xmlns:a="http://schemas.openxmlformats.org/drawingml/2006/main">
-            <a:r>
+              <a:t>0.FFF₂ × 2⁻²</a:t>
+            </a:r>
+          </a:p>
+          <a:p xmlns:a="http://schemas.openxmlformats.org/drawingml/2006/main">
+            <a:pPr>
+              <a:buNone/>
+              <a:defRPr sz="1650" b="0">
+                <a:solidFill>
+                  <a:srgbClr val="A7F3D0"/>
+                </a:solidFill>
+                <a:latin typeface="Courier New"/>
+                <a:ea typeface="Courier New"/>
+                <a:cs typeface="Courier New"/>
+              </a:defRPr>
+            </a:pPr>
+            <a:r>
+              <a:rPr sz="1650" b="0">
+                <a:solidFill>
+                  <a:srgbClr val="A7F3D0"/>
+                </a:solidFill>
+                <a:latin typeface="Courier New"/>
+                <a:ea typeface="Courier New"/>
+                <a:cs typeface="Courier New"/>
+              </a:rPr>
               <a:t/>
             </a:r>
           </a:p>
@@ -12499,7 +13781,31 @@
                 <a:ea typeface="Courier New"/>
                 <a:cs typeface="Courier New"/>
               </a:rPr>
-              <a:t>Check: (4/8) × 2⁻² = 1/8</a:t>
+              <a:t>F = 000  →  0.000₂ × 2⁻² = 0</a:t>
+            </a:r>
+          </a:p>
+          <a:p xmlns:a="http://schemas.openxmlformats.org/drawingml/2006/main">
+            <a:pPr>
+              <a:buNone/>
+              <a:defRPr sz="1650" b="0">
+                <a:solidFill>
+                  <a:srgbClr val="A7F3D0"/>
+                </a:solidFill>
+                <a:latin typeface="Courier New"/>
+                <a:ea typeface="Courier New"/>
+                <a:cs typeface="Courier New"/>
+              </a:defRPr>
+            </a:pPr>
+            <a:r>
+              <a:rPr sz="1650" b="0">
+                <a:solidFill>
+                  <a:srgbClr val="A7F3D0"/>
+                </a:solidFill>
+                <a:latin typeface="Courier New"/>
+                <a:ea typeface="Courier New"/>
+                <a:cs typeface="Courier New"/>
+              </a:rPr>
+              <a:t>F = 100  →  0.100₂ × 2⁻² = 1/8</a:t>
             </a:r>
           </a:p>
         </p:txBody>
@@ -12557,7 +13863,7 @@
                 <a:ea typeface="Arial"/>
                 <a:cs typeface="Arial"/>
               </a:rPr>
-              <a:t>The stored fraction is 100₂. There is no leading 1 in the subnormal formula.</a:t>
+              <a:t>The leading 0 or 1 is implied; only FFF is stored.</a:t>
             </a:r>
           </a:p>
         </p:txBody>
@@ -12615,7 +13921,7 @@
                 <a:ea typeface="Courier New"/>
                 <a:cs typeface="Courier New"/>
               </a:rPr>
-              <a:t>09 / 20</a:t>
+              <a:t>09 / 22</a:t>
             </a:r>
           </a:p>
         </p:txBody>

</xml_diff>

<commit_message>
Add floating point quiz review slides
</commit_message>
<xml_diff>
--- a/public/presentations/CS211_Recitation_3.pptx
+++ b/public/presentations/CS211_Recitation_3.pptx
@@ -2,34 +2,36 @@
 <file path=ppt/presentation.xml><?xml version="1.0" encoding="utf-8"?>
 <p:presentation xmlns:p="http://schemas.openxmlformats.org/presentationml/2006/main">
   <p:sldMasterIdLst>
-    <p:sldMasterId xmlns:r="http://schemas.openxmlformats.org/officeDocument/2006/relationships" id="2147483648" r:id="R8d68ad4fd84a47cc"/>
+    <p:sldMasterId xmlns:r="http://schemas.openxmlformats.org/officeDocument/2006/relationships" id="2147483648" r:id="Ra581eb1e70f04890"/>
   </p:sldMasterIdLst>
   <p:notesMasterIdLst>
-    <p:notesMasterId xmlns:r="http://schemas.openxmlformats.org/officeDocument/2006/relationships" r:id="Rf14b7f2b99254511"/>
+    <p:notesMasterId xmlns:r="http://schemas.openxmlformats.org/officeDocument/2006/relationships" r:id="Rbb865c280d434164"/>
   </p:notesMasterIdLst>
   <p:sldIdLst>
-    <p:sldId xmlns:r="http://schemas.openxmlformats.org/officeDocument/2006/relationships" id="256" r:id="R5267d73aa5874270"/>
-    <p:sldId xmlns:r="http://schemas.openxmlformats.org/officeDocument/2006/relationships" id="257" r:id="R4aae4a14d1454a16"/>
-    <p:sldId xmlns:r="http://schemas.openxmlformats.org/officeDocument/2006/relationships" id="258" r:id="Rc0f65d20b6634bdb"/>
-    <p:sldId xmlns:r="http://schemas.openxmlformats.org/officeDocument/2006/relationships" id="259" r:id="Rd38053d8d9e74084"/>
-    <p:sldId xmlns:r="http://schemas.openxmlformats.org/officeDocument/2006/relationships" id="260" r:id="R3b9dd25fa84345d1"/>
-    <p:sldId xmlns:r="http://schemas.openxmlformats.org/officeDocument/2006/relationships" id="261" r:id="R6b5d7bf35bdf495a"/>
-    <p:sldId xmlns:r="http://schemas.openxmlformats.org/officeDocument/2006/relationships" id="262" r:id="R2ec18e9e512745e0"/>
-    <p:sldId xmlns:r="http://schemas.openxmlformats.org/officeDocument/2006/relationships" id="263" r:id="R1f840f1fbef04f32"/>
-    <p:sldId xmlns:r="http://schemas.openxmlformats.org/officeDocument/2006/relationships" id="264" r:id="Rfecf66dcab394e97"/>
-    <p:sldId xmlns:r="http://schemas.openxmlformats.org/officeDocument/2006/relationships" id="265" r:id="R60723292eea841aa"/>
-    <p:sldId xmlns:r="http://schemas.openxmlformats.org/officeDocument/2006/relationships" id="266" r:id="Re1f14d0166f34c45"/>
-    <p:sldId xmlns:r="http://schemas.openxmlformats.org/officeDocument/2006/relationships" id="267" r:id="R7fb7ed0b61e149be"/>
-    <p:sldId xmlns:r="http://schemas.openxmlformats.org/officeDocument/2006/relationships" id="268" r:id="Rc9360792d54144b3"/>
-    <p:sldId xmlns:r="http://schemas.openxmlformats.org/officeDocument/2006/relationships" id="269" r:id="R194cd94b0dce415d"/>
-    <p:sldId xmlns:r="http://schemas.openxmlformats.org/officeDocument/2006/relationships" id="270" r:id="R27ffca7f438c4ed5"/>
-    <p:sldId xmlns:r="http://schemas.openxmlformats.org/officeDocument/2006/relationships" id="271" r:id="Rc8e7e17d97f643df"/>
-    <p:sldId xmlns:r="http://schemas.openxmlformats.org/officeDocument/2006/relationships" id="272" r:id="Rf2a99ac22aca4a16"/>
-    <p:sldId xmlns:r="http://schemas.openxmlformats.org/officeDocument/2006/relationships" id="273" r:id="Rd4ee585781d84149"/>
-    <p:sldId xmlns:r="http://schemas.openxmlformats.org/officeDocument/2006/relationships" id="274" r:id="Re9e87104bc05434b"/>
-    <p:sldId xmlns:r="http://schemas.openxmlformats.org/officeDocument/2006/relationships" id="275" r:id="Rb2e27981acfa43a2"/>
-    <p:sldId xmlns:r="http://schemas.openxmlformats.org/officeDocument/2006/relationships" id="276" r:id="R188c15c14f384b7c"/>
-    <p:sldId xmlns:r="http://schemas.openxmlformats.org/officeDocument/2006/relationships" id="277" r:id="Rf43030d33e9541e3"/>
+    <p:sldId xmlns:r="http://schemas.openxmlformats.org/officeDocument/2006/relationships" id="256" r:id="R3b3728e610b24b82"/>
+    <p:sldId xmlns:r="http://schemas.openxmlformats.org/officeDocument/2006/relationships" id="257" r:id="Rdf587f2ca1514ed5"/>
+    <p:sldId xmlns:r="http://schemas.openxmlformats.org/officeDocument/2006/relationships" id="258" r:id="R788d641bee0e46f7"/>
+    <p:sldId xmlns:r="http://schemas.openxmlformats.org/officeDocument/2006/relationships" id="259" r:id="R30cfa2125db74ca6"/>
+    <p:sldId xmlns:r="http://schemas.openxmlformats.org/officeDocument/2006/relationships" id="260" r:id="R7d53adca072f4738"/>
+    <p:sldId xmlns:r="http://schemas.openxmlformats.org/officeDocument/2006/relationships" id="261" r:id="R6c66a994006c45e0"/>
+    <p:sldId xmlns:r="http://schemas.openxmlformats.org/officeDocument/2006/relationships" id="262" r:id="R6f1480aea06143a6"/>
+    <p:sldId xmlns:r="http://schemas.openxmlformats.org/officeDocument/2006/relationships" id="263" r:id="R9f5c3e9ab19c4953"/>
+    <p:sldId xmlns:r="http://schemas.openxmlformats.org/officeDocument/2006/relationships" id="264" r:id="R163ed676201b4ca9"/>
+    <p:sldId xmlns:r="http://schemas.openxmlformats.org/officeDocument/2006/relationships" id="265" r:id="R6fb00f9d361c4b4b"/>
+    <p:sldId xmlns:r="http://schemas.openxmlformats.org/officeDocument/2006/relationships" id="266" r:id="Rd5a016d5364547db"/>
+    <p:sldId xmlns:r="http://schemas.openxmlformats.org/officeDocument/2006/relationships" id="267" r:id="R5b09294dfc4c4a08"/>
+    <p:sldId xmlns:r="http://schemas.openxmlformats.org/officeDocument/2006/relationships" id="268" r:id="Rcab8b974bc2a495c"/>
+    <p:sldId xmlns:r="http://schemas.openxmlformats.org/officeDocument/2006/relationships" id="269" r:id="R4db0ca0f0c1a4f87"/>
+    <p:sldId xmlns:r="http://schemas.openxmlformats.org/officeDocument/2006/relationships" id="270" r:id="R805499bc847d4ef1"/>
+    <p:sldId xmlns:r="http://schemas.openxmlformats.org/officeDocument/2006/relationships" id="271" r:id="Raec2f52b08104e65"/>
+    <p:sldId xmlns:r="http://schemas.openxmlformats.org/officeDocument/2006/relationships" id="272" r:id="R26a40352e6c84eb9"/>
+    <p:sldId xmlns:r="http://schemas.openxmlformats.org/officeDocument/2006/relationships" id="273" r:id="Rae14098eac234600"/>
+    <p:sldId xmlns:r="http://schemas.openxmlformats.org/officeDocument/2006/relationships" id="274" r:id="Rd20e5cfba2c24adb"/>
+    <p:sldId xmlns:r="http://schemas.openxmlformats.org/officeDocument/2006/relationships" id="275" r:id="R0540b3cf26454380"/>
+    <p:sldId xmlns:r="http://schemas.openxmlformats.org/officeDocument/2006/relationships" id="276" r:id="R03d16bfa308b42ed"/>
+    <p:sldId xmlns:r="http://schemas.openxmlformats.org/officeDocument/2006/relationships" id="277" r:id="R14fcb46eb35546e3"/>
+    <p:sldId xmlns:r="http://schemas.openxmlformats.org/officeDocument/2006/relationships" id="278" r:id="R86a7c2badc484d81"/>
+    <p:sldId xmlns:r="http://schemas.openxmlformats.org/officeDocument/2006/relationships" id="279" r:id="Rac8466e2a79d4548"/>
   </p:sldIdLst>
   <p:sldSz cx="12192000" cy="6858000"/>
   <p:notesSz cx="6858000" cy="9144000"/>
@@ -463,7 +465,7 @@
           <a:lstStyle xmlns:a="http://schemas.openxmlformats.org/drawingml/2006/main"/>
           <a:p xmlns:a="http://schemas.openxmlformats.org/drawingml/2006/main">
             <a:r>
-              <a:t>Suggested 50-minute pacing: binary place values and fields 7 min; normal values 10 min; subnormals and the boundary 14 min; decoding and encoding practice 8 min; rounding and spacing 4 min; HW3 preview and recap 7 min. Pause after the subnormal step table and ask students to name the next value after 7/32. The HW3 details are based on the professor’s description supplied by the TA; the assignment is not officially posted. Source: lecture 6.</a:t>
+              <a:t>Suggested 50-minute pacing: binary place values and fields 7 min; normal values 10 min; quiz review 4 min; subnormals and the boundary 12 min; decoding and encoding practice 7 min; rounding and spacing 3 min; HW3 preview and recap 7 min. Pause after the quiz question before revealing the answer. The HW3 details are based on the professor’s description supplied by the TA; the assignment is not officially posted. Source: lecture 6 and the quiz screenshot supplied by the TA.</a:t>
             </a:r>
           </a:p>
         </p:txBody>
@@ -533,7 +535,7 @@
           <a:lstStyle xmlns:a="http://schemas.openxmlformats.org/drawingml/2006/main"/>
           <a:p xmlns:a="http://schemas.openxmlformats.org/drawingml/2006/main">
             <a:r>
-              <a:t>Derive the step: one fraction unit is 1/8; multiplying by 2^-2=1/4 gives 1/32. For this practice format, E=0,F=0 is zero and E=0,F=1..7 are positive subnormals. Let students answer 8/32=1/4 before the boundary slide. Source: lecture 6 subnormal equation.</a:t>
+              <a:t>Pause before giving the subnormal rule. Ask: if E=1 is the smallest normal field, where could 1/8 go? A normal encoding would need true exponent −3 and stored E=0, but zero is reserved for a different rule. The next slide explains that rule using binary digits rather than a formula first. Source: lecture 6 normal and subnormal equations.</a:t>
             </a:r>
           </a:p>
         </p:txBody>
@@ -603,7 +605,7 @@
           <a:lstStyle xmlns:a="http://schemas.openxmlformats.org/drawingml/2006/main"/>
           <a:p xmlns:a="http://schemas.openxmlformats.org/drawingml/2006/main">
             <a:r>
-              <a:t>Keep the calculation concrete: 1/8=4/32, so F=4. Decode using 0.100 binary times 2^-2: 1/2 times 1/4 is 1/8. Ask why E is zero and why F is four. Source: lecture 6 subnormal equation.</a:t>
+              <a:t>Use the same scale before and after the boundary: 2^(1−bias)=2^-2. This is the key change: replace the normal hidden 1 with 0. Do not compute 0−bias for E=0. Ask students why 0.100 binary is 1/2, then multiply by 1/4 to get 1/8. Source: lecture 6 subnormal equation.</a:t>
             </a:r>
           </a:p>
         </p:txBody>
@@ -673,7 +675,7 @@
           <a:lstStyle xmlns:a="http://schemas.openxmlformats.org/drawingml/2006/main"/>
           <a:p xmlns:a="http://schemas.openxmlformats.org/drawingml/2006/main">
             <a:r>
-              <a:t>Link back to the question on the previous step table. The step from 7/32 to 8/32 is 1/32, matching the subnormal spacing. E=0 does not mean exponent −3; both values use 2^-2. Source: lecture 6 normal and subnormal equations.</a:t>
+              <a:t>Derive the step: one fraction unit is 1/8; multiplying by 2^-2=1/4 gives 1/32. For this practice format, E=0,F=0 is zero and E=0,F=1..7 are positive subnormals. Let students answer 8/32=1/4 before the boundary slide. Source: lecture 6 subnormal equation.</a:t>
             </a:r>
           </a:p>
         </p:txBody>
@@ -743,7 +745,7 @@
           <a:lstStyle xmlns:a="http://schemas.openxmlformats.org/drawingml/2006/main"/>
           <a:p xmlns:a="http://schemas.openxmlformats.org/drawingml/2006/main">
             <a:r>
-              <a:t>Allow two to three minutes. A is normal: E=2,F=4, value (1+4/8)×2^-1=3/4. B is subnormal: E=0,F=3, value 3/32. Ask students to name the equation before calculating.</a:t>
+              <a:t>Keep the calculation concrete: 1/8=4/32, so F=4. Decode using 0.100 binary times 2^-2: 1/2 times 1/4 is 1/8. Ask why E is zero and why F is four. Source: lecture 6 subnormal equation.</a:t>
             </a:r>
           </a:p>
         </p:txBody>
@@ -813,7 +815,7 @@
           <a:lstStyle xmlns:a="http://schemas.openxmlformats.org/drawingml/2006/main"/>
           <a:p xmlns:a="http://schemas.openxmlformats.org/drawingml/2006/main">
             <a:r>
-              <a:t>Have students explain why B is not (1+3/8)×2^-3. The exponent for subnormals is fixed at 1−bias=-2, and the leading 1 is absent.</a:t>
+              <a:t>Link back to the question on the previous step table. The step from 7/32 to 8/32 is 1/32, matching the subnormal spacing. E=0 does not mean exponent −3; both values use 2^-2. Source: lecture 6 normal and subnormal equations.</a:t>
             </a:r>
           </a:p>
         </p:txBody>
@@ -883,7 +885,7 @@
           <a:lstStyle xmlns:a="http://schemas.openxmlformats.org/drawingml/2006/main"/>
           <a:p xmlns:a="http://schemas.openxmlformats.org/drawingml/2006/main">
             <a:r>
-              <a:t>Give two minutes. Both examples are exactly representable, so no rounding rule is needed. Ask students to check results by substituting E and F into the appropriate formula.</a:t>
+              <a:t>Allow two to three minutes. A is normal: E=2,F=4, value (1+4/8)×2^-1=3/4. B is subnormal: E=0,F=3, value 3/32. Ask students to name the equation before calculating.</a:t>
             </a:r>
           </a:p>
         </p:txBody>
@@ -953,7 +955,7 @@
           <a:lstStyle xmlns:a="http://schemas.openxmlformats.org/drawingml/2006/main"/>
           <a:p xmlns:a="http://schemas.openxmlformats.org/drawingml/2006/main">
             <a:r>
-              <a:t>Do not reveal until students have tried both. Emphasize that E=0 is a category marker here, not the unbiased exponent. E=3 represents true exponent zero because bias is three.</a:t>
+              <a:t>Have students explain why B is not (1+3/8)×2^-3. The exponent for subnormals is fixed at 1−bias=-2, and the leading 1 is absent.</a:t>
             </a:r>
           </a:p>
         </p:txBody>
@@ -1023,7 +1025,7 @@
           <a:lstStyle xmlns:a="http://schemas.openxmlformats.org/drawingml/2006/main"/>
           <a:p xmlns:a="http://schemas.openxmlformats.org/drawingml/2006/main">
             <a:r>
-              <a:t>The future homework description does not specify rounding, so do not teach truncation or nearest as a required rule. Here E=1 for both nearby normals. 5/16=0.3125, 11/32=0.34375, and 1/3≈0.3333. This replaces the earlier abstract associativity slide with a representation example directly tied to the professor's stated learning goal.</a:t>
+              <a:t>Give two minutes. Both examples are exactly representable, so no rounding rule is needed. Ask students to check results by substituting E and F into the appropriate formula.</a:t>
             </a:r>
           </a:p>
         </p:txBody>
@@ -1093,7 +1095,7 @@
           <a:lstStyle xmlns:a="http://schemas.openxmlformats.org/drawingml/2006/main"/>
           <a:p xmlns:a="http://schemas.openxmlformats.org/drawingml/2006/main">
             <a:r>
-              <a:t>For normals with fixed E, incrementing F by one changes the value by 2^(E−bias)/8. Show how this connects to the rounding slide and lecture 6’s discussion of gaps between floats.</a:t>
+              <a:t>Do not reveal until students have tried both. Emphasize that E=0 is a category marker here, not the unbiased exponent. E=3 represents true exponent zero because bias is three.</a:t>
             </a:r>
           </a:p>
         </p:txBody>
@@ -1163,7 +1165,7 @@
           <a:lstStyle xmlns:a="http://schemas.openxmlformats.org/drawingml/2006/main"/>
           <a:p xmlns:a="http://schemas.openxmlformats.org/drawingml/2006/main">
             <a:r>
-              <a:t>Based on the professor’s preview supplied by the TA. The intended command-line inputs are exponent bits, bias, significand bits, numerator, and denominator, in that order. The output contains the exponent and significand field values. Use 5/2 as a new teaching example. The final handout may add input and rounding details.</a:t>
+              <a:t>The future homework description does not specify rounding, so do not teach truncation or nearest as a required rule. Here E=1 for both nearby normals. 5/16=0.3125, 11/32=0.34375, and 1/3≈0.3333. This replaces the earlier abstract associativity slide with a representation example directly tied to the professor's stated learning goal.</a:t>
             </a:r>
           </a:p>
         </p:txBody>
@@ -1303,7 +1305,7 @@
           <a:lstStyle xmlns:a="http://schemas.openxmlformats.org/drawingml/2006/main"/>
           <a:p xmlns:a="http://schemas.openxmlformats.org/drawingml/2006/main">
             <a:r>
-              <a:t>This example is mathematically exact and uses the planned input order. Important TA note: the supplied draft solution computes the normal significand as (numerator &lt;&lt; sig_bits)/denominator − 2^sig_bits without scaling by 2^power_of_two. For these inputs that draft gives F=12, outside the three-bit range, rather than F=2. Do not present that draft code as a correct answer key until the normal path is fixed. Source: professor’s preview and lecture 6 normal-value equation.</a:t>
+              <a:t>For normals with fixed E, incrementing F by one changes the value by 2^(E−bias)/8. Show how this connects to the rounding slide and lecture 6’s discussion of gaps between floats.</a:t>
             </a:r>
           </a:p>
         </p:txBody>
@@ -1373,7 +1375,7 @@
           <a:lstStyle xmlns:a="http://schemas.openxmlformats.org/drawingml/2006/main"/>
           <a:p xmlns:a="http://schemas.openxmlformats.org/drawingml/2006/main">
             <a:r>
-              <a:t>Here p is the number of significand bits. For exact examples, solve the equation algebraically. The eventual homework may specify how to round values that fall between encodings, so do not assume a rounding rule yet. This is a conceptual approach, not a copy of the unreleased source code. Source: professor’s preview and lecture 6 equations.</a:t>
+              <a:t>Based on the professor’s preview supplied by the TA. The intended command-line inputs are exponent bits, bias, significand bits, numerator, and denominator, in that order. The output contains the exponent and significand field values. Use 5/2 as a new teaching example. The final handout may add input and rounding details.</a:t>
             </a:r>
           </a:p>
         </p:txBody>
@@ -1443,6 +1445,146 @@
           <a:lstStyle xmlns:a="http://schemas.openxmlformats.org/drawingml/2006/main"/>
           <a:p xmlns:a="http://schemas.openxmlformats.org/drawingml/2006/main">
             <a:r>
+              <a:t>This example is mathematically exact and uses the planned input order. Important TA note: the supplied draft solution computes the normal significand as (numerator &lt;&lt; sig_bits)/denominator − 2^sig_bits without scaling by 2^power_of_two. For these inputs that draft gives F=12, outside the three-bit range, rather than F=2. Do not present that draft code as a correct answer key until the normal path is fixed. Source: professor’s preview and lecture 6 normal-value equation.</a:t>
+            </a:r>
+          </a:p>
+        </p:txBody>
+      </p:sp>
+      <p:sp>
+        <p:nvSpPr>
+          <p:cNvPr id="4" name="Slide Number Placeholder 3"/>
+          <p:cNvSpPr>
+            <a:spLocks xmlns:a="http://schemas.openxmlformats.org/drawingml/2006/main" noGrp="1"/>
+          </p:cNvSpPr>
+          <p:nvPr>
+            <p:ph type="sldNum" idx="5"/>
+          </p:nvPr>
+        </p:nvSpPr>
+        <p:spPr/>
+        <p:txBody>
+          <a:bodyPr xmlns:a="http://schemas.openxmlformats.org/drawingml/2006/main"/>
+          <a:lstStyle xmlns:a="http://schemas.openxmlformats.org/drawingml/2006/main"/>
+          <a:p xmlns:a="http://schemas.openxmlformats.org/drawingml/2006/main"/>
+        </p:txBody>
+      </p:sp>
+    </p:spTree>
+  </p:cSld>
+  <p:clrMapOvr>
+    <a:masterClrMapping xmlns:a="http://schemas.openxmlformats.org/drawingml/2006/main"/>
+  </p:clrMapOvr>
+</p:notes>
+</file>
+
+<file path=ppt/notesSlides/notesSlide23.xml><?xml version="1.0" encoding="utf-8"?>
+<p:notes xmlns:p="http://schemas.openxmlformats.org/presentationml/2006/main">
+  <p:cSld>
+    <p:spTree>
+      <p:nvGrpSpPr>
+        <p:cNvPr id="1" name=""/>
+        <p:cNvGrpSpPr/>
+        <p:nvPr/>
+      </p:nvGrpSpPr>
+      <p:grpSpPr>
+        <a:xfrm xmlns:a="http://schemas.openxmlformats.org/drawingml/2006/main"/>
+      </p:grpSpPr>
+      <p:sp>
+        <p:nvSpPr>
+          <p:cNvPr id="2" name="Slide Image Placeholder 1"/>
+          <p:cNvSpPr>
+            <a:spLocks xmlns:a="http://schemas.openxmlformats.org/drawingml/2006/main" noGrp="1"/>
+          </p:cNvSpPr>
+          <p:nvPr>
+            <p:ph type="sldImg" idx="0"/>
+          </p:nvPr>
+        </p:nvSpPr>
+        <p:spPr/>
+      </p:sp>
+      <p:sp>
+        <p:nvSpPr>
+          <p:cNvPr id="3" name="Notes Placeholder 2"/>
+          <p:cNvSpPr>
+            <a:spLocks xmlns:a="http://schemas.openxmlformats.org/drawingml/2006/main" noGrp="1"/>
+          </p:cNvSpPr>
+          <p:nvPr>
+            <p:ph type="body" idx="1"/>
+          </p:nvPr>
+        </p:nvSpPr>
+        <p:spPr/>
+        <p:txBody>
+          <a:bodyPr xmlns:a="http://schemas.openxmlformats.org/drawingml/2006/main"/>
+          <a:lstStyle xmlns:a="http://schemas.openxmlformats.org/drawingml/2006/main"/>
+          <a:p xmlns:a="http://schemas.openxmlformats.org/drawingml/2006/main">
+            <a:r>
+              <a:t>Here p is the number of significand bits. For exact examples, solve the equation algebraically. The eventual homework may specify how to round values that fall between encodings, so do not assume a rounding rule yet. This is a conceptual approach, not a copy of the unreleased source code. Source: professor’s preview and lecture 6 equations.</a:t>
+            </a:r>
+          </a:p>
+        </p:txBody>
+      </p:sp>
+      <p:sp>
+        <p:nvSpPr>
+          <p:cNvPr id="4" name="Slide Number Placeholder 3"/>
+          <p:cNvSpPr>
+            <a:spLocks xmlns:a="http://schemas.openxmlformats.org/drawingml/2006/main" noGrp="1"/>
+          </p:cNvSpPr>
+          <p:nvPr>
+            <p:ph type="sldNum" idx="5"/>
+          </p:nvPr>
+        </p:nvSpPr>
+        <p:spPr/>
+        <p:txBody>
+          <a:bodyPr xmlns:a="http://schemas.openxmlformats.org/drawingml/2006/main"/>
+          <a:lstStyle xmlns:a="http://schemas.openxmlformats.org/drawingml/2006/main"/>
+          <a:p xmlns:a="http://schemas.openxmlformats.org/drawingml/2006/main"/>
+        </p:txBody>
+      </p:sp>
+    </p:spTree>
+  </p:cSld>
+  <p:clrMapOvr>
+    <a:masterClrMapping xmlns:a="http://schemas.openxmlformats.org/drawingml/2006/main"/>
+  </p:clrMapOvr>
+</p:notes>
+</file>
+
+<file path=ppt/notesSlides/notesSlide24.xml><?xml version="1.0" encoding="utf-8"?>
+<p:notes xmlns:p="http://schemas.openxmlformats.org/presentationml/2006/main">
+  <p:cSld>
+    <p:spTree>
+      <p:nvGrpSpPr>
+        <p:cNvPr id="1" name=""/>
+        <p:cNvGrpSpPr/>
+        <p:nvPr/>
+      </p:nvGrpSpPr>
+      <p:grpSpPr>
+        <a:xfrm xmlns:a="http://schemas.openxmlformats.org/drawingml/2006/main"/>
+      </p:grpSpPr>
+      <p:sp>
+        <p:nvSpPr>
+          <p:cNvPr id="2" name="Slide Image Placeholder 1"/>
+          <p:cNvSpPr>
+            <a:spLocks xmlns:a="http://schemas.openxmlformats.org/drawingml/2006/main" noGrp="1"/>
+          </p:cNvSpPr>
+          <p:nvPr>
+            <p:ph type="sldImg" idx="0"/>
+          </p:nvPr>
+        </p:nvSpPr>
+        <p:spPr/>
+      </p:sp>
+      <p:sp>
+        <p:nvSpPr>
+          <p:cNvPr id="3" name="Notes Placeholder 2"/>
+          <p:cNvSpPr>
+            <a:spLocks xmlns:a="http://schemas.openxmlformats.org/drawingml/2006/main" noGrp="1"/>
+          </p:cNvSpPr>
+          <p:nvPr>
+            <p:ph type="body" idx="1"/>
+          </p:nvPr>
+        </p:nvSpPr>
+        <p:spPr/>
+        <p:txBody>
+          <a:bodyPr xmlns:a="http://schemas.openxmlformats.org/drawingml/2006/main"/>
+          <a:lstStyle xmlns:a="http://schemas.openxmlformats.org/drawingml/2006/main"/>
+          <a:p xmlns:a="http://schemas.openxmlformats.org/drawingml/2006/main">
+            <a:r>
               <a:t>Review the two mistakes most likely to occur: forgetting to add the bias for a normal exponent, and using the normal hidden 1 for a subnormal. Do not reveal the unreleased homework solution. Remind students to follow the eventual assignment’s rounding and valid-input rules.</a:t>
             </a:r>
           </a:p>
@@ -1863,7 +2005,7 @@
           <a:lstStyle xmlns:a="http://schemas.openxmlformats.org/drawingml/2006/main"/>
           <a:p xmlns:a="http://schemas.openxmlformats.org/drawingml/2006/main">
             <a:r>
-              <a:t>Pause before giving the subnormal rule. Ask: if E=1 is the smallest normal field, where could 1/8 go? A normal encoding would need true exponent −3 and stored E=0, but zero is reserved for a different rule. The next slide explains that rule using binary digits rather than a formula first. Source: lecture 6 normal and subnormal equations.</a:t>
+              <a:t>This is adapted from the quiz screenshot supplied by the TA. Give students one or two minutes. The question asks for the closest representable value and the decimal values of the sign, exponent, and significand fields. It is an exact case, so no rounding is needed. Keep the answer hidden until the next slide. The quiz calls the two stored fraction bits significand bits.</a:t>
             </a:r>
           </a:p>
         </p:txBody>
@@ -1933,7 +2075,7 @@
           <a:lstStyle xmlns:a="http://schemas.openxmlformats.org/drawingml/2006/main"/>
           <a:p xmlns:a="http://schemas.openxmlformats.org/drawingml/2006/main">
             <a:r>
-              <a:t>Use the same scale before and after the boundary: 2^(1−bias)=2^-2. This is the key change: replace the normal hidden 1 with 0. Do not compute 0−bias for E=0. Ask students why 0.100 binary is 1/2, then multiply by 1/4 to get 1/8. Source: lecture 6 subnormal equation.</a:t>
+              <a:t>Quiz screenshot supplied by the TA. Decode the fields aloud: sign bit 1 makes the value negative; 01111₂ is 15, so true exponent 15−15=0; 00₂ is stored significand field 0, with implied leading 1 for a normal value. Thus (−1)^1 × (1+0/4) × 2^0=−1.0. The reserved all-ones exponent is 11111₂=31, not 01111₂=15. Explicitly tell students that an exact target is its own closest representable value.</a:t>
             </a:r>
           </a:p>
         </p:txBody>
@@ -2001,7 +2143,7 @@
   </p:cSld>
   <p:clrMap bg1="lt1" tx1="dk1" bg2="lt2" tx2="dk2" accent1="accent1" accent2="accent2" accent3="accent3" accent4="accent4" accent5="accent5" accent6="accent6" hlink="hlink" folHlink="folHlink"/>
   <p:sldLayoutIdLst>
-    <p:sldLayoutId xmlns:r="http://schemas.openxmlformats.org/officeDocument/2006/relationships" id="2147483649" r:id="R2eed2ef29c5a483c"/>
+    <p:sldLayoutId xmlns:r="http://schemas.openxmlformats.org/officeDocument/2006/relationships" id="2147483649" r:id="R37788616201544a6"/>
   </p:sldLayoutIdLst>
   <p:txStyles>
     <p:titleStyle>
@@ -2851,6 +2993,30 @@
                 <a:ea typeface="Courier New"/>
                 <a:cs typeface="Courier New"/>
               </a:rPr>
+              <a:t>Quiz review: −1.0</a:t>
+            </a:r>
+          </a:p>
+          <a:p xmlns:a="http://schemas.openxmlformats.org/drawingml/2006/main">
+            <a:pPr>
+              <a:buNone/>
+              <a:defRPr sz="1650" b="0">
+                <a:solidFill>
+                  <a:srgbClr val="A7F3D0"/>
+                </a:solidFill>
+                <a:latin typeface="Courier New"/>
+                <a:ea typeface="Courier New"/>
+                <a:cs typeface="Courier New"/>
+              </a:defRPr>
+            </a:pPr>
+            <a:r>
+              <a:rPr sz="1650" b="0">
+                <a:solidFill>
+                  <a:srgbClr val="A7F3D0"/>
+                </a:solidFill>
+                <a:latin typeface="Courier New"/>
+                <a:ea typeface="Courier New"/>
+                <a:cs typeface="Courier New"/>
+              </a:rPr>
               <a:t>Normal and subnormal values</a:t>
             </a:r>
           </a:p>
@@ -3015,7 +3181,7 @@
                 <a:ea typeface="Courier New"/>
                 <a:cs typeface="Courier New"/>
               </a:rPr>
-              <a:t>01 / 22</a:t>
+              <a:t>01 / 24</a:t>
             </a:r>
           </a:p>
         </p:txBody>
@@ -3054,7 +3220,7 @@
           <p:cNvPr id="7" name="">
             <a:extLst xmlns:a="http://schemas.openxmlformats.org/drawingml/2006/main">
               <a:ext uri="{FF2B5EF4-FFF2-40B4-BE49-F238E27FC236}">
-                <a16:creationId xmlns:a16="http://schemas.microsoft.com/office/drawing/2014/main" id="{DF65E5C3-C59B-4F4C-8123-D26BB20B62FC}"/>
+                <a16:creationId xmlns:a16="http://schemas.microsoft.com/office/drawing/2014/main" id="{52BEAABF-BD4F-40AF-A282-4DA602FE61EE}"/>
               </a:ext>
             </a:extLst>
           </p:cNvPr>
@@ -3102,7 +3268,7 @@
                 <a:ea typeface="Courier New"/>
                 <a:cs typeface="Courier New"/>
               </a:rPr>
-              <a:t>FLOATING POINT · PLACE VALUES</a:t>
+              <a:t>FLOATING POINT · WHY SUBNORMALS</a:t>
             </a:r>
           </a:p>
         </p:txBody>
@@ -3112,7 +3278,7 @@
           <p:cNvPr id="2" name="">
             <a:extLst xmlns:a="http://schemas.openxmlformats.org/drawingml/2006/main">
               <a:ext uri="{FF2B5EF4-FFF2-40B4-BE49-F238E27FC236}">
-                <a16:creationId xmlns:a16="http://schemas.microsoft.com/office/drawing/2014/main" id="{AAF148DA-667A-4F17-8947-3A10B5D66209}"/>
+                <a16:creationId xmlns:a16="http://schemas.microsoft.com/office/drawing/2014/main" id="{55B309F2-033B-47F8-941D-460A77FAB0C8}"/>
               </a:ext>
             </a:extLst>
           </p:cNvPr>
@@ -3160,7 +3326,7 @@
                 <a:ea typeface="Arial"/>
                 <a:cs typeface="Arial"/>
               </a:rPr>
-              <a:t>Subnormals count in steps of 1/32</a:t>
+              <a:t>The smallest normal is 1/4</a:t>
             </a:r>
           </a:p>
         </p:txBody>
@@ -3170,7 +3336,7 @@
           <p:cNvPr id="3" name="">
             <a:extLst xmlns:a="http://schemas.openxmlformats.org/drawingml/2006/main">
               <a:ext uri="{FF2B5EF4-FFF2-40B4-BE49-F238E27FC236}">
-                <a16:creationId xmlns:a16="http://schemas.microsoft.com/office/drawing/2014/main" id="{9CBE9A2B-E617-4407-BF21-6D1C10DB5F7C}"/>
+                <a16:creationId xmlns:a16="http://schemas.microsoft.com/office/drawing/2014/main" id="{2413D46C-F548-4E0D-8AC8-B55CC5C096EA}"/>
               </a:ext>
             </a:extLst>
           </p:cNvPr>
@@ -3218,7 +3384,7 @@
                 <a:ea typeface="Arial"/>
                 <a:cs typeface="Arial"/>
               </a:rPr>
-              <a:t>The three stored fraction bits make 0.FFF₂ increase by 1/8 each time. Multiplying by the fixed 2⁻² scale makes each step 1/32. So the field value F counts steps of 1/32.</a:t>
+              <a:t>The smallest normal exponent field is E = 1. With bias 3, that means e = −2. If the stored fraction is 000, the value is 1/4. We need another way to represent smaller positive values such as 1/8.</a:t>
             </a:r>
           </a:p>
         </p:txBody>
@@ -3228,7 +3394,7 @@
           <p:cNvPr id="4" name="">
             <a:extLst xmlns:a="http://schemas.openxmlformats.org/drawingml/2006/main">
               <a:ext uri="{FF2B5EF4-FFF2-40B4-BE49-F238E27FC236}">
-                <a16:creationId xmlns:a16="http://schemas.microsoft.com/office/drawing/2014/main" id="{F24EA955-1341-477F-B9E0-1F67FB906026}"/>
+                <a16:creationId xmlns:a16="http://schemas.microsoft.com/office/drawing/2014/main" id="{F4B5AD63-6E91-45DD-AE29-2F54895B988B}"/>
               </a:ext>
             </a:extLst>
           </p:cNvPr>
@@ -3276,7 +3442,7 @@
                 <a:ea typeface="Courier New"/>
                 <a:cs typeface="Courier New"/>
               </a:rPr>
-              <a:t>F     bits     value</a:t>
+              <a:t>Smallest normal</a:t>
             </a:r>
           </a:p>
           <a:p xmlns:a="http://schemas.openxmlformats.org/drawingml/2006/main">
@@ -3300,11 +3466,12 @@
                 <a:ea typeface="Courier New"/>
                 <a:cs typeface="Courier New"/>
               </a:rPr>
-              <a:t>0     000      0/32</a:t>
-            </a:r>
-          </a:p>
-          <a:p xmlns:a="http://schemas.openxmlformats.org/drawingml/2006/main">
-            <a:pPr>
+              <a:t/>
+            </a:r>
+          </a:p>
+          <a:p xmlns:a="http://schemas.openxmlformats.org/drawingml/2006/main">
+            <a:pPr>
+              <a:buNone/>
               <a:defRPr sz="1650">
                 <a:solidFill>
                   <a:srgbClr val="A7F3D0"/>
@@ -3323,7 +3490,7 @@
                 <a:ea typeface="Courier New"/>
                 <a:cs typeface="Courier New"/>
               </a:rPr>
-              <a:t>1     001      1/32</a:t>
+              <a:t>E = 001₂  →  e = 1 − 3 = −2</a:t>
             </a:r>
           </a:p>
           <a:p xmlns:a="http://schemas.openxmlformats.org/drawingml/2006/main">
@@ -3347,7 +3514,7 @@
                 <a:ea typeface="Courier New"/>
                 <a:cs typeface="Courier New"/>
               </a:rPr>
-              <a:t>4     100      4/32 = 1/8</a:t>
+              <a:t>F = 000₂  →  significand 1.000₂</a:t>
             </a:r>
           </a:p>
           <a:p xmlns:a="http://schemas.openxmlformats.org/drawingml/2006/main">
@@ -3371,11 +3538,6 @@
                 <a:ea typeface="Courier New"/>
                 <a:cs typeface="Courier New"/>
               </a:rPr>
-              <a:t>7     111      7/32</a:t>
-            </a:r>
-          </a:p>
-          <a:p xmlns:a="http://schemas.openxmlformats.org/drawingml/2006/main">
-            <a:r>
               <a:t/>
             </a:r>
           </a:p>
@@ -3400,7 +3562,55 @@
                 <a:ea typeface="Courier New"/>
                 <a:cs typeface="Courier New"/>
               </a:rPr>
-              <a:t>Subnormal value = F/32</a:t>
+              <a:t>value = 1.000₂ × 2⁻² = 1/4</a:t>
+            </a:r>
+          </a:p>
+          <a:p xmlns:a="http://schemas.openxmlformats.org/drawingml/2006/main">
+            <a:pPr>
+              <a:buNone/>
+              <a:defRPr sz="1650" b="0">
+                <a:solidFill>
+                  <a:srgbClr val="A7F3D0"/>
+                </a:solidFill>
+                <a:latin typeface="Courier New"/>
+                <a:ea typeface="Courier New"/>
+                <a:cs typeface="Courier New"/>
+              </a:defRPr>
+            </a:pPr>
+            <a:r>
+              <a:rPr sz="1650" b="0">
+                <a:solidFill>
+                  <a:srgbClr val="A7F3D0"/>
+                </a:solidFill>
+                <a:latin typeface="Courier New"/>
+                <a:ea typeface="Courier New"/>
+                <a:cs typeface="Courier New"/>
+              </a:rPr>
+              <a:t/>
+            </a:r>
+          </a:p>
+          <a:p xmlns:a="http://schemas.openxmlformats.org/drawingml/2006/main">
+            <a:pPr>
+              <a:buNone/>
+              <a:defRPr sz="1650" b="0">
+                <a:solidFill>
+                  <a:srgbClr val="A7F3D0"/>
+                </a:solidFill>
+                <a:latin typeface="Courier New"/>
+                <a:ea typeface="Courier New"/>
+                <a:cs typeface="Courier New"/>
+              </a:defRPr>
+            </a:pPr>
+            <a:r>
+              <a:rPr sz="1650" b="0">
+                <a:solidFill>
+                  <a:srgbClr val="A7F3D0"/>
+                </a:solidFill>
+                <a:latin typeface="Courier New"/>
+                <a:ea typeface="Courier New"/>
+                <a:cs typeface="Courier New"/>
+              </a:rPr>
+              <a:t>1/8 is smaller. E = 0 marks a new case.</a:t>
             </a:r>
           </a:p>
         </p:txBody>
@@ -3410,7 +3620,7 @@
           <p:cNvPr id="5" name="">
             <a:extLst xmlns:a="http://schemas.openxmlformats.org/drawingml/2006/main">
               <a:ext uri="{FF2B5EF4-FFF2-40B4-BE49-F238E27FC236}">
-                <a16:creationId xmlns:a16="http://schemas.microsoft.com/office/drawing/2014/main" id="{E8B59BBF-C1FE-4848-A1BE-0E49C6150211}"/>
+                <a16:creationId xmlns:a16="http://schemas.microsoft.com/office/drawing/2014/main" id="{10C83417-6965-41D8-8054-D122A500127B}"/>
               </a:ext>
             </a:extLst>
           </p:cNvPr>
@@ -3458,7 +3668,7 @@
                 <a:ea typeface="Arial"/>
                 <a:cs typeface="Arial"/>
               </a:rPr>
-              <a:t>Ask: what is the next value after 7/32?</a:t>
+              <a:t>For E = 0, use the subnormal rule instead of subtracting the bias.</a:t>
             </a:r>
           </a:p>
         </p:txBody>
@@ -3468,7 +3678,7 @@
           <p:cNvPr id="6" name="">
             <a:extLst xmlns:a="http://schemas.openxmlformats.org/drawingml/2006/main">
               <a:ext uri="{FF2B5EF4-FFF2-40B4-BE49-F238E27FC236}">
-                <a16:creationId xmlns:a16="http://schemas.microsoft.com/office/drawing/2014/main" id="{C1D8CDEF-F520-47D3-A60F-E6AFCB834AE6}"/>
+                <a16:creationId xmlns:a16="http://schemas.microsoft.com/office/drawing/2014/main" id="{8E1F2603-246C-497E-B2CC-C75AC3901746}"/>
               </a:ext>
             </a:extLst>
           </p:cNvPr>
@@ -3516,7 +3726,7 @@
                 <a:ea typeface="Courier New"/>
                 <a:cs typeface="Courier New"/>
               </a:rPr>
-              <a:t>10 / 22</a:t>
+              <a:t>10 / 24</a:t>
             </a:r>
           </a:p>
         </p:txBody>
@@ -3524,7 +3734,7 @@
     </p:spTree>
     <p:extLst>
       <p:ext uri="{BB962C8B-B14F-4D97-AF65-F5344CB8AC3E}">
-        <p14:creationId xmlns:p14="http://schemas.microsoft.com/office/powerpoint/2010/main" val="1006218793"/>
+        <p14:creationId xmlns:p14="http://schemas.microsoft.com/office/powerpoint/2010/main" val="1857122576"/>
       </p:ext>
     </p:extLst>
   </p:cSld>
@@ -3603,7 +3813,7 @@
                 <a:ea typeface="Courier New"/>
                 <a:cs typeface="Courier New"/>
               </a:rPr>
-              <a:t>FLOATING POINT · WORKED EXAMPLE</a:t>
+              <a:t>FLOATING POINT · SUBNORMAL RULE</a:t>
             </a:r>
           </a:p>
         </p:txBody>
@@ -3661,7 +3871,7 @@
                 <a:ea typeface="Arial"/>
                 <a:cs typeface="Arial"/>
               </a:rPr>
-              <a:t>Encode a subnormal: 1/8</a:t>
+              <a:t>E = 0 drops the hidden 1</a:t>
             </a:r>
           </a:p>
         </p:txBody>
@@ -3719,7 +3929,7 @@
                 <a:ea typeface="Arial"/>
                 <a:cs typeface="Arial"/>
               </a:rPr>
-              <a:t>1/8 is below the smallest normal, 1/4, so E = 0. A subnormal here is worth F/32. Solve F/32 = 1/8: F = 4, which is 100₂ in three bits.</a:t>
+              <a:t>Normal values start with an implied 1 before the fraction bits. When E = 0, use an implied 0 instead. Keep the same 2⁻² scale as the smallest normal so the values grow smoothly from zero.</a:t>
             </a:r>
           </a:p>
         </p:txBody>
@@ -3777,7 +3987,7 @@
                 <a:ea typeface="Courier New"/>
                 <a:cs typeface="Courier New"/>
               </a:rPr>
-              <a:t>S = 0</a:t>
+              <a:t>Fixed e = 1 − bias = −2</a:t>
             </a:r>
           </a:p>
           <a:p xmlns:a="http://schemas.openxmlformats.org/drawingml/2006/main">
@@ -3801,7 +4011,7 @@
                 <a:ea typeface="Courier New"/>
                 <a:cs typeface="Courier New"/>
               </a:rPr>
-              <a:t>E = 0 = 000₂</a:t>
+              <a:t/>
             </a:r>
           </a:p>
           <a:p xmlns:a="http://schemas.openxmlformats.org/drawingml/2006/main">
@@ -3825,17 +4035,84 @@
                 <a:ea typeface="Courier New"/>
                 <a:cs typeface="Courier New"/>
               </a:rPr>
-              <a:t>F = 4 = 100₂</a:t>
-            </a:r>
-          </a:p>
-          <a:p xmlns:a="http://schemas.openxmlformats.org/drawingml/2006/main">
-            <a:r>
+              <a:t>Normal, E = 1:</a:t>
+            </a:r>
+          </a:p>
+          <a:p xmlns:a="http://schemas.openxmlformats.org/drawingml/2006/main">
+            <a:pPr>
+              <a:buNone/>
+              <a:defRPr sz="1650">
+                <a:solidFill>
+                  <a:srgbClr val="A7F3D0"/>
+                </a:solidFill>
+                <a:latin typeface="Courier New"/>
+                <a:ea typeface="Courier New"/>
+                <a:cs typeface="Courier New"/>
+              </a:defRPr>
+            </a:pPr>
+            <a:r>
+              <a:rPr sz="1650">
+                <a:solidFill>
+                  <a:srgbClr val="A7F3D0"/>
+                </a:solidFill>
+                <a:latin typeface="Courier New"/>
+                <a:ea typeface="Courier New"/>
+                <a:cs typeface="Courier New"/>
+              </a:rPr>
+              <a:t>1.FFF₂ × 2⁻²</a:t>
+            </a:r>
+          </a:p>
+          <a:p xmlns:a="http://schemas.openxmlformats.org/drawingml/2006/main">
+            <a:pPr>
+              <a:buNone/>
+              <a:defRPr sz="1650" b="0">
+                <a:solidFill>
+                  <a:srgbClr val="A7F3D0"/>
+                </a:solidFill>
+                <a:latin typeface="Courier New"/>
+                <a:ea typeface="Courier New"/>
+                <a:cs typeface="Courier New"/>
+              </a:defRPr>
+            </a:pPr>
+            <a:r>
+              <a:rPr sz="1650" b="0">
+                <a:solidFill>
+                  <a:srgbClr val="A7F3D0"/>
+                </a:solidFill>
+                <a:latin typeface="Courier New"/>
+                <a:ea typeface="Courier New"/>
+                <a:cs typeface="Courier New"/>
+              </a:rPr>
               <a:t/>
             </a:r>
           </a:p>
           <a:p xmlns:a="http://schemas.openxmlformats.org/drawingml/2006/main">
             <a:pPr>
               <a:buNone/>
+              <a:defRPr sz="1650">
+                <a:solidFill>
+                  <a:srgbClr val="A7F3D0"/>
+                </a:solidFill>
+                <a:latin typeface="Courier New"/>
+                <a:ea typeface="Courier New"/>
+                <a:cs typeface="Courier New"/>
+              </a:defRPr>
+            </a:pPr>
+            <a:r>
+              <a:rPr sz="1650">
+                <a:solidFill>
+                  <a:srgbClr val="A7F3D0"/>
+                </a:solidFill>
+                <a:latin typeface="Courier New"/>
+                <a:ea typeface="Courier New"/>
+                <a:cs typeface="Courier New"/>
+              </a:rPr>
+              <a:t>Subnormal, E = 0:</a:t>
+            </a:r>
+          </a:p>
+          <a:p xmlns:a="http://schemas.openxmlformats.org/drawingml/2006/main">
+            <a:pPr>
+              <a:buNone/>
               <a:defRPr sz="1650" b="0">
                 <a:solidFill>
                   <a:srgbClr val="A7F3D0"/>
@@ -3854,11 +4131,30 @@
                 <a:ea typeface="Courier New"/>
                 <a:cs typeface="Courier New"/>
               </a:rPr>
-              <a:t>Fields: 0 | 000 | 100</a:t>
-            </a:r>
-          </a:p>
-          <a:p xmlns:a="http://schemas.openxmlformats.org/drawingml/2006/main">
-            <a:r>
+              <a:t>0.FFF₂ × 2⁻²</a:t>
+            </a:r>
+          </a:p>
+          <a:p xmlns:a="http://schemas.openxmlformats.org/drawingml/2006/main">
+            <a:pPr>
+              <a:buNone/>
+              <a:defRPr sz="1650" b="0">
+                <a:solidFill>
+                  <a:srgbClr val="A7F3D0"/>
+                </a:solidFill>
+                <a:latin typeface="Courier New"/>
+                <a:ea typeface="Courier New"/>
+                <a:cs typeface="Courier New"/>
+              </a:defRPr>
+            </a:pPr>
+            <a:r>
+              <a:rPr sz="1650" b="0">
+                <a:solidFill>
+                  <a:srgbClr val="A7F3D0"/>
+                </a:solidFill>
+                <a:latin typeface="Courier New"/>
+                <a:ea typeface="Courier New"/>
+                <a:cs typeface="Courier New"/>
+              </a:rPr>
               <a:t/>
             </a:r>
           </a:p>
@@ -3883,7 +4179,31 @@
                 <a:ea typeface="Courier New"/>
                 <a:cs typeface="Courier New"/>
               </a:rPr>
-              <a:t>Check: 4/32 = 1/8</a:t>
+              <a:t>F = 000  →  0.000₂ × 2⁻² = 0</a:t>
+            </a:r>
+          </a:p>
+          <a:p xmlns:a="http://schemas.openxmlformats.org/drawingml/2006/main">
+            <a:pPr>
+              <a:buNone/>
+              <a:defRPr sz="1650" b="0">
+                <a:solidFill>
+                  <a:srgbClr val="A7F3D0"/>
+                </a:solidFill>
+                <a:latin typeface="Courier New"/>
+                <a:ea typeface="Courier New"/>
+                <a:cs typeface="Courier New"/>
+              </a:defRPr>
+            </a:pPr>
+            <a:r>
+              <a:rPr sz="1650" b="0">
+                <a:solidFill>
+                  <a:srgbClr val="A7F3D0"/>
+                </a:solidFill>
+                <a:latin typeface="Courier New"/>
+                <a:ea typeface="Courier New"/>
+                <a:cs typeface="Courier New"/>
+              </a:rPr>
+              <a:t>F = 100  →  0.100₂ × 2⁻² = 1/8</a:t>
             </a:r>
           </a:p>
         </p:txBody>
@@ -3941,7 +4261,7 @@
                 <a:ea typeface="Arial"/>
                 <a:cs typeface="Arial"/>
               </a:rPr>
-              <a:t>No hidden 1: read the significand as 0.100₂.</a:t>
+              <a:t>The leading 0 or 1 is implied; only FFF is stored.</a:t>
             </a:r>
           </a:p>
         </p:txBody>
@@ -3999,7 +4319,7 @@
                 <a:ea typeface="Courier New"/>
                 <a:cs typeface="Courier New"/>
               </a:rPr>
-              <a:t>11 / 22</a:t>
+              <a:t>11 / 24</a:t>
             </a:r>
           </a:p>
         </p:txBody>
@@ -4086,7 +4406,7 @@
                 <a:ea typeface="Courier New"/>
                 <a:cs typeface="Courier New"/>
               </a:rPr>
-              <a:t>FLOATING POINT · BOUNDARY</a:t>
+              <a:t>FLOATING POINT · PLACE VALUES</a:t>
             </a:r>
           </a:p>
         </p:txBody>
@@ -4144,7 +4464,7 @@
                 <a:ea typeface="Arial"/>
                 <a:cs typeface="Arial"/>
               </a:rPr>
-              <a:t>The next normal is one step away</a:t>
+              <a:t>Subnormals count in steps of 1/32</a:t>
             </a:r>
           </a:p>
         </p:txBody>
@@ -4202,7 +4522,7 @@
                 <a:ea typeface="Arial"/>
                 <a:cs typeface="Arial"/>
               </a:rPr>
-              <a:t>The largest subnormal is 7/32. The smallest normal is 8/32. Both use the 2⁻² scale; the implied leading digit changes from 0 to 1 when E changes from 0 to 1.</a:t>
+              <a:t>The three stored fraction bits make 0.FFF₂ increase by 1/8 each time. Multiplying by the fixed 2⁻² scale makes each step 1/32. So the field value F counts steps of 1/32.</a:t>
             </a:r>
           </a:p>
         </p:txBody>
@@ -4260,7 +4580,7 @@
                 <a:ea typeface="Courier New"/>
                 <a:cs typeface="Courier New"/>
               </a:rPr>
-              <a:t>E = 0, F = 111₂</a:t>
+              <a:t>F     bits     value</a:t>
             </a:r>
           </a:p>
           <a:p xmlns:a="http://schemas.openxmlformats.org/drawingml/2006/main">
@@ -4284,7 +4604,79 @@
                 <a:ea typeface="Courier New"/>
                 <a:cs typeface="Courier New"/>
               </a:rPr>
-              <a:t>0.111₂ × 2⁻² = 7/32</a:t>
+              <a:t>0     000      0/32</a:t>
+            </a:r>
+          </a:p>
+          <a:p xmlns:a="http://schemas.openxmlformats.org/drawingml/2006/main">
+            <a:pPr>
+              <a:buNone/>
+              <a:defRPr sz="1650">
+                <a:solidFill>
+                  <a:srgbClr val="A7F3D0"/>
+                </a:solidFill>
+                <a:latin typeface="Courier New"/>
+                <a:ea typeface="Courier New"/>
+                <a:cs typeface="Courier New"/>
+              </a:defRPr>
+            </a:pPr>
+            <a:r>
+              <a:rPr sz="1650">
+                <a:solidFill>
+                  <a:srgbClr val="A7F3D0"/>
+                </a:solidFill>
+                <a:latin typeface="Courier New"/>
+                <a:ea typeface="Courier New"/>
+                <a:cs typeface="Courier New"/>
+              </a:rPr>
+              <a:t>1     001      1/32</a:t>
+            </a:r>
+          </a:p>
+          <a:p xmlns:a="http://schemas.openxmlformats.org/drawingml/2006/main">
+            <a:pPr>
+              <a:buNone/>
+              <a:defRPr sz="1650" b="0">
+                <a:solidFill>
+                  <a:srgbClr val="A7F3D0"/>
+                </a:solidFill>
+                <a:latin typeface="Courier New"/>
+                <a:ea typeface="Courier New"/>
+                <a:cs typeface="Courier New"/>
+              </a:defRPr>
+            </a:pPr>
+            <a:r>
+              <a:rPr sz="1650" b="0">
+                <a:solidFill>
+                  <a:srgbClr val="A7F3D0"/>
+                </a:solidFill>
+                <a:latin typeface="Courier New"/>
+                <a:ea typeface="Courier New"/>
+                <a:cs typeface="Courier New"/>
+              </a:rPr>
+              <a:t>4     100      4/32 = 1/8</a:t>
+            </a:r>
+          </a:p>
+          <a:p xmlns:a="http://schemas.openxmlformats.org/drawingml/2006/main">
+            <a:pPr>
+              <a:buNone/>
+              <a:defRPr sz="1650" b="0">
+                <a:solidFill>
+                  <a:srgbClr val="A7F3D0"/>
+                </a:solidFill>
+                <a:latin typeface="Courier New"/>
+                <a:ea typeface="Courier New"/>
+                <a:cs typeface="Courier New"/>
+              </a:defRPr>
+            </a:pPr>
+            <a:r>
+              <a:rPr sz="1650" b="0">
+                <a:solidFill>
+                  <a:srgbClr val="A7F3D0"/>
+                </a:solidFill>
+                <a:latin typeface="Courier New"/>
+                <a:ea typeface="Courier New"/>
+                <a:cs typeface="Courier New"/>
+              </a:rPr>
+              <a:t>7     111      7/32</a:t>
             </a:r>
           </a:p>
           <a:p xmlns:a="http://schemas.openxmlformats.org/drawingml/2006/main">
@@ -4313,60 +4705,7 @@
                 <a:ea typeface="Courier New"/>
                 <a:cs typeface="Courier New"/>
               </a:rPr>
-              <a:t>E = 1, F = 000₂</a:t>
-            </a:r>
-          </a:p>
-          <a:p xmlns:a="http://schemas.openxmlformats.org/drawingml/2006/main">
-            <a:pPr>
-              <a:buNone/>
-              <a:defRPr sz="1650" b="0">
-                <a:solidFill>
-                  <a:srgbClr val="A7F3D0"/>
-                </a:solidFill>
-                <a:latin typeface="Courier New"/>
-                <a:ea typeface="Courier New"/>
-                <a:cs typeface="Courier New"/>
-              </a:defRPr>
-            </a:pPr>
-            <a:r>
-              <a:rPr sz="1650" b="0">
-                <a:solidFill>
-                  <a:srgbClr val="A7F3D0"/>
-                </a:solidFill>
-                <a:latin typeface="Courier New"/>
-                <a:ea typeface="Courier New"/>
-                <a:cs typeface="Courier New"/>
-              </a:rPr>
-              <a:t>1.000₂ × 2⁻² = 8/32</a:t>
-            </a:r>
-          </a:p>
-          <a:p xmlns:a="http://schemas.openxmlformats.org/drawingml/2006/main">
-            <a:r>
-              <a:t/>
-            </a:r>
-          </a:p>
-          <a:p xmlns:a="http://schemas.openxmlformats.org/drawingml/2006/main">
-            <a:pPr>
-              <a:buNone/>
-              <a:defRPr sz="1650" b="0">
-                <a:solidFill>
-                  <a:srgbClr val="A7F3D0"/>
-                </a:solidFill>
-                <a:latin typeface="Courier New"/>
-                <a:ea typeface="Courier New"/>
-                <a:cs typeface="Courier New"/>
-              </a:defRPr>
-            </a:pPr>
-            <a:r>
-              <a:rPr sz="1650" b="0">
-                <a:solidFill>
-                  <a:srgbClr val="A7F3D0"/>
-                </a:solidFill>
-                <a:latin typeface="Courier New"/>
-                <a:ea typeface="Courier New"/>
-                <a:cs typeface="Courier New"/>
-              </a:rPr>
-              <a:t>Gap = 1/32</a:t>
+              <a:t>Subnormal value = F/32</a:t>
             </a:r>
           </a:p>
         </p:txBody>
@@ -4424,7 +4763,7 @@
                 <a:ea typeface="Arial"/>
                 <a:cs typeface="Arial"/>
               </a:rPr>
-              <a:t>Subnormal values fill the space between zero and 1/4.</a:t>
+              <a:t>Ask: what is the next value after 7/32?</a:t>
             </a:r>
           </a:p>
         </p:txBody>
@@ -4482,7 +4821,7 @@
                 <a:ea typeface="Courier New"/>
                 <a:cs typeface="Courier New"/>
               </a:rPr>
-              <a:t>12 / 22</a:t>
+              <a:t>12 / 24</a:t>
             </a:r>
           </a:p>
         </p:txBody>
@@ -4521,7 +4860,7 @@
           <p:cNvPr id="7" name="">
             <a:extLst xmlns:a="http://schemas.openxmlformats.org/drawingml/2006/main">
               <a:ext uri="{FF2B5EF4-FFF2-40B4-BE49-F238E27FC236}">
-                <a16:creationId xmlns:a16="http://schemas.microsoft.com/office/drawing/2014/main" id="{ED6F0A3D-C361-4FA6-9CFE-2E669E0D919F}"/>
+                <a16:creationId xmlns:a16="http://schemas.microsoft.com/office/drawing/2014/main" id="{0E1C1D56-F3B0-4FC7-8312-5DCE66DE8296}"/>
               </a:ext>
             </a:extLst>
           </p:cNvPr>
@@ -4569,7 +4908,7 @@
                 <a:ea typeface="Courier New"/>
                 <a:cs typeface="Courier New"/>
               </a:rPr>
-              <a:t>FLOATING POINT · PRACTICE</a:t>
+              <a:t>FLOATING POINT · WORKED EXAMPLE</a:t>
             </a:r>
           </a:p>
         </p:txBody>
@@ -4579,7 +4918,7 @@
           <p:cNvPr id="2" name="">
             <a:extLst xmlns:a="http://schemas.openxmlformats.org/drawingml/2006/main">
               <a:ext uri="{FF2B5EF4-FFF2-40B4-BE49-F238E27FC236}">
-                <a16:creationId xmlns:a16="http://schemas.microsoft.com/office/drawing/2014/main" id="{8531682B-A598-4D48-84FE-CD10468FEB1D}"/>
+                <a16:creationId xmlns:a16="http://schemas.microsoft.com/office/drawing/2014/main" id="{47EC4111-990D-4F27-A48D-9B66E8564E29}"/>
               </a:ext>
             </a:extLst>
           </p:cNvPr>
@@ -4627,7 +4966,7 @@
                 <a:ea typeface="Arial"/>
                 <a:cs typeface="Arial"/>
               </a:rPr>
-              <a:t>Your turn: decode two patterns</a:t>
+              <a:t>Encode a subnormal: 1/8</a:t>
             </a:r>
           </a:p>
         </p:txBody>
@@ -4637,7 +4976,7 @@
           <p:cNvPr id="3" name="">
             <a:extLst xmlns:a="http://schemas.openxmlformats.org/drawingml/2006/main">
               <a:ext uri="{FF2B5EF4-FFF2-40B4-BE49-F238E27FC236}">
-                <a16:creationId xmlns:a16="http://schemas.microsoft.com/office/drawing/2014/main" id="{7C4976BE-C2D5-4F13-B1DA-E2F9D2612B6A}"/>
+                <a16:creationId xmlns:a16="http://schemas.microsoft.com/office/drawing/2014/main" id="{EA7FC2C0-68E4-440B-B218-A53A78DE1183}"/>
               </a:ext>
             </a:extLst>
           </p:cNvPr>
@@ -4685,36 +5024,7 @@
                 <a:ea typeface="Arial"/>
                 <a:cs typeface="Arial"/>
               </a:rPr>
-              <a:t>Use the same format: 3 exponent bits, bias 3, and 3 fraction bits.</a:t>
-            </a:r>
-          </a:p>
-          <a:p xmlns:a="http://schemas.openxmlformats.org/drawingml/2006/main">
-            <a:r>
-              <a:t/>
-            </a:r>
-          </a:p>
-          <a:p xmlns:a="http://schemas.openxmlformats.org/drawingml/2006/main">
-            <a:pPr>
-              <a:buNone/>
-              <a:defRPr sz="1950" b="0">
-                <a:solidFill>
-                  <a:srgbClr val="D4D4D8"/>
-                </a:solidFill>
-                <a:latin typeface="Arial"/>
-                <a:ea typeface="Arial"/>
-                <a:cs typeface="Arial"/>
-              </a:defRPr>
-            </a:pPr>
-            <a:r>
-              <a:rPr sz="1950" b="0">
-                <a:solidFill>
-                  <a:srgbClr val="D4D4D8"/>
-                </a:solidFill>
-                <a:latin typeface="Arial"/>
-                <a:ea typeface="Arial"/>
-                <a:cs typeface="Arial"/>
-              </a:rPr>
-              <a:t>For each pattern, classify it, find E and F, then calculate the value.</a:t>
+              <a:t>1/8 is below the smallest normal, 1/4, so E = 0. A subnormal here is worth F/32. Solve F/32 = 1/8: F = 4, which is 100₂ in three bits.</a:t>
             </a:r>
           </a:p>
         </p:txBody>
@@ -4724,7 +5034,7 @@
           <p:cNvPr id="4" name="">
             <a:extLst xmlns:a="http://schemas.openxmlformats.org/drawingml/2006/main">
               <a:ext uri="{FF2B5EF4-FFF2-40B4-BE49-F238E27FC236}">
-                <a16:creationId xmlns:a16="http://schemas.microsoft.com/office/drawing/2014/main" id="{97877AB9-DA81-4CB4-8D40-AAADEA86261B}"/>
+                <a16:creationId xmlns:a16="http://schemas.microsoft.com/office/drawing/2014/main" id="{C7B97746-2F05-4C79-997B-46EF673FF248}"/>
               </a:ext>
             </a:extLst>
           </p:cNvPr>
@@ -4772,7 +5082,7 @@
                 <a:ea typeface="Courier New"/>
                 <a:cs typeface="Courier New"/>
               </a:rPr>
-              <a:t>A. 0 | 010 | 100</a:t>
+              <a:t>S = 0</a:t>
             </a:r>
           </a:p>
           <a:p xmlns:a="http://schemas.openxmlformats.org/drawingml/2006/main">
@@ -4796,7 +5106,7 @@
                 <a:ea typeface="Courier New"/>
                 <a:cs typeface="Courier New"/>
               </a:rPr>
-              <a:t>   normal or subnormal?</a:t>
+              <a:t>E = 0 = 000₂</a:t>
             </a:r>
           </a:p>
           <a:p xmlns:a="http://schemas.openxmlformats.org/drawingml/2006/main">
@@ -4820,7 +5130,7 @@
                 <a:ea typeface="Courier New"/>
                 <a:cs typeface="Courier New"/>
               </a:rPr>
-              <a:t>   value = ?</a:t>
+              <a:t>F = 4 = 100₂</a:t>
             </a:r>
           </a:p>
           <a:p xmlns:a="http://schemas.openxmlformats.org/drawingml/2006/main">
@@ -4849,7 +5159,12 @@
                 <a:ea typeface="Courier New"/>
                 <a:cs typeface="Courier New"/>
               </a:rPr>
-              <a:t>B. 0 | 000 | 011</a:t>
+              <a:t>Fields: 0 | 000 | 100</a:t>
+            </a:r>
+          </a:p>
+          <a:p xmlns:a="http://schemas.openxmlformats.org/drawingml/2006/main">
+            <a:r>
+              <a:t/>
             </a:r>
           </a:p>
           <a:p xmlns:a="http://schemas.openxmlformats.org/drawingml/2006/main">
@@ -4873,31 +5188,7 @@
                 <a:ea typeface="Courier New"/>
                 <a:cs typeface="Courier New"/>
               </a:rPr>
-              <a:t>   normal or subnormal?</a:t>
-            </a:r>
-          </a:p>
-          <a:p xmlns:a="http://schemas.openxmlformats.org/drawingml/2006/main">
-            <a:pPr>
-              <a:buNone/>
-              <a:defRPr sz="1650" b="0">
-                <a:solidFill>
-                  <a:srgbClr val="A7F3D0"/>
-                </a:solidFill>
-                <a:latin typeface="Courier New"/>
-                <a:ea typeface="Courier New"/>
-                <a:cs typeface="Courier New"/>
-              </a:defRPr>
-            </a:pPr>
-            <a:r>
-              <a:rPr sz="1650" b="0">
-                <a:solidFill>
-                  <a:srgbClr val="A7F3D0"/>
-                </a:solidFill>
-                <a:latin typeface="Courier New"/>
-                <a:ea typeface="Courier New"/>
-                <a:cs typeface="Courier New"/>
-              </a:rPr>
-              <a:t>   value = ?</a:t>
+              <a:t>Check: 4/32 = 1/8</a:t>
             </a:r>
           </a:p>
         </p:txBody>
@@ -4907,7 +5198,7 @@
           <p:cNvPr id="5" name="">
             <a:extLst xmlns:a="http://schemas.openxmlformats.org/drawingml/2006/main">
               <a:ext uri="{FF2B5EF4-FFF2-40B4-BE49-F238E27FC236}">
-                <a16:creationId xmlns:a16="http://schemas.microsoft.com/office/drawing/2014/main" id="{0C768E93-B810-439B-9ECE-DACDD6255183}"/>
+                <a16:creationId xmlns:a16="http://schemas.microsoft.com/office/drawing/2014/main" id="{C953FAB2-7571-49A3-B6C8-87F90FA9D556}"/>
               </a:ext>
             </a:extLst>
           </p:cNvPr>
@@ -4955,7 +5246,7 @@
                 <a:ea typeface="Arial"/>
                 <a:cs typeface="Arial"/>
               </a:rPr>
-              <a:t>If E = 0, count F steps of 1/32. Otherwise use the normal rule.</a:t>
+              <a:t>No hidden 1: read the significand as 0.100₂.</a:t>
             </a:r>
           </a:p>
         </p:txBody>
@@ -4965,7 +5256,7 @@
           <p:cNvPr id="6" name="">
             <a:extLst xmlns:a="http://schemas.openxmlformats.org/drawingml/2006/main">
               <a:ext uri="{FF2B5EF4-FFF2-40B4-BE49-F238E27FC236}">
-                <a16:creationId xmlns:a16="http://schemas.microsoft.com/office/drawing/2014/main" id="{4E485357-E888-4A45-92E1-47CDEA8A71B2}"/>
+                <a16:creationId xmlns:a16="http://schemas.microsoft.com/office/drawing/2014/main" id="{ECE7F5E9-2417-44C6-925E-4767F90FA696}"/>
               </a:ext>
             </a:extLst>
           </p:cNvPr>
@@ -5013,7 +5304,7 @@
                 <a:ea typeface="Courier New"/>
                 <a:cs typeface="Courier New"/>
               </a:rPr>
-              <a:t>13 / 22</a:t>
+              <a:t>13 / 24</a:t>
             </a:r>
           </a:p>
         </p:txBody>
@@ -5021,7 +5312,7 @@
     </p:spTree>
     <p:extLst>
       <p:ext uri="{BB962C8B-B14F-4D97-AF65-F5344CB8AC3E}">
-        <p14:creationId xmlns:p14="http://schemas.microsoft.com/office/powerpoint/2010/main" val="1507595076"/>
+        <p14:creationId xmlns:p14="http://schemas.microsoft.com/office/powerpoint/2010/main" val="1082036242"/>
       </p:ext>
     </p:extLst>
   </p:cSld>
@@ -5052,7 +5343,7 @@
           <p:cNvPr id="7" name="">
             <a:extLst xmlns:a="http://schemas.openxmlformats.org/drawingml/2006/main">
               <a:ext uri="{FF2B5EF4-FFF2-40B4-BE49-F238E27FC236}">
-                <a16:creationId xmlns:a16="http://schemas.microsoft.com/office/drawing/2014/main" id="{7AC5D697-73A9-4130-AF88-3B9A153D538D}"/>
+                <a16:creationId xmlns:a16="http://schemas.microsoft.com/office/drawing/2014/main" id="{DF65E5C3-C59B-4F4C-8123-D26BB20B62FC}"/>
               </a:ext>
             </a:extLst>
           </p:cNvPr>
@@ -5100,7 +5391,7 @@
                 <a:ea typeface="Courier New"/>
                 <a:cs typeface="Courier New"/>
               </a:rPr>
-              <a:t>FLOATING POINT · CHECK</a:t>
+              <a:t>FLOATING POINT · BOUNDARY</a:t>
             </a:r>
           </a:p>
         </p:txBody>
@@ -5110,7 +5401,7 @@
           <p:cNvPr id="2" name="">
             <a:extLst xmlns:a="http://schemas.openxmlformats.org/drawingml/2006/main">
               <a:ext uri="{FF2B5EF4-FFF2-40B4-BE49-F238E27FC236}">
-                <a16:creationId xmlns:a16="http://schemas.microsoft.com/office/drawing/2014/main" id="{1059792B-54CD-4C1F-8A87-49C3F494D2AD}"/>
+                <a16:creationId xmlns:a16="http://schemas.microsoft.com/office/drawing/2014/main" id="{AAF148DA-667A-4F17-8947-3A10B5D66209}"/>
               </a:ext>
             </a:extLst>
           </p:cNvPr>
@@ -5158,7 +5449,7 @@
                 <a:ea typeface="Arial"/>
                 <a:cs typeface="Arial"/>
               </a:rPr>
-              <a:t>Decode answers</a:t>
+              <a:t>The next normal is one step away</a:t>
             </a:r>
           </a:p>
         </p:txBody>
@@ -5168,7 +5459,7 @@
           <p:cNvPr id="3" name="">
             <a:extLst xmlns:a="http://schemas.openxmlformats.org/drawingml/2006/main">
               <a:ext uri="{FF2B5EF4-FFF2-40B4-BE49-F238E27FC236}">
-                <a16:creationId xmlns:a16="http://schemas.microsoft.com/office/drawing/2014/main" id="{26F3E9C7-6AC5-4E40-B664-B323C1BA5CEA}"/>
+                <a16:creationId xmlns:a16="http://schemas.microsoft.com/office/drawing/2014/main" id="{9CBE9A2B-E617-4407-BF21-6D1C10DB5F7C}"/>
               </a:ext>
             </a:extLst>
           </p:cNvPr>
@@ -5216,7 +5507,7 @@
                 <a:ea typeface="Arial"/>
                 <a:cs typeface="Arial"/>
               </a:rPr>
-              <a:t>A has E = 2, so decode a normal value. B has E = 0, so its F = 3 means three steps of 1/32.</a:t>
+              <a:t>The largest subnormal is 7/32. The smallest normal is 8/32. Both use the 2⁻² scale; the implied leading digit changes from 0 to 1 when E changes from 0 to 1.</a:t>
             </a:r>
           </a:p>
         </p:txBody>
@@ -5226,7 +5517,7 @@
           <p:cNvPr id="4" name="">
             <a:extLst xmlns:a="http://schemas.openxmlformats.org/drawingml/2006/main">
               <a:ext uri="{FF2B5EF4-FFF2-40B4-BE49-F238E27FC236}">
-                <a16:creationId xmlns:a16="http://schemas.microsoft.com/office/drawing/2014/main" id="{737C1F1B-87F6-43C2-BCA8-B1C729031D72}"/>
+                <a16:creationId xmlns:a16="http://schemas.microsoft.com/office/drawing/2014/main" id="{F24EA955-1341-477F-B9E0-1F67FB906026}"/>
               </a:ext>
             </a:extLst>
           </p:cNvPr>
@@ -5274,7 +5565,7 @@
                 <a:ea typeface="Courier New"/>
                 <a:cs typeface="Courier New"/>
               </a:rPr>
-              <a:t>A. 0 | 010 | 100</a:t>
+              <a:t>E = 0, F = 111₂</a:t>
             </a:r>
           </a:p>
           <a:p xmlns:a="http://schemas.openxmlformats.org/drawingml/2006/main">
@@ -5298,7 +5589,7 @@
                 <a:ea typeface="Courier New"/>
                 <a:cs typeface="Courier New"/>
               </a:rPr>
-              <a:t>   (1 + 4/8) × 2⁻¹ = 3/4</a:t>
+              <a:t>0.111₂ × 2⁻² = 7/32</a:t>
             </a:r>
           </a:p>
           <a:p xmlns:a="http://schemas.openxmlformats.org/drawingml/2006/main">
@@ -5327,7 +5618,7 @@
                 <a:ea typeface="Courier New"/>
                 <a:cs typeface="Courier New"/>
               </a:rPr>
-              <a:t>B. 0 | 000 | 011</a:t>
+              <a:t>E = 1, F = 000₂</a:t>
             </a:r>
           </a:p>
           <a:p xmlns:a="http://schemas.openxmlformats.org/drawingml/2006/main">
@@ -5351,7 +5642,36 @@
                 <a:ea typeface="Courier New"/>
                 <a:cs typeface="Courier New"/>
               </a:rPr>
-              <a:t>   F = 3  →  3/32</a:t>
+              <a:t>1.000₂ × 2⁻² = 8/32</a:t>
+            </a:r>
+          </a:p>
+          <a:p xmlns:a="http://schemas.openxmlformats.org/drawingml/2006/main">
+            <a:r>
+              <a:t/>
+            </a:r>
+          </a:p>
+          <a:p xmlns:a="http://schemas.openxmlformats.org/drawingml/2006/main">
+            <a:pPr>
+              <a:buNone/>
+              <a:defRPr sz="1650" b="0">
+                <a:solidFill>
+                  <a:srgbClr val="A7F3D0"/>
+                </a:solidFill>
+                <a:latin typeface="Courier New"/>
+                <a:ea typeface="Courier New"/>
+                <a:cs typeface="Courier New"/>
+              </a:defRPr>
+            </a:pPr>
+            <a:r>
+              <a:rPr sz="1650" b="0">
+                <a:solidFill>
+                  <a:srgbClr val="A7F3D0"/>
+                </a:solidFill>
+                <a:latin typeface="Courier New"/>
+                <a:ea typeface="Courier New"/>
+                <a:cs typeface="Courier New"/>
+              </a:rPr>
+              <a:t>Gap = 1/32</a:t>
             </a:r>
           </a:p>
         </p:txBody>
@@ -5361,7 +5681,7 @@
           <p:cNvPr id="5" name="">
             <a:extLst xmlns:a="http://schemas.openxmlformats.org/drawingml/2006/main">
               <a:ext uri="{FF2B5EF4-FFF2-40B4-BE49-F238E27FC236}">
-                <a16:creationId xmlns:a16="http://schemas.microsoft.com/office/drawing/2014/main" id="{9DAD2664-9B32-4402-A088-C1DEBD68E3CD}"/>
+                <a16:creationId xmlns:a16="http://schemas.microsoft.com/office/drawing/2014/main" id="{E8B59BBF-C1FE-4848-A1BE-0E49C6150211}"/>
               </a:ext>
             </a:extLst>
           </p:cNvPr>
@@ -5409,7 +5729,7 @@
                 <a:ea typeface="Arial"/>
                 <a:cs typeface="Arial"/>
               </a:rPr>
-              <a:t>If the answer seems surprising, decode the same fields back into the formula.</a:t>
+              <a:t>Subnormal values fill the space between zero and 1/4.</a:t>
             </a:r>
           </a:p>
         </p:txBody>
@@ -5419,7 +5739,7 @@
           <p:cNvPr id="6" name="">
             <a:extLst xmlns:a="http://schemas.openxmlformats.org/drawingml/2006/main">
               <a:ext uri="{FF2B5EF4-FFF2-40B4-BE49-F238E27FC236}">
-                <a16:creationId xmlns:a16="http://schemas.microsoft.com/office/drawing/2014/main" id="{DBE61FAB-FD81-4893-85F8-90700B31187C}"/>
+                <a16:creationId xmlns:a16="http://schemas.microsoft.com/office/drawing/2014/main" id="{C1D8CDEF-F520-47D3-A60F-E6AFCB834AE6}"/>
               </a:ext>
             </a:extLst>
           </p:cNvPr>
@@ -5467,7 +5787,7 @@
                 <a:ea typeface="Courier New"/>
                 <a:cs typeface="Courier New"/>
               </a:rPr>
-              <a:t>14 / 22</a:t>
+              <a:t>14 / 24</a:t>
             </a:r>
           </a:p>
         </p:txBody>
@@ -5475,7 +5795,7 @@
     </p:spTree>
     <p:extLst>
       <p:ext uri="{BB962C8B-B14F-4D97-AF65-F5344CB8AC3E}">
-        <p14:creationId xmlns:p14="http://schemas.microsoft.com/office/powerpoint/2010/main" val="1502731382"/>
+        <p14:creationId xmlns:p14="http://schemas.microsoft.com/office/powerpoint/2010/main" val="1006218793"/>
       </p:ext>
     </p:extLst>
   </p:cSld>
@@ -5506,7 +5826,7 @@
           <p:cNvPr id="7" name="">
             <a:extLst xmlns:a="http://schemas.openxmlformats.org/drawingml/2006/main">
               <a:ext uri="{FF2B5EF4-FFF2-40B4-BE49-F238E27FC236}">
-                <a16:creationId xmlns:a16="http://schemas.microsoft.com/office/drawing/2014/main" id="{35A724E8-02D1-4C78-A9D3-AE6AD6E2D594}"/>
+                <a16:creationId xmlns:a16="http://schemas.microsoft.com/office/drawing/2014/main" id="{ED6F0A3D-C361-4FA6-9CFE-2E669E0D919F}"/>
               </a:ext>
             </a:extLst>
           </p:cNvPr>
@@ -5564,7 +5884,7 @@
           <p:cNvPr id="2" name="">
             <a:extLst xmlns:a="http://schemas.openxmlformats.org/drawingml/2006/main">
               <a:ext uri="{FF2B5EF4-FFF2-40B4-BE49-F238E27FC236}">
-                <a16:creationId xmlns:a16="http://schemas.microsoft.com/office/drawing/2014/main" id="{D68140D5-AD40-4B2D-9276-45B94835A98B}"/>
+                <a16:creationId xmlns:a16="http://schemas.microsoft.com/office/drawing/2014/main" id="{8531682B-A598-4D48-84FE-CD10468FEB1D}"/>
               </a:ext>
             </a:extLst>
           </p:cNvPr>
@@ -5612,7 +5932,7 @@
                 <a:ea typeface="Arial"/>
                 <a:cs typeface="Arial"/>
               </a:rPr>
-              <a:t>Your turn: classify two ratios</a:t>
+              <a:t>Your turn: decode two patterns</a:t>
             </a:r>
           </a:p>
         </p:txBody>
@@ -5622,7 +5942,7 @@
           <p:cNvPr id="3" name="">
             <a:extLst xmlns:a="http://schemas.openxmlformats.org/drawingml/2006/main">
               <a:ext uri="{FF2B5EF4-FFF2-40B4-BE49-F238E27FC236}">
-                <a16:creationId xmlns:a16="http://schemas.microsoft.com/office/drawing/2014/main" id="{AA9609DC-0513-451F-B1A4-CD75618D8A9F}"/>
+                <a16:creationId xmlns:a16="http://schemas.microsoft.com/office/drawing/2014/main" id="{7C4976BE-C2D5-4F13-B1DA-E2F9D2612B6A}"/>
               </a:ext>
             </a:extLst>
           </p:cNvPr>
@@ -5670,7 +5990,7 @@
                 <a:ea typeface="Arial"/>
                 <a:cs typeface="Arial"/>
               </a:rPr>
-              <a:t>Use the same practice format: 3 exponent bits, bias 3, and 3 fraction bits.</a:t>
+              <a:t>Use the same format: 3 exponent bits, bias 3, and 3 fraction bits.</a:t>
             </a:r>
           </a:p>
           <a:p xmlns:a="http://schemas.openxmlformats.org/drawingml/2006/main">
@@ -5699,7 +6019,7 @@
                 <a:ea typeface="Arial"/>
                 <a:cs typeface="Arial"/>
               </a:rPr>
-              <a:t>For each ratio, decide normal or subnormal, then find E and F.</a:t>
+              <a:t>For each pattern, classify it, find E and F, then calculate the value.</a:t>
             </a:r>
           </a:p>
         </p:txBody>
@@ -5709,7 +6029,7 @@
           <p:cNvPr id="4" name="">
             <a:extLst xmlns:a="http://schemas.openxmlformats.org/drawingml/2006/main">
               <a:ext uri="{FF2B5EF4-FFF2-40B4-BE49-F238E27FC236}">
-                <a16:creationId xmlns:a16="http://schemas.microsoft.com/office/drawing/2014/main" id="{37A2E272-B675-4F8B-8D9A-1DD0C7D3E885}"/>
+                <a16:creationId xmlns:a16="http://schemas.microsoft.com/office/drawing/2014/main" id="{97877AB9-DA81-4CB4-8D40-AAADEA86261B}"/>
               </a:ext>
             </a:extLst>
           </p:cNvPr>
@@ -5757,7 +6077,7 @@
                 <a:ea typeface="Courier New"/>
                 <a:cs typeface="Courier New"/>
               </a:rPr>
-              <a:t>A. 3/2</a:t>
+              <a:t>A. 0 | 010 | 100</a:t>
             </a:r>
           </a:p>
           <a:p xmlns:a="http://schemas.openxmlformats.org/drawingml/2006/main">
@@ -5805,7 +6125,7 @@
                 <a:ea typeface="Courier New"/>
                 <a:cs typeface="Courier New"/>
               </a:rPr>
-              <a:t>   E = ?   F = ?</a:t>
+              <a:t>   value = ?</a:t>
             </a:r>
           </a:p>
           <a:p xmlns:a="http://schemas.openxmlformats.org/drawingml/2006/main">
@@ -5834,7 +6154,7 @@
                 <a:ea typeface="Courier New"/>
                 <a:cs typeface="Courier New"/>
               </a:rPr>
-              <a:t>B. 3/16</a:t>
+              <a:t>B. 0 | 000 | 011</a:t>
             </a:r>
           </a:p>
           <a:p xmlns:a="http://schemas.openxmlformats.org/drawingml/2006/main">
@@ -5882,7 +6202,7 @@
                 <a:ea typeface="Courier New"/>
                 <a:cs typeface="Courier New"/>
               </a:rPr>
-              <a:t>   E = ?   F = ?</a:t>
+              <a:t>   value = ?</a:t>
             </a:r>
           </a:p>
         </p:txBody>
@@ -5892,7 +6212,7 @@
           <p:cNvPr id="5" name="">
             <a:extLst xmlns:a="http://schemas.openxmlformats.org/drawingml/2006/main">
               <a:ext uri="{FF2B5EF4-FFF2-40B4-BE49-F238E27FC236}">
-                <a16:creationId xmlns:a16="http://schemas.microsoft.com/office/drawing/2014/main" id="{8F900304-F8E7-4C1C-B3A0-F1A0DD604211}"/>
+                <a16:creationId xmlns:a16="http://schemas.microsoft.com/office/drawing/2014/main" id="{0C768E93-B810-439B-9ECE-DACDD6255183}"/>
               </a:ext>
             </a:extLst>
           </p:cNvPr>
@@ -5940,7 +6260,7 @@
                 <a:ea typeface="Arial"/>
                 <a:cs typeface="Arial"/>
               </a:rPr>
-              <a:t>Compare each value with the smallest normal, 1/4, before finding bits.</a:t>
+              <a:t>If E = 0, count F steps of 1/32. Otherwise use the normal rule.</a:t>
             </a:r>
           </a:p>
         </p:txBody>
@@ -5950,7 +6270,7 @@
           <p:cNvPr id="6" name="">
             <a:extLst xmlns:a="http://schemas.openxmlformats.org/drawingml/2006/main">
               <a:ext uri="{FF2B5EF4-FFF2-40B4-BE49-F238E27FC236}">
-                <a16:creationId xmlns:a16="http://schemas.microsoft.com/office/drawing/2014/main" id="{16200DCD-0F16-4BE6-9538-9FDAF86C958E}"/>
+                <a16:creationId xmlns:a16="http://schemas.microsoft.com/office/drawing/2014/main" id="{4E485357-E888-4A45-92E1-47CDEA8A71B2}"/>
               </a:ext>
             </a:extLst>
           </p:cNvPr>
@@ -5998,7 +6318,7 @@
                 <a:ea typeface="Courier New"/>
                 <a:cs typeface="Courier New"/>
               </a:rPr>
-              <a:t>15 / 22</a:t>
+              <a:t>15 / 24</a:t>
             </a:r>
           </a:p>
         </p:txBody>
@@ -6006,7 +6326,7 @@
     </p:spTree>
     <p:extLst>
       <p:ext uri="{BB962C8B-B14F-4D97-AF65-F5344CB8AC3E}">
-        <p14:creationId xmlns:p14="http://schemas.microsoft.com/office/powerpoint/2010/main" val="2079659254"/>
+        <p14:creationId xmlns:p14="http://schemas.microsoft.com/office/powerpoint/2010/main" val="1507595076"/>
       </p:ext>
     </p:extLst>
   </p:cSld>
@@ -6037,7 +6357,7 @@
           <p:cNvPr id="7" name="">
             <a:extLst xmlns:a="http://schemas.openxmlformats.org/drawingml/2006/main">
               <a:ext uri="{FF2B5EF4-FFF2-40B4-BE49-F238E27FC236}">
-                <a16:creationId xmlns:a16="http://schemas.microsoft.com/office/drawing/2014/main" id="{D25A2A70-779E-4A39-9AD5-537DDE3C5B7A}"/>
+                <a16:creationId xmlns:a16="http://schemas.microsoft.com/office/drawing/2014/main" id="{7AC5D697-73A9-4130-AF88-3B9A153D538D}"/>
               </a:ext>
             </a:extLst>
           </p:cNvPr>
@@ -6095,7 +6415,7 @@
           <p:cNvPr id="2" name="">
             <a:extLst xmlns:a="http://schemas.openxmlformats.org/drawingml/2006/main">
               <a:ext uri="{FF2B5EF4-FFF2-40B4-BE49-F238E27FC236}">
-                <a16:creationId xmlns:a16="http://schemas.microsoft.com/office/drawing/2014/main" id="{2F2733A3-E106-4C90-B097-BE7CB4577892}"/>
+                <a16:creationId xmlns:a16="http://schemas.microsoft.com/office/drawing/2014/main" id="{1059792B-54CD-4C1F-8A87-49C3F494D2AD}"/>
               </a:ext>
             </a:extLst>
           </p:cNvPr>
@@ -6143,7 +6463,7 @@
                 <a:ea typeface="Arial"/>
                 <a:cs typeface="Arial"/>
               </a:rPr>
-              <a:t>Practice answers</a:t>
+              <a:t>Decode answers</a:t>
             </a:r>
           </a:p>
         </p:txBody>
@@ -6153,7 +6473,7 @@
           <p:cNvPr id="3" name="">
             <a:extLst xmlns:a="http://schemas.openxmlformats.org/drawingml/2006/main">
               <a:ext uri="{FF2B5EF4-FFF2-40B4-BE49-F238E27FC236}">
-                <a16:creationId xmlns:a16="http://schemas.microsoft.com/office/drawing/2014/main" id="{53BB6D32-B5C1-4BFB-8D41-7B7055B1A606}"/>
+                <a16:creationId xmlns:a16="http://schemas.microsoft.com/office/drawing/2014/main" id="{26F3E9C7-6AC5-4E40-B664-B323C1BA5CEA}"/>
               </a:ext>
             </a:extLst>
           </p:cNvPr>
@@ -6201,36 +6521,7 @@
                 <a:ea typeface="Arial"/>
                 <a:cs typeface="Arial"/>
               </a:rPr>
-              <a:t>3/2 = 1.100₂ × 2⁰, so it is normal.</a:t>
-            </a:r>
-          </a:p>
-          <a:p xmlns:a="http://schemas.openxmlformats.org/drawingml/2006/main">
-            <a:r>
-              <a:t/>
-            </a:r>
-          </a:p>
-          <a:p xmlns:a="http://schemas.openxmlformats.org/drawingml/2006/main">
-            <a:pPr>
-              <a:buNone/>
-              <a:defRPr sz="1950" b="0">
-                <a:solidFill>
-                  <a:srgbClr val="D4D4D8"/>
-                </a:solidFill>
-                <a:latin typeface="Arial"/>
-                <a:ea typeface="Arial"/>
-                <a:cs typeface="Arial"/>
-              </a:defRPr>
-            </a:pPr>
-            <a:r>
-              <a:rPr sz="1950" b="0">
-                <a:solidFill>
-                  <a:srgbClr val="D4D4D8"/>
-                </a:solidFill>
-                <a:latin typeface="Arial"/>
-                <a:ea typeface="Arial"/>
-                <a:cs typeface="Arial"/>
-              </a:rPr>
-              <a:t>3/16 is below 1/4, so it is subnormal. Since value = F/32, F = 6.</a:t>
+              <a:t>A has E = 2, so decode a normal value. B has E = 0, so its F = 3 means three steps of 1/32.</a:t>
             </a:r>
           </a:p>
         </p:txBody>
@@ -6240,7 +6531,7 @@
           <p:cNvPr id="4" name="">
             <a:extLst xmlns:a="http://schemas.openxmlformats.org/drawingml/2006/main">
               <a:ext uri="{FF2B5EF4-FFF2-40B4-BE49-F238E27FC236}">
-                <a16:creationId xmlns:a16="http://schemas.microsoft.com/office/drawing/2014/main" id="{CD85FA7D-EF72-4F2A-85B4-517634BC5BE7}"/>
+                <a16:creationId xmlns:a16="http://schemas.microsoft.com/office/drawing/2014/main" id="{737C1F1B-87F6-43C2-BCA8-B1C729031D72}"/>
               </a:ext>
             </a:extLst>
           </p:cNvPr>
@@ -6288,7 +6579,7 @@
                 <a:ea typeface="Courier New"/>
                 <a:cs typeface="Courier New"/>
               </a:rPr>
-              <a:t>A. 3/2</a:t>
+              <a:t>A. 0 | 010 | 100</a:t>
             </a:r>
           </a:p>
           <a:p xmlns:a="http://schemas.openxmlformats.org/drawingml/2006/main">
@@ -6312,7 +6603,12 @@
                 <a:ea typeface="Courier New"/>
                 <a:cs typeface="Courier New"/>
               </a:rPr>
-              <a:t>   E = 3 = 011₂</a:t>
+              <a:t>   (1 + 4/8) × 2⁻¹ = 3/4</a:t>
+            </a:r>
+          </a:p>
+          <a:p xmlns:a="http://schemas.openxmlformats.org/drawingml/2006/main">
+            <a:r>
+              <a:t/>
             </a:r>
           </a:p>
           <a:p xmlns:a="http://schemas.openxmlformats.org/drawingml/2006/main">
@@ -6336,7 +6632,7 @@
                 <a:ea typeface="Courier New"/>
                 <a:cs typeface="Courier New"/>
               </a:rPr>
-              <a:t>   F = 4 = 100₂</a:t>
+              <a:t>B. 0 | 000 | 011</a:t>
             </a:r>
           </a:p>
           <a:p xmlns:a="http://schemas.openxmlformats.org/drawingml/2006/main">
@@ -6360,108 +6656,7 @@
                 <a:ea typeface="Courier New"/>
                 <a:cs typeface="Courier New"/>
               </a:rPr>
-              <a:t>   Check: (1 + 4/8) × 1 = 3/2</a:t>
-            </a:r>
-          </a:p>
-          <a:p xmlns:a="http://schemas.openxmlformats.org/drawingml/2006/main">
-            <a:r>
-              <a:t/>
-            </a:r>
-          </a:p>
-          <a:p xmlns:a="http://schemas.openxmlformats.org/drawingml/2006/main">
-            <a:pPr>
-              <a:buNone/>
-              <a:defRPr sz="1650" b="0">
-                <a:solidFill>
-                  <a:srgbClr val="A7F3D0"/>
-                </a:solidFill>
-                <a:latin typeface="Courier New"/>
-                <a:ea typeface="Courier New"/>
-                <a:cs typeface="Courier New"/>
-              </a:defRPr>
-            </a:pPr>
-            <a:r>
-              <a:rPr sz="1650" b="0">
-                <a:solidFill>
-                  <a:srgbClr val="A7F3D0"/>
-                </a:solidFill>
-                <a:latin typeface="Courier New"/>
-                <a:ea typeface="Courier New"/>
-                <a:cs typeface="Courier New"/>
-              </a:rPr>
-              <a:t>B. 3/16</a:t>
-            </a:r>
-          </a:p>
-          <a:p xmlns:a="http://schemas.openxmlformats.org/drawingml/2006/main">
-            <a:pPr>
-              <a:buNone/>
-              <a:defRPr sz="1650" b="0">
-                <a:solidFill>
-                  <a:srgbClr val="A7F3D0"/>
-                </a:solidFill>
-                <a:latin typeface="Courier New"/>
-                <a:ea typeface="Courier New"/>
-                <a:cs typeface="Courier New"/>
-              </a:defRPr>
-            </a:pPr>
-            <a:r>
-              <a:rPr sz="1650" b="0">
-                <a:solidFill>
-                  <a:srgbClr val="A7F3D0"/>
-                </a:solidFill>
-                <a:latin typeface="Courier New"/>
-                <a:ea typeface="Courier New"/>
-                <a:cs typeface="Courier New"/>
-              </a:rPr>
-              <a:t>   E = 0 = 000₂</a:t>
-            </a:r>
-          </a:p>
-          <a:p xmlns:a="http://schemas.openxmlformats.org/drawingml/2006/main">
-            <a:pPr>
-              <a:buNone/>
-              <a:defRPr sz="1650" b="0">
-                <a:solidFill>
-                  <a:srgbClr val="A7F3D0"/>
-                </a:solidFill>
-                <a:latin typeface="Courier New"/>
-                <a:ea typeface="Courier New"/>
-                <a:cs typeface="Courier New"/>
-              </a:defRPr>
-            </a:pPr>
-            <a:r>
-              <a:rPr sz="1650" b="0">
-                <a:solidFill>
-                  <a:srgbClr val="A7F3D0"/>
-                </a:solidFill>
-                <a:latin typeface="Courier New"/>
-                <a:ea typeface="Courier New"/>
-                <a:cs typeface="Courier New"/>
-              </a:rPr>
-              <a:t>   F = 6 = 110₂</a:t>
-            </a:r>
-          </a:p>
-          <a:p xmlns:a="http://schemas.openxmlformats.org/drawingml/2006/main">
-            <a:pPr>
-              <a:buNone/>
-              <a:defRPr sz="1650" b="0">
-                <a:solidFill>
-                  <a:srgbClr val="A7F3D0"/>
-                </a:solidFill>
-                <a:latin typeface="Courier New"/>
-                <a:ea typeface="Courier New"/>
-                <a:cs typeface="Courier New"/>
-              </a:defRPr>
-            </a:pPr>
-            <a:r>
-              <a:rPr sz="1650" b="0">
-                <a:solidFill>
-                  <a:srgbClr val="A7F3D0"/>
-                </a:solidFill>
-                <a:latin typeface="Courier New"/>
-                <a:ea typeface="Courier New"/>
-                <a:cs typeface="Courier New"/>
-              </a:rPr>
-              <a:t>   Check: 6/32 = 3/16</a:t>
+              <a:t>   F = 3  →  3/32</a:t>
             </a:r>
           </a:p>
         </p:txBody>
@@ -6471,7 +6666,7 @@
           <p:cNvPr id="5" name="">
             <a:extLst xmlns:a="http://schemas.openxmlformats.org/drawingml/2006/main">
               <a:ext uri="{FF2B5EF4-FFF2-40B4-BE49-F238E27FC236}">
-                <a16:creationId xmlns:a16="http://schemas.microsoft.com/office/drawing/2014/main" id="{09DD94A5-8CF6-4CC6-9FAF-1AAE9F86C651}"/>
+                <a16:creationId xmlns:a16="http://schemas.microsoft.com/office/drawing/2014/main" id="{9DAD2664-9B32-4402-A088-C1DEBD68E3CD}"/>
               </a:ext>
             </a:extLst>
           </p:cNvPr>
@@ -6519,7 +6714,7 @@
                 <a:ea typeface="Arial"/>
                 <a:cs typeface="Arial"/>
               </a:rPr>
-              <a:t>A fraction can be exactly representable in one format and not another.</a:t>
+              <a:t>If the answer seems surprising, decode the same fields back into the formula.</a:t>
             </a:r>
           </a:p>
         </p:txBody>
@@ -6529,7 +6724,7 @@
           <p:cNvPr id="6" name="">
             <a:extLst xmlns:a="http://schemas.openxmlformats.org/drawingml/2006/main">
               <a:ext uri="{FF2B5EF4-FFF2-40B4-BE49-F238E27FC236}">
-                <a16:creationId xmlns:a16="http://schemas.microsoft.com/office/drawing/2014/main" id="{BEB8226B-AC16-4616-9E79-3B5C231B3962}"/>
+                <a16:creationId xmlns:a16="http://schemas.microsoft.com/office/drawing/2014/main" id="{DBE61FAB-FD81-4893-85F8-90700B31187C}"/>
               </a:ext>
             </a:extLst>
           </p:cNvPr>
@@ -6577,7 +6772,7 @@
                 <a:ea typeface="Courier New"/>
                 <a:cs typeface="Courier New"/>
               </a:rPr>
-              <a:t>16 / 22</a:t>
+              <a:t>16 / 24</a:t>
             </a:r>
           </a:p>
         </p:txBody>
@@ -6585,7 +6780,7 @@
     </p:spTree>
     <p:extLst>
       <p:ext uri="{BB962C8B-B14F-4D97-AF65-F5344CB8AC3E}">
-        <p14:creationId xmlns:p14="http://schemas.microsoft.com/office/powerpoint/2010/main" val="1590754296"/>
+        <p14:creationId xmlns:p14="http://schemas.microsoft.com/office/powerpoint/2010/main" val="1502731382"/>
       </p:ext>
     </p:extLst>
   </p:cSld>
@@ -6616,7 +6811,7 @@
           <p:cNvPr id="7" name="">
             <a:extLst xmlns:a="http://schemas.openxmlformats.org/drawingml/2006/main">
               <a:ext uri="{FF2B5EF4-FFF2-40B4-BE49-F238E27FC236}">
-                <a16:creationId xmlns:a16="http://schemas.microsoft.com/office/drawing/2014/main" id="{93E43C1D-677A-4484-B42E-435337BCED51}"/>
+                <a16:creationId xmlns:a16="http://schemas.microsoft.com/office/drawing/2014/main" id="{35A724E8-02D1-4C78-A9D3-AE6AD6E2D594}"/>
               </a:ext>
             </a:extLst>
           </p:cNvPr>
@@ -6664,7 +6859,7 @@
                 <a:ea typeface="Courier New"/>
                 <a:cs typeface="Courier New"/>
               </a:rPr>
-              <a:t>FLOATING POINT · PRECISION</a:t>
+              <a:t>FLOATING POINT · PRACTICE</a:t>
             </a:r>
           </a:p>
         </p:txBody>
@@ -6674,7 +6869,7 @@
           <p:cNvPr id="2" name="">
             <a:extLst xmlns:a="http://schemas.openxmlformats.org/drawingml/2006/main">
               <a:ext uri="{FF2B5EF4-FFF2-40B4-BE49-F238E27FC236}">
-                <a16:creationId xmlns:a16="http://schemas.microsoft.com/office/drawing/2014/main" id="{074B736B-6CBC-48AB-BB9C-B94B56E89F35}"/>
+                <a16:creationId xmlns:a16="http://schemas.microsoft.com/office/drawing/2014/main" id="{D68140D5-AD40-4B2D-9276-45B94835A98B}"/>
               </a:ext>
             </a:extLst>
           </p:cNvPr>
@@ -6722,7 +6917,7 @@
                 <a:ea typeface="Arial"/>
                 <a:cs typeface="Arial"/>
               </a:rPr>
-              <a:t>Some ratios need rounding</a:t>
+              <a:t>Your turn: classify two ratios</a:t>
             </a:r>
           </a:p>
         </p:txBody>
@@ -6732,7 +6927,7 @@
           <p:cNvPr id="3" name="">
             <a:extLst xmlns:a="http://schemas.openxmlformats.org/drawingml/2006/main">
               <a:ext uri="{FF2B5EF4-FFF2-40B4-BE49-F238E27FC236}">
-                <a16:creationId xmlns:a16="http://schemas.microsoft.com/office/drawing/2014/main" id="{31BF5015-85C0-4422-9A8D-3AB1598AB1B5}"/>
+                <a16:creationId xmlns:a16="http://schemas.microsoft.com/office/drawing/2014/main" id="{AA9609DC-0513-451F-B1A4-CD75618D8A9F}"/>
               </a:ext>
             </a:extLst>
           </p:cNvPr>
@@ -6780,7 +6975,7 @@
                 <a:ea typeface="Arial"/>
                 <a:cs typeface="Arial"/>
               </a:rPr>
-              <a:t>Only eight fraction patterns fit in three bits. A ratio such as 1/3 has a repeating binary expansion and cannot be stored exactly.</a:t>
+              <a:t>Use the same practice format: 3 exponent bits, bias 3, and 3 fraction bits.</a:t>
             </a:r>
           </a:p>
           <a:p xmlns:a="http://schemas.openxmlformats.org/drawingml/2006/main">
@@ -6809,7 +7004,7 @@
                 <a:ea typeface="Arial"/>
                 <a:cs typeface="Arial"/>
               </a:rPr>
-              <a:t>The required rounding rule decides which nearby value to store.</a:t>
+              <a:t>For each ratio, decide normal or subnormal, then find E and F.</a:t>
             </a:r>
           </a:p>
         </p:txBody>
@@ -6819,7 +7014,7 @@
           <p:cNvPr id="4" name="">
             <a:extLst xmlns:a="http://schemas.openxmlformats.org/drawingml/2006/main">
               <a:ext uri="{FF2B5EF4-FFF2-40B4-BE49-F238E27FC236}">
-                <a16:creationId xmlns:a16="http://schemas.microsoft.com/office/drawing/2014/main" id="{442E6650-2F07-46E8-968E-92CAC81BA173}"/>
+                <a16:creationId xmlns:a16="http://schemas.microsoft.com/office/drawing/2014/main" id="{37A2E272-B675-4F8B-8D9A-1DD0C7D3E885}"/>
               </a:ext>
             </a:extLst>
           </p:cNvPr>
@@ -6867,7 +7062,55 @@
                 <a:ea typeface="Courier New"/>
                 <a:cs typeface="Courier New"/>
               </a:rPr>
-              <a:t>1/3 = 1.010101…₂ × 2⁻²</a:t>
+              <a:t>A. 3/2</a:t>
+            </a:r>
+          </a:p>
+          <a:p xmlns:a="http://schemas.openxmlformats.org/drawingml/2006/main">
+            <a:pPr>
+              <a:buNone/>
+              <a:defRPr sz="1650" b="0">
+                <a:solidFill>
+                  <a:srgbClr val="A7F3D0"/>
+                </a:solidFill>
+                <a:latin typeface="Courier New"/>
+                <a:ea typeface="Courier New"/>
+                <a:cs typeface="Courier New"/>
+              </a:defRPr>
+            </a:pPr>
+            <a:r>
+              <a:rPr sz="1650" b="0">
+                <a:solidFill>
+                  <a:srgbClr val="A7F3D0"/>
+                </a:solidFill>
+                <a:latin typeface="Courier New"/>
+                <a:ea typeface="Courier New"/>
+                <a:cs typeface="Courier New"/>
+              </a:rPr>
+              <a:t>   normal or subnormal?</a:t>
+            </a:r>
+          </a:p>
+          <a:p xmlns:a="http://schemas.openxmlformats.org/drawingml/2006/main">
+            <a:pPr>
+              <a:buNone/>
+              <a:defRPr sz="1650" b="0">
+                <a:solidFill>
+                  <a:srgbClr val="A7F3D0"/>
+                </a:solidFill>
+                <a:latin typeface="Courier New"/>
+                <a:ea typeface="Courier New"/>
+                <a:cs typeface="Courier New"/>
+              </a:defRPr>
+            </a:pPr>
+            <a:r>
+              <a:rPr sz="1650" b="0">
+                <a:solidFill>
+                  <a:srgbClr val="A7F3D0"/>
+                </a:solidFill>
+                <a:latin typeface="Courier New"/>
+                <a:ea typeface="Courier New"/>
+                <a:cs typeface="Courier New"/>
+              </a:rPr>
+              <a:t>   E = ?   F = ?</a:t>
             </a:r>
           </a:p>
           <a:p xmlns:a="http://schemas.openxmlformats.org/drawingml/2006/main">
@@ -6896,7 +7139,7 @@
                 <a:ea typeface="Courier New"/>
                 <a:cs typeface="Courier New"/>
               </a:rPr>
-              <a:t>Nearby values in this format:</a:t>
+              <a:t>B. 3/16</a:t>
             </a:r>
           </a:p>
           <a:p xmlns:a="http://schemas.openxmlformats.org/drawingml/2006/main">
@@ -6920,7 +7163,7 @@
                 <a:ea typeface="Courier New"/>
                 <a:cs typeface="Courier New"/>
               </a:rPr>
-              <a:t>F = 010₂  →  5/16</a:t>
+              <a:t>   normal or subnormal?</a:t>
             </a:r>
           </a:p>
           <a:p xmlns:a="http://schemas.openxmlformats.org/drawingml/2006/main">
@@ -6944,36 +7187,7 @@
                 <a:ea typeface="Courier New"/>
                 <a:cs typeface="Courier New"/>
               </a:rPr>
-              <a:t>F = 011₂  →  11/32</a:t>
-            </a:r>
-          </a:p>
-          <a:p xmlns:a="http://schemas.openxmlformats.org/drawingml/2006/main">
-            <a:r>
-              <a:t/>
-            </a:r>
-          </a:p>
-          <a:p xmlns:a="http://schemas.openxmlformats.org/drawingml/2006/main">
-            <a:pPr>
-              <a:buNone/>
-              <a:defRPr sz="1650" b="0">
-                <a:solidFill>
-                  <a:srgbClr val="A7F3D0"/>
-                </a:solidFill>
-                <a:latin typeface="Courier New"/>
-                <a:ea typeface="Courier New"/>
-                <a:cs typeface="Courier New"/>
-              </a:defRPr>
-            </a:pPr>
-            <a:r>
-              <a:rPr sz="1650" b="0">
-                <a:solidFill>
-                  <a:srgbClr val="A7F3D0"/>
-                </a:solidFill>
-                <a:latin typeface="Courier New"/>
-                <a:ea typeface="Courier New"/>
-                <a:cs typeface="Courier New"/>
-              </a:rPr>
-              <a:t>Neither is exactly 1/3.</a:t>
+              <a:t>   E = ?   F = ?</a:t>
             </a:r>
           </a:p>
         </p:txBody>
@@ -6983,7 +7197,7 @@
           <p:cNvPr id="5" name="">
             <a:extLst xmlns:a="http://schemas.openxmlformats.org/drawingml/2006/main">
               <a:ext uri="{FF2B5EF4-FFF2-40B4-BE49-F238E27FC236}">
-                <a16:creationId xmlns:a16="http://schemas.microsoft.com/office/drawing/2014/main" id="{7550F9BB-98E4-470C-A339-F30A270C656C}"/>
+                <a16:creationId xmlns:a16="http://schemas.microsoft.com/office/drawing/2014/main" id="{8F900304-F8E7-4C1C-B3A0-F1A0DD604211}"/>
               </a:ext>
             </a:extLst>
           </p:cNvPr>
@@ -7031,7 +7245,7 @@
                 <a:ea typeface="Arial"/>
                 <a:cs typeface="Arial"/>
               </a:rPr>
-              <a:t>Wait for the assignment’s rounding instructions before choosing a stored result.</a:t>
+              <a:t>Compare each value with the smallest normal, 1/4, before finding bits.</a:t>
             </a:r>
           </a:p>
         </p:txBody>
@@ -7041,7 +7255,7 @@
           <p:cNvPr id="6" name="">
             <a:extLst xmlns:a="http://schemas.openxmlformats.org/drawingml/2006/main">
               <a:ext uri="{FF2B5EF4-FFF2-40B4-BE49-F238E27FC236}">
-                <a16:creationId xmlns:a16="http://schemas.microsoft.com/office/drawing/2014/main" id="{73B702C8-3DF9-406E-8087-CF675ECCC2D1}"/>
+                <a16:creationId xmlns:a16="http://schemas.microsoft.com/office/drawing/2014/main" id="{16200DCD-0F16-4BE6-9538-9FDAF86C958E}"/>
               </a:ext>
             </a:extLst>
           </p:cNvPr>
@@ -7089,7 +7303,7 @@
                 <a:ea typeface="Courier New"/>
                 <a:cs typeface="Courier New"/>
               </a:rPr>
-              <a:t>17 / 22</a:t>
+              <a:t>17 / 24</a:t>
             </a:r>
           </a:p>
         </p:txBody>
@@ -7097,7 +7311,7 @@
     </p:spTree>
     <p:extLst>
       <p:ext uri="{BB962C8B-B14F-4D97-AF65-F5344CB8AC3E}">
-        <p14:creationId xmlns:p14="http://schemas.microsoft.com/office/powerpoint/2010/main" val="1704851840"/>
+        <p14:creationId xmlns:p14="http://schemas.microsoft.com/office/powerpoint/2010/main" val="2079659254"/>
       </p:ext>
     </p:extLst>
   </p:cSld>
@@ -7128,7 +7342,7 @@
           <p:cNvPr id="7" name="">
             <a:extLst xmlns:a="http://schemas.openxmlformats.org/drawingml/2006/main">
               <a:ext uri="{FF2B5EF4-FFF2-40B4-BE49-F238E27FC236}">
-                <a16:creationId xmlns:a16="http://schemas.microsoft.com/office/drawing/2014/main" id="{0BCE7827-648B-4B62-AE80-F3CE9BFFD594}"/>
+                <a16:creationId xmlns:a16="http://schemas.microsoft.com/office/drawing/2014/main" id="{D25A2A70-779E-4A39-9AD5-537DDE3C5B7A}"/>
               </a:ext>
             </a:extLst>
           </p:cNvPr>
@@ -7176,7 +7390,7 @@
                 <a:ea typeface="Courier New"/>
                 <a:cs typeface="Courier New"/>
               </a:rPr>
-              <a:t>FLOATING POINT · SPACING</a:t>
+              <a:t>FLOATING POINT · CHECK</a:t>
             </a:r>
           </a:p>
         </p:txBody>
@@ -7186,7 +7400,7 @@
           <p:cNvPr id="2" name="">
             <a:extLst xmlns:a="http://schemas.openxmlformats.org/drawingml/2006/main">
               <a:ext uri="{FF2B5EF4-FFF2-40B4-BE49-F238E27FC236}">
-                <a16:creationId xmlns:a16="http://schemas.microsoft.com/office/drawing/2014/main" id="{E6B69FE5-5D95-4306-AAF0-9A70AD531613}"/>
+                <a16:creationId xmlns:a16="http://schemas.microsoft.com/office/drawing/2014/main" id="{2F2733A3-E106-4C90-B097-BE7CB4577892}"/>
               </a:ext>
             </a:extLst>
           </p:cNvPr>
@@ -7234,7 +7448,7 @@
                 <a:ea typeface="Arial"/>
                 <a:cs typeface="Arial"/>
               </a:rPr>
-              <a:t>Precision changes with scale</a:t>
+              <a:t>Practice answers</a:t>
             </a:r>
           </a:p>
         </p:txBody>
@@ -7244,7 +7458,7 @@
           <p:cNvPr id="3" name="">
             <a:extLst xmlns:a="http://schemas.openxmlformats.org/drawingml/2006/main">
               <a:ext uri="{FF2B5EF4-FFF2-40B4-BE49-F238E27FC236}">
-                <a16:creationId xmlns:a16="http://schemas.microsoft.com/office/drawing/2014/main" id="{887FE9A9-E5DE-4BC1-94AD-59371BF9B78C}"/>
+                <a16:creationId xmlns:a16="http://schemas.microsoft.com/office/drawing/2014/main" id="{53BB6D32-B5C1-4BFB-8D41-7B7055B1A606}"/>
               </a:ext>
             </a:extLst>
           </p:cNvPr>
@@ -7292,7 +7506,7 @@
                 <a:ea typeface="Arial"/>
                 <a:cs typeface="Arial"/>
               </a:rPr>
-              <a:t>The same three fraction bits give eight values within each normal exponent range.</a:t>
+              <a:t>3/2 = 1.100₂ × 2⁰, so it is normal.</a:t>
             </a:r>
           </a:p>
           <a:p xmlns:a="http://schemas.openxmlformats.org/drawingml/2006/main">
@@ -7321,7 +7535,7 @@
                 <a:ea typeface="Arial"/>
                 <a:cs typeface="Arial"/>
               </a:rPr>
-              <a:t>When the exponent increases by one, the distance between neighboring values doubles.</a:t>
+              <a:t>3/16 is below 1/4, so it is subnormal. Since value = F/32, F = 6.</a:t>
             </a:r>
           </a:p>
         </p:txBody>
@@ -7331,7 +7545,7 @@
           <p:cNvPr id="4" name="">
             <a:extLst xmlns:a="http://schemas.openxmlformats.org/drawingml/2006/main">
               <a:ext uri="{FF2B5EF4-FFF2-40B4-BE49-F238E27FC236}">
-                <a16:creationId xmlns:a16="http://schemas.microsoft.com/office/drawing/2014/main" id="{CED75AEC-85E3-4520-B63E-09FCF9AACAE6}"/>
+                <a16:creationId xmlns:a16="http://schemas.microsoft.com/office/drawing/2014/main" id="{CD85FA7D-EF72-4F2A-85B4-517634BC5BE7}"/>
               </a:ext>
             </a:extLst>
           </p:cNvPr>
@@ -7379,7 +7593,7 @@
                 <a:ea typeface="Courier New"/>
                 <a:cs typeface="Courier New"/>
               </a:rPr>
-              <a:t>E = 3 (e = 0)</a:t>
+              <a:t>A. 3/2</a:t>
             </a:r>
           </a:p>
           <a:p xmlns:a="http://schemas.openxmlformats.org/drawingml/2006/main">
@@ -7403,7 +7617,7 @@
                 <a:ea typeface="Courier New"/>
                 <a:cs typeface="Courier New"/>
               </a:rPr>
-              <a:t>F = 0 → 1       F = 1 → 9/8</a:t>
+              <a:t>   E = 3 = 011₂</a:t>
             </a:r>
           </a:p>
           <a:p xmlns:a="http://schemas.openxmlformats.org/drawingml/2006/main">
@@ -7427,7 +7641,31 @@
                 <a:ea typeface="Courier New"/>
                 <a:cs typeface="Courier New"/>
               </a:rPr>
-              <a:t>step = 1/8</a:t>
+              <a:t>   F = 4 = 100₂</a:t>
+            </a:r>
+          </a:p>
+          <a:p xmlns:a="http://schemas.openxmlformats.org/drawingml/2006/main">
+            <a:pPr>
+              <a:buNone/>
+              <a:defRPr sz="1650" b="0">
+                <a:solidFill>
+                  <a:srgbClr val="A7F3D0"/>
+                </a:solidFill>
+                <a:latin typeface="Courier New"/>
+                <a:ea typeface="Courier New"/>
+                <a:cs typeface="Courier New"/>
+              </a:defRPr>
+            </a:pPr>
+            <a:r>
+              <a:rPr sz="1650" b="0">
+                <a:solidFill>
+                  <a:srgbClr val="A7F3D0"/>
+                </a:solidFill>
+                <a:latin typeface="Courier New"/>
+                <a:ea typeface="Courier New"/>
+                <a:cs typeface="Courier New"/>
+              </a:rPr>
+              <a:t>   Check: (1 + 4/8) × 1 = 3/2</a:t>
             </a:r>
           </a:p>
           <a:p xmlns:a="http://schemas.openxmlformats.org/drawingml/2006/main">
@@ -7456,7 +7694,7 @@
                 <a:ea typeface="Courier New"/>
                 <a:cs typeface="Courier New"/>
               </a:rPr>
-              <a:t>E = 4 (e = 1)</a:t>
+              <a:t>B. 3/16</a:t>
             </a:r>
           </a:p>
           <a:p xmlns:a="http://schemas.openxmlformats.org/drawingml/2006/main">
@@ -7480,7 +7718,7 @@
                 <a:ea typeface="Courier New"/>
                 <a:cs typeface="Courier New"/>
               </a:rPr>
-              <a:t>F = 0 → 2       F = 1 → 9/4</a:t>
+              <a:t>   E = 0 = 000₂</a:t>
             </a:r>
           </a:p>
           <a:p xmlns:a="http://schemas.openxmlformats.org/drawingml/2006/main">
@@ -7504,7 +7742,31 @@
                 <a:ea typeface="Courier New"/>
                 <a:cs typeface="Courier New"/>
               </a:rPr>
-              <a:t>step = 1/4</a:t>
+              <a:t>   F = 6 = 110₂</a:t>
+            </a:r>
+          </a:p>
+          <a:p xmlns:a="http://schemas.openxmlformats.org/drawingml/2006/main">
+            <a:pPr>
+              <a:buNone/>
+              <a:defRPr sz="1650" b="0">
+                <a:solidFill>
+                  <a:srgbClr val="A7F3D0"/>
+                </a:solidFill>
+                <a:latin typeface="Courier New"/>
+                <a:ea typeface="Courier New"/>
+                <a:cs typeface="Courier New"/>
+              </a:defRPr>
+            </a:pPr>
+            <a:r>
+              <a:rPr sz="1650" b="0">
+                <a:solidFill>
+                  <a:srgbClr val="A7F3D0"/>
+                </a:solidFill>
+                <a:latin typeface="Courier New"/>
+                <a:ea typeface="Courier New"/>
+                <a:cs typeface="Courier New"/>
+              </a:rPr>
+              <a:t>   Check: 6/32 = 3/16</a:t>
             </a:r>
           </a:p>
         </p:txBody>
@@ -7514,7 +7776,7 @@
           <p:cNvPr id="5" name="">
             <a:extLst xmlns:a="http://schemas.openxmlformats.org/drawingml/2006/main">
               <a:ext uri="{FF2B5EF4-FFF2-40B4-BE49-F238E27FC236}">
-                <a16:creationId xmlns:a16="http://schemas.microsoft.com/office/drawing/2014/main" id="{7A18BC8F-2DC5-4B6B-A4F9-10CDE1183DE6}"/>
+                <a16:creationId xmlns:a16="http://schemas.microsoft.com/office/drawing/2014/main" id="{09DD94A5-8CF6-4CC6-9FAF-1AAE9F86C651}"/>
               </a:ext>
             </a:extLst>
           </p:cNvPr>
@@ -7562,7 +7824,7 @@
                 <a:ea typeface="Arial"/>
                 <a:cs typeface="Arial"/>
               </a:rPr>
-              <a:t>This is why large floating point values have larger gaps.</a:t>
+              <a:t>A fraction can be exactly representable in one format and not another.</a:t>
             </a:r>
           </a:p>
         </p:txBody>
@@ -7572,7 +7834,7 @@
           <p:cNvPr id="6" name="">
             <a:extLst xmlns:a="http://schemas.openxmlformats.org/drawingml/2006/main">
               <a:ext uri="{FF2B5EF4-FFF2-40B4-BE49-F238E27FC236}">
-                <a16:creationId xmlns:a16="http://schemas.microsoft.com/office/drawing/2014/main" id="{94269C50-3A0A-4FBB-A1D2-A33411F72ECA}"/>
+                <a16:creationId xmlns:a16="http://schemas.microsoft.com/office/drawing/2014/main" id="{BEB8226B-AC16-4616-9E79-3B5C231B3962}"/>
               </a:ext>
             </a:extLst>
           </p:cNvPr>
@@ -7620,7 +7882,7 @@
                 <a:ea typeface="Courier New"/>
                 <a:cs typeface="Courier New"/>
               </a:rPr>
-              <a:t>18 / 22</a:t>
+              <a:t>18 / 24</a:t>
             </a:r>
           </a:p>
         </p:txBody>
@@ -7628,7 +7890,7 @@
     </p:spTree>
     <p:extLst>
       <p:ext uri="{BB962C8B-B14F-4D97-AF65-F5344CB8AC3E}">
-        <p14:creationId xmlns:p14="http://schemas.microsoft.com/office/powerpoint/2010/main" val="1018474765"/>
+        <p14:creationId xmlns:p14="http://schemas.microsoft.com/office/powerpoint/2010/main" val="1590754296"/>
       </p:ext>
     </p:extLst>
   </p:cSld>
@@ -7659,7 +7921,7 @@
           <p:cNvPr id="7" name="">
             <a:extLst xmlns:a="http://schemas.openxmlformats.org/drawingml/2006/main">
               <a:ext uri="{FF2B5EF4-FFF2-40B4-BE49-F238E27FC236}">
-                <a16:creationId xmlns:a16="http://schemas.microsoft.com/office/drawing/2014/main" id="{0BCE7827-648B-4B62-AE80-F3CE9BFFD594}"/>
+                <a16:creationId xmlns:a16="http://schemas.microsoft.com/office/drawing/2014/main" id="{93E43C1D-677A-4484-B42E-435337BCED51}"/>
               </a:ext>
             </a:extLst>
           </p:cNvPr>
@@ -7707,7 +7969,7 @@
                 <a:ea typeface="Courier New"/>
                 <a:cs typeface="Courier New"/>
               </a:rPr>
-              <a:t>FLOATING POINT · ASSIGNMENT PREVIEW</a:t>
+              <a:t>FLOATING POINT · PRECISION</a:t>
             </a:r>
           </a:p>
         </p:txBody>
@@ -7717,7 +7979,7 @@
           <p:cNvPr id="2" name="">
             <a:extLst xmlns:a="http://schemas.openxmlformats.org/drawingml/2006/main">
               <a:ext uri="{FF2B5EF4-FFF2-40B4-BE49-F238E27FC236}">
-                <a16:creationId xmlns:a16="http://schemas.microsoft.com/office/drawing/2014/main" id="{E6B69FE5-5D95-4306-AAF0-9A70AD531613}"/>
+                <a16:creationId xmlns:a16="http://schemas.microsoft.com/office/drawing/2014/main" id="{074B736B-6CBC-48AB-BB9C-B94B56E89F35}"/>
               </a:ext>
             </a:extLst>
           </p:cNvPr>
@@ -7765,7 +8027,7 @@
                 <a:ea typeface="Arial"/>
                 <a:cs typeface="Arial"/>
               </a:rPr>
-              <a:t>HW3 preview: five inputs</a:t>
+              <a:t>Some ratios need rounding</a:t>
             </a:r>
           </a:p>
         </p:txBody>
@@ -7775,7 +8037,7 @@
           <p:cNvPr id="3" name="">
             <a:extLst xmlns:a="http://schemas.openxmlformats.org/drawingml/2006/main">
               <a:ext uri="{FF2B5EF4-FFF2-40B4-BE49-F238E27FC236}">
-                <a16:creationId xmlns:a16="http://schemas.microsoft.com/office/drawing/2014/main" id="{887FE9A9-E5DE-4BC1-94AD-59371BF9B78C}"/>
+                <a16:creationId xmlns:a16="http://schemas.microsoft.com/office/drawing/2014/main" id="{31BF5015-85C0-4422-9A8D-3AB1598AB1B5}"/>
               </a:ext>
             </a:extLst>
           </p:cNvPr>
@@ -7823,7 +8085,36 @@
                 <a:ea typeface="Arial"/>
                 <a:cs typeface="Arial"/>
               </a:rPr>
-              <a:t>The professor plans a program that reads a format and a nonnegative ratio. The assignment has not been posted, so treat these details as a preview.</a:t>
+              <a:t>Only eight fraction patterns fit in three bits. A ratio such as 1/3 has a repeating binary expansion and cannot be stored exactly.</a:t>
+            </a:r>
+          </a:p>
+          <a:p xmlns:a="http://schemas.openxmlformats.org/drawingml/2006/main">
+            <a:r>
+              <a:t/>
+            </a:r>
+          </a:p>
+          <a:p xmlns:a="http://schemas.openxmlformats.org/drawingml/2006/main">
+            <a:pPr>
+              <a:buNone/>
+              <a:defRPr sz="1950" b="0">
+                <a:solidFill>
+                  <a:srgbClr val="D4D4D8"/>
+                </a:solidFill>
+                <a:latin typeface="Arial"/>
+                <a:ea typeface="Arial"/>
+                <a:cs typeface="Arial"/>
+              </a:defRPr>
+            </a:pPr>
+            <a:r>
+              <a:rPr sz="1950" b="0">
+                <a:solidFill>
+                  <a:srgbClr val="D4D4D8"/>
+                </a:solidFill>
+                <a:latin typeface="Arial"/>
+                <a:ea typeface="Arial"/>
+                <a:cs typeface="Arial"/>
+              </a:rPr>
+              <a:t>The required rounding rule decides which nearby value to store.</a:t>
             </a:r>
           </a:p>
         </p:txBody>
@@ -7833,7 +8124,7 @@
           <p:cNvPr id="4" name="">
             <a:extLst xmlns:a="http://schemas.openxmlformats.org/drawingml/2006/main">
               <a:ext uri="{FF2B5EF4-FFF2-40B4-BE49-F238E27FC236}">
-                <a16:creationId xmlns:a16="http://schemas.microsoft.com/office/drawing/2014/main" id="{CED75AEC-85E3-4520-B63E-09FCF9AACAE6}"/>
+                <a16:creationId xmlns:a16="http://schemas.microsoft.com/office/drawing/2014/main" id="{442E6650-2F07-46E8-968E-92CAC81BA173}"/>
               </a:ext>
             </a:extLst>
           </p:cNvPr>
@@ -7881,7 +8172,12 @@
                 <a:ea typeface="Courier New"/>
                 <a:cs typeface="Courier New"/>
               </a:rPr>
-              <a:t>format:  exp_bits = 3</a:t>
+              <a:t>1/3 = 1.010101…₂ × 2⁻²</a:t>
+            </a:r>
+          </a:p>
+          <a:p xmlns:a="http://schemas.openxmlformats.org/drawingml/2006/main">
+            <a:r>
+              <a:t/>
             </a:r>
           </a:p>
           <a:p xmlns:a="http://schemas.openxmlformats.org/drawingml/2006/main">
@@ -7905,7 +8201,7 @@
                 <a:ea typeface="Courier New"/>
                 <a:cs typeface="Courier New"/>
               </a:rPr>
-              <a:t>         bias = 3</a:t>
+              <a:t>Nearby values in this format:</a:t>
             </a:r>
           </a:p>
           <a:p xmlns:a="http://schemas.openxmlformats.org/drawingml/2006/main">
@@ -7929,7 +8225,31 @@
                 <a:ea typeface="Courier New"/>
                 <a:cs typeface="Courier New"/>
               </a:rPr>
-              <a:t>         sig_bits = 3</a:t>
+              <a:t>F = 010₂  →  5/16</a:t>
+            </a:r>
+          </a:p>
+          <a:p xmlns:a="http://schemas.openxmlformats.org/drawingml/2006/main">
+            <a:pPr>
+              <a:buNone/>
+              <a:defRPr sz="1650" b="0">
+                <a:solidFill>
+                  <a:srgbClr val="A7F3D0"/>
+                </a:solidFill>
+                <a:latin typeface="Courier New"/>
+                <a:ea typeface="Courier New"/>
+                <a:cs typeface="Courier New"/>
+              </a:defRPr>
+            </a:pPr>
+            <a:r>
+              <a:rPr sz="1650" b="0">
+                <a:solidFill>
+                  <a:srgbClr val="A7F3D0"/>
+                </a:solidFill>
+                <a:latin typeface="Courier New"/>
+                <a:ea typeface="Courier New"/>
+                <a:cs typeface="Courier New"/>
+              </a:rPr>
+              <a:t>F = 011₂  →  11/32</a:t>
             </a:r>
           </a:p>
           <a:p xmlns:a="http://schemas.openxmlformats.org/drawingml/2006/main">
@@ -7958,79 +8278,7 @@
                 <a:ea typeface="Courier New"/>
                 <a:cs typeface="Courier New"/>
               </a:rPr>
-              <a:t>value:   numerator = 5</a:t>
-            </a:r>
-          </a:p>
-          <a:p xmlns:a="http://schemas.openxmlformats.org/drawingml/2006/main">
-            <a:pPr>
-              <a:buNone/>
-              <a:defRPr sz="1650" b="0">
-                <a:solidFill>
-                  <a:srgbClr val="A7F3D0"/>
-                </a:solidFill>
-                <a:latin typeface="Courier New"/>
-                <a:ea typeface="Courier New"/>
-                <a:cs typeface="Courier New"/>
-              </a:defRPr>
-            </a:pPr>
-            <a:r>
-              <a:rPr sz="1650" b="0">
-                <a:solidFill>
-                  <a:srgbClr val="A7F3D0"/>
-                </a:solidFill>
-                <a:latin typeface="Courier New"/>
-                <a:ea typeface="Courier New"/>
-                <a:cs typeface="Courier New"/>
-              </a:rPr>
-              <a:t>         denominator = 2</a:t>
-            </a:r>
-          </a:p>
-          <a:p xmlns:a="http://schemas.openxmlformats.org/drawingml/2006/main">
-            <a:pPr>
-              <a:buNone/>
-              <a:defRPr sz="1650" b="0">
-                <a:solidFill>
-                  <a:srgbClr val="A7F3D0"/>
-                </a:solidFill>
-                <a:latin typeface="Courier New"/>
-                <a:ea typeface="Courier New"/>
-                <a:cs typeface="Courier New"/>
-              </a:defRPr>
-            </a:pPr>
-            <a:r>
-              <a:rPr sz="1650" b="0">
-                <a:solidFill>
-                  <a:srgbClr val="A7F3D0"/>
-                </a:solidFill>
-                <a:latin typeface="Courier New"/>
-                <a:ea typeface="Courier New"/>
-                <a:cs typeface="Courier New"/>
-              </a:rPr>
-              <a:t/>
-            </a:r>
-          </a:p>
-          <a:p xmlns:a="http://schemas.openxmlformats.org/drawingml/2006/main">
-            <a:pPr>
-              <a:buNone/>
-              <a:defRPr sz="1650" b="0">
-                <a:solidFill>
-                  <a:srgbClr val="A7F3D0"/>
-                </a:solidFill>
-                <a:latin typeface="Courier New"/>
-                <a:ea typeface="Courier New"/>
-                <a:cs typeface="Courier New"/>
-              </a:defRPr>
-            </a:pPr>
-            <a:r>
-              <a:rPr sz="1650" b="0">
-                <a:solidFill>
-                  <a:srgbClr val="A7F3D0"/>
-                </a:solidFill>
-                <a:latin typeface="Courier New"/>
-                <a:ea typeface="Courier New"/>
-                <a:cs typeface="Courier New"/>
-              </a:rPr>
-              <a:t>Find: E (exponent), F (fraction)</a:t>
+              <a:t>Neither is exactly 1/3.</a:t>
             </a:r>
           </a:p>
         </p:txBody>
@@ -8040,7 +8288,7 @@
           <p:cNvPr id="5" name="">
             <a:extLst xmlns:a="http://schemas.openxmlformats.org/drawingml/2006/main">
               <a:ext uri="{FF2B5EF4-FFF2-40B4-BE49-F238E27FC236}">
-                <a16:creationId xmlns:a16="http://schemas.microsoft.com/office/drawing/2014/main" id="{7A18BC8F-2DC5-4B6B-A4F9-10CDE1183DE6}"/>
+                <a16:creationId xmlns:a16="http://schemas.microsoft.com/office/drawing/2014/main" id="{7550F9BB-98E4-470C-A339-F30A270C656C}"/>
               </a:ext>
             </a:extLst>
           </p:cNvPr>
@@ -8088,7 +8336,7 @@
                 <a:ea typeface="Arial"/>
                 <a:cs typeface="Arial"/>
               </a:rPr>
-              <a:t>The first three inputs define the format; the last two define the value.</a:t>
+              <a:t>Wait for the assignment’s rounding instructions before choosing a stored result.</a:t>
             </a:r>
           </a:p>
         </p:txBody>
@@ -8098,7 +8346,7 @@
           <p:cNvPr id="6" name="">
             <a:extLst xmlns:a="http://schemas.openxmlformats.org/drawingml/2006/main">
               <a:ext uri="{FF2B5EF4-FFF2-40B4-BE49-F238E27FC236}">
-                <a16:creationId xmlns:a16="http://schemas.microsoft.com/office/drawing/2014/main" id="{94269C50-3A0A-4FBB-A1D2-A33411F72ECA}"/>
+                <a16:creationId xmlns:a16="http://schemas.microsoft.com/office/drawing/2014/main" id="{73B702C8-3DF9-406E-8087-CF675ECCC2D1}"/>
               </a:ext>
             </a:extLst>
           </p:cNvPr>
@@ -8146,7 +8394,7 @@
                 <a:ea typeface="Courier New"/>
                 <a:cs typeface="Courier New"/>
               </a:rPr>
-              <a:t>19 / 22</a:t>
+              <a:t>19 / 24</a:t>
             </a:r>
           </a:p>
         </p:txBody>
@@ -8154,7 +8402,7 @@
     </p:spTree>
     <p:extLst>
       <p:ext uri="{BB962C8B-B14F-4D97-AF65-F5344CB8AC3E}">
-        <p14:creationId xmlns:p14="http://schemas.microsoft.com/office/powerpoint/2010/main" val="1018474765"/>
+        <p14:creationId xmlns:p14="http://schemas.microsoft.com/office/powerpoint/2010/main" val="1704851840"/>
       </p:ext>
     </p:extLst>
   </p:cSld>
@@ -8658,7 +8906,7 @@
                 <a:ea typeface="Courier New"/>
                 <a:cs typeface="Courier New"/>
               </a:rPr>
-              <a:t>02 / 22</a:t>
+              <a:t>02 / 24</a:t>
             </a:r>
           </a:p>
         </p:txBody>
@@ -8745,7 +8993,7 @@
                 <a:ea typeface="Courier New"/>
                 <a:cs typeface="Courier New"/>
               </a:rPr>
-              <a:t>FLOATING POINT · WORKED INPUT</a:t>
+              <a:t>FLOATING POINT · SPACING</a:t>
             </a:r>
           </a:p>
         </p:txBody>
@@ -8803,7 +9051,7 @@
                 <a:ea typeface="Arial"/>
                 <a:cs typeface="Arial"/>
               </a:rPr>
-              <a:t>HW3 preview: encode 5/2</a:t>
+              <a:t>Precision changes with scale</a:t>
             </a:r>
           </a:p>
         </p:txBody>
@@ -8861,7 +9109,36 @@
                 <a:ea typeface="Arial"/>
                 <a:cs typeface="Arial"/>
               </a:rPr>
-              <a:t>With 3 exponent bits, bias 3, and 3 fraction bits, write 5/2 as 1.010₂ × 2¹. The true exponent is 1, so E = 1 + 3 = 4. The stored fraction is 010₂, so F = 2.</a:t>
+              <a:t>The same three fraction bits give eight values within each normal exponent range.</a:t>
+            </a:r>
+          </a:p>
+          <a:p xmlns:a="http://schemas.openxmlformats.org/drawingml/2006/main">
+            <a:r>
+              <a:t/>
+            </a:r>
+          </a:p>
+          <a:p xmlns:a="http://schemas.openxmlformats.org/drawingml/2006/main">
+            <a:pPr>
+              <a:buNone/>
+              <a:defRPr sz="1950" b="0">
+                <a:solidFill>
+                  <a:srgbClr val="D4D4D8"/>
+                </a:solidFill>
+                <a:latin typeface="Arial"/>
+                <a:ea typeface="Arial"/>
+                <a:cs typeface="Arial"/>
+              </a:defRPr>
+            </a:pPr>
+            <a:r>
+              <a:rPr sz="1950" b="0">
+                <a:solidFill>
+                  <a:srgbClr val="D4D4D8"/>
+                </a:solidFill>
+                <a:latin typeface="Arial"/>
+                <a:ea typeface="Arial"/>
+                <a:cs typeface="Arial"/>
+              </a:rPr>
+              <a:t>When the exponent increases by one, the distance between neighboring values doubles.</a:t>
             </a:r>
           </a:p>
         </p:txBody>
@@ -8919,7 +9196,7 @@
                 <a:ea typeface="Courier New"/>
                 <a:cs typeface="Courier New"/>
               </a:rPr>
-              <a:t>Inputs: 3 3 3 5 2</a:t>
+              <a:t>E = 3 (e = 0)</a:t>
             </a:r>
           </a:p>
           <a:p xmlns:a="http://schemas.openxmlformats.org/drawingml/2006/main">
@@ -8943,6 +9220,35 @@
                 <a:ea typeface="Courier New"/>
                 <a:cs typeface="Courier New"/>
               </a:rPr>
+              <a:t>F = 0 → 1       F = 1 → 9/8</a:t>
+            </a:r>
+          </a:p>
+          <a:p xmlns:a="http://schemas.openxmlformats.org/drawingml/2006/main">
+            <a:pPr>
+              <a:buNone/>
+              <a:defRPr sz="1650" b="0">
+                <a:solidFill>
+                  <a:srgbClr val="A7F3D0"/>
+                </a:solidFill>
+                <a:latin typeface="Courier New"/>
+                <a:ea typeface="Courier New"/>
+                <a:cs typeface="Courier New"/>
+              </a:defRPr>
+            </a:pPr>
+            <a:r>
+              <a:rPr sz="1650" b="0">
+                <a:solidFill>
+                  <a:srgbClr val="A7F3D0"/>
+                </a:solidFill>
+                <a:latin typeface="Courier New"/>
+                <a:ea typeface="Courier New"/>
+                <a:cs typeface="Courier New"/>
+              </a:rPr>
+              <a:t>step = 1/8</a:t>
+            </a:r>
+          </a:p>
+          <a:p xmlns:a="http://schemas.openxmlformats.org/drawingml/2006/main">
+            <a:r>
               <a:t/>
             </a:r>
           </a:p>
@@ -8967,31 +9273,7 @@
                 <a:ea typeface="Courier New"/>
                 <a:cs typeface="Courier New"/>
               </a:rPr>
-              <a:t>E = 4 = 100₂</a:t>
-            </a:r>
-          </a:p>
-          <a:p xmlns:a="http://schemas.openxmlformats.org/drawingml/2006/main">
-            <a:pPr>
-              <a:buNone/>
-              <a:defRPr sz="1650">
-                <a:solidFill>
-                  <a:srgbClr val="A7F3D0"/>
-                </a:solidFill>
-                <a:latin typeface="Courier New"/>
-                <a:ea typeface="Courier New"/>
-                <a:cs typeface="Courier New"/>
-              </a:defRPr>
-            </a:pPr>
-            <a:r>
-              <a:rPr sz="1650">
-                <a:solidFill>
-                  <a:srgbClr val="A7F3D0"/>
-                </a:solidFill>
-                <a:latin typeface="Courier New"/>
-                <a:ea typeface="Courier New"/>
-                <a:cs typeface="Courier New"/>
-              </a:rPr>
-              <a:t>F = 2 = 010₂</a:t>
+              <a:t>E = 4 (e = 1)</a:t>
             </a:r>
           </a:p>
           <a:p xmlns:a="http://schemas.openxmlformats.org/drawingml/2006/main">
@@ -9015,7 +9297,7 @@
                 <a:ea typeface="Courier New"/>
                 <a:cs typeface="Courier New"/>
               </a:rPr>
-              <a:t/>
+              <a:t>F = 0 → 2       F = 1 → 9/4</a:t>
             </a:r>
           </a:p>
           <a:p xmlns:a="http://schemas.openxmlformats.org/drawingml/2006/main">
@@ -9039,55 +9321,7 @@
                 <a:ea typeface="Courier New"/>
                 <a:cs typeface="Courier New"/>
               </a:rPr>
-              <a:t>Output: 4 2</a:t>
-            </a:r>
-          </a:p>
-          <a:p xmlns:a="http://schemas.openxmlformats.org/drawingml/2006/main">
-            <a:pPr>
-              <a:buNone/>
-              <a:defRPr sz="1650" b="0">
-                <a:solidFill>
-                  <a:srgbClr val="A7F3D0"/>
-                </a:solidFill>
-                <a:latin typeface="Courier New"/>
-                <a:ea typeface="Courier New"/>
-                <a:cs typeface="Courier New"/>
-              </a:defRPr>
-            </a:pPr>
-            <a:r>
-              <a:rPr sz="1650" b="0">
-                <a:solidFill>
-                  <a:srgbClr val="A7F3D0"/>
-                </a:solidFill>
-                <a:latin typeface="Courier New"/>
-                <a:ea typeface="Courier New"/>
-                <a:cs typeface="Courier New"/>
-              </a:rPr>
-              <a:t/>
-            </a:r>
-          </a:p>
-          <a:p xmlns:a="http://schemas.openxmlformats.org/drawingml/2006/main">
-            <a:pPr>
-              <a:buNone/>
-              <a:defRPr sz="1650" b="0">
-                <a:solidFill>
-                  <a:srgbClr val="A7F3D0"/>
-                </a:solidFill>
-                <a:latin typeface="Courier New"/>
-                <a:ea typeface="Courier New"/>
-                <a:cs typeface="Courier New"/>
-              </a:defRPr>
-            </a:pPr>
-            <a:r>
-              <a:rPr sz="1650" b="0">
-                <a:solidFill>
-                  <a:srgbClr val="A7F3D0"/>
-                </a:solidFill>
-                <a:latin typeface="Courier New"/>
-                <a:ea typeface="Courier New"/>
-                <a:cs typeface="Courier New"/>
-              </a:rPr>
-              <a:t>Check: (1 + 2/8) × 2¹ = 5/2</a:t>
+              <a:t>step = 1/4</a:t>
             </a:r>
           </a:p>
         </p:txBody>
@@ -9145,7 +9379,7 @@
                 <a:ea typeface="Arial"/>
                 <a:cs typeface="Arial"/>
               </a:rPr>
-              <a:t>Move the binary point before taking the stored fraction bits.</a:t>
+              <a:t>This is why large floating point values have larger gaps.</a:t>
             </a:r>
           </a:p>
         </p:txBody>
@@ -9203,7 +9437,7 @@
                 <a:ea typeface="Courier New"/>
                 <a:cs typeface="Courier New"/>
               </a:rPr>
-              <a:t>20 / 22</a:t>
+              <a:t>20 / 24</a:t>
             </a:r>
           </a:p>
         </p:txBody>
@@ -9290,7 +9524,7 @@
                 <a:ea typeface="Courier New"/>
                 <a:cs typeface="Courier New"/>
               </a:rPr>
-              <a:t>FLOATING POINT · METHOD</a:t>
+              <a:t>FLOATING POINT · ASSIGNMENT PREVIEW</a:t>
             </a:r>
           </a:p>
         </p:txBody>
@@ -9348,7 +9582,7 @@
                 <a:ea typeface="Arial"/>
                 <a:cs typeface="Arial"/>
               </a:rPr>
-              <a:t>HW3 preview: choose the equation</a:t>
+              <a:t>HW3 preview: five inputs</a:t>
             </a:r>
           </a:p>
         </p:txBody>
@@ -9406,55 +9640,7 @@
                 <a:ea typeface="Arial"/>
                 <a:cs typeface="Arial"/>
               </a:rPr>
-              <a:t>Compare a nonzero ratio with the smallest normal, 2^(1−bias). Below that threshold, set E = 0 and use no hidden 1.</a:t>
-            </a:r>
-          </a:p>
-          <a:p xmlns:a="http://schemas.openxmlformats.org/drawingml/2006/main">
-            <a:pPr>
-              <a:buNone/>
-              <a:defRPr sz="1950" b="0">
-                <a:solidFill>
-                  <a:srgbClr val="D4D4D8"/>
-                </a:solidFill>
-                <a:latin typeface="Arial"/>
-                <a:ea typeface="Arial"/>
-                <a:cs typeface="Arial"/>
-              </a:defRPr>
-            </a:pPr>
-            <a:r>
-              <a:rPr sz="1950" b="0">
-                <a:solidFill>
-                  <a:srgbClr val="D4D4D8"/>
-                </a:solidFill>
-                <a:latin typeface="Arial"/>
-                <a:ea typeface="Arial"/>
-                <a:cs typeface="Arial"/>
-              </a:rPr>
-              <a:t/>
-            </a:r>
-          </a:p>
-          <a:p xmlns:a="http://schemas.openxmlformats.org/drawingml/2006/main">
-            <a:pPr>
-              <a:buNone/>
-              <a:defRPr sz="1950" b="0">
-                <a:solidFill>
-                  <a:srgbClr val="D4D4D8"/>
-                </a:solidFill>
-                <a:latin typeface="Arial"/>
-                <a:ea typeface="Arial"/>
-                <a:cs typeface="Arial"/>
-              </a:defRPr>
-            </a:pPr>
-            <a:r>
-              <a:rPr sz="1950" b="0">
-                <a:solidFill>
-                  <a:srgbClr val="D4D4D8"/>
-                </a:solidFill>
-                <a:latin typeface="Arial"/>
-                <a:ea typeface="Arial"/>
-                <a:cs typeface="Arial"/>
-              </a:rPr>
-              <a:t>Otherwise find the true exponent e and store E = e + bias. Solve for F, then decode to check.</a:t>
+              <a:t>The professor plans a program that reads a format and a nonnegative ratio. The assignment has not been posted, so treat these details as a preview.</a:t>
             </a:r>
           </a:p>
         </p:txBody>
@@ -9512,7 +9698,7 @@
                 <a:ea typeface="Courier New"/>
                 <a:cs typeface="Courier New"/>
               </a:rPr>
-              <a:t>Normal (E &gt; 0):</a:t>
+              <a:t>format:  exp_bits = 3</a:t>
             </a:r>
           </a:p>
           <a:p xmlns:a="http://schemas.openxmlformats.org/drawingml/2006/main">
@@ -9536,7 +9722,7 @@
                 <a:ea typeface="Courier New"/>
                 <a:cs typeface="Courier New"/>
               </a:rPr>
-              <a:t>value = (1 + F/2^p) × 2^(E−bias)</a:t>
+              <a:t>         bias = 3</a:t>
             </a:r>
           </a:p>
           <a:p xmlns:a="http://schemas.openxmlformats.org/drawingml/2006/main">
@@ -9560,36 +9746,17 @@
                 <a:ea typeface="Courier New"/>
                 <a:cs typeface="Courier New"/>
               </a:rPr>
+              <a:t>         sig_bits = 3</a:t>
+            </a:r>
+          </a:p>
+          <a:p xmlns:a="http://schemas.openxmlformats.org/drawingml/2006/main">
+            <a:r>
               <a:t/>
             </a:r>
           </a:p>
           <a:p xmlns:a="http://schemas.openxmlformats.org/drawingml/2006/main">
             <a:pPr>
               <a:buNone/>
-              <a:defRPr sz="1650">
-                <a:solidFill>
-                  <a:srgbClr val="A7F3D0"/>
-                </a:solidFill>
-                <a:latin typeface="Courier New"/>
-                <a:ea typeface="Courier New"/>
-                <a:cs typeface="Courier New"/>
-              </a:defRPr>
-            </a:pPr>
-            <a:r>
-              <a:rPr sz="1650">
-                <a:solidFill>
-                  <a:srgbClr val="A7F3D0"/>
-                </a:solidFill>
-                <a:latin typeface="Courier New"/>
-                <a:ea typeface="Courier New"/>
-                <a:cs typeface="Courier New"/>
-              </a:rPr>
-              <a:t>Subnormal (E = 0):</a:t>
-            </a:r>
-          </a:p>
-          <a:p xmlns:a="http://schemas.openxmlformats.org/drawingml/2006/main">
-            <a:pPr>
-              <a:buNone/>
               <a:defRPr sz="1650" b="0">
                 <a:solidFill>
                   <a:srgbClr val="A7F3D0"/>
@@ -9608,7 +9775,7 @@
                 <a:ea typeface="Courier New"/>
                 <a:cs typeface="Courier New"/>
               </a:rPr>
-              <a:t>value = (F/2^p) × 2^(1−bias)</a:t>
+              <a:t>value:   numerator = 5</a:t>
             </a:r>
           </a:p>
           <a:p xmlns:a="http://schemas.openxmlformats.org/drawingml/2006/main">
@@ -9632,6 +9799,30 @@
                 <a:ea typeface="Courier New"/>
                 <a:cs typeface="Courier New"/>
               </a:rPr>
+              <a:t>         denominator = 2</a:t>
+            </a:r>
+          </a:p>
+          <a:p xmlns:a="http://schemas.openxmlformats.org/drawingml/2006/main">
+            <a:pPr>
+              <a:buNone/>
+              <a:defRPr sz="1650" b="0">
+                <a:solidFill>
+                  <a:srgbClr val="A7F3D0"/>
+                </a:solidFill>
+                <a:latin typeface="Courier New"/>
+                <a:ea typeface="Courier New"/>
+                <a:cs typeface="Courier New"/>
+              </a:defRPr>
+            </a:pPr>
+            <a:r>
+              <a:rPr sz="1650" b="0">
+                <a:solidFill>
+                  <a:srgbClr val="A7F3D0"/>
+                </a:solidFill>
+                <a:latin typeface="Courier New"/>
+                <a:ea typeface="Courier New"/>
+                <a:cs typeface="Courier New"/>
+              </a:rPr>
               <a:t/>
             </a:r>
           </a:p>
@@ -9656,7 +9847,7 @@
                 <a:ea typeface="Courier New"/>
                 <a:cs typeface="Courier New"/>
               </a:rPr>
-              <a:t>If numerator = 0: E = 0, F = 0</a:t>
+              <a:t>Find: E (exponent), F (fraction)</a:t>
             </a:r>
           </a:p>
         </p:txBody>
@@ -9714,7 +9905,7 @@
                 <a:ea typeface="Arial"/>
                 <a:cs typeface="Arial"/>
               </a:rPr>
-              <a:t>Use the supplied p and bias, not the values from our practice format.</a:t>
+              <a:t>The first three inputs define the format; the last two define the value.</a:t>
             </a:r>
           </a:p>
         </p:txBody>
@@ -9772,7 +9963,7 @@
                 <a:ea typeface="Courier New"/>
                 <a:cs typeface="Courier New"/>
               </a:rPr>
-              <a:t>21 / 22</a:t>
+              <a:t>21 / 24</a:t>
             </a:r>
           </a:p>
         </p:txBody>
@@ -9811,7 +10002,7 @@
           <p:cNvPr id="7" name="">
             <a:extLst xmlns:a="http://schemas.openxmlformats.org/drawingml/2006/main">
               <a:ext uri="{FF2B5EF4-FFF2-40B4-BE49-F238E27FC236}">
-                <a16:creationId xmlns:a16="http://schemas.microsoft.com/office/drawing/2014/main" id="{4989B079-C3E8-43BB-8638-96121018769A}"/>
+                <a16:creationId xmlns:a16="http://schemas.microsoft.com/office/drawing/2014/main" id="{0BCE7827-648B-4B62-AE80-F3CE9BFFD594}"/>
               </a:ext>
             </a:extLst>
           </p:cNvPr>
@@ -9859,7 +10050,7 @@
                 <a:ea typeface="Courier New"/>
                 <a:cs typeface="Courier New"/>
               </a:rPr>
-              <a:t>FLOATING POINT · RECAP</a:t>
+              <a:t>FLOATING POINT · WORKED INPUT</a:t>
             </a:r>
           </a:p>
         </p:txBody>
@@ -9869,7 +10060,7 @@
           <p:cNvPr id="2" name="">
             <a:extLst xmlns:a="http://schemas.openxmlformats.org/drawingml/2006/main">
               <a:ext uri="{FF2B5EF4-FFF2-40B4-BE49-F238E27FC236}">
-                <a16:creationId xmlns:a16="http://schemas.microsoft.com/office/drawing/2014/main" id="{95D3113E-85F1-4E22-A62E-265E94FE3617}"/>
+                <a16:creationId xmlns:a16="http://schemas.microsoft.com/office/drawing/2014/main" id="{E6B69FE5-5D95-4306-AAF0-9A70AD531613}"/>
               </a:ext>
             </a:extLst>
           </p:cNvPr>
@@ -9917,7 +10108,7 @@
                 <a:ea typeface="Arial"/>
                 <a:cs typeface="Arial"/>
               </a:rPr>
-              <a:t>How to check an encoding</a:t>
+              <a:t>HW3 preview: encode 5/2</a:t>
             </a:r>
           </a:p>
         </p:txBody>
@@ -9927,7 +10118,7 @@
           <p:cNvPr id="3" name="">
             <a:extLst xmlns:a="http://schemas.openxmlformats.org/drawingml/2006/main">
               <a:ext uri="{FF2B5EF4-FFF2-40B4-BE49-F238E27FC236}">
-                <a16:creationId xmlns:a16="http://schemas.microsoft.com/office/drawing/2014/main" id="{8EC5E33C-BA7C-4ADE-9FC3-9ABD9F3C6FD4}"/>
+                <a16:creationId xmlns:a16="http://schemas.microsoft.com/office/drawing/2014/main" id="{887FE9A9-E5DE-4BC1-94AD-59371BF9B78C}"/>
               </a:ext>
             </a:extLst>
           </p:cNvPr>
@@ -9975,36 +10166,7 @@
                 <a:ea typeface="Arial"/>
                 <a:cs typeface="Arial"/>
               </a:rPr>
-              <a:t>In our practice format, E = 0 means count F steps of 1/32. Otherwise decode e = E − 3 and use the implied leading 1.</a:t>
-            </a:r>
-          </a:p>
-          <a:p xmlns:a="http://schemas.openxmlformats.org/drawingml/2006/main">
-            <a:r>
-              <a:t/>
-            </a:r>
-          </a:p>
-          <a:p xmlns:a="http://schemas.openxmlformats.org/drawingml/2006/main">
-            <a:pPr>
-              <a:buNone/>
-              <a:defRPr sz="1950" b="0">
-                <a:solidFill>
-                  <a:srgbClr val="D4D4D8"/>
-                </a:solidFill>
-                <a:latin typeface="Arial"/>
-                <a:ea typeface="Arial"/>
-                <a:cs typeface="Arial"/>
-              </a:defRPr>
-            </a:pPr>
-            <a:r>
-              <a:rPr sz="1950" b="0">
-                <a:solidFill>
-                  <a:srgbClr val="D4D4D8"/>
-                </a:solidFill>
-                <a:latin typeface="Arial"/>
-                <a:ea typeface="Arial"/>
-                <a:cs typeface="Arial"/>
-              </a:rPr>
-              <a:t>For an inexact value, follow the problem’s rounding rule.</a:t>
+              <a:t>With 3 exponent bits, bias 3, and 3 fraction bits, write 5/2 as 1.010₂ × 2¹. The true exponent is 1, so E = 1 + 3 = 4. The stored fraction is 010₂, so F = 2.</a:t>
             </a:r>
           </a:p>
         </p:txBody>
@@ -10014,7 +10176,7 @@
           <p:cNvPr id="4" name="">
             <a:extLst xmlns:a="http://schemas.openxmlformats.org/drawingml/2006/main">
               <a:ext uri="{FF2B5EF4-FFF2-40B4-BE49-F238E27FC236}">
-                <a16:creationId xmlns:a16="http://schemas.microsoft.com/office/drawing/2014/main" id="{EA939046-DA6B-448C-A179-5B13743C72F3}"/>
+                <a16:creationId xmlns:a16="http://schemas.microsoft.com/office/drawing/2014/main" id="{CED75AEC-85E3-4520-B63E-09FCF9AACAE6}"/>
               </a:ext>
             </a:extLst>
           </p:cNvPr>
@@ -10062,11 +10224,30 @@
                 <a:ea typeface="Courier New"/>
                 <a:cs typeface="Courier New"/>
               </a:rPr>
-              <a:t>Our practice format</a:t>
-            </a:r>
-          </a:p>
-          <a:p xmlns:a="http://schemas.openxmlformats.org/drawingml/2006/main">
-            <a:r>
+              <a:t>Inputs: 3 3 3 5 2</a:t>
+            </a:r>
+          </a:p>
+          <a:p xmlns:a="http://schemas.openxmlformats.org/drawingml/2006/main">
+            <a:pPr>
+              <a:buNone/>
+              <a:defRPr sz="1650" b="0">
+                <a:solidFill>
+                  <a:srgbClr val="A7F3D0"/>
+                </a:solidFill>
+                <a:latin typeface="Courier New"/>
+                <a:ea typeface="Courier New"/>
+                <a:cs typeface="Courier New"/>
+              </a:defRPr>
+            </a:pPr>
+            <a:r>
+              <a:rPr sz="1650" b="0">
+                <a:solidFill>
+                  <a:srgbClr val="A7F3D0"/>
+                </a:solidFill>
+                <a:latin typeface="Courier New"/>
+                <a:ea typeface="Courier New"/>
+                <a:cs typeface="Courier New"/>
+              </a:rPr>
               <a:t/>
             </a:r>
           </a:p>
@@ -10091,7 +10272,31 @@
                 <a:ea typeface="Courier New"/>
                 <a:cs typeface="Courier New"/>
               </a:rPr>
-              <a:t>Normal:    (1 + F/8) × 2^(E−3)</a:t>
+              <a:t>E = 4 = 100₂</a:t>
+            </a:r>
+          </a:p>
+          <a:p xmlns:a="http://schemas.openxmlformats.org/drawingml/2006/main">
+            <a:pPr>
+              <a:buNone/>
+              <a:defRPr sz="1650">
+                <a:solidFill>
+                  <a:srgbClr val="A7F3D0"/>
+                </a:solidFill>
+                <a:latin typeface="Courier New"/>
+                <a:ea typeface="Courier New"/>
+                <a:cs typeface="Courier New"/>
+              </a:defRPr>
+            </a:pPr>
+            <a:r>
+              <a:rPr sz="1650">
+                <a:solidFill>
+                  <a:srgbClr val="A7F3D0"/>
+                </a:solidFill>
+                <a:latin typeface="Courier New"/>
+                <a:ea typeface="Courier New"/>
+                <a:cs typeface="Courier New"/>
+              </a:rPr>
+              <a:t>F = 2 = 010₂</a:t>
             </a:r>
           </a:p>
           <a:p xmlns:a="http://schemas.openxmlformats.org/drawingml/2006/main">
@@ -10115,11 +10320,6 @@
                 <a:ea typeface="Courier New"/>
                 <a:cs typeface="Courier New"/>
               </a:rPr>
-              <a:t>Subnormal: F/32  (E = 0)</a:t>
-            </a:r>
-          </a:p>
-          <a:p xmlns:a="http://schemas.openxmlformats.org/drawingml/2006/main">
-            <a:r>
               <a:t/>
             </a:r>
           </a:p>
@@ -10144,11 +10344,30 @@
                 <a:ea typeface="Courier New"/>
                 <a:cs typeface="Courier New"/>
               </a:rPr>
-              <a:t>E = 0, F = 0  →  zero</a:t>
-            </a:r>
-          </a:p>
-          <a:p xmlns:a="http://schemas.openxmlformats.org/drawingml/2006/main">
-            <a:r>
+              <a:t>Output: 4 2</a:t>
+            </a:r>
+          </a:p>
+          <a:p xmlns:a="http://schemas.openxmlformats.org/drawingml/2006/main">
+            <a:pPr>
+              <a:buNone/>
+              <a:defRPr sz="1650" b="0">
+                <a:solidFill>
+                  <a:srgbClr val="A7F3D0"/>
+                </a:solidFill>
+                <a:latin typeface="Courier New"/>
+                <a:ea typeface="Courier New"/>
+                <a:cs typeface="Courier New"/>
+              </a:defRPr>
+            </a:pPr>
+            <a:r>
+              <a:rPr sz="1650" b="0">
+                <a:solidFill>
+                  <a:srgbClr val="A7F3D0"/>
+                </a:solidFill>
+                <a:latin typeface="Courier New"/>
+                <a:ea typeface="Courier New"/>
+                <a:cs typeface="Courier New"/>
+              </a:rPr>
               <a:t/>
             </a:r>
           </a:p>
@@ -10173,7 +10392,7 @@
                 <a:ea typeface="Courier New"/>
                 <a:cs typeface="Courier New"/>
               </a:rPr>
-              <a:t>Decode your bits as a final check.</a:t>
+              <a:t>Check: (1 + 2/8) × 2¹ = 5/2</a:t>
             </a:r>
           </a:p>
         </p:txBody>
@@ -10183,7 +10402,7 @@
           <p:cNvPr id="5" name="">
             <a:extLst xmlns:a="http://schemas.openxmlformats.org/drawingml/2006/main">
               <a:ext uri="{FF2B5EF4-FFF2-40B4-BE49-F238E27FC236}">
-                <a16:creationId xmlns:a16="http://schemas.microsoft.com/office/drawing/2014/main" id="{585A0E73-828D-45A1-9AD7-8EED8C5E7EB1}"/>
+                <a16:creationId xmlns:a16="http://schemas.microsoft.com/office/drawing/2014/main" id="{7A18BC8F-2DC5-4B6B-A4F9-10CDE1183DE6}"/>
               </a:ext>
             </a:extLst>
           </p:cNvPr>
@@ -10231,7 +10450,7 @@
                 <a:ea typeface="Arial"/>
                 <a:cs typeface="Arial"/>
               </a:rPr>
-              <a:t>A correct encoding must reproduce the intended value or its required rounded value.</a:t>
+              <a:t>Move the binary point before taking the stored fraction bits.</a:t>
             </a:r>
           </a:p>
         </p:txBody>
@@ -10241,7 +10460,7 @@
           <p:cNvPr id="6" name="">
             <a:extLst xmlns:a="http://schemas.openxmlformats.org/drawingml/2006/main">
               <a:ext uri="{FF2B5EF4-FFF2-40B4-BE49-F238E27FC236}">
-                <a16:creationId xmlns:a16="http://schemas.microsoft.com/office/drawing/2014/main" id="{E1FBC5BD-1F5D-42FA-AC83-E0BF862F4EDF}"/>
+                <a16:creationId xmlns:a16="http://schemas.microsoft.com/office/drawing/2014/main" id="{94269C50-3A0A-4FBB-A1D2-A33411F72ECA}"/>
               </a:ext>
             </a:extLst>
           </p:cNvPr>
@@ -10289,7 +10508,1093 @@
                 <a:ea typeface="Courier New"/>
                 <a:cs typeface="Courier New"/>
               </a:rPr>
-              <a:t>22 / 22</a:t>
+              <a:t>22 / 24</a:t>
+            </a:r>
+          </a:p>
+        </p:txBody>
+      </p:sp>
+    </p:spTree>
+    <p:extLst>
+      <p:ext uri="{BB962C8B-B14F-4D97-AF65-F5344CB8AC3E}">
+        <p14:creationId xmlns:p14="http://schemas.microsoft.com/office/powerpoint/2010/main" val="1018474765"/>
+      </p:ext>
+    </p:extLst>
+  </p:cSld>
+</p:sld>
+</file>
+
+<file path=ppt/slides/slide23.xml><?xml version="1.0" encoding="utf-8"?>
+<p:sld xmlns:p="http://schemas.openxmlformats.org/presentationml/2006/main">
+  <p:cSld>
+    <p:bg>
+      <p:bgPr>
+        <a:solidFill xmlns:a="http://schemas.openxmlformats.org/drawingml/2006/main">
+          <a:srgbClr val="09090B"/>
+        </a:solidFill>
+      </p:bgPr>
+    </p:bg>
+    <p:spTree>
+      <p:nvGrpSpPr>
+        <p:cNvPr id="1" name=""/>
+        <p:cNvGrpSpPr/>
+        <p:nvPr/>
+      </p:nvGrpSpPr>
+      <p:grpSpPr>
+        <a:xfrm xmlns:a="http://schemas.openxmlformats.org/drawingml/2006/main"/>
+      </p:grpSpPr>
+      <p:sp>
+        <p:nvSpPr>
+          <p:cNvPr id="7" name="">
+            <a:extLst xmlns:a="http://schemas.openxmlformats.org/drawingml/2006/main">
+              <a:ext uri="{FF2B5EF4-FFF2-40B4-BE49-F238E27FC236}">
+                <a16:creationId xmlns:a16="http://schemas.microsoft.com/office/drawing/2014/main" id="{0BCE7827-648B-4B62-AE80-F3CE9BFFD594}"/>
+              </a:ext>
+            </a:extLst>
+          </p:cNvPr>
+          <p:cNvSpPr>
+            <a:spLocks xmlns:a="http://schemas.openxmlformats.org/drawingml/2006/main" noGrp="1"/>
+          </p:cNvSpPr>
+          <p:nvPr/>
+        </p:nvSpPr>
+        <p:spPr>
+          <a:xfrm xmlns:a="http://schemas.openxmlformats.org/drawingml/2006/main">
+            <a:off x="685800" y="361950"/>
+            <a:ext cx="10477500" cy="285750"/>
+          </a:xfrm>
+          <a:prstGeom xmlns:a="http://schemas.openxmlformats.org/drawingml/2006/main" prst="rect">
+            <a:avLst/>
+          </a:prstGeom>
+          <a:noFill xmlns:a="http://schemas.openxmlformats.org/drawingml/2006/main"/>
+          <a:ln xmlns:a="http://schemas.openxmlformats.org/drawingml/2006/main" w="0">
+            <a:noFill/>
+          </a:ln>
+        </p:spPr>
+        <p:txBody>
+          <a:bodyPr xmlns:a="http://schemas.openxmlformats.org/drawingml/2006/main" anchor="t">
+            <a:normAutofit fontScale="100000"/>
+          </a:bodyPr>
+          <a:lstStyle xmlns:a="http://schemas.openxmlformats.org/drawingml/2006/main"/>
+          <a:p xmlns:a="http://schemas.openxmlformats.org/drawingml/2006/main">
+            <a:pPr>
+              <a:buNone/>
+              <a:defRPr sz="1275" b="0">
+                <a:solidFill>
+                  <a:srgbClr val="6EE7B7"/>
+                </a:solidFill>
+                <a:latin typeface="Courier New"/>
+                <a:ea typeface="Courier New"/>
+                <a:cs typeface="Courier New"/>
+              </a:defRPr>
+            </a:pPr>
+            <a:r>
+              <a:rPr sz="1275" b="0">
+                <a:solidFill>
+                  <a:srgbClr val="6EE7B7"/>
+                </a:solidFill>
+                <a:latin typeface="Courier New"/>
+                <a:ea typeface="Courier New"/>
+                <a:cs typeface="Courier New"/>
+              </a:rPr>
+              <a:t>FLOATING POINT · METHOD</a:t>
+            </a:r>
+          </a:p>
+        </p:txBody>
+      </p:sp>
+      <p:sp>
+        <p:nvSpPr>
+          <p:cNvPr id="2" name="">
+            <a:extLst xmlns:a="http://schemas.openxmlformats.org/drawingml/2006/main">
+              <a:ext uri="{FF2B5EF4-FFF2-40B4-BE49-F238E27FC236}">
+                <a16:creationId xmlns:a16="http://schemas.microsoft.com/office/drawing/2014/main" id="{E6B69FE5-5D95-4306-AAF0-9A70AD531613}"/>
+              </a:ext>
+            </a:extLst>
+          </p:cNvPr>
+          <p:cNvSpPr>
+            <a:spLocks xmlns:a="http://schemas.openxmlformats.org/drawingml/2006/main" noGrp="1"/>
+          </p:cNvSpPr>
+          <p:nvPr/>
+        </p:nvSpPr>
+        <p:spPr>
+          <a:xfrm xmlns:a="http://schemas.openxmlformats.org/drawingml/2006/main">
+            <a:off x="685800" y="885825"/>
+            <a:ext cx="10820400" cy="1066800"/>
+          </a:xfrm>
+          <a:prstGeom xmlns:a="http://schemas.openxmlformats.org/drawingml/2006/main" prst="rect">
+            <a:avLst/>
+          </a:prstGeom>
+          <a:noFill xmlns:a="http://schemas.openxmlformats.org/drawingml/2006/main"/>
+          <a:ln xmlns:a="http://schemas.openxmlformats.org/drawingml/2006/main" w="0">
+            <a:noFill/>
+          </a:ln>
+        </p:spPr>
+        <p:txBody>
+          <a:bodyPr xmlns:a="http://schemas.openxmlformats.org/drawingml/2006/main" anchor="t">
+            <a:normAutofit fontScale="100000"/>
+          </a:bodyPr>
+          <a:lstStyle xmlns:a="http://schemas.openxmlformats.org/drawingml/2006/main"/>
+          <a:p xmlns:a="http://schemas.openxmlformats.org/drawingml/2006/main">
+            <a:pPr>
+              <a:buNone/>
+              <a:defRPr sz="3600" b="0">
+                <a:solidFill>
+                  <a:srgbClr val="FAFAFA"/>
+                </a:solidFill>
+                <a:latin typeface="Arial"/>
+                <a:ea typeface="Arial"/>
+                <a:cs typeface="Arial"/>
+              </a:defRPr>
+            </a:pPr>
+            <a:r>
+              <a:rPr sz="3600" b="0">
+                <a:solidFill>
+                  <a:srgbClr val="FAFAFA"/>
+                </a:solidFill>
+                <a:latin typeface="Arial"/>
+                <a:ea typeface="Arial"/>
+                <a:cs typeface="Arial"/>
+              </a:rPr>
+              <a:t>HW3 preview: choose the equation</a:t>
+            </a:r>
+          </a:p>
+        </p:txBody>
+      </p:sp>
+      <p:sp>
+        <p:nvSpPr>
+          <p:cNvPr id="3" name="">
+            <a:extLst xmlns:a="http://schemas.openxmlformats.org/drawingml/2006/main">
+              <a:ext uri="{FF2B5EF4-FFF2-40B4-BE49-F238E27FC236}">
+                <a16:creationId xmlns:a16="http://schemas.microsoft.com/office/drawing/2014/main" id="{887FE9A9-E5DE-4BC1-94AD-59371BF9B78C}"/>
+              </a:ext>
+            </a:extLst>
+          </p:cNvPr>
+          <p:cNvSpPr>
+            <a:spLocks xmlns:a="http://schemas.openxmlformats.org/drawingml/2006/main" noGrp="1"/>
+          </p:cNvSpPr>
+          <p:nvPr/>
+        </p:nvSpPr>
+        <p:spPr>
+          <a:xfrm xmlns:a="http://schemas.openxmlformats.org/drawingml/2006/main">
+            <a:off x="685800" y="2200275"/>
+            <a:ext cx="4857750" cy="3124200"/>
+          </a:xfrm>
+          <a:prstGeom xmlns:a="http://schemas.openxmlformats.org/drawingml/2006/main" prst="rect">
+            <a:avLst/>
+          </a:prstGeom>
+          <a:noFill xmlns:a="http://schemas.openxmlformats.org/drawingml/2006/main"/>
+          <a:ln xmlns:a="http://schemas.openxmlformats.org/drawingml/2006/main" w="0">
+            <a:noFill/>
+          </a:ln>
+        </p:spPr>
+        <p:txBody>
+          <a:bodyPr xmlns:a="http://schemas.openxmlformats.org/drawingml/2006/main" anchor="t">
+            <a:normAutofit fontScale="100000"/>
+          </a:bodyPr>
+          <a:lstStyle xmlns:a="http://schemas.openxmlformats.org/drawingml/2006/main"/>
+          <a:p xmlns:a="http://schemas.openxmlformats.org/drawingml/2006/main">
+            <a:pPr>
+              <a:buNone/>
+              <a:defRPr sz="1950" b="0">
+                <a:solidFill>
+                  <a:srgbClr val="D4D4D8"/>
+                </a:solidFill>
+                <a:latin typeface="Arial"/>
+                <a:ea typeface="Arial"/>
+                <a:cs typeface="Arial"/>
+              </a:defRPr>
+            </a:pPr>
+            <a:r>
+              <a:rPr sz="1950" b="0">
+                <a:solidFill>
+                  <a:srgbClr val="D4D4D8"/>
+                </a:solidFill>
+                <a:latin typeface="Arial"/>
+                <a:ea typeface="Arial"/>
+                <a:cs typeface="Arial"/>
+              </a:rPr>
+              <a:t>Compare a nonzero ratio with the smallest normal, 2^(1−bias). Below that threshold, set E = 0 and use no hidden 1.</a:t>
+            </a:r>
+          </a:p>
+          <a:p xmlns:a="http://schemas.openxmlformats.org/drawingml/2006/main">
+            <a:pPr>
+              <a:buNone/>
+              <a:defRPr sz="1950" b="0">
+                <a:solidFill>
+                  <a:srgbClr val="D4D4D8"/>
+                </a:solidFill>
+                <a:latin typeface="Arial"/>
+                <a:ea typeface="Arial"/>
+                <a:cs typeface="Arial"/>
+              </a:defRPr>
+            </a:pPr>
+            <a:r>
+              <a:rPr sz="1950" b="0">
+                <a:solidFill>
+                  <a:srgbClr val="D4D4D8"/>
+                </a:solidFill>
+                <a:latin typeface="Arial"/>
+                <a:ea typeface="Arial"/>
+                <a:cs typeface="Arial"/>
+              </a:rPr>
+              <a:t/>
+            </a:r>
+          </a:p>
+          <a:p xmlns:a="http://schemas.openxmlformats.org/drawingml/2006/main">
+            <a:pPr>
+              <a:buNone/>
+              <a:defRPr sz="1950" b="0">
+                <a:solidFill>
+                  <a:srgbClr val="D4D4D8"/>
+                </a:solidFill>
+                <a:latin typeface="Arial"/>
+                <a:ea typeface="Arial"/>
+                <a:cs typeface="Arial"/>
+              </a:defRPr>
+            </a:pPr>
+            <a:r>
+              <a:rPr sz="1950" b="0">
+                <a:solidFill>
+                  <a:srgbClr val="D4D4D8"/>
+                </a:solidFill>
+                <a:latin typeface="Arial"/>
+                <a:ea typeface="Arial"/>
+                <a:cs typeface="Arial"/>
+              </a:rPr>
+              <a:t>Otherwise find the true exponent e and store E = e + bias. Solve for F, then decode to check.</a:t>
+            </a:r>
+          </a:p>
+        </p:txBody>
+      </p:sp>
+      <p:sp>
+        <p:nvSpPr>
+          <p:cNvPr id="4" name="">
+            <a:extLst xmlns:a="http://schemas.openxmlformats.org/drawingml/2006/main">
+              <a:ext uri="{FF2B5EF4-FFF2-40B4-BE49-F238E27FC236}">
+                <a16:creationId xmlns:a16="http://schemas.microsoft.com/office/drawing/2014/main" id="{CED75AEC-85E3-4520-B63E-09FCF9AACAE6}"/>
+              </a:ext>
+            </a:extLst>
+          </p:cNvPr>
+          <p:cNvSpPr>
+            <a:spLocks xmlns:a="http://schemas.openxmlformats.org/drawingml/2006/main" noGrp="1"/>
+          </p:cNvSpPr>
+          <p:nvPr/>
+        </p:nvSpPr>
+        <p:spPr>
+          <a:xfrm xmlns:a="http://schemas.openxmlformats.org/drawingml/2006/main">
+            <a:off x="6181725" y="2200275"/>
+            <a:ext cx="5238750" cy="3286125"/>
+          </a:xfrm>
+          <a:prstGeom xmlns:a="http://schemas.openxmlformats.org/drawingml/2006/main" prst="rect">
+            <a:avLst/>
+          </a:prstGeom>
+          <a:noFill xmlns:a="http://schemas.openxmlformats.org/drawingml/2006/main"/>
+          <a:ln xmlns:a="http://schemas.openxmlformats.org/drawingml/2006/main" w="0">
+            <a:noFill/>
+          </a:ln>
+        </p:spPr>
+        <p:txBody>
+          <a:bodyPr xmlns:a="http://schemas.openxmlformats.org/drawingml/2006/main" anchor="t">
+            <a:normAutofit fontScale="100000"/>
+          </a:bodyPr>
+          <a:lstStyle xmlns:a="http://schemas.openxmlformats.org/drawingml/2006/main"/>
+          <a:p xmlns:a="http://schemas.openxmlformats.org/drawingml/2006/main">
+            <a:pPr>
+              <a:buNone/>
+              <a:defRPr sz="1650" b="0">
+                <a:solidFill>
+                  <a:srgbClr val="A7F3D0"/>
+                </a:solidFill>
+                <a:latin typeface="Courier New"/>
+                <a:ea typeface="Courier New"/>
+                <a:cs typeface="Courier New"/>
+              </a:defRPr>
+            </a:pPr>
+            <a:r>
+              <a:rPr sz="1650" b="0">
+                <a:solidFill>
+                  <a:srgbClr val="A7F3D0"/>
+                </a:solidFill>
+                <a:latin typeface="Courier New"/>
+                <a:ea typeface="Courier New"/>
+                <a:cs typeface="Courier New"/>
+              </a:rPr>
+              <a:t>Normal (E &gt; 0):</a:t>
+            </a:r>
+          </a:p>
+          <a:p xmlns:a="http://schemas.openxmlformats.org/drawingml/2006/main">
+            <a:pPr>
+              <a:buNone/>
+              <a:defRPr sz="1650" b="0">
+                <a:solidFill>
+                  <a:srgbClr val="A7F3D0"/>
+                </a:solidFill>
+                <a:latin typeface="Courier New"/>
+                <a:ea typeface="Courier New"/>
+                <a:cs typeface="Courier New"/>
+              </a:defRPr>
+            </a:pPr>
+            <a:r>
+              <a:rPr sz="1650" b="0">
+                <a:solidFill>
+                  <a:srgbClr val="A7F3D0"/>
+                </a:solidFill>
+                <a:latin typeface="Courier New"/>
+                <a:ea typeface="Courier New"/>
+                <a:cs typeface="Courier New"/>
+              </a:rPr>
+              <a:t>value = (1 + F/2^p) × 2^(E−bias)</a:t>
+            </a:r>
+          </a:p>
+          <a:p xmlns:a="http://schemas.openxmlformats.org/drawingml/2006/main">
+            <a:pPr>
+              <a:buNone/>
+              <a:defRPr sz="1650" b="0">
+                <a:solidFill>
+                  <a:srgbClr val="A7F3D0"/>
+                </a:solidFill>
+                <a:latin typeface="Courier New"/>
+                <a:ea typeface="Courier New"/>
+                <a:cs typeface="Courier New"/>
+              </a:defRPr>
+            </a:pPr>
+            <a:r>
+              <a:rPr sz="1650" b="0">
+                <a:solidFill>
+                  <a:srgbClr val="A7F3D0"/>
+                </a:solidFill>
+                <a:latin typeface="Courier New"/>
+                <a:ea typeface="Courier New"/>
+                <a:cs typeface="Courier New"/>
+              </a:rPr>
+              <a:t/>
+            </a:r>
+          </a:p>
+          <a:p xmlns:a="http://schemas.openxmlformats.org/drawingml/2006/main">
+            <a:pPr>
+              <a:buNone/>
+              <a:defRPr sz="1650">
+                <a:solidFill>
+                  <a:srgbClr val="A7F3D0"/>
+                </a:solidFill>
+                <a:latin typeface="Courier New"/>
+                <a:ea typeface="Courier New"/>
+                <a:cs typeface="Courier New"/>
+              </a:defRPr>
+            </a:pPr>
+            <a:r>
+              <a:rPr sz="1650">
+                <a:solidFill>
+                  <a:srgbClr val="A7F3D0"/>
+                </a:solidFill>
+                <a:latin typeface="Courier New"/>
+                <a:ea typeface="Courier New"/>
+                <a:cs typeface="Courier New"/>
+              </a:rPr>
+              <a:t>Subnormal (E = 0):</a:t>
+            </a:r>
+          </a:p>
+          <a:p xmlns:a="http://schemas.openxmlformats.org/drawingml/2006/main">
+            <a:pPr>
+              <a:buNone/>
+              <a:defRPr sz="1650" b="0">
+                <a:solidFill>
+                  <a:srgbClr val="A7F3D0"/>
+                </a:solidFill>
+                <a:latin typeface="Courier New"/>
+                <a:ea typeface="Courier New"/>
+                <a:cs typeface="Courier New"/>
+              </a:defRPr>
+            </a:pPr>
+            <a:r>
+              <a:rPr sz="1650" b="0">
+                <a:solidFill>
+                  <a:srgbClr val="A7F3D0"/>
+                </a:solidFill>
+                <a:latin typeface="Courier New"/>
+                <a:ea typeface="Courier New"/>
+                <a:cs typeface="Courier New"/>
+              </a:rPr>
+              <a:t>value = (F/2^p) × 2^(1−bias)</a:t>
+            </a:r>
+          </a:p>
+          <a:p xmlns:a="http://schemas.openxmlformats.org/drawingml/2006/main">
+            <a:pPr>
+              <a:buNone/>
+              <a:defRPr sz="1650" b="0">
+                <a:solidFill>
+                  <a:srgbClr val="A7F3D0"/>
+                </a:solidFill>
+                <a:latin typeface="Courier New"/>
+                <a:ea typeface="Courier New"/>
+                <a:cs typeface="Courier New"/>
+              </a:defRPr>
+            </a:pPr>
+            <a:r>
+              <a:rPr sz="1650" b="0">
+                <a:solidFill>
+                  <a:srgbClr val="A7F3D0"/>
+                </a:solidFill>
+                <a:latin typeface="Courier New"/>
+                <a:ea typeface="Courier New"/>
+                <a:cs typeface="Courier New"/>
+              </a:rPr>
+              <a:t/>
+            </a:r>
+          </a:p>
+          <a:p xmlns:a="http://schemas.openxmlformats.org/drawingml/2006/main">
+            <a:pPr>
+              <a:buNone/>
+              <a:defRPr sz="1650" b="0">
+                <a:solidFill>
+                  <a:srgbClr val="A7F3D0"/>
+                </a:solidFill>
+                <a:latin typeface="Courier New"/>
+                <a:ea typeface="Courier New"/>
+                <a:cs typeface="Courier New"/>
+              </a:defRPr>
+            </a:pPr>
+            <a:r>
+              <a:rPr sz="1650" b="0">
+                <a:solidFill>
+                  <a:srgbClr val="A7F3D0"/>
+                </a:solidFill>
+                <a:latin typeface="Courier New"/>
+                <a:ea typeface="Courier New"/>
+                <a:cs typeface="Courier New"/>
+              </a:rPr>
+              <a:t>If numerator = 0: E = 0, F = 0</a:t>
+            </a:r>
+          </a:p>
+        </p:txBody>
+      </p:sp>
+      <p:sp>
+        <p:nvSpPr>
+          <p:cNvPr id="5" name="">
+            <a:extLst xmlns:a="http://schemas.openxmlformats.org/drawingml/2006/main">
+              <a:ext uri="{FF2B5EF4-FFF2-40B4-BE49-F238E27FC236}">
+                <a16:creationId xmlns:a16="http://schemas.microsoft.com/office/drawing/2014/main" id="{7A18BC8F-2DC5-4B6B-A4F9-10CDE1183DE6}"/>
+              </a:ext>
+            </a:extLst>
+          </p:cNvPr>
+          <p:cNvSpPr>
+            <a:spLocks xmlns:a="http://schemas.openxmlformats.org/drawingml/2006/main" noGrp="1"/>
+          </p:cNvSpPr>
+          <p:nvPr/>
+        </p:nvSpPr>
+        <p:spPr>
+          <a:xfrm xmlns:a="http://schemas.openxmlformats.org/drawingml/2006/main">
+            <a:off x="685800" y="5743575"/>
+            <a:ext cx="10191750" cy="428625"/>
+          </a:xfrm>
+          <a:prstGeom xmlns:a="http://schemas.openxmlformats.org/drawingml/2006/main" prst="rect">
+            <a:avLst/>
+          </a:prstGeom>
+          <a:noFill xmlns:a="http://schemas.openxmlformats.org/drawingml/2006/main"/>
+          <a:ln xmlns:a="http://schemas.openxmlformats.org/drawingml/2006/main" w="0">
+            <a:noFill/>
+          </a:ln>
+        </p:spPr>
+        <p:txBody>
+          <a:bodyPr xmlns:a="http://schemas.openxmlformats.org/drawingml/2006/main" anchor="t">
+            <a:normAutofit fontScale="100000"/>
+          </a:bodyPr>
+          <a:lstStyle xmlns:a="http://schemas.openxmlformats.org/drawingml/2006/main"/>
+          <a:p xmlns:a="http://schemas.openxmlformats.org/drawingml/2006/main">
+            <a:pPr>
+              <a:buNone/>
+              <a:defRPr sz="1350" b="0">
+                <a:solidFill>
+                  <a:srgbClr val="A1A1AA"/>
+                </a:solidFill>
+                <a:latin typeface="Arial"/>
+                <a:ea typeface="Arial"/>
+                <a:cs typeface="Arial"/>
+              </a:defRPr>
+            </a:pPr>
+            <a:r>
+              <a:rPr sz="1350" b="0">
+                <a:solidFill>
+                  <a:srgbClr val="A1A1AA"/>
+                </a:solidFill>
+                <a:latin typeface="Arial"/>
+                <a:ea typeface="Arial"/>
+                <a:cs typeface="Arial"/>
+              </a:rPr>
+              <a:t>Use the supplied p and bias, not the values from our practice format.</a:t>
+            </a:r>
+          </a:p>
+        </p:txBody>
+      </p:sp>
+      <p:sp>
+        <p:nvSpPr>
+          <p:cNvPr id="6" name="">
+            <a:extLst xmlns:a="http://schemas.openxmlformats.org/drawingml/2006/main">
+              <a:ext uri="{FF2B5EF4-FFF2-40B4-BE49-F238E27FC236}">
+                <a16:creationId xmlns:a16="http://schemas.microsoft.com/office/drawing/2014/main" id="{94269C50-3A0A-4FBB-A1D2-A33411F72ECA}"/>
+              </a:ext>
+            </a:extLst>
+          </p:cNvPr>
+          <p:cNvSpPr>
+            <a:spLocks xmlns:a="http://schemas.openxmlformats.org/drawingml/2006/main" noGrp="1"/>
+          </p:cNvSpPr>
+          <p:nvPr/>
+        </p:nvSpPr>
+        <p:spPr>
+          <a:xfrm xmlns:a="http://schemas.openxmlformats.org/drawingml/2006/main">
+            <a:off x="10477500" y="6210300"/>
+            <a:ext cx="1000125" cy="219075"/>
+          </a:xfrm>
+          <a:prstGeom xmlns:a="http://schemas.openxmlformats.org/drawingml/2006/main" prst="rect">
+            <a:avLst/>
+          </a:prstGeom>
+          <a:noFill xmlns:a="http://schemas.openxmlformats.org/drawingml/2006/main"/>
+          <a:ln xmlns:a="http://schemas.openxmlformats.org/drawingml/2006/main" w="0">
+            <a:noFill/>
+          </a:ln>
+        </p:spPr>
+        <p:txBody>
+          <a:bodyPr xmlns:a="http://schemas.openxmlformats.org/drawingml/2006/main" anchor="t">
+            <a:normAutofit fontScale="79762"/>
+          </a:bodyPr>
+          <a:lstStyle xmlns:a="http://schemas.openxmlformats.org/drawingml/2006/main"/>
+          <a:p xmlns:a="http://schemas.openxmlformats.org/drawingml/2006/main">
+            <a:pPr>
+              <a:buNone/>
+              <a:defRPr sz="1050" b="0">
+                <a:solidFill>
+                  <a:srgbClr val="71717A"/>
+                </a:solidFill>
+                <a:latin typeface="Courier New"/>
+                <a:ea typeface="Courier New"/>
+                <a:cs typeface="Courier New"/>
+              </a:defRPr>
+            </a:pPr>
+            <a:r>
+              <a:rPr sz="1050" b="0">
+                <a:solidFill>
+                  <a:srgbClr val="71717A"/>
+                </a:solidFill>
+                <a:latin typeface="Courier New"/>
+                <a:ea typeface="Courier New"/>
+                <a:cs typeface="Courier New"/>
+              </a:rPr>
+              <a:t>23 / 24</a:t>
+            </a:r>
+          </a:p>
+        </p:txBody>
+      </p:sp>
+    </p:spTree>
+    <p:extLst>
+      <p:ext uri="{BB962C8B-B14F-4D97-AF65-F5344CB8AC3E}">
+        <p14:creationId xmlns:p14="http://schemas.microsoft.com/office/powerpoint/2010/main" val="1018474765"/>
+      </p:ext>
+    </p:extLst>
+  </p:cSld>
+</p:sld>
+</file>
+
+<file path=ppt/slides/slide24.xml><?xml version="1.0" encoding="utf-8"?>
+<p:sld xmlns:p="http://schemas.openxmlformats.org/presentationml/2006/main">
+  <p:cSld>
+    <p:bg>
+      <p:bgPr>
+        <a:solidFill xmlns:a="http://schemas.openxmlformats.org/drawingml/2006/main">
+          <a:srgbClr val="09090B"/>
+        </a:solidFill>
+      </p:bgPr>
+    </p:bg>
+    <p:spTree>
+      <p:nvGrpSpPr>
+        <p:cNvPr id="1" name=""/>
+        <p:cNvGrpSpPr/>
+        <p:nvPr/>
+      </p:nvGrpSpPr>
+      <p:grpSpPr>
+        <a:xfrm xmlns:a="http://schemas.openxmlformats.org/drawingml/2006/main"/>
+      </p:grpSpPr>
+      <p:sp>
+        <p:nvSpPr>
+          <p:cNvPr id="7" name="">
+            <a:extLst xmlns:a="http://schemas.openxmlformats.org/drawingml/2006/main">
+              <a:ext uri="{FF2B5EF4-FFF2-40B4-BE49-F238E27FC236}">
+                <a16:creationId xmlns:a16="http://schemas.microsoft.com/office/drawing/2014/main" id="{4989B079-C3E8-43BB-8638-96121018769A}"/>
+              </a:ext>
+            </a:extLst>
+          </p:cNvPr>
+          <p:cNvSpPr>
+            <a:spLocks xmlns:a="http://schemas.openxmlformats.org/drawingml/2006/main" noGrp="1"/>
+          </p:cNvSpPr>
+          <p:nvPr/>
+        </p:nvSpPr>
+        <p:spPr>
+          <a:xfrm xmlns:a="http://schemas.openxmlformats.org/drawingml/2006/main">
+            <a:off x="685800" y="361950"/>
+            <a:ext cx="10477500" cy="285750"/>
+          </a:xfrm>
+          <a:prstGeom xmlns:a="http://schemas.openxmlformats.org/drawingml/2006/main" prst="rect">
+            <a:avLst/>
+          </a:prstGeom>
+          <a:noFill xmlns:a="http://schemas.openxmlformats.org/drawingml/2006/main"/>
+          <a:ln xmlns:a="http://schemas.openxmlformats.org/drawingml/2006/main" w="0">
+            <a:noFill/>
+          </a:ln>
+        </p:spPr>
+        <p:txBody>
+          <a:bodyPr xmlns:a="http://schemas.openxmlformats.org/drawingml/2006/main" anchor="t">
+            <a:normAutofit fontScale="100000"/>
+          </a:bodyPr>
+          <a:lstStyle xmlns:a="http://schemas.openxmlformats.org/drawingml/2006/main"/>
+          <a:p xmlns:a="http://schemas.openxmlformats.org/drawingml/2006/main">
+            <a:pPr>
+              <a:buNone/>
+              <a:defRPr sz="1275" b="0">
+                <a:solidFill>
+                  <a:srgbClr val="6EE7B7"/>
+                </a:solidFill>
+                <a:latin typeface="Courier New"/>
+                <a:ea typeface="Courier New"/>
+                <a:cs typeface="Courier New"/>
+              </a:defRPr>
+            </a:pPr>
+            <a:r>
+              <a:rPr sz="1275" b="0">
+                <a:solidFill>
+                  <a:srgbClr val="6EE7B7"/>
+                </a:solidFill>
+                <a:latin typeface="Courier New"/>
+                <a:ea typeface="Courier New"/>
+                <a:cs typeface="Courier New"/>
+              </a:rPr>
+              <a:t>FLOATING POINT · RECAP</a:t>
+            </a:r>
+          </a:p>
+        </p:txBody>
+      </p:sp>
+      <p:sp>
+        <p:nvSpPr>
+          <p:cNvPr id="2" name="">
+            <a:extLst xmlns:a="http://schemas.openxmlformats.org/drawingml/2006/main">
+              <a:ext uri="{FF2B5EF4-FFF2-40B4-BE49-F238E27FC236}">
+                <a16:creationId xmlns:a16="http://schemas.microsoft.com/office/drawing/2014/main" id="{95D3113E-85F1-4E22-A62E-265E94FE3617}"/>
+              </a:ext>
+            </a:extLst>
+          </p:cNvPr>
+          <p:cNvSpPr>
+            <a:spLocks xmlns:a="http://schemas.openxmlformats.org/drawingml/2006/main" noGrp="1"/>
+          </p:cNvSpPr>
+          <p:nvPr/>
+        </p:nvSpPr>
+        <p:spPr>
+          <a:xfrm xmlns:a="http://schemas.openxmlformats.org/drawingml/2006/main">
+            <a:off x="685800" y="885825"/>
+            <a:ext cx="10820400" cy="1066800"/>
+          </a:xfrm>
+          <a:prstGeom xmlns:a="http://schemas.openxmlformats.org/drawingml/2006/main" prst="rect">
+            <a:avLst/>
+          </a:prstGeom>
+          <a:noFill xmlns:a="http://schemas.openxmlformats.org/drawingml/2006/main"/>
+          <a:ln xmlns:a="http://schemas.openxmlformats.org/drawingml/2006/main" w="0">
+            <a:noFill/>
+          </a:ln>
+        </p:spPr>
+        <p:txBody>
+          <a:bodyPr xmlns:a="http://schemas.openxmlformats.org/drawingml/2006/main" anchor="t">
+            <a:normAutofit fontScale="100000"/>
+          </a:bodyPr>
+          <a:lstStyle xmlns:a="http://schemas.openxmlformats.org/drawingml/2006/main"/>
+          <a:p xmlns:a="http://schemas.openxmlformats.org/drawingml/2006/main">
+            <a:pPr>
+              <a:buNone/>
+              <a:defRPr sz="3600" b="0">
+                <a:solidFill>
+                  <a:srgbClr val="FAFAFA"/>
+                </a:solidFill>
+                <a:latin typeface="Arial"/>
+                <a:ea typeface="Arial"/>
+                <a:cs typeface="Arial"/>
+              </a:defRPr>
+            </a:pPr>
+            <a:r>
+              <a:rPr sz="3600" b="0">
+                <a:solidFill>
+                  <a:srgbClr val="FAFAFA"/>
+                </a:solidFill>
+                <a:latin typeface="Arial"/>
+                <a:ea typeface="Arial"/>
+                <a:cs typeface="Arial"/>
+              </a:rPr>
+              <a:t>How to check an encoding</a:t>
+            </a:r>
+          </a:p>
+        </p:txBody>
+      </p:sp>
+      <p:sp>
+        <p:nvSpPr>
+          <p:cNvPr id="3" name="">
+            <a:extLst xmlns:a="http://schemas.openxmlformats.org/drawingml/2006/main">
+              <a:ext uri="{FF2B5EF4-FFF2-40B4-BE49-F238E27FC236}">
+                <a16:creationId xmlns:a16="http://schemas.microsoft.com/office/drawing/2014/main" id="{8EC5E33C-BA7C-4ADE-9FC3-9ABD9F3C6FD4}"/>
+              </a:ext>
+            </a:extLst>
+          </p:cNvPr>
+          <p:cNvSpPr>
+            <a:spLocks xmlns:a="http://schemas.openxmlformats.org/drawingml/2006/main" noGrp="1"/>
+          </p:cNvSpPr>
+          <p:nvPr/>
+        </p:nvSpPr>
+        <p:spPr>
+          <a:xfrm xmlns:a="http://schemas.openxmlformats.org/drawingml/2006/main">
+            <a:off x="685800" y="2200275"/>
+            <a:ext cx="4857750" cy="3124200"/>
+          </a:xfrm>
+          <a:prstGeom xmlns:a="http://schemas.openxmlformats.org/drawingml/2006/main" prst="rect">
+            <a:avLst/>
+          </a:prstGeom>
+          <a:noFill xmlns:a="http://schemas.openxmlformats.org/drawingml/2006/main"/>
+          <a:ln xmlns:a="http://schemas.openxmlformats.org/drawingml/2006/main" w="0">
+            <a:noFill/>
+          </a:ln>
+        </p:spPr>
+        <p:txBody>
+          <a:bodyPr xmlns:a="http://schemas.openxmlformats.org/drawingml/2006/main" anchor="t">
+            <a:normAutofit fontScale="100000"/>
+          </a:bodyPr>
+          <a:lstStyle xmlns:a="http://schemas.openxmlformats.org/drawingml/2006/main"/>
+          <a:p xmlns:a="http://schemas.openxmlformats.org/drawingml/2006/main">
+            <a:pPr>
+              <a:buNone/>
+              <a:defRPr sz="1950" b="0">
+                <a:solidFill>
+                  <a:srgbClr val="D4D4D8"/>
+                </a:solidFill>
+                <a:latin typeface="Arial"/>
+                <a:ea typeface="Arial"/>
+                <a:cs typeface="Arial"/>
+              </a:defRPr>
+            </a:pPr>
+            <a:r>
+              <a:rPr sz="1950" b="0">
+                <a:solidFill>
+                  <a:srgbClr val="D4D4D8"/>
+                </a:solidFill>
+                <a:latin typeface="Arial"/>
+                <a:ea typeface="Arial"/>
+                <a:cs typeface="Arial"/>
+              </a:rPr>
+              <a:t>In our practice format, E = 0 means count F steps of 1/32. Otherwise decode e = E − 3 and use the implied leading 1.</a:t>
+            </a:r>
+          </a:p>
+          <a:p xmlns:a="http://schemas.openxmlformats.org/drawingml/2006/main">
+            <a:r>
+              <a:t/>
+            </a:r>
+          </a:p>
+          <a:p xmlns:a="http://schemas.openxmlformats.org/drawingml/2006/main">
+            <a:pPr>
+              <a:buNone/>
+              <a:defRPr sz="1950" b="0">
+                <a:solidFill>
+                  <a:srgbClr val="D4D4D8"/>
+                </a:solidFill>
+                <a:latin typeface="Arial"/>
+                <a:ea typeface="Arial"/>
+                <a:cs typeface="Arial"/>
+              </a:defRPr>
+            </a:pPr>
+            <a:r>
+              <a:rPr sz="1950" b="0">
+                <a:solidFill>
+                  <a:srgbClr val="D4D4D8"/>
+                </a:solidFill>
+                <a:latin typeface="Arial"/>
+                <a:ea typeface="Arial"/>
+                <a:cs typeface="Arial"/>
+              </a:rPr>
+              <a:t>For an inexact value, follow the problem’s rounding rule.</a:t>
+            </a:r>
+          </a:p>
+        </p:txBody>
+      </p:sp>
+      <p:sp>
+        <p:nvSpPr>
+          <p:cNvPr id="4" name="">
+            <a:extLst xmlns:a="http://schemas.openxmlformats.org/drawingml/2006/main">
+              <a:ext uri="{FF2B5EF4-FFF2-40B4-BE49-F238E27FC236}">
+                <a16:creationId xmlns:a16="http://schemas.microsoft.com/office/drawing/2014/main" id="{EA939046-DA6B-448C-A179-5B13743C72F3}"/>
+              </a:ext>
+            </a:extLst>
+          </p:cNvPr>
+          <p:cNvSpPr>
+            <a:spLocks xmlns:a="http://schemas.openxmlformats.org/drawingml/2006/main" noGrp="1"/>
+          </p:cNvSpPr>
+          <p:nvPr/>
+        </p:nvSpPr>
+        <p:spPr>
+          <a:xfrm xmlns:a="http://schemas.openxmlformats.org/drawingml/2006/main">
+            <a:off x="6181725" y="2200275"/>
+            <a:ext cx="5238750" cy="3286125"/>
+          </a:xfrm>
+          <a:prstGeom xmlns:a="http://schemas.openxmlformats.org/drawingml/2006/main" prst="rect">
+            <a:avLst/>
+          </a:prstGeom>
+          <a:noFill xmlns:a="http://schemas.openxmlformats.org/drawingml/2006/main"/>
+          <a:ln xmlns:a="http://schemas.openxmlformats.org/drawingml/2006/main" w="0">
+            <a:noFill/>
+          </a:ln>
+        </p:spPr>
+        <p:txBody>
+          <a:bodyPr xmlns:a="http://schemas.openxmlformats.org/drawingml/2006/main" anchor="t">
+            <a:normAutofit fontScale="100000"/>
+          </a:bodyPr>
+          <a:lstStyle xmlns:a="http://schemas.openxmlformats.org/drawingml/2006/main"/>
+          <a:p xmlns:a="http://schemas.openxmlformats.org/drawingml/2006/main">
+            <a:pPr>
+              <a:buNone/>
+              <a:defRPr sz="1650" b="0">
+                <a:solidFill>
+                  <a:srgbClr val="A7F3D0"/>
+                </a:solidFill>
+                <a:latin typeface="Courier New"/>
+                <a:ea typeface="Courier New"/>
+                <a:cs typeface="Courier New"/>
+              </a:defRPr>
+            </a:pPr>
+            <a:r>
+              <a:rPr sz="1650" b="0">
+                <a:solidFill>
+                  <a:srgbClr val="A7F3D0"/>
+                </a:solidFill>
+                <a:latin typeface="Courier New"/>
+                <a:ea typeface="Courier New"/>
+                <a:cs typeface="Courier New"/>
+              </a:rPr>
+              <a:t>Our practice format</a:t>
+            </a:r>
+          </a:p>
+          <a:p xmlns:a="http://schemas.openxmlformats.org/drawingml/2006/main">
+            <a:r>
+              <a:t/>
+            </a:r>
+          </a:p>
+          <a:p xmlns:a="http://schemas.openxmlformats.org/drawingml/2006/main">
+            <a:pPr>
+              <a:buNone/>
+              <a:defRPr sz="1650" b="0">
+                <a:solidFill>
+                  <a:srgbClr val="A7F3D0"/>
+                </a:solidFill>
+                <a:latin typeface="Courier New"/>
+                <a:ea typeface="Courier New"/>
+                <a:cs typeface="Courier New"/>
+              </a:defRPr>
+            </a:pPr>
+            <a:r>
+              <a:rPr sz="1650" b="0">
+                <a:solidFill>
+                  <a:srgbClr val="A7F3D0"/>
+                </a:solidFill>
+                <a:latin typeface="Courier New"/>
+                <a:ea typeface="Courier New"/>
+                <a:cs typeface="Courier New"/>
+              </a:rPr>
+              <a:t>Normal:    (1 + F/8) × 2^(E−3)</a:t>
+            </a:r>
+          </a:p>
+          <a:p xmlns:a="http://schemas.openxmlformats.org/drawingml/2006/main">
+            <a:pPr>
+              <a:buNone/>
+              <a:defRPr sz="1650" b="0">
+                <a:solidFill>
+                  <a:srgbClr val="A7F3D0"/>
+                </a:solidFill>
+                <a:latin typeface="Courier New"/>
+                <a:ea typeface="Courier New"/>
+                <a:cs typeface="Courier New"/>
+              </a:defRPr>
+            </a:pPr>
+            <a:r>
+              <a:rPr sz="1650" b="0">
+                <a:solidFill>
+                  <a:srgbClr val="A7F3D0"/>
+                </a:solidFill>
+                <a:latin typeface="Courier New"/>
+                <a:ea typeface="Courier New"/>
+                <a:cs typeface="Courier New"/>
+              </a:rPr>
+              <a:t>Subnormal: F/32  (E = 0)</a:t>
+            </a:r>
+          </a:p>
+          <a:p xmlns:a="http://schemas.openxmlformats.org/drawingml/2006/main">
+            <a:r>
+              <a:t/>
+            </a:r>
+          </a:p>
+          <a:p xmlns:a="http://schemas.openxmlformats.org/drawingml/2006/main">
+            <a:pPr>
+              <a:buNone/>
+              <a:defRPr sz="1650" b="0">
+                <a:solidFill>
+                  <a:srgbClr val="A7F3D0"/>
+                </a:solidFill>
+                <a:latin typeface="Courier New"/>
+                <a:ea typeface="Courier New"/>
+                <a:cs typeface="Courier New"/>
+              </a:defRPr>
+            </a:pPr>
+            <a:r>
+              <a:rPr sz="1650" b="0">
+                <a:solidFill>
+                  <a:srgbClr val="A7F3D0"/>
+                </a:solidFill>
+                <a:latin typeface="Courier New"/>
+                <a:ea typeface="Courier New"/>
+                <a:cs typeface="Courier New"/>
+              </a:rPr>
+              <a:t>E = 0, F = 0  →  zero</a:t>
+            </a:r>
+          </a:p>
+          <a:p xmlns:a="http://schemas.openxmlformats.org/drawingml/2006/main">
+            <a:r>
+              <a:t/>
+            </a:r>
+          </a:p>
+          <a:p xmlns:a="http://schemas.openxmlformats.org/drawingml/2006/main">
+            <a:pPr>
+              <a:buNone/>
+              <a:defRPr sz="1650" b="0">
+                <a:solidFill>
+                  <a:srgbClr val="A7F3D0"/>
+                </a:solidFill>
+                <a:latin typeface="Courier New"/>
+                <a:ea typeface="Courier New"/>
+                <a:cs typeface="Courier New"/>
+              </a:defRPr>
+            </a:pPr>
+            <a:r>
+              <a:rPr sz="1650" b="0">
+                <a:solidFill>
+                  <a:srgbClr val="A7F3D0"/>
+                </a:solidFill>
+                <a:latin typeface="Courier New"/>
+                <a:ea typeface="Courier New"/>
+                <a:cs typeface="Courier New"/>
+              </a:rPr>
+              <a:t>Decode your bits as a final check.</a:t>
+            </a:r>
+          </a:p>
+        </p:txBody>
+      </p:sp>
+      <p:sp>
+        <p:nvSpPr>
+          <p:cNvPr id="5" name="">
+            <a:extLst xmlns:a="http://schemas.openxmlformats.org/drawingml/2006/main">
+              <a:ext uri="{FF2B5EF4-FFF2-40B4-BE49-F238E27FC236}">
+                <a16:creationId xmlns:a16="http://schemas.microsoft.com/office/drawing/2014/main" id="{585A0E73-828D-45A1-9AD7-8EED8C5E7EB1}"/>
+              </a:ext>
+            </a:extLst>
+          </p:cNvPr>
+          <p:cNvSpPr>
+            <a:spLocks xmlns:a="http://schemas.openxmlformats.org/drawingml/2006/main" noGrp="1"/>
+          </p:cNvSpPr>
+          <p:nvPr/>
+        </p:nvSpPr>
+        <p:spPr>
+          <a:xfrm xmlns:a="http://schemas.openxmlformats.org/drawingml/2006/main">
+            <a:off x="685800" y="5743575"/>
+            <a:ext cx="10191750" cy="428625"/>
+          </a:xfrm>
+          <a:prstGeom xmlns:a="http://schemas.openxmlformats.org/drawingml/2006/main" prst="rect">
+            <a:avLst/>
+          </a:prstGeom>
+          <a:noFill xmlns:a="http://schemas.openxmlformats.org/drawingml/2006/main"/>
+          <a:ln xmlns:a="http://schemas.openxmlformats.org/drawingml/2006/main" w="0">
+            <a:noFill/>
+          </a:ln>
+        </p:spPr>
+        <p:txBody>
+          <a:bodyPr xmlns:a="http://schemas.openxmlformats.org/drawingml/2006/main" anchor="t">
+            <a:normAutofit fontScale="100000"/>
+          </a:bodyPr>
+          <a:lstStyle xmlns:a="http://schemas.openxmlformats.org/drawingml/2006/main"/>
+          <a:p xmlns:a="http://schemas.openxmlformats.org/drawingml/2006/main">
+            <a:pPr>
+              <a:buNone/>
+              <a:defRPr sz="1350" b="0">
+                <a:solidFill>
+                  <a:srgbClr val="A1A1AA"/>
+                </a:solidFill>
+                <a:latin typeface="Arial"/>
+                <a:ea typeface="Arial"/>
+                <a:cs typeface="Arial"/>
+              </a:defRPr>
+            </a:pPr>
+            <a:r>
+              <a:rPr sz="1350" b="0">
+                <a:solidFill>
+                  <a:srgbClr val="A1A1AA"/>
+                </a:solidFill>
+                <a:latin typeface="Arial"/>
+                <a:ea typeface="Arial"/>
+                <a:cs typeface="Arial"/>
+              </a:rPr>
+              <a:t>A correct encoding must reproduce the intended value or its required rounded value.</a:t>
+            </a:r>
+          </a:p>
+        </p:txBody>
+      </p:sp>
+      <p:sp>
+        <p:nvSpPr>
+          <p:cNvPr id="6" name="">
+            <a:extLst xmlns:a="http://schemas.openxmlformats.org/drawingml/2006/main">
+              <a:ext uri="{FF2B5EF4-FFF2-40B4-BE49-F238E27FC236}">
+                <a16:creationId xmlns:a16="http://schemas.microsoft.com/office/drawing/2014/main" id="{E1FBC5BD-1F5D-42FA-AC83-E0BF862F4EDF}"/>
+              </a:ext>
+            </a:extLst>
+          </p:cNvPr>
+          <p:cNvSpPr>
+            <a:spLocks xmlns:a="http://schemas.openxmlformats.org/drawingml/2006/main" noGrp="1"/>
+          </p:cNvSpPr>
+          <p:nvPr/>
+        </p:nvSpPr>
+        <p:spPr>
+          <a:xfrm xmlns:a="http://schemas.openxmlformats.org/drawingml/2006/main">
+            <a:off x="10477500" y="6210300"/>
+            <a:ext cx="1000125" cy="219075"/>
+          </a:xfrm>
+          <a:prstGeom xmlns:a="http://schemas.openxmlformats.org/drawingml/2006/main" prst="rect">
+            <a:avLst/>
+          </a:prstGeom>
+          <a:noFill xmlns:a="http://schemas.openxmlformats.org/drawingml/2006/main"/>
+          <a:ln xmlns:a="http://schemas.openxmlformats.org/drawingml/2006/main" w="0">
+            <a:noFill/>
+          </a:ln>
+        </p:spPr>
+        <p:txBody>
+          <a:bodyPr xmlns:a="http://schemas.openxmlformats.org/drawingml/2006/main" anchor="t">
+            <a:normAutofit fontScale="79762"/>
+          </a:bodyPr>
+          <a:lstStyle xmlns:a="http://schemas.openxmlformats.org/drawingml/2006/main"/>
+          <a:p xmlns:a="http://schemas.openxmlformats.org/drawingml/2006/main">
+            <a:pPr>
+              <a:buNone/>
+              <a:defRPr sz="1050" b="0">
+                <a:solidFill>
+                  <a:srgbClr val="71717A"/>
+                </a:solidFill>
+                <a:latin typeface="Courier New"/>
+                <a:ea typeface="Courier New"/>
+                <a:cs typeface="Courier New"/>
+              </a:defRPr>
+            </a:pPr>
+            <a:r>
+              <a:rPr sz="1050" b="0">
+                <a:solidFill>
+                  <a:srgbClr val="71717A"/>
+                </a:solidFill>
+                <a:latin typeface="Courier New"/>
+                <a:ea typeface="Courier New"/>
+                <a:cs typeface="Courier New"/>
+              </a:rPr>
+              <a:t>24 / 24</a:t>
             </a:r>
           </a:p>
         </p:txBody>
@@ -10801,7 +12106,7 @@
                 <a:ea typeface="Courier New"/>
                 <a:cs typeface="Courier New"/>
               </a:rPr>
-              <a:t>03 / 22</a:t>
+              <a:t>03 / 24</a:t>
             </a:r>
           </a:p>
         </p:txBody>
@@ -11284,7 +12589,7 @@
                 <a:ea typeface="Courier New"/>
                 <a:cs typeface="Courier New"/>
               </a:rPr>
-              <a:t>04 / 22</a:t>
+              <a:t>04 / 24</a:t>
             </a:r>
           </a:p>
         </p:txBody>
@@ -11786,7 +13091,7 @@
                 <a:ea typeface="Courier New"/>
                 <a:cs typeface="Courier New"/>
               </a:rPr>
-              <a:t>05 / 22</a:t>
+              <a:t>05 / 24</a:t>
             </a:r>
           </a:p>
         </p:txBody>
@@ -12298,7 +13603,7 @@
                 <a:ea typeface="Courier New"/>
                 <a:cs typeface="Courier New"/>
               </a:rPr>
-              <a:t>06 / 22</a:t>
+              <a:t>06 / 24</a:t>
             </a:r>
           </a:p>
         </p:txBody>
@@ -12786,7 +14091,7 @@
                 <a:ea typeface="Courier New"/>
                 <a:cs typeface="Courier New"/>
               </a:rPr>
-              <a:t>07 / 22</a:t>
+              <a:t>07 / 24</a:t>
             </a:r>
           </a:p>
         </p:txBody>
@@ -12825,7 +14130,7 @@
           <p:cNvPr id="7" name="">
             <a:extLst xmlns:a="http://schemas.openxmlformats.org/drawingml/2006/main">
               <a:ext uri="{FF2B5EF4-FFF2-40B4-BE49-F238E27FC236}">
-                <a16:creationId xmlns:a16="http://schemas.microsoft.com/office/drawing/2014/main" id="{52BEAABF-BD4F-40AF-A282-4DA602FE61EE}"/>
+                <a16:creationId xmlns:a16="http://schemas.microsoft.com/office/drawing/2014/main" id="{514F9435-A104-4D30-A188-4EE2456CA2BB}"/>
               </a:ext>
             </a:extLst>
           </p:cNvPr>
@@ -12873,7 +14178,7 @@
                 <a:ea typeface="Courier New"/>
                 <a:cs typeface="Courier New"/>
               </a:rPr>
-              <a:t>FLOATING POINT · WHY SUBNORMALS</a:t>
+              <a:t>FLOATING POINT · QUIZ REVIEW</a:t>
             </a:r>
           </a:p>
         </p:txBody>
@@ -12883,7 +14188,7 @@
           <p:cNvPr id="2" name="">
             <a:extLst xmlns:a="http://schemas.openxmlformats.org/drawingml/2006/main">
               <a:ext uri="{FF2B5EF4-FFF2-40B4-BE49-F238E27FC236}">
-                <a16:creationId xmlns:a16="http://schemas.microsoft.com/office/drawing/2014/main" id="{55B309F2-033B-47F8-941D-460A77FAB0C8}"/>
+                <a16:creationId xmlns:a16="http://schemas.microsoft.com/office/drawing/2014/main" id="{E3CC3344-C3E4-4449-AF40-33DADFB16B1E}"/>
               </a:ext>
             </a:extLst>
           </p:cNvPr>
@@ -12931,7 +14236,7 @@
                 <a:ea typeface="Arial"/>
                 <a:cs typeface="Arial"/>
               </a:rPr>
-              <a:t>The smallest normal is 1/4</a:t>
+              <a:t>Quiz review: −1.0 in 8 bits</a:t>
             </a:r>
           </a:p>
         </p:txBody>
@@ -12941,7 +14246,7 @@
           <p:cNvPr id="3" name="">
             <a:extLst xmlns:a="http://schemas.openxmlformats.org/drawingml/2006/main">
               <a:ext uri="{FF2B5EF4-FFF2-40B4-BE49-F238E27FC236}">
-                <a16:creationId xmlns:a16="http://schemas.microsoft.com/office/drawing/2014/main" id="{2413D46C-F548-4E0D-8AC8-B55CC5C096EA}"/>
+                <a16:creationId xmlns:a16="http://schemas.microsoft.com/office/drawing/2014/main" id="{798D5084-9296-4E15-A9DC-A45F46A15641}"/>
               </a:ext>
             </a:extLst>
           </p:cNvPr>
@@ -12989,7 +14294,7 @@
                 <a:ea typeface="Arial"/>
                 <a:cs typeface="Arial"/>
               </a:rPr>
-              <a:t>The smallest normal exponent field is E = 1. With bias 3, that means e = −2. If the stored fraction is 000, the value is 1/4. We need another way to represent smaller positive values such as 1/8.</a:t>
+              <a:t>An 8-bit format has 1 sign bit, 5 exponent bits, 2 stored significand bits, and bias 15. An exponent field of 11111₂ is reserved for infinity and NaN. What representable value is closest to −1.0?</a:t>
             </a:r>
           </a:p>
         </p:txBody>
@@ -12999,7 +14304,7 @@
           <p:cNvPr id="4" name="">
             <a:extLst xmlns:a="http://schemas.openxmlformats.org/drawingml/2006/main">
               <a:ext uri="{FF2B5EF4-FFF2-40B4-BE49-F238E27FC236}">
-                <a16:creationId xmlns:a16="http://schemas.microsoft.com/office/drawing/2014/main" id="{F4B5AD63-6E91-45DD-AE29-2F54895B988B}"/>
+                <a16:creationId xmlns:a16="http://schemas.microsoft.com/office/drawing/2014/main" id="{FD548711-085C-45B3-A8BC-2D9BA414882B}"/>
               </a:ext>
             </a:extLst>
           </p:cNvPr>
@@ -13047,7 +14352,12 @@
                 <a:ea typeface="Courier New"/>
                 <a:cs typeface="Courier New"/>
               </a:rPr>
-              <a:t>Smallest normal</a:t>
+              <a:t>Write each answer in decimal:</a:t>
+            </a:r>
+          </a:p>
+          <a:p xmlns:a="http://schemas.openxmlformats.org/drawingml/2006/main">
+            <a:r>
+              <a:t/>
             </a:r>
           </a:p>
           <a:p xmlns:a="http://schemas.openxmlformats.org/drawingml/2006/main">
@@ -13071,7 +14381,31 @@
                 <a:ea typeface="Courier New"/>
                 <a:cs typeface="Courier New"/>
               </a:rPr>
-              <a:t/>
+              <a:t>value = ?</a:t>
+            </a:r>
+          </a:p>
+          <a:p xmlns:a="http://schemas.openxmlformats.org/drawingml/2006/main">
+            <a:pPr>
+              <a:buNone/>
+              <a:defRPr sz="1650" b="0">
+                <a:solidFill>
+                  <a:srgbClr val="A7F3D0"/>
+                </a:solidFill>
+                <a:latin typeface="Courier New"/>
+                <a:ea typeface="Courier New"/>
+                <a:cs typeface="Courier New"/>
+              </a:defRPr>
+            </a:pPr>
+            <a:r>
+              <a:rPr sz="1650" b="0">
+                <a:solidFill>
+                  <a:srgbClr val="A7F3D0"/>
+                </a:solidFill>
+                <a:latin typeface="Courier New"/>
+                <a:ea typeface="Courier New"/>
+                <a:cs typeface="Courier New"/>
+              </a:rPr>
+              <a:t>sign = ?</a:t>
             </a:r>
           </a:p>
           <a:p xmlns:a="http://schemas.openxmlformats.org/drawingml/2006/main">
@@ -13094,7 +14428,7 @@
                 <a:ea typeface="Courier New"/>
                 <a:cs typeface="Courier New"/>
               </a:rPr>
-              <a:t>E = 001₂  →  e = 1 − 3 = −2</a:t>
+              <a:t>exponent = ?</a:t>
             </a:r>
           </a:p>
           <a:p xmlns:a="http://schemas.openxmlformats.org/drawingml/2006/main">
@@ -13118,103 +14452,7 @@
                 <a:ea typeface="Courier New"/>
                 <a:cs typeface="Courier New"/>
               </a:rPr>
-              <a:t>F = 000₂  →  significand 1.000₂</a:t>
-            </a:r>
-          </a:p>
-          <a:p xmlns:a="http://schemas.openxmlformats.org/drawingml/2006/main">
-            <a:pPr>
-              <a:buNone/>
-              <a:defRPr sz="1650" b="0">
-                <a:solidFill>
-                  <a:srgbClr val="A7F3D0"/>
-                </a:solidFill>
-                <a:latin typeface="Courier New"/>
-                <a:ea typeface="Courier New"/>
-                <a:cs typeface="Courier New"/>
-              </a:defRPr>
-            </a:pPr>
-            <a:r>
-              <a:rPr sz="1650" b="0">
-                <a:solidFill>
-                  <a:srgbClr val="A7F3D0"/>
-                </a:solidFill>
-                <a:latin typeface="Courier New"/>
-                <a:ea typeface="Courier New"/>
-                <a:cs typeface="Courier New"/>
-              </a:rPr>
-              <a:t/>
-            </a:r>
-          </a:p>
-          <a:p xmlns:a="http://schemas.openxmlformats.org/drawingml/2006/main">
-            <a:pPr>
-              <a:buNone/>
-              <a:defRPr sz="1650" b="0">
-                <a:solidFill>
-                  <a:srgbClr val="A7F3D0"/>
-                </a:solidFill>
-                <a:latin typeface="Courier New"/>
-                <a:ea typeface="Courier New"/>
-                <a:cs typeface="Courier New"/>
-              </a:defRPr>
-            </a:pPr>
-            <a:r>
-              <a:rPr sz="1650" b="0">
-                <a:solidFill>
-                  <a:srgbClr val="A7F3D0"/>
-                </a:solidFill>
-                <a:latin typeface="Courier New"/>
-                <a:ea typeface="Courier New"/>
-                <a:cs typeface="Courier New"/>
-              </a:rPr>
-              <a:t>value = 1.000₂ × 2⁻² = 1/4</a:t>
-            </a:r>
-          </a:p>
-          <a:p xmlns:a="http://schemas.openxmlformats.org/drawingml/2006/main">
-            <a:pPr>
-              <a:buNone/>
-              <a:defRPr sz="1650" b="0">
-                <a:solidFill>
-                  <a:srgbClr val="A7F3D0"/>
-                </a:solidFill>
-                <a:latin typeface="Courier New"/>
-                <a:ea typeface="Courier New"/>
-                <a:cs typeface="Courier New"/>
-              </a:defRPr>
-            </a:pPr>
-            <a:r>
-              <a:rPr sz="1650" b="0">
-                <a:solidFill>
-                  <a:srgbClr val="A7F3D0"/>
-                </a:solidFill>
-                <a:latin typeface="Courier New"/>
-                <a:ea typeface="Courier New"/>
-                <a:cs typeface="Courier New"/>
-              </a:rPr>
-              <a:t/>
-            </a:r>
-          </a:p>
-          <a:p xmlns:a="http://schemas.openxmlformats.org/drawingml/2006/main">
-            <a:pPr>
-              <a:buNone/>
-              <a:defRPr sz="1650" b="0">
-                <a:solidFill>
-                  <a:srgbClr val="A7F3D0"/>
-                </a:solidFill>
-                <a:latin typeface="Courier New"/>
-                <a:ea typeface="Courier New"/>
-                <a:cs typeface="Courier New"/>
-              </a:defRPr>
-            </a:pPr>
-            <a:r>
-              <a:rPr sz="1650" b="0">
-                <a:solidFill>
-                  <a:srgbClr val="A7F3D0"/>
-                </a:solidFill>
-                <a:latin typeface="Courier New"/>
-                <a:ea typeface="Courier New"/>
-                <a:cs typeface="Courier New"/>
-              </a:rPr>
-              <a:t>1/8 is smaller. E = 0 marks a new case.</a:t>
+              <a:t>significand = ?</a:t>
             </a:r>
           </a:p>
         </p:txBody>
@@ -13224,7 +14462,7 @@
           <p:cNvPr id="5" name="">
             <a:extLst xmlns:a="http://schemas.openxmlformats.org/drawingml/2006/main">
               <a:ext uri="{FF2B5EF4-FFF2-40B4-BE49-F238E27FC236}">
-                <a16:creationId xmlns:a16="http://schemas.microsoft.com/office/drawing/2014/main" id="{10C83417-6965-41D8-8054-D122A500127B}"/>
+                <a16:creationId xmlns:a16="http://schemas.microsoft.com/office/drawing/2014/main" id="{584E23CF-F2CD-46A9-9F4D-20949170792D}"/>
               </a:ext>
             </a:extLst>
           </p:cNvPr>
@@ -13272,7 +14510,7 @@
                 <a:ea typeface="Arial"/>
                 <a:cs typeface="Arial"/>
               </a:rPr>
-              <a:t>For E = 0, use the subnormal rule instead of subtracting the bias.</a:t>
+              <a:t>Work out the fields before revealing the answer.</a:t>
             </a:r>
           </a:p>
         </p:txBody>
@@ -13282,7 +14520,7 @@
           <p:cNvPr id="6" name="">
             <a:extLst xmlns:a="http://schemas.openxmlformats.org/drawingml/2006/main">
               <a:ext uri="{FF2B5EF4-FFF2-40B4-BE49-F238E27FC236}">
-                <a16:creationId xmlns:a16="http://schemas.microsoft.com/office/drawing/2014/main" id="{8E1F2603-246C-497E-B2CC-C75AC3901746}"/>
+                <a16:creationId xmlns:a16="http://schemas.microsoft.com/office/drawing/2014/main" id="{96E02F47-A9E9-43B2-AC22-5EF03769EDD4}"/>
               </a:ext>
             </a:extLst>
           </p:cNvPr>
@@ -13330,7 +14568,7 @@
                 <a:ea typeface="Courier New"/>
                 <a:cs typeface="Courier New"/>
               </a:rPr>
-              <a:t>08 / 22</a:t>
+              <a:t>08 / 24</a:t>
             </a:r>
           </a:p>
         </p:txBody>
@@ -13338,7 +14576,7 @@
     </p:spTree>
     <p:extLst>
       <p:ext uri="{BB962C8B-B14F-4D97-AF65-F5344CB8AC3E}">
-        <p14:creationId xmlns:p14="http://schemas.microsoft.com/office/powerpoint/2010/main" val="1857122576"/>
+        <p14:creationId xmlns:p14="http://schemas.microsoft.com/office/powerpoint/2010/main" val="659736008"/>
       </p:ext>
     </p:extLst>
   </p:cSld>
@@ -13369,7 +14607,7 @@
           <p:cNvPr id="7" name="">
             <a:extLst xmlns:a="http://schemas.openxmlformats.org/drawingml/2006/main">
               <a:ext uri="{FF2B5EF4-FFF2-40B4-BE49-F238E27FC236}">
-                <a16:creationId xmlns:a16="http://schemas.microsoft.com/office/drawing/2014/main" id="{0E1C1D56-F3B0-4FC7-8312-5DCE66DE8296}"/>
+                <a16:creationId xmlns:a16="http://schemas.microsoft.com/office/drawing/2014/main" id="{514F9435-A104-4D30-A188-4EE2456CA2BB}"/>
               </a:ext>
             </a:extLst>
           </p:cNvPr>
@@ -13417,7 +14655,7 @@
                 <a:ea typeface="Courier New"/>
                 <a:cs typeface="Courier New"/>
               </a:rPr>
-              <a:t>FLOATING POINT · SUBNORMAL RULE</a:t>
+              <a:t>FLOATING POINT · WORKED ANSWER</a:t>
             </a:r>
           </a:p>
         </p:txBody>
@@ -13427,7 +14665,7 @@
           <p:cNvPr id="2" name="">
             <a:extLst xmlns:a="http://schemas.openxmlformats.org/drawingml/2006/main">
               <a:ext uri="{FF2B5EF4-FFF2-40B4-BE49-F238E27FC236}">
-                <a16:creationId xmlns:a16="http://schemas.microsoft.com/office/drawing/2014/main" id="{47EC4111-990D-4F27-A48D-9B66E8564E29}"/>
+                <a16:creationId xmlns:a16="http://schemas.microsoft.com/office/drawing/2014/main" id="{E3CC3344-C3E4-4449-AF40-33DADFB16B1E}"/>
               </a:ext>
             </a:extLst>
           </p:cNvPr>
@@ -13475,7 +14713,7 @@
                 <a:ea typeface="Arial"/>
                 <a:cs typeface="Arial"/>
               </a:rPr>
-              <a:t>E = 0 drops the hidden 1</a:t>
+              <a:t>Quiz answer: −1.0 is exact</a:t>
             </a:r>
           </a:p>
         </p:txBody>
@@ -13485,7 +14723,7 @@
           <p:cNvPr id="3" name="">
             <a:extLst xmlns:a="http://schemas.openxmlformats.org/drawingml/2006/main">
               <a:ext uri="{FF2B5EF4-FFF2-40B4-BE49-F238E27FC236}">
-                <a16:creationId xmlns:a16="http://schemas.microsoft.com/office/drawing/2014/main" id="{EA7FC2C0-68E4-440B-B218-A53A78DE1183}"/>
+                <a16:creationId xmlns:a16="http://schemas.microsoft.com/office/drawing/2014/main" id="{798D5084-9296-4E15-A9DC-A45F46A15641}"/>
               </a:ext>
             </a:extLst>
           </p:cNvPr>
@@ -13533,7 +14771,7 @@
                 <a:ea typeface="Arial"/>
                 <a:cs typeface="Arial"/>
               </a:rPr>
-              <a:t>Normal values start with an implied 1 before the fraction bits. When E = 0, use an implied 0 instead. Keep the same 2⁻² scale as the smallest normal so the values grow smoothly from zero.</a:t>
+              <a:t>−1.0 is representable exactly. Its magnitude is 1.00₂ × 2⁰, so the sign is 1, the true exponent is 0, and the stored fraction is 00₂. Add bias 15 to encode the exponent field.</a:t>
             </a:r>
           </a:p>
         </p:txBody>
@@ -13543,7 +14781,7 @@
           <p:cNvPr id="4" name="">
             <a:extLst xmlns:a="http://schemas.openxmlformats.org/drawingml/2006/main">
               <a:ext uri="{FF2B5EF4-FFF2-40B4-BE49-F238E27FC236}">
-                <a16:creationId xmlns:a16="http://schemas.microsoft.com/office/drawing/2014/main" id="{C7B97746-2F05-4C79-997B-46EF673FF248}"/>
+                <a16:creationId xmlns:a16="http://schemas.microsoft.com/office/drawing/2014/main" id="{FD548711-085C-45B3-A8BC-2D9BA414882B}"/>
               </a:ext>
             </a:extLst>
           </p:cNvPr>
@@ -13591,7 +14829,30 @@
                 <a:ea typeface="Courier New"/>
                 <a:cs typeface="Courier New"/>
               </a:rPr>
-              <a:t>Fixed e = 1 − bias = −2</a:t>
+              <a:t>value = −1.0</a:t>
+            </a:r>
+          </a:p>
+          <a:p xmlns:a="http://schemas.openxmlformats.org/drawingml/2006/main">
+            <a:pPr>
+              <a:defRPr sz="1650">
+                <a:solidFill>
+                  <a:srgbClr val="A7F3D0"/>
+                </a:solidFill>
+                <a:latin typeface="Courier New"/>
+                <a:ea typeface="Courier New"/>
+                <a:cs typeface="Courier New"/>
+              </a:defRPr>
+            </a:pPr>
+            <a:r>
+              <a:rPr sz="1650">
+                <a:solidFill>
+                  <a:srgbClr val="A7F3D0"/>
+                </a:solidFill>
+                <a:latin typeface="Courier New"/>
+                <a:ea typeface="Courier New"/>
+                <a:cs typeface="Courier New"/>
+              </a:rPr>
+              <a:t>sign = 1</a:t>
             </a:r>
           </a:p>
           <a:p xmlns:a="http://schemas.openxmlformats.org/drawingml/2006/main">
@@ -13615,6 +14876,35 @@
                 <a:ea typeface="Courier New"/>
                 <a:cs typeface="Courier New"/>
               </a:rPr>
+              <a:t>exponent = 15</a:t>
+            </a:r>
+          </a:p>
+          <a:p xmlns:a="http://schemas.openxmlformats.org/drawingml/2006/main">
+            <a:pPr>
+              <a:buNone/>
+              <a:defRPr sz="1650" b="0">
+                <a:solidFill>
+                  <a:srgbClr val="A7F3D0"/>
+                </a:solidFill>
+                <a:latin typeface="Courier New"/>
+                <a:ea typeface="Courier New"/>
+                <a:cs typeface="Courier New"/>
+              </a:defRPr>
+            </a:pPr>
+            <a:r>
+              <a:rPr sz="1650" b="0">
+                <a:solidFill>
+                  <a:srgbClr val="A7F3D0"/>
+                </a:solidFill>
+                <a:latin typeface="Courier New"/>
+                <a:ea typeface="Courier New"/>
+                <a:cs typeface="Courier New"/>
+              </a:rPr>
+              <a:t>significand = 0</a:t>
+            </a:r>
+          </a:p>
+          <a:p xmlns:a="http://schemas.openxmlformats.org/drawingml/2006/main">
+            <a:r>
               <a:t/>
             </a:r>
           </a:p>
@@ -13639,30 +14929,7 @@
                 <a:ea typeface="Courier New"/>
                 <a:cs typeface="Courier New"/>
               </a:rPr>
-              <a:t>Normal, E = 1:</a:t>
-            </a:r>
-          </a:p>
-          <a:p xmlns:a="http://schemas.openxmlformats.org/drawingml/2006/main">
-            <a:pPr>
-              <a:defRPr sz="1650">
-                <a:solidFill>
-                  <a:srgbClr val="A7F3D0"/>
-                </a:solidFill>
-                <a:latin typeface="Courier New"/>
-                <a:ea typeface="Courier New"/>
-                <a:cs typeface="Courier New"/>
-              </a:defRPr>
-            </a:pPr>
-            <a:r>
-              <a:rPr sz="1650">
-                <a:solidFill>
-                  <a:srgbClr val="A7F3D0"/>
-                </a:solidFill>
-                <a:latin typeface="Courier New"/>
-                <a:ea typeface="Courier New"/>
-                <a:cs typeface="Courier New"/>
-              </a:rPr>
-              <a:t>1.FFF₂ × 2⁻²</a:t>
+              <a:t>Bits: 1 | 01111 | 00</a:t>
             </a:r>
           </a:p>
           <a:p xmlns:a="http://schemas.openxmlformats.org/drawingml/2006/main">
@@ -13691,29 +14958,6 @@
           </a:p>
           <a:p xmlns:a="http://schemas.openxmlformats.org/drawingml/2006/main">
             <a:pPr>
-              <a:defRPr sz="1650">
-                <a:solidFill>
-                  <a:srgbClr val="A7F3D0"/>
-                </a:solidFill>
-                <a:latin typeface="Courier New"/>
-                <a:ea typeface="Courier New"/>
-                <a:cs typeface="Courier New"/>
-              </a:defRPr>
-            </a:pPr>
-            <a:r>
-              <a:rPr sz="1650">
-                <a:solidFill>
-                  <a:srgbClr val="A7F3D0"/>
-                </a:solidFill>
-                <a:latin typeface="Courier New"/>
-                <a:ea typeface="Courier New"/>
-                <a:cs typeface="Courier New"/>
-              </a:rPr>
-              <a:t>Subnormal, E = 0:</a:t>
-            </a:r>
-          </a:p>
-          <a:p xmlns:a="http://schemas.openxmlformats.org/drawingml/2006/main">
-            <a:pPr>
               <a:buNone/>
               <a:defRPr sz="1650" b="0">
                 <a:solidFill>
@@ -13733,79 +14977,7 @@
                 <a:ea typeface="Courier New"/>
                 <a:cs typeface="Courier New"/>
               </a:rPr>
-              <a:t>0.FFF₂ × 2⁻²</a:t>
-            </a:r>
-          </a:p>
-          <a:p xmlns:a="http://schemas.openxmlformats.org/drawingml/2006/main">
-            <a:pPr>
-              <a:buNone/>
-              <a:defRPr sz="1650" b="0">
-                <a:solidFill>
-                  <a:srgbClr val="A7F3D0"/>
-                </a:solidFill>
-                <a:latin typeface="Courier New"/>
-                <a:ea typeface="Courier New"/>
-                <a:cs typeface="Courier New"/>
-              </a:defRPr>
-            </a:pPr>
-            <a:r>
-              <a:rPr sz="1650" b="0">
-                <a:solidFill>
-                  <a:srgbClr val="A7F3D0"/>
-                </a:solidFill>
-                <a:latin typeface="Courier New"/>
-                <a:ea typeface="Courier New"/>
-                <a:cs typeface="Courier New"/>
-              </a:rPr>
-              <a:t/>
-            </a:r>
-          </a:p>
-          <a:p xmlns:a="http://schemas.openxmlformats.org/drawingml/2006/main">
-            <a:pPr>
-              <a:buNone/>
-              <a:defRPr sz="1650" b="0">
-                <a:solidFill>
-                  <a:srgbClr val="A7F3D0"/>
-                </a:solidFill>
-                <a:latin typeface="Courier New"/>
-                <a:ea typeface="Courier New"/>
-                <a:cs typeface="Courier New"/>
-              </a:defRPr>
-            </a:pPr>
-            <a:r>
-              <a:rPr sz="1650" b="0">
-                <a:solidFill>
-                  <a:srgbClr val="A7F3D0"/>
-                </a:solidFill>
-                <a:latin typeface="Courier New"/>
-                <a:ea typeface="Courier New"/>
-                <a:cs typeface="Courier New"/>
-              </a:rPr>
-              <a:t>F = 000  →  0.000₂ × 2⁻² = 0</a:t>
-            </a:r>
-          </a:p>
-          <a:p xmlns:a="http://schemas.openxmlformats.org/drawingml/2006/main">
-            <a:pPr>
-              <a:buNone/>
-              <a:defRPr sz="1650" b="0">
-                <a:solidFill>
-                  <a:srgbClr val="A7F3D0"/>
-                </a:solidFill>
-                <a:latin typeface="Courier New"/>
-                <a:ea typeface="Courier New"/>
-                <a:cs typeface="Courier New"/>
-              </a:defRPr>
-            </a:pPr>
-            <a:r>
-              <a:rPr sz="1650" b="0">
-                <a:solidFill>
-                  <a:srgbClr val="A7F3D0"/>
-                </a:solidFill>
-                <a:latin typeface="Courier New"/>
-                <a:ea typeface="Courier New"/>
-                <a:cs typeface="Courier New"/>
-              </a:rPr>
-              <a:t>F = 100  →  0.100₂ × 2⁻² = 1/8</a:t>
+              <a:t>Check: −(1 + 0/4) × 2^(15−15) = −1</a:t>
             </a:r>
           </a:p>
         </p:txBody>
@@ -13815,7 +14987,7 @@
           <p:cNvPr id="5" name="">
             <a:extLst xmlns:a="http://schemas.openxmlformats.org/drawingml/2006/main">
               <a:ext uri="{FF2B5EF4-FFF2-40B4-BE49-F238E27FC236}">
-                <a16:creationId xmlns:a16="http://schemas.microsoft.com/office/drawing/2014/main" id="{C953FAB2-7571-49A3-B6C8-87F90FA9D556}"/>
+                <a16:creationId xmlns:a16="http://schemas.microsoft.com/office/drawing/2014/main" id="{584E23CF-F2CD-46A9-9F4D-20949170792D}"/>
               </a:ext>
             </a:extLst>
           </p:cNvPr>
@@ -13863,7 +15035,7 @@
                 <a:ea typeface="Arial"/>
                 <a:cs typeface="Arial"/>
               </a:rPr>
-              <a:t>The leading 0 or 1 is implied; only FFF is stored.</a:t>
+              <a:t>E = 15 is valid; all five exponent bits set would be E = 31.</a:t>
             </a:r>
           </a:p>
         </p:txBody>
@@ -13873,7 +15045,7 @@
           <p:cNvPr id="6" name="">
             <a:extLst xmlns:a="http://schemas.openxmlformats.org/drawingml/2006/main">
               <a:ext uri="{FF2B5EF4-FFF2-40B4-BE49-F238E27FC236}">
-                <a16:creationId xmlns:a16="http://schemas.microsoft.com/office/drawing/2014/main" id="{ECE7F5E9-2417-44C6-925E-4767F90FA696}"/>
+                <a16:creationId xmlns:a16="http://schemas.microsoft.com/office/drawing/2014/main" id="{96E02F47-A9E9-43B2-AC22-5EF03769EDD4}"/>
               </a:ext>
             </a:extLst>
           </p:cNvPr>
@@ -13921,7 +15093,7 @@
                 <a:ea typeface="Courier New"/>
                 <a:cs typeface="Courier New"/>
               </a:rPr>
-              <a:t>09 / 22</a:t>
+              <a:t>09 / 24</a:t>
             </a:r>
           </a:p>
         </p:txBody>
@@ -13929,7 +15101,7 @@
     </p:spTree>
     <p:extLst>
       <p:ext uri="{BB962C8B-B14F-4D97-AF65-F5344CB8AC3E}">
-        <p14:creationId xmlns:p14="http://schemas.microsoft.com/office/powerpoint/2010/main" val="1082036242"/>
+        <p14:creationId xmlns:p14="http://schemas.microsoft.com/office/powerpoint/2010/main" val="659736008"/>
       </p:ext>
     </p:extLst>
   </p:cSld>

</xml_diff>

<commit_message>
Turn binary fraction example into practice prompt
</commit_message>
<xml_diff>
--- a/public/presentations/CS211_Recitation_3.pptx
+++ b/public/presentations/CS211_Recitation_3.pptx
@@ -2,36 +2,36 @@
 <file path=ppt/presentation.xml><?xml version="1.0" encoding="utf-8"?>
 <p:presentation xmlns:p="http://schemas.openxmlformats.org/presentationml/2006/main">
   <p:sldMasterIdLst>
-    <p:sldMasterId xmlns:r="http://schemas.openxmlformats.org/officeDocument/2006/relationships" id="2147483648" r:id="Ra581eb1e70f04890"/>
+    <p:sldMasterId xmlns:r="http://schemas.openxmlformats.org/officeDocument/2006/relationships" id="2147483648" r:id="R1019ac9d30db4862"/>
   </p:sldMasterIdLst>
   <p:notesMasterIdLst>
-    <p:notesMasterId xmlns:r="http://schemas.openxmlformats.org/officeDocument/2006/relationships" r:id="Rbb865c280d434164"/>
+    <p:notesMasterId xmlns:r="http://schemas.openxmlformats.org/officeDocument/2006/relationships" r:id="Rdb8619b902f649c6"/>
   </p:notesMasterIdLst>
   <p:sldIdLst>
-    <p:sldId xmlns:r="http://schemas.openxmlformats.org/officeDocument/2006/relationships" id="256" r:id="R3b3728e610b24b82"/>
-    <p:sldId xmlns:r="http://schemas.openxmlformats.org/officeDocument/2006/relationships" id="257" r:id="Rdf587f2ca1514ed5"/>
-    <p:sldId xmlns:r="http://schemas.openxmlformats.org/officeDocument/2006/relationships" id="258" r:id="R788d641bee0e46f7"/>
-    <p:sldId xmlns:r="http://schemas.openxmlformats.org/officeDocument/2006/relationships" id="259" r:id="R30cfa2125db74ca6"/>
-    <p:sldId xmlns:r="http://schemas.openxmlformats.org/officeDocument/2006/relationships" id="260" r:id="R7d53adca072f4738"/>
-    <p:sldId xmlns:r="http://schemas.openxmlformats.org/officeDocument/2006/relationships" id="261" r:id="R6c66a994006c45e0"/>
-    <p:sldId xmlns:r="http://schemas.openxmlformats.org/officeDocument/2006/relationships" id="262" r:id="R6f1480aea06143a6"/>
-    <p:sldId xmlns:r="http://schemas.openxmlformats.org/officeDocument/2006/relationships" id="263" r:id="R9f5c3e9ab19c4953"/>
-    <p:sldId xmlns:r="http://schemas.openxmlformats.org/officeDocument/2006/relationships" id="264" r:id="R163ed676201b4ca9"/>
-    <p:sldId xmlns:r="http://schemas.openxmlformats.org/officeDocument/2006/relationships" id="265" r:id="R6fb00f9d361c4b4b"/>
-    <p:sldId xmlns:r="http://schemas.openxmlformats.org/officeDocument/2006/relationships" id="266" r:id="Rd5a016d5364547db"/>
-    <p:sldId xmlns:r="http://schemas.openxmlformats.org/officeDocument/2006/relationships" id="267" r:id="R5b09294dfc4c4a08"/>
-    <p:sldId xmlns:r="http://schemas.openxmlformats.org/officeDocument/2006/relationships" id="268" r:id="Rcab8b974bc2a495c"/>
-    <p:sldId xmlns:r="http://schemas.openxmlformats.org/officeDocument/2006/relationships" id="269" r:id="R4db0ca0f0c1a4f87"/>
-    <p:sldId xmlns:r="http://schemas.openxmlformats.org/officeDocument/2006/relationships" id="270" r:id="R805499bc847d4ef1"/>
-    <p:sldId xmlns:r="http://schemas.openxmlformats.org/officeDocument/2006/relationships" id="271" r:id="Raec2f52b08104e65"/>
-    <p:sldId xmlns:r="http://schemas.openxmlformats.org/officeDocument/2006/relationships" id="272" r:id="R26a40352e6c84eb9"/>
-    <p:sldId xmlns:r="http://schemas.openxmlformats.org/officeDocument/2006/relationships" id="273" r:id="Rae14098eac234600"/>
-    <p:sldId xmlns:r="http://schemas.openxmlformats.org/officeDocument/2006/relationships" id="274" r:id="Rd20e5cfba2c24adb"/>
-    <p:sldId xmlns:r="http://schemas.openxmlformats.org/officeDocument/2006/relationships" id="275" r:id="R0540b3cf26454380"/>
-    <p:sldId xmlns:r="http://schemas.openxmlformats.org/officeDocument/2006/relationships" id="276" r:id="R03d16bfa308b42ed"/>
-    <p:sldId xmlns:r="http://schemas.openxmlformats.org/officeDocument/2006/relationships" id="277" r:id="R14fcb46eb35546e3"/>
-    <p:sldId xmlns:r="http://schemas.openxmlformats.org/officeDocument/2006/relationships" id="278" r:id="R86a7c2badc484d81"/>
-    <p:sldId xmlns:r="http://schemas.openxmlformats.org/officeDocument/2006/relationships" id="279" r:id="Rac8466e2a79d4548"/>
+    <p:sldId xmlns:r="http://schemas.openxmlformats.org/officeDocument/2006/relationships" id="256" r:id="R6ba236134733443e"/>
+    <p:sldId xmlns:r="http://schemas.openxmlformats.org/officeDocument/2006/relationships" id="257" r:id="R34f5fff1d2fb477a"/>
+    <p:sldId xmlns:r="http://schemas.openxmlformats.org/officeDocument/2006/relationships" id="258" r:id="R001cb5dba51c4517"/>
+    <p:sldId xmlns:r="http://schemas.openxmlformats.org/officeDocument/2006/relationships" id="259" r:id="R55a78fa90afc4869"/>
+    <p:sldId xmlns:r="http://schemas.openxmlformats.org/officeDocument/2006/relationships" id="260" r:id="Rca8e234d66784667"/>
+    <p:sldId xmlns:r="http://schemas.openxmlformats.org/officeDocument/2006/relationships" id="261" r:id="R55e01ce370084027"/>
+    <p:sldId xmlns:r="http://schemas.openxmlformats.org/officeDocument/2006/relationships" id="262" r:id="R822bdbcdd4ad4cb0"/>
+    <p:sldId xmlns:r="http://schemas.openxmlformats.org/officeDocument/2006/relationships" id="263" r:id="R18832adb7e704e98"/>
+    <p:sldId xmlns:r="http://schemas.openxmlformats.org/officeDocument/2006/relationships" id="264" r:id="R2c17979014aa4707"/>
+    <p:sldId xmlns:r="http://schemas.openxmlformats.org/officeDocument/2006/relationships" id="265" r:id="Rf7fea7c6a65547cf"/>
+    <p:sldId xmlns:r="http://schemas.openxmlformats.org/officeDocument/2006/relationships" id="266" r:id="R2e9b4ec5e6994b56"/>
+    <p:sldId xmlns:r="http://schemas.openxmlformats.org/officeDocument/2006/relationships" id="267" r:id="R55a3e558356a487e"/>
+    <p:sldId xmlns:r="http://schemas.openxmlformats.org/officeDocument/2006/relationships" id="268" r:id="R4fd32bb66f1d4348"/>
+    <p:sldId xmlns:r="http://schemas.openxmlformats.org/officeDocument/2006/relationships" id="269" r:id="R4394d82d39944aac"/>
+    <p:sldId xmlns:r="http://schemas.openxmlformats.org/officeDocument/2006/relationships" id="270" r:id="Re6c518dcb49d40ba"/>
+    <p:sldId xmlns:r="http://schemas.openxmlformats.org/officeDocument/2006/relationships" id="271" r:id="Rf8062d929f1a4ab8"/>
+    <p:sldId xmlns:r="http://schemas.openxmlformats.org/officeDocument/2006/relationships" id="272" r:id="R1535b5ecf1d940c6"/>
+    <p:sldId xmlns:r="http://schemas.openxmlformats.org/officeDocument/2006/relationships" id="273" r:id="R2e7736863938452e"/>
+    <p:sldId xmlns:r="http://schemas.openxmlformats.org/officeDocument/2006/relationships" id="274" r:id="R5e304eec38da40db"/>
+    <p:sldId xmlns:r="http://schemas.openxmlformats.org/officeDocument/2006/relationships" id="275" r:id="R6465cdf01deb4580"/>
+    <p:sldId xmlns:r="http://schemas.openxmlformats.org/officeDocument/2006/relationships" id="276" r:id="R4b9184e4013d4cc9"/>
+    <p:sldId xmlns:r="http://schemas.openxmlformats.org/officeDocument/2006/relationships" id="277" r:id="Recb98edfc6ef43ad"/>
+    <p:sldId xmlns:r="http://schemas.openxmlformats.org/officeDocument/2006/relationships" id="278" r:id="Ra0f0dd9475bb4b57"/>
+    <p:sldId xmlns:r="http://schemas.openxmlformats.org/officeDocument/2006/relationships" id="279" r:id="Rc359c217dc1642e0"/>
   </p:sldIdLst>
   <p:sldSz cx="12192000" cy="6858000"/>
   <p:notesSz cx="6858000" cy="9144000"/>
@@ -1655,7 +1655,7 @@
           <a:lstStyle xmlns:a="http://schemas.openxmlformats.org/drawingml/2006/main"/>
           <a:p xmlns:a="http://schemas.openxmlformats.org/drawingml/2006/main">
             <a:r>
-              <a:t>Draw place-value columns before introducing exponent fields. This bridges base-2 arithmetic to the 5/4 and 3/16 examples. The 0.101₂ example equals 0.625.</a:t>
+              <a:t>Draw place-value columns before introducing exponent fields. This bridges base-2 arithmetic to the 5/4 and 3/16 examples. The worked 0.101₂ example equals 5/8. Pause for students to solve 0.011₂; the answer is 1/4 + 1/8 = 3/8.</a:t>
             </a:r>
           </a:p>
         </p:txBody>
@@ -2143,7 +2143,7 @@
   </p:cSld>
   <p:clrMap bg1="lt1" tx1="dk1" bg2="lt2" tx2="dk2" accent1="accent1" accent2="accent2" accent3="accent3" accent4="accent4" accent5="accent5" accent6="accent6" hlink="hlink" folHlink="folHlink"/>
   <p:sldLayoutIdLst>
-    <p:sldLayoutId xmlns:r="http://schemas.openxmlformats.org/officeDocument/2006/relationships" id="2147483649" r:id="R37788616201544a6"/>
+    <p:sldLayoutId xmlns:r="http://schemas.openxmlformats.org/officeDocument/2006/relationships" id="2147483649" r:id="R5842b14d28c342ce"/>
   </p:sldLayoutIdLst>
   <p:txStyles>
     <p:titleStyle>
@@ -12048,7 +12048,7 @@
                 <a:ea typeface="Arial"/>
                 <a:cs typeface="Arial"/>
               </a:rPr>
-              <a:t>Ask students to read 0.011₂ aloud as 1/4 + 1/8 = 3/8.</a:t>
+              <a:t>Your turn: What fraction is 0.011₂? Show the place values you used.</a:t>
             </a:r>
           </a:p>
         </p:txBody>
@@ -14410,6 +14410,7 @@
           </a:p>
           <a:p xmlns:a="http://schemas.openxmlformats.org/drawingml/2006/main">
             <a:pPr>
+              <a:buNone/>
               <a:defRPr sz="1650">
                 <a:solidFill>
                   <a:srgbClr val="A7F3D0"/>
@@ -14834,6 +14835,7 @@
           </a:p>
           <a:p xmlns:a="http://schemas.openxmlformats.org/drawingml/2006/main">
             <a:pPr>
+              <a:buNone/>
               <a:defRPr sz="1650">
                 <a:solidFill>
                   <a:srgbClr val="A7F3D0"/>

</xml_diff>

<commit_message>
Remove formula item from recitation agenda
</commit_message>
<xml_diff>
--- a/public/presentations/CS211_Recitation_3.pptx
+++ b/public/presentations/CS211_Recitation_3.pptx
@@ -2,38 +2,38 @@
 <file path=ppt/presentation.xml><?xml version="1.0" encoding="utf-8"?>
 <p:presentation xmlns:p="http://schemas.openxmlformats.org/presentationml/2006/main">
   <p:sldMasterIdLst>
-    <p:sldMasterId xmlns:r="http://schemas.openxmlformats.org/officeDocument/2006/relationships" id="2147483648" r:id="R37680de94059499a"/>
+    <p:sldMasterId xmlns:r="http://schemas.openxmlformats.org/officeDocument/2006/relationships" id="2147483648" r:id="R82fcb09f96334701"/>
   </p:sldMasterIdLst>
   <p:notesMasterIdLst>
-    <p:notesMasterId xmlns:r="http://schemas.openxmlformats.org/officeDocument/2006/relationships" r:id="Rbc8e1e2c45334134"/>
+    <p:notesMasterId xmlns:r="http://schemas.openxmlformats.org/officeDocument/2006/relationships" r:id="R474a467d0120440c"/>
   </p:notesMasterIdLst>
   <p:sldIdLst>
-    <p:sldId xmlns:r="http://schemas.openxmlformats.org/officeDocument/2006/relationships" id="256" r:id="R940dc9cb7acc45cb"/>
-    <p:sldId xmlns:r="http://schemas.openxmlformats.org/officeDocument/2006/relationships" id="257" r:id="R7b841f58357e4433"/>
-    <p:sldId xmlns:r="http://schemas.openxmlformats.org/officeDocument/2006/relationships" id="258" r:id="R2868d2b31b6b4e92"/>
-    <p:sldId xmlns:r="http://schemas.openxmlformats.org/officeDocument/2006/relationships" id="259" r:id="R45b077fff45f4382"/>
-    <p:sldId xmlns:r="http://schemas.openxmlformats.org/officeDocument/2006/relationships" id="260" r:id="Rbc52cf803f544a74"/>
-    <p:sldId xmlns:r="http://schemas.openxmlformats.org/officeDocument/2006/relationships" id="261" r:id="Raec4052dc8224440"/>
-    <p:sldId xmlns:r="http://schemas.openxmlformats.org/officeDocument/2006/relationships" id="262" r:id="R2d140b9904d94459"/>
-    <p:sldId xmlns:r="http://schemas.openxmlformats.org/officeDocument/2006/relationships" id="263" r:id="Ra99ff6ad601c4478"/>
-    <p:sldId xmlns:r="http://schemas.openxmlformats.org/officeDocument/2006/relationships" id="264" r:id="Rd85da423900746da"/>
-    <p:sldId xmlns:r="http://schemas.openxmlformats.org/officeDocument/2006/relationships" id="265" r:id="R7a3e18f265944b3d"/>
-    <p:sldId xmlns:r="http://schemas.openxmlformats.org/officeDocument/2006/relationships" id="266" r:id="R760a6842863e42cf"/>
-    <p:sldId xmlns:r="http://schemas.openxmlformats.org/officeDocument/2006/relationships" id="267" r:id="Rdc9ee0c25e094a13"/>
-    <p:sldId xmlns:r="http://schemas.openxmlformats.org/officeDocument/2006/relationships" id="268" r:id="R65169ae9db9d4b33"/>
-    <p:sldId xmlns:r="http://schemas.openxmlformats.org/officeDocument/2006/relationships" id="269" r:id="Rfe6235fada264ae0"/>
-    <p:sldId xmlns:r="http://schemas.openxmlformats.org/officeDocument/2006/relationships" id="270" r:id="Rdcc9b7f9a87f43e1"/>
-    <p:sldId xmlns:r="http://schemas.openxmlformats.org/officeDocument/2006/relationships" id="271" r:id="Rfcac26cf11d34c77"/>
-    <p:sldId xmlns:r="http://schemas.openxmlformats.org/officeDocument/2006/relationships" id="272" r:id="R6868f5890e2a4b98"/>
-    <p:sldId xmlns:r="http://schemas.openxmlformats.org/officeDocument/2006/relationships" id="273" r:id="R6faddac8d57f45cd"/>
-    <p:sldId xmlns:r="http://schemas.openxmlformats.org/officeDocument/2006/relationships" id="274" r:id="R75d1b85af1df4135"/>
-    <p:sldId xmlns:r="http://schemas.openxmlformats.org/officeDocument/2006/relationships" id="275" r:id="R7cc0bf07befc460c"/>
-    <p:sldId xmlns:r="http://schemas.openxmlformats.org/officeDocument/2006/relationships" id="276" r:id="Ra93cd562dc944029"/>
-    <p:sldId xmlns:r="http://schemas.openxmlformats.org/officeDocument/2006/relationships" id="277" r:id="R6d09ffd060664596"/>
-    <p:sldId xmlns:r="http://schemas.openxmlformats.org/officeDocument/2006/relationships" id="278" r:id="R412a0c63c0db427e"/>
-    <p:sldId xmlns:r="http://schemas.openxmlformats.org/officeDocument/2006/relationships" id="279" r:id="R8af56e70733c4c3b"/>
-    <p:sldId xmlns:r="http://schemas.openxmlformats.org/officeDocument/2006/relationships" id="280" r:id="R4298338e0f9a43eb"/>
-    <p:sldId xmlns:r="http://schemas.openxmlformats.org/officeDocument/2006/relationships" id="281" r:id="R3a6e000efa074efd"/>
+    <p:sldId xmlns:r="http://schemas.openxmlformats.org/officeDocument/2006/relationships" id="256" r:id="Ra3d37a84d0a64374"/>
+    <p:sldId xmlns:r="http://schemas.openxmlformats.org/officeDocument/2006/relationships" id="257" r:id="R378aa6ce9e1644f6"/>
+    <p:sldId xmlns:r="http://schemas.openxmlformats.org/officeDocument/2006/relationships" id="258" r:id="R18c0225dd3024101"/>
+    <p:sldId xmlns:r="http://schemas.openxmlformats.org/officeDocument/2006/relationships" id="259" r:id="Rb66dca7862594817"/>
+    <p:sldId xmlns:r="http://schemas.openxmlformats.org/officeDocument/2006/relationships" id="260" r:id="R87e7b0b109244a3b"/>
+    <p:sldId xmlns:r="http://schemas.openxmlformats.org/officeDocument/2006/relationships" id="261" r:id="R0e9950f9f8e14af8"/>
+    <p:sldId xmlns:r="http://schemas.openxmlformats.org/officeDocument/2006/relationships" id="262" r:id="R08bf74868a8f481f"/>
+    <p:sldId xmlns:r="http://schemas.openxmlformats.org/officeDocument/2006/relationships" id="263" r:id="Rf297d606c7824529"/>
+    <p:sldId xmlns:r="http://schemas.openxmlformats.org/officeDocument/2006/relationships" id="264" r:id="Rfdf45718ac5b496a"/>
+    <p:sldId xmlns:r="http://schemas.openxmlformats.org/officeDocument/2006/relationships" id="265" r:id="R9898d2d361a44491"/>
+    <p:sldId xmlns:r="http://schemas.openxmlformats.org/officeDocument/2006/relationships" id="266" r:id="Re33468a2cb834722"/>
+    <p:sldId xmlns:r="http://schemas.openxmlformats.org/officeDocument/2006/relationships" id="267" r:id="R00519ed4bae841fc"/>
+    <p:sldId xmlns:r="http://schemas.openxmlformats.org/officeDocument/2006/relationships" id="268" r:id="Rdff174f64df84585"/>
+    <p:sldId xmlns:r="http://schemas.openxmlformats.org/officeDocument/2006/relationships" id="269" r:id="R7f4319538780495c"/>
+    <p:sldId xmlns:r="http://schemas.openxmlformats.org/officeDocument/2006/relationships" id="270" r:id="R549de014dc6a446c"/>
+    <p:sldId xmlns:r="http://schemas.openxmlformats.org/officeDocument/2006/relationships" id="271" r:id="R823a94f0d9b0413b"/>
+    <p:sldId xmlns:r="http://schemas.openxmlformats.org/officeDocument/2006/relationships" id="272" r:id="Rd52abeb6e1864609"/>
+    <p:sldId xmlns:r="http://schemas.openxmlformats.org/officeDocument/2006/relationships" id="273" r:id="Rbe73d3ff010445df"/>
+    <p:sldId xmlns:r="http://schemas.openxmlformats.org/officeDocument/2006/relationships" id="274" r:id="R36c3521d99074887"/>
+    <p:sldId xmlns:r="http://schemas.openxmlformats.org/officeDocument/2006/relationships" id="275" r:id="Rd711777c67754a83"/>
+    <p:sldId xmlns:r="http://schemas.openxmlformats.org/officeDocument/2006/relationships" id="276" r:id="Rcb6ad129dcd642da"/>
+    <p:sldId xmlns:r="http://schemas.openxmlformats.org/officeDocument/2006/relationships" id="277" r:id="R88d3fa45748c415b"/>
+    <p:sldId xmlns:r="http://schemas.openxmlformats.org/officeDocument/2006/relationships" id="278" r:id="R25e575ce39144c85"/>
+    <p:sldId xmlns:r="http://schemas.openxmlformats.org/officeDocument/2006/relationships" id="279" r:id="Rf364721da4444bec"/>
+    <p:sldId xmlns:r="http://schemas.openxmlformats.org/officeDocument/2006/relationships" id="280" r:id="R28565863f92c4eee"/>
+    <p:sldId xmlns:r="http://schemas.openxmlformats.org/officeDocument/2006/relationships" id="281" r:id="R6035c293abeb4503"/>
   </p:sldIdLst>
   <p:sldSz cx="12192000" cy="6858000"/>
   <p:notesSz cx="6858000" cy="9144000"/>
@@ -2285,7 +2285,7 @@
   </p:cSld>
   <p:clrMap bg1="lt1" tx1="dk1" bg2="lt2" tx2="dk2" accent1="accent1" accent2="accent2" accent3="accent3" accent4="accent4" accent5="accent5" accent6="accent6" hlink="hlink" folHlink="folHlink"/>
   <p:sldLayoutIdLst>
-    <p:sldLayoutId xmlns:r="http://schemas.openxmlformats.org/officeDocument/2006/relationships" id="2147483649" r:id="R33028cef623841ad"/>
+    <p:sldLayoutId xmlns:r="http://schemas.openxmlformats.org/officeDocument/2006/relationships" id="2147483649" r:id="Rfeba335572f146e8"/>
   </p:sldLayoutIdLst>
   <p:txStyles>
     <p:titleStyle>
@@ -3111,30 +3111,6 @@
                 <a:ea typeface="Courier New"/>
                 <a:cs typeface="Courier New"/>
               </a:rPr>
-              <a:t>Firner’s value equations</a:t>
-            </a:r>
-          </a:p>
-          <a:p xmlns:a="http://schemas.openxmlformats.org/drawingml/2006/main">
-            <a:pPr>
-              <a:buNone/>
-              <a:defRPr sz="1650" b="0">
-                <a:solidFill>
-                  <a:srgbClr val="A7F3D0"/>
-                </a:solidFill>
-                <a:latin typeface="Courier New"/>
-                <a:ea typeface="Courier New"/>
-                <a:cs typeface="Courier New"/>
-              </a:defRPr>
-            </a:pPr>
-            <a:r>
-              <a:rPr sz="1650" b="0">
-                <a:solidFill>
-                  <a:srgbClr val="A7F3D0"/>
-                </a:solidFill>
-                <a:latin typeface="Courier New"/>
-                <a:ea typeface="Courier New"/>
-                <a:cs typeface="Courier New"/>
-              </a:rPr>
               <a:t>Normal values and quiz review</a:t>
             </a:r>
           </a:p>

</xml_diff>